<commit_message>
build: export and validate defense package
</commit_message>
<xml_diff>
--- a/Document/outputs/final-defense/G6519692_Zaw_Ye_Htut_Ko_Final_Thesis_Defense.pptx
+++ b/Document/outputs/final-defense/G6519692_Zaw_Ye_Htut_Ko_Final_Thesis_Defense.pptx
@@ -11938,7 +11938,7 @@
                       </a:endParaRPr>
                     </a:p>
                   </a:txBody>
-                  <a:tcPr marL="82296" marR="82296" marT="82296" marB="82296" anchor="mid">
+                  <a:tcPr marL="82296" marR="82296" marT="82296" marB="82296" anchor="ctr">
                     <a:lnL w="10160" cap="flat" cmpd="sng" algn="ctr">
                       <a:solidFill>
                         <a:srgbClr val="D9DEE5"/>
@@ -12006,7 +12006,7 @@
                       </a:endParaRPr>
                     </a:p>
                   </a:txBody>
-                  <a:tcPr marL="82296" marR="82296" marT="82296" marB="82296" anchor="mid">
+                  <a:tcPr marL="82296" marR="82296" marT="82296" marB="82296" anchor="ctr">
                     <a:lnL w="10160" cap="flat" cmpd="sng" algn="ctr">
                       <a:solidFill>
                         <a:srgbClr val="D9DEE5"/>
@@ -12074,7 +12074,7 @@
                       </a:endParaRPr>
                     </a:p>
                   </a:txBody>
-                  <a:tcPr marL="82296" marR="82296" marT="82296" marB="82296" anchor="mid">
+                  <a:tcPr marL="82296" marR="82296" marT="82296" marB="82296" anchor="ctr">
                     <a:lnL w="10160" cap="flat" cmpd="sng" algn="ctr">
                       <a:solidFill>
                         <a:srgbClr val="D9DEE5"/>
@@ -12142,7 +12142,7 @@
                       </a:endParaRPr>
                     </a:p>
                   </a:txBody>
-                  <a:tcPr marL="82296" marR="82296" marT="82296" marB="82296" anchor="mid">
+                  <a:tcPr marL="82296" marR="82296" marT="82296" marB="82296" anchor="ctr">
                     <a:lnL w="10160" cap="flat" cmpd="sng" algn="ctr">
                       <a:solidFill>
                         <a:srgbClr val="D9DEE5"/>
@@ -12212,7 +12212,7 @@
                       </a:endParaRPr>
                     </a:p>
                   </a:txBody>
-                  <a:tcPr marL="82296" marR="82296" marT="82296" marB="82296" anchor="mid">
+                  <a:tcPr marL="82296" marR="82296" marT="82296" marB="82296" anchor="ctr">
                     <a:lnL w="10160" cap="flat" cmpd="sng" algn="ctr">
                       <a:solidFill>
                         <a:srgbClr val="D9DEE5"/>
@@ -12280,7 +12280,7 @@
                       </a:endParaRPr>
                     </a:p>
                   </a:txBody>
-                  <a:tcPr marL="82296" marR="82296" marT="82296" marB="82296" anchor="mid">
+                  <a:tcPr marL="82296" marR="82296" marT="82296" marB="82296" anchor="ctr">
                     <a:lnL w="10160" cap="flat" cmpd="sng" algn="ctr">
                       <a:solidFill>
                         <a:srgbClr val="D9DEE5"/>
@@ -12348,7 +12348,7 @@
                       </a:endParaRPr>
                     </a:p>
                   </a:txBody>
-                  <a:tcPr marL="82296" marR="82296" marT="82296" marB="82296" anchor="mid">
+                  <a:tcPr marL="82296" marR="82296" marT="82296" marB="82296" anchor="ctr">
                     <a:lnL w="10160" cap="flat" cmpd="sng" algn="ctr">
                       <a:solidFill>
                         <a:srgbClr val="D9DEE5"/>
@@ -12416,7 +12416,7 @@
                       </a:endParaRPr>
                     </a:p>
                   </a:txBody>
-                  <a:tcPr marL="82296" marR="82296" marT="82296" marB="82296" anchor="mid">
+                  <a:tcPr marL="82296" marR="82296" marT="82296" marB="82296" anchor="ctr">
                     <a:lnL w="10160" cap="flat" cmpd="sng" algn="ctr">
                       <a:solidFill>
                         <a:srgbClr val="D9DEE5"/>
@@ -12486,7 +12486,7 @@
                       </a:endParaRPr>
                     </a:p>
                   </a:txBody>
-                  <a:tcPr marL="82296" marR="82296" marT="82296" marB="82296" anchor="mid">
+                  <a:tcPr marL="82296" marR="82296" marT="82296" marB="82296" anchor="ctr">
                     <a:lnL w="10160" cap="flat" cmpd="sng" algn="ctr">
                       <a:solidFill>
                         <a:srgbClr val="D9DEE5"/>
@@ -12554,7 +12554,7 @@
                       </a:endParaRPr>
                     </a:p>
                   </a:txBody>
-                  <a:tcPr marL="82296" marR="82296" marT="82296" marB="82296" anchor="mid">
+                  <a:tcPr marL="82296" marR="82296" marT="82296" marB="82296" anchor="ctr">
                     <a:lnL w="10160" cap="flat" cmpd="sng" algn="ctr">
                       <a:solidFill>
                         <a:srgbClr val="D9DEE5"/>
@@ -12622,7 +12622,7 @@
                       </a:endParaRPr>
                     </a:p>
                   </a:txBody>
-                  <a:tcPr marL="82296" marR="82296" marT="82296" marB="82296" anchor="mid">
+                  <a:tcPr marL="82296" marR="82296" marT="82296" marB="82296" anchor="ctr">
                     <a:lnL w="10160" cap="flat" cmpd="sng" algn="ctr">
                       <a:solidFill>
                         <a:srgbClr val="D9DEE5"/>
@@ -12690,7 +12690,7 @@
                       </a:endParaRPr>
                     </a:p>
                   </a:txBody>
-                  <a:tcPr marL="82296" marR="82296" marT="82296" marB="82296" anchor="mid">
+                  <a:tcPr marL="82296" marR="82296" marT="82296" marB="82296" anchor="ctr">
                     <a:lnL w="10160" cap="flat" cmpd="sng" algn="ctr">
                       <a:solidFill>
                         <a:srgbClr val="D9DEE5"/>
@@ -12760,7 +12760,7 @@
                       </a:endParaRPr>
                     </a:p>
                   </a:txBody>
-                  <a:tcPr marL="82296" marR="82296" marT="82296" marB="82296" anchor="mid">
+                  <a:tcPr marL="82296" marR="82296" marT="82296" marB="82296" anchor="ctr">
                     <a:lnL w="10160" cap="flat" cmpd="sng" algn="ctr">
                       <a:solidFill>
                         <a:srgbClr val="D9DEE5"/>
@@ -12828,7 +12828,7 @@
                       </a:endParaRPr>
                     </a:p>
                   </a:txBody>
-                  <a:tcPr marL="82296" marR="82296" marT="82296" marB="82296" anchor="mid">
+                  <a:tcPr marL="82296" marR="82296" marT="82296" marB="82296" anchor="ctr">
                     <a:lnL w="10160" cap="flat" cmpd="sng" algn="ctr">
                       <a:solidFill>
                         <a:srgbClr val="D9DEE5"/>
@@ -12896,7 +12896,7 @@
                       </a:endParaRPr>
                     </a:p>
                   </a:txBody>
-                  <a:tcPr marL="82296" marR="82296" marT="82296" marB="82296" anchor="mid">
+                  <a:tcPr marL="82296" marR="82296" marT="82296" marB="82296" anchor="ctr">
                     <a:lnL w="10160" cap="flat" cmpd="sng" algn="ctr">
                       <a:solidFill>
                         <a:srgbClr val="D9DEE5"/>
@@ -12964,7 +12964,7 @@
                       </a:endParaRPr>
                     </a:p>
                   </a:txBody>
-                  <a:tcPr marL="82296" marR="82296" marT="82296" marB="82296" anchor="mid">
+                  <a:tcPr marL="82296" marR="82296" marT="82296" marB="82296" anchor="ctr">
                     <a:lnL w="10160" cap="flat" cmpd="sng" algn="ctr">
                       <a:solidFill>
                         <a:srgbClr val="D9DEE5"/>
@@ -13034,7 +13034,7 @@
                       </a:endParaRPr>
                     </a:p>
                   </a:txBody>
-                  <a:tcPr marL="82296" marR="82296" marT="82296" marB="82296" anchor="mid">
+                  <a:tcPr marL="82296" marR="82296" marT="82296" marB="82296" anchor="ctr">
                     <a:lnL w="10160" cap="flat" cmpd="sng" algn="ctr">
                       <a:solidFill>
                         <a:srgbClr val="D9DEE5"/>
@@ -13102,7 +13102,7 @@
                       </a:endParaRPr>
                     </a:p>
                   </a:txBody>
-                  <a:tcPr marL="82296" marR="82296" marT="82296" marB="82296" anchor="mid">
+                  <a:tcPr marL="82296" marR="82296" marT="82296" marB="82296" anchor="ctr">
                     <a:lnL w="10160" cap="flat" cmpd="sng" algn="ctr">
                       <a:solidFill>
                         <a:srgbClr val="D9DEE5"/>
@@ -13170,7 +13170,7 @@
                       </a:endParaRPr>
                     </a:p>
                   </a:txBody>
-                  <a:tcPr marL="82296" marR="82296" marT="82296" marB="82296" anchor="mid">
+                  <a:tcPr marL="82296" marR="82296" marT="82296" marB="82296" anchor="ctr">
                     <a:lnL w="10160" cap="flat" cmpd="sng" algn="ctr">
                       <a:solidFill>
                         <a:srgbClr val="D9DEE5"/>
@@ -13238,7 +13238,7 @@
                       </a:endParaRPr>
                     </a:p>
                   </a:txBody>
-                  <a:tcPr marL="82296" marR="82296" marT="82296" marB="82296" anchor="mid">
+                  <a:tcPr marL="82296" marR="82296" marT="82296" marB="82296" anchor="ctr">
                     <a:lnL w="10160" cap="flat" cmpd="sng" algn="ctr">
                       <a:solidFill>
                         <a:srgbClr val="D9DEE5"/>
@@ -13606,7 +13606,7 @@
                       </a:endParaRPr>
                     </a:p>
                   </a:txBody>
-                  <a:tcPr marL="82296" marR="82296" marT="82296" marB="82296" anchor="mid">
+                  <a:tcPr marL="82296" marR="82296" marT="82296" marB="82296" anchor="ctr">
                     <a:lnL w="10160" cap="flat" cmpd="sng" algn="ctr">
                       <a:solidFill>
                         <a:srgbClr val="D9DEE5"/>
@@ -13674,7 +13674,7 @@
                       </a:endParaRPr>
                     </a:p>
                   </a:txBody>
-                  <a:tcPr marL="82296" marR="82296" marT="82296" marB="82296" anchor="mid">
+                  <a:tcPr marL="82296" marR="82296" marT="82296" marB="82296" anchor="ctr">
                     <a:lnL w="10160" cap="flat" cmpd="sng" algn="ctr">
                       <a:solidFill>
                         <a:srgbClr val="D9DEE5"/>
@@ -13742,7 +13742,7 @@
                       </a:endParaRPr>
                     </a:p>
                   </a:txBody>
-                  <a:tcPr marL="82296" marR="82296" marT="82296" marB="82296" anchor="mid">
+                  <a:tcPr marL="82296" marR="82296" marT="82296" marB="82296" anchor="ctr">
                     <a:lnL w="10160" cap="flat" cmpd="sng" algn="ctr">
                       <a:solidFill>
                         <a:srgbClr val="D9DEE5"/>
@@ -13812,7 +13812,7 @@
                       </a:endParaRPr>
                     </a:p>
                   </a:txBody>
-                  <a:tcPr marL="82296" marR="82296" marT="82296" marB="82296" anchor="mid">
+                  <a:tcPr marL="82296" marR="82296" marT="82296" marB="82296" anchor="ctr">
                     <a:lnL w="10160" cap="flat" cmpd="sng" algn="ctr">
                       <a:solidFill>
                         <a:srgbClr val="D9DEE5"/>
@@ -13880,7 +13880,7 @@
                       </a:endParaRPr>
                     </a:p>
                   </a:txBody>
-                  <a:tcPr marL="82296" marR="82296" marT="82296" marB="82296" anchor="mid">
+                  <a:tcPr marL="82296" marR="82296" marT="82296" marB="82296" anchor="ctr">
                     <a:lnL w="10160" cap="flat" cmpd="sng" algn="ctr">
                       <a:solidFill>
                         <a:srgbClr val="D9DEE5"/>
@@ -13948,7 +13948,7 @@
                       </a:endParaRPr>
                     </a:p>
                   </a:txBody>
-                  <a:tcPr marL="82296" marR="82296" marT="82296" marB="82296" anchor="mid">
+                  <a:tcPr marL="82296" marR="82296" marT="82296" marB="82296" anchor="ctr">
                     <a:lnL w="10160" cap="flat" cmpd="sng" algn="ctr">
                       <a:solidFill>
                         <a:srgbClr val="D9DEE5"/>
@@ -14018,7 +14018,7 @@
                       </a:endParaRPr>
                     </a:p>
                   </a:txBody>
-                  <a:tcPr marL="82296" marR="82296" marT="82296" marB="82296" anchor="mid">
+                  <a:tcPr marL="82296" marR="82296" marT="82296" marB="82296" anchor="ctr">
                     <a:lnL w="10160" cap="flat" cmpd="sng" algn="ctr">
                       <a:solidFill>
                         <a:srgbClr val="D9DEE5"/>
@@ -14086,7 +14086,7 @@
                       </a:endParaRPr>
                     </a:p>
                   </a:txBody>
-                  <a:tcPr marL="82296" marR="82296" marT="82296" marB="82296" anchor="mid">
+                  <a:tcPr marL="82296" marR="82296" marT="82296" marB="82296" anchor="ctr">
                     <a:lnL w="10160" cap="flat" cmpd="sng" algn="ctr">
                       <a:solidFill>
                         <a:srgbClr val="D9DEE5"/>
@@ -14154,7 +14154,7 @@
                       </a:endParaRPr>
                     </a:p>
                   </a:txBody>
-                  <a:tcPr marL="82296" marR="82296" marT="82296" marB="82296" anchor="mid">
+                  <a:tcPr marL="82296" marR="82296" marT="82296" marB="82296" anchor="ctr">
                     <a:lnL w="10160" cap="flat" cmpd="sng" algn="ctr">
                       <a:solidFill>
                         <a:srgbClr val="D9DEE5"/>
@@ -14224,7 +14224,7 @@
                       </a:endParaRPr>
                     </a:p>
                   </a:txBody>
-                  <a:tcPr marL="82296" marR="82296" marT="82296" marB="82296" anchor="mid">
+                  <a:tcPr marL="82296" marR="82296" marT="82296" marB="82296" anchor="ctr">
                     <a:lnL w="10160" cap="flat" cmpd="sng" algn="ctr">
                       <a:solidFill>
                         <a:srgbClr val="D9DEE5"/>
@@ -14292,7 +14292,7 @@
                       </a:endParaRPr>
                     </a:p>
                   </a:txBody>
-                  <a:tcPr marL="82296" marR="82296" marT="82296" marB="82296" anchor="mid">
+                  <a:tcPr marL="82296" marR="82296" marT="82296" marB="82296" anchor="ctr">
                     <a:lnL w="10160" cap="flat" cmpd="sng" algn="ctr">
                       <a:solidFill>
                         <a:srgbClr val="D9DEE5"/>
@@ -14360,7 +14360,7 @@
                       </a:endParaRPr>
                     </a:p>
                   </a:txBody>
-                  <a:tcPr marL="82296" marR="82296" marT="82296" marB="82296" anchor="mid">
+                  <a:tcPr marL="82296" marR="82296" marT="82296" marB="82296" anchor="ctr">
                     <a:lnL w="10160" cap="flat" cmpd="sng" algn="ctr">
                       <a:solidFill>
                         <a:srgbClr val="D9DEE5"/>
@@ -14430,7 +14430,7 @@
                       </a:endParaRPr>
                     </a:p>
                   </a:txBody>
-                  <a:tcPr marL="82296" marR="82296" marT="82296" marB="82296" anchor="mid">
+                  <a:tcPr marL="82296" marR="82296" marT="82296" marB="82296" anchor="ctr">
                     <a:lnL w="10160" cap="flat" cmpd="sng" algn="ctr">
                       <a:solidFill>
                         <a:srgbClr val="D9DEE5"/>
@@ -14498,7 +14498,7 @@
                       </a:endParaRPr>
                     </a:p>
                   </a:txBody>
-                  <a:tcPr marL="82296" marR="82296" marT="82296" marB="82296" anchor="mid">
+                  <a:tcPr marL="82296" marR="82296" marT="82296" marB="82296" anchor="ctr">
                     <a:lnL w="10160" cap="flat" cmpd="sng" algn="ctr">
                       <a:solidFill>
                         <a:srgbClr val="D9DEE5"/>
@@ -14566,7 +14566,7 @@
                       </a:endParaRPr>
                     </a:p>
                   </a:txBody>
-                  <a:tcPr marL="82296" marR="82296" marT="82296" marB="82296" anchor="mid">
+                  <a:tcPr marL="82296" marR="82296" marT="82296" marB="82296" anchor="ctr">
                     <a:lnL w="10160" cap="flat" cmpd="sng" algn="ctr">
                       <a:solidFill>
                         <a:srgbClr val="D9DEE5"/>
@@ -14636,7 +14636,7 @@
                       </a:endParaRPr>
                     </a:p>
                   </a:txBody>
-                  <a:tcPr marL="82296" marR="82296" marT="82296" marB="82296" anchor="mid">
+                  <a:tcPr marL="82296" marR="82296" marT="82296" marB="82296" anchor="ctr">
                     <a:lnL w="10160" cap="flat" cmpd="sng" algn="ctr">
                       <a:solidFill>
                         <a:srgbClr val="D9DEE5"/>
@@ -14704,7 +14704,7 @@
                       </a:endParaRPr>
                     </a:p>
                   </a:txBody>
-                  <a:tcPr marL="82296" marR="82296" marT="82296" marB="82296" anchor="mid">
+                  <a:tcPr marL="82296" marR="82296" marT="82296" marB="82296" anchor="ctr">
                     <a:lnL w="10160" cap="flat" cmpd="sng" algn="ctr">
                       <a:solidFill>
                         <a:srgbClr val="D9DEE5"/>
@@ -14772,7 +14772,7 @@
                       </a:endParaRPr>
                     </a:p>
                   </a:txBody>
-                  <a:tcPr marL="82296" marR="82296" marT="82296" marB="82296" anchor="mid">
+                  <a:tcPr marL="82296" marR="82296" marT="82296" marB="82296" anchor="ctr">
                     <a:lnL w="10160" cap="flat" cmpd="sng" algn="ctr">
                       <a:solidFill>
                         <a:srgbClr val="D9DEE5"/>
@@ -18448,7 +18448,7 @@
                       </a:endParaRPr>
                     </a:p>
                   </a:txBody>
-                  <a:tcPr marL="82296" marR="82296" marT="82296" marB="82296" anchor="mid">
+                  <a:tcPr marL="82296" marR="82296" marT="82296" marB="82296" anchor="ctr">
                     <a:lnL w="10160" cap="flat" cmpd="sng" algn="ctr">
                       <a:solidFill>
                         <a:srgbClr val="D9DEE5"/>
@@ -18516,7 +18516,7 @@
                       </a:endParaRPr>
                     </a:p>
                   </a:txBody>
-                  <a:tcPr marL="82296" marR="82296" marT="82296" marB="82296" anchor="mid">
+                  <a:tcPr marL="82296" marR="82296" marT="82296" marB="82296" anchor="ctr">
                     <a:lnL w="10160" cap="flat" cmpd="sng" algn="ctr">
                       <a:solidFill>
                         <a:srgbClr val="D9DEE5"/>
@@ -18584,7 +18584,7 @@
                       </a:endParaRPr>
                     </a:p>
                   </a:txBody>
-                  <a:tcPr marL="82296" marR="82296" marT="82296" marB="82296" anchor="mid">
+                  <a:tcPr marL="82296" marR="82296" marT="82296" marB="82296" anchor="ctr">
                     <a:lnL w="10160" cap="flat" cmpd="sng" algn="ctr">
                       <a:solidFill>
                         <a:srgbClr val="D9DEE5"/>
@@ -18654,7 +18654,7 @@
                       </a:endParaRPr>
                     </a:p>
                   </a:txBody>
-                  <a:tcPr marL="82296" marR="82296" marT="82296" marB="82296" anchor="mid">
+                  <a:tcPr marL="82296" marR="82296" marT="82296" marB="82296" anchor="ctr">
                     <a:lnL w="10160" cap="flat" cmpd="sng" algn="ctr">
                       <a:solidFill>
                         <a:srgbClr val="D9DEE5"/>
@@ -18722,7 +18722,7 @@
                       </a:endParaRPr>
                     </a:p>
                   </a:txBody>
-                  <a:tcPr marL="82296" marR="82296" marT="82296" marB="82296" anchor="mid">
+                  <a:tcPr marL="82296" marR="82296" marT="82296" marB="82296" anchor="ctr">
                     <a:lnL w="10160" cap="flat" cmpd="sng" algn="ctr">
                       <a:solidFill>
                         <a:srgbClr val="D9DEE5"/>
@@ -18790,7 +18790,7 @@
                       </a:endParaRPr>
                     </a:p>
                   </a:txBody>
-                  <a:tcPr marL="82296" marR="82296" marT="82296" marB="82296" anchor="mid">
+                  <a:tcPr marL="82296" marR="82296" marT="82296" marB="82296" anchor="ctr">
                     <a:lnL w="10160" cap="flat" cmpd="sng" algn="ctr">
                       <a:solidFill>
                         <a:srgbClr val="D9DEE5"/>
@@ -18860,7 +18860,7 @@
                       </a:endParaRPr>
                     </a:p>
                   </a:txBody>
-                  <a:tcPr marL="82296" marR="82296" marT="82296" marB="82296" anchor="mid">
+                  <a:tcPr marL="82296" marR="82296" marT="82296" marB="82296" anchor="ctr">
                     <a:lnL w="10160" cap="flat" cmpd="sng" algn="ctr">
                       <a:solidFill>
                         <a:srgbClr val="D9DEE5"/>
@@ -18928,7 +18928,7 @@
                       </a:endParaRPr>
                     </a:p>
                   </a:txBody>
-                  <a:tcPr marL="82296" marR="82296" marT="82296" marB="82296" anchor="mid">
+                  <a:tcPr marL="82296" marR="82296" marT="82296" marB="82296" anchor="ctr">
                     <a:lnL w="10160" cap="flat" cmpd="sng" algn="ctr">
                       <a:solidFill>
                         <a:srgbClr val="D9DEE5"/>
@@ -18996,7 +18996,7 @@
                       </a:endParaRPr>
                     </a:p>
                   </a:txBody>
-                  <a:tcPr marL="82296" marR="82296" marT="82296" marB="82296" anchor="mid">
+                  <a:tcPr marL="82296" marR="82296" marT="82296" marB="82296" anchor="ctr">
                     <a:lnL w="10160" cap="flat" cmpd="sng" algn="ctr">
                       <a:solidFill>
                         <a:srgbClr val="D9DEE5"/>
@@ -19066,7 +19066,7 @@
                       </a:endParaRPr>
                     </a:p>
                   </a:txBody>
-                  <a:tcPr marL="82296" marR="82296" marT="82296" marB="82296" anchor="mid">
+                  <a:tcPr marL="82296" marR="82296" marT="82296" marB="82296" anchor="ctr">
                     <a:lnL w="10160" cap="flat" cmpd="sng" algn="ctr">
                       <a:solidFill>
                         <a:srgbClr val="D9DEE5"/>
@@ -19134,7 +19134,7 @@
                       </a:endParaRPr>
                     </a:p>
                   </a:txBody>
-                  <a:tcPr marL="82296" marR="82296" marT="82296" marB="82296" anchor="mid">
+                  <a:tcPr marL="82296" marR="82296" marT="82296" marB="82296" anchor="ctr">
                     <a:lnL w="10160" cap="flat" cmpd="sng" algn="ctr">
                       <a:solidFill>
                         <a:srgbClr val="D9DEE5"/>
@@ -19202,7 +19202,7 @@
                       </a:endParaRPr>
                     </a:p>
                   </a:txBody>
-                  <a:tcPr marL="82296" marR="82296" marT="82296" marB="82296" anchor="mid">
+                  <a:tcPr marL="82296" marR="82296" marT="82296" marB="82296" anchor="ctr">
                     <a:lnL w="10160" cap="flat" cmpd="sng" algn="ctr">
                       <a:solidFill>
                         <a:srgbClr val="D9DEE5"/>
@@ -19272,7 +19272,7 @@
                       </a:endParaRPr>
                     </a:p>
                   </a:txBody>
-                  <a:tcPr marL="82296" marR="82296" marT="82296" marB="82296" anchor="mid">
+                  <a:tcPr marL="82296" marR="82296" marT="82296" marB="82296" anchor="ctr">
                     <a:lnL w="10160" cap="flat" cmpd="sng" algn="ctr">
                       <a:solidFill>
                         <a:srgbClr val="D9DEE5"/>
@@ -19340,7 +19340,7 @@
                       </a:endParaRPr>
                     </a:p>
                   </a:txBody>
-                  <a:tcPr marL="82296" marR="82296" marT="82296" marB="82296" anchor="mid">
+                  <a:tcPr marL="82296" marR="82296" marT="82296" marB="82296" anchor="ctr">
                     <a:lnL w="10160" cap="flat" cmpd="sng" algn="ctr">
                       <a:solidFill>
                         <a:srgbClr val="D9DEE5"/>
@@ -19408,7 +19408,7 @@
                       </a:endParaRPr>
                     </a:p>
                   </a:txBody>
-                  <a:tcPr marL="82296" marR="82296" marT="82296" marB="82296" anchor="mid">
+                  <a:tcPr marL="82296" marR="82296" marT="82296" marB="82296" anchor="ctr">
                     <a:lnL w="10160" cap="flat" cmpd="sng" algn="ctr">
                       <a:solidFill>
                         <a:srgbClr val="D9DEE5"/>
@@ -19478,7 +19478,7 @@
                       </a:endParaRPr>
                     </a:p>
                   </a:txBody>
-                  <a:tcPr marL="82296" marR="82296" marT="82296" marB="82296" anchor="mid">
+                  <a:tcPr marL="82296" marR="82296" marT="82296" marB="82296" anchor="ctr">
                     <a:lnL w="10160" cap="flat" cmpd="sng" algn="ctr">
                       <a:solidFill>
                         <a:srgbClr val="D9DEE5"/>
@@ -19546,7 +19546,7 @@
                       </a:endParaRPr>
                     </a:p>
                   </a:txBody>
-                  <a:tcPr marL="82296" marR="82296" marT="82296" marB="82296" anchor="mid">
+                  <a:tcPr marL="82296" marR="82296" marT="82296" marB="82296" anchor="ctr">
                     <a:lnL w="10160" cap="flat" cmpd="sng" algn="ctr">
                       <a:solidFill>
                         <a:srgbClr val="D9DEE5"/>
@@ -19614,7 +19614,7 @@
                       </a:endParaRPr>
                     </a:p>
                   </a:txBody>
-                  <a:tcPr marL="82296" marR="82296" marT="82296" marB="82296" anchor="mid">
+                  <a:tcPr marL="82296" marR="82296" marT="82296" marB="82296" anchor="ctr">
                     <a:lnL w="10160" cap="flat" cmpd="sng" algn="ctr">
                       <a:solidFill>
                         <a:srgbClr val="D9DEE5"/>
@@ -19984,7 +19984,7 @@
                       </a:endParaRPr>
                     </a:p>
                   </a:txBody>
-                  <a:tcPr marL="82296" marR="82296" marT="82296" marB="82296" anchor="mid">
+                  <a:tcPr marL="82296" marR="82296" marT="82296" marB="82296" anchor="ctr">
                     <a:lnL w="10160" cap="flat" cmpd="sng" algn="ctr">
                       <a:solidFill>
                         <a:srgbClr val="D9DEE5"/>
@@ -20052,7 +20052,7 @@
                       </a:endParaRPr>
                     </a:p>
                   </a:txBody>
-                  <a:tcPr marL="82296" marR="82296" marT="82296" marB="82296" anchor="mid">
+                  <a:tcPr marL="82296" marR="82296" marT="82296" marB="82296" anchor="ctr">
                     <a:lnL w="10160" cap="flat" cmpd="sng" algn="ctr">
                       <a:solidFill>
                         <a:srgbClr val="D9DEE5"/>
@@ -20120,7 +20120,7 @@
                       </a:endParaRPr>
                     </a:p>
                   </a:txBody>
-                  <a:tcPr marL="82296" marR="82296" marT="82296" marB="82296" anchor="mid">
+                  <a:tcPr marL="82296" marR="82296" marT="82296" marB="82296" anchor="ctr">
                     <a:lnL w="10160" cap="flat" cmpd="sng" algn="ctr">
                       <a:solidFill>
                         <a:srgbClr val="D9DEE5"/>
@@ -20188,7 +20188,7 @@
                       </a:endParaRPr>
                     </a:p>
                   </a:txBody>
-                  <a:tcPr marL="82296" marR="82296" marT="82296" marB="82296" anchor="mid">
+                  <a:tcPr marL="82296" marR="82296" marT="82296" marB="82296" anchor="ctr">
                     <a:lnL w="10160" cap="flat" cmpd="sng" algn="ctr">
                       <a:solidFill>
                         <a:srgbClr val="D9DEE5"/>
@@ -20256,7 +20256,7 @@
                       </a:endParaRPr>
                     </a:p>
                   </a:txBody>
-                  <a:tcPr marL="82296" marR="82296" marT="82296" marB="82296" anchor="mid">
+                  <a:tcPr marL="82296" marR="82296" marT="82296" marB="82296" anchor="ctr">
                     <a:lnL w="10160" cap="flat" cmpd="sng" algn="ctr">
                       <a:solidFill>
                         <a:srgbClr val="D9DEE5"/>
@@ -20326,7 +20326,7 @@
                       </a:endParaRPr>
                     </a:p>
                   </a:txBody>
-                  <a:tcPr marL="82296" marR="82296" marT="82296" marB="82296" anchor="mid">
+                  <a:tcPr marL="82296" marR="82296" marT="82296" marB="82296" anchor="ctr">
                     <a:lnL w="10160" cap="flat" cmpd="sng" algn="ctr">
                       <a:solidFill>
                         <a:srgbClr val="D9DEE5"/>
@@ -20394,7 +20394,7 @@
                       </a:endParaRPr>
                     </a:p>
                   </a:txBody>
-                  <a:tcPr marL="82296" marR="82296" marT="82296" marB="82296" anchor="mid">
+                  <a:tcPr marL="82296" marR="82296" marT="82296" marB="82296" anchor="ctr">
                     <a:lnL w="10160" cap="flat" cmpd="sng" algn="ctr">
                       <a:solidFill>
                         <a:srgbClr val="D9DEE5"/>
@@ -20462,7 +20462,7 @@
                       </a:endParaRPr>
                     </a:p>
                   </a:txBody>
-                  <a:tcPr marL="82296" marR="82296" marT="82296" marB="82296" anchor="mid">
+                  <a:tcPr marL="82296" marR="82296" marT="82296" marB="82296" anchor="ctr">
                     <a:lnL w="10160" cap="flat" cmpd="sng" algn="ctr">
                       <a:solidFill>
                         <a:srgbClr val="D9DEE5"/>
@@ -20530,7 +20530,7 @@
                       </a:endParaRPr>
                     </a:p>
                   </a:txBody>
-                  <a:tcPr marL="82296" marR="82296" marT="82296" marB="82296" anchor="mid">
+                  <a:tcPr marL="82296" marR="82296" marT="82296" marB="82296" anchor="ctr">
                     <a:lnL w="10160" cap="flat" cmpd="sng" algn="ctr">
                       <a:solidFill>
                         <a:srgbClr val="D9DEE5"/>
@@ -20598,7 +20598,7 @@
                       </a:endParaRPr>
                     </a:p>
                   </a:txBody>
-                  <a:tcPr marL="82296" marR="82296" marT="82296" marB="82296" anchor="mid">
+                  <a:tcPr marL="82296" marR="82296" marT="82296" marB="82296" anchor="ctr">
                     <a:lnL w="10160" cap="flat" cmpd="sng" algn="ctr">
                       <a:solidFill>
                         <a:srgbClr val="D9DEE5"/>
@@ -20668,7 +20668,7 @@
                       </a:endParaRPr>
                     </a:p>
                   </a:txBody>
-                  <a:tcPr marL="82296" marR="82296" marT="82296" marB="82296" anchor="mid">
+                  <a:tcPr marL="82296" marR="82296" marT="82296" marB="82296" anchor="ctr">
                     <a:lnL w="10160" cap="flat" cmpd="sng" algn="ctr">
                       <a:solidFill>
                         <a:srgbClr val="D9DEE5"/>
@@ -20736,7 +20736,7 @@
                       </a:endParaRPr>
                     </a:p>
                   </a:txBody>
-                  <a:tcPr marL="82296" marR="82296" marT="82296" marB="82296" anchor="mid">
+                  <a:tcPr marL="82296" marR="82296" marT="82296" marB="82296" anchor="ctr">
                     <a:lnL w="10160" cap="flat" cmpd="sng" algn="ctr">
                       <a:solidFill>
                         <a:srgbClr val="D9DEE5"/>
@@ -20804,7 +20804,7 @@
                       </a:endParaRPr>
                     </a:p>
                   </a:txBody>
-                  <a:tcPr marL="82296" marR="82296" marT="82296" marB="82296" anchor="mid">
+                  <a:tcPr marL="82296" marR="82296" marT="82296" marB="82296" anchor="ctr">
                     <a:lnL w="10160" cap="flat" cmpd="sng" algn="ctr">
                       <a:solidFill>
                         <a:srgbClr val="D9DEE5"/>
@@ -20872,7 +20872,7 @@
                       </a:endParaRPr>
                     </a:p>
                   </a:txBody>
-                  <a:tcPr marL="82296" marR="82296" marT="82296" marB="82296" anchor="mid">
+                  <a:tcPr marL="82296" marR="82296" marT="82296" marB="82296" anchor="ctr">
                     <a:lnL w="10160" cap="flat" cmpd="sng" algn="ctr">
                       <a:solidFill>
                         <a:srgbClr val="D9DEE5"/>
@@ -20940,7 +20940,7 @@
                       </a:endParaRPr>
                     </a:p>
                   </a:txBody>
-                  <a:tcPr marL="82296" marR="82296" marT="82296" marB="82296" anchor="mid">
+                  <a:tcPr marL="82296" marR="82296" marT="82296" marB="82296" anchor="ctr">
                     <a:lnL w="10160" cap="flat" cmpd="sng" algn="ctr">
                       <a:solidFill>
                         <a:srgbClr val="D9DEE5"/>
@@ -21010,7 +21010,7 @@
                       </a:endParaRPr>
                     </a:p>
                   </a:txBody>
-                  <a:tcPr marL="82296" marR="82296" marT="82296" marB="82296" anchor="mid">
+                  <a:tcPr marL="82296" marR="82296" marT="82296" marB="82296" anchor="ctr">
                     <a:lnL w="10160" cap="flat" cmpd="sng" algn="ctr">
                       <a:solidFill>
                         <a:srgbClr val="D9DEE5"/>
@@ -21078,7 +21078,7 @@
                       </a:endParaRPr>
                     </a:p>
                   </a:txBody>
-                  <a:tcPr marL="82296" marR="82296" marT="82296" marB="82296" anchor="mid">
+                  <a:tcPr marL="82296" marR="82296" marT="82296" marB="82296" anchor="ctr">
                     <a:lnL w="10160" cap="flat" cmpd="sng" algn="ctr">
                       <a:solidFill>
                         <a:srgbClr val="D9DEE5"/>
@@ -21146,7 +21146,7 @@
                       </a:endParaRPr>
                     </a:p>
                   </a:txBody>
-                  <a:tcPr marL="82296" marR="82296" marT="82296" marB="82296" anchor="mid">
+                  <a:tcPr marL="82296" marR="82296" marT="82296" marB="82296" anchor="ctr">
                     <a:lnL w="10160" cap="flat" cmpd="sng" algn="ctr">
                       <a:solidFill>
                         <a:srgbClr val="D9DEE5"/>
@@ -21214,7 +21214,7 @@
                       </a:endParaRPr>
                     </a:p>
                   </a:txBody>
-                  <a:tcPr marL="82296" marR="82296" marT="82296" marB="82296" anchor="mid">
+                  <a:tcPr marL="82296" marR="82296" marT="82296" marB="82296" anchor="ctr">
                     <a:lnL w="10160" cap="flat" cmpd="sng" algn="ctr">
                       <a:solidFill>
                         <a:srgbClr val="D9DEE5"/>
@@ -21282,7 +21282,7 @@
                       </a:endParaRPr>
                     </a:p>
                   </a:txBody>
-                  <a:tcPr marL="82296" marR="82296" marT="82296" marB="82296" anchor="mid">
+                  <a:tcPr marL="82296" marR="82296" marT="82296" marB="82296" anchor="ctr">
                     <a:lnL w="10160" cap="flat" cmpd="sng" algn="ctr">
                       <a:solidFill>
                         <a:srgbClr val="D9DEE5"/>
@@ -21352,7 +21352,7 @@
                       </a:endParaRPr>
                     </a:p>
                   </a:txBody>
-                  <a:tcPr marL="82296" marR="82296" marT="82296" marB="82296" anchor="mid">
+                  <a:tcPr marL="82296" marR="82296" marT="82296" marB="82296" anchor="ctr">
                     <a:lnL w="10160" cap="flat" cmpd="sng" algn="ctr">
                       <a:solidFill>
                         <a:srgbClr val="D9DEE5"/>
@@ -21420,7 +21420,7 @@
                       </a:endParaRPr>
                     </a:p>
                   </a:txBody>
-                  <a:tcPr marL="82296" marR="82296" marT="82296" marB="82296" anchor="mid">
+                  <a:tcPr marL="82296" marR="82296" marT="82296" marB="82296" anchor="ctr">
                     <a:lnL w="10160" cap="flat" cmpd="sng" algn="ctr">
                       <a:solidFill>
                         <a:srgbClr val="D9DEE5"/>
@@ -21488,7 +21488,7 @@
                       </a:endParaRPr>
                     </a:p>
                   </a:txBody>
-                  <a:tcPr marL="82296" marR="82296" marT="82296" marB="82296" anchor="mid">
+                  <a:tcPr marL="82296" marR="82296" marT="82296" marB="82296" anchor="ctr">
                     <a:lnL w="10160" cap="flat" cmpd="sng" algn="ctr">
                       <a:solidFill>
                         <a:srgbClr val="D9DEE5"/>
@@ -21556,7 +21556,7 @@
                       </a:endParaRPr>
                     </a:p>
                   </a:txBody>
-                  <a:tcPr marL="82296" marR="82296" marT="82296" marB="82296" anchor="mid">
+                  <a:tcPr marL="82296" marR="82296" marT="82296" marB="82296" anchor="ctr">
                     <a:lnL w="10160" cap="flat" cmpd="sng" algn="ctr">
                       <a:solidFill>
                         <a:srgbClr val="D9DEE5"/>
@@ -21624,7 +21624,7 @@
                       </a:endParaRPr>
                     </a:p>
                   </a:txBody>
-                  <a:tcPr marL="82296" marR="82296" marT="82296" marB="82296" anchor="mid">
+                  <a:tcPr marL="82296" marR="82296" marT="82296" marB="82296" anchor="ctr">
                     <a:lnL w="10160" cap="flat" cmpd="sng" algn="ctr">
                       <a:solidFill>
                         <a:srgbClr val="D9DEE5"/>
@@ -21694,7 +21694,7 @@
                       </a:endParaRPr>
                     </a:p>
                   </a:txBody>
-                  <a:tcPr marL="82296" marR="82296" marT="82296" marB="82296" anchor="mid">
+                  <a:tcPr marL="82296" marR="82296" marT="82296" marB="82296" anchor="ctr">
                     <a:lnL w="10160" cap="flat" cmpd="sng" algn="ctr">
                       <a:solidFill>
                         <a:srgbClr val="D9DEE5"/>
@@ -21762,7 +21762,7 @@
                       </a:endParaRPr>
                     </a:p>
                   </a:txBody>
-                  <a:tcPr marL="82296" marR="82296" marT="82296" marB="82296" anchor="mid">
+                  <a:tcPr marL="82296" marR="82296" marT="82296" marB="82296" anchor="ctr">
                     <a:lnL w="10160" cap="flat" cmpd="sng" algn="ctr">
                       <a:solidFill>
                         <a:srgbClr val="D9DEE5"/>
@@ -21830,7 +21830,7 @@
                       </a:endParaRPr>
                     </a:p>
                   </a:txBody>
-                  <a:tcPr marL="82296" marR="82296" marT="82296" marB="82296" anchor="mid">
+                  <a:tcPr marL="82296" marR="82296" marT="82296" marB="82296" anchor="ctr">
                     <a:lnL w="10160" cap="flat" cmpd="sng" algn="ctr">
                       <a:solidFill>
                         <a:srgbClr val="D9DEE5"/>
@@ -21898,7 +21898,7 @@
                       </a:endParaRPr>
                     </a:p>
                   </a:txBody>
-                  <a:tcPr marL="82296" marR="82296" marT="82296" marB="82296" anchor="mid">
+                  <a:tcPr marL="82296" marR="82296" marT="82296" marB="82296" anchor="ctr">
                     <a:lnL w="10160" cap="flat" cmpd="sng" algn="ctr">
                       <a:solidFill>
                         <a:srgbClr val="D9DEE5"/>
@@ -21966,7 +21966,7 @@
                       </a:endParaRPr>
                     </a:p>
                   </a:txBody>
-                  <a:tcPr marL="82296" marR="82296" marT="82296" marB="82296" anchor="mid">
+                  <a:tcPr marL="82296" marR="82296" marT="82296" marB="82296" anchor="ctr">
                     <a:lnL w="10160" cap="flat" cmpd="sng" algn="ctr">
                       <a:solidFill>
                         <a:srgbClr val="D9DEE5"/>
@@ -22036,7 +22036,7 @@
                       </a:endParaRPr>
                     </a:p>
                   </a:txBody>
-                  <a:tcPr marL="82296" marR="82296" marT="82296" marB="82296" anchor="mid">
+                  <a:tcPr marL="82296" marR="82296" marT="82296" marB="82296" anchor="ctr">
                     <a:lnL w="10160" cap="flat" cmpd="sng" algn="ctr">
                       <a:solidFill>
                         <a:srgbClr val="D9DEE5"/>
@@ -22104,7 +22104,7 @@
                       </a:endParaRPr>
                     </a:p>
                   </a:txBody>
-                  <a:tcPr marL="82296" marR="82296" marT="82296" marB="82296" anchor="mid">
+                  <a:tcPr marL="82296" marR="82296" marT="82296" marB="82296" anchor="ctr">
                     <a:lnL w="10160" cap="flat" cmpd="sng" algn="ctr">
                       <a:solidFill>
                         <a:srgbClr val="D9DEE5"/>
@@ -22172,7 +22172,7 @@
                       </a:endParaRPr>
                     </a:p>
                   </a:txBody>
-                  <a:tcPr marL="82296" marR="82296" marT="82296" marB="82296" anchor="mid">
+                  <a:tcPr marL="82296" marR="82296" marT="82296" marB="82296" anchor="ctr">
                     <a:lnL w="10160" cap="flat" cmpd="sng" algn="ctr">
                       <a:solidFill>
                         <a:srgbClr val="D9DEE5"/>
@@ -22240,7 +22240,7 @@
                       </a:endParaRPr>
                     </a:p>
                   </a:txBody>
-                  <a:tcPr marL="82296" marR="82296" marT="82296" marB="82296" anchor="mid">
+                  <a:tcPr marL="82296" marR="82296" marT="82296" marB="82296" anchor="ctr">
                     <a:lnL w="10160" cap="flat" cmpd="sng" algn="ctr">
                       <a:solidFill>
                         <a:srgbClr val="D9DEE5"/>
@@ -22308,7 +22308,7 @@
                       </a:endParaRPr>
                     </a:p>
                   </a:txBody>
-                  <a:tcPr marL="82296" marR="82296" marT="82296" marB="82296" anchor="mid">
+                  <a:tcPr marL="82296" marR="82296" marT="82296" marB="82296" anchor="ctr">
                     <a:lnL w="10160" cap="flat" cmpd="sng" algn="ctr">
                       <a:solidFill>
                         <a:srgbClr val="D9DEE5"/>
@@ -22378,7 +22378,7 @@
                       </a:endParaRPr>
                     </a:p>
                   </a:txBody>
-                  <a:tcPr marL="82296" marR="82296" marT="82296" marB="82296" anchor="mid">
+                  <a:tcPr marL="82296" marR="82296" marT="82296" marB="82296" anchor="ctr">
                     <a:lnL w="10160" cap="flat" cmpd="sng" algn="ctr">
                       <a:solidFill>
                         <a:srgbClr val="D9DEE5"/>
@@ -22446,7 +22446,7 @@
                       </a:endParaRPr>
                     </a:p>
                   </a:txBody>
-                  <a:tcPr marL="82296" marR="82296" marT="82296" marB="82296" anchor="mid">
+                  <a:tcPr marL="82296" marR="82296" marT="82296" marB="82296" anchor="ctr">
                     <a:lnL w="10160" cap="flat" cmpd="sng" algn="ctr">
                       <a:solidFill>
                         <a:srgbClr val="D9DEE5"/>
@@ -22514,7 +22514,7 @@
                       </a:endParaRPr>
                     </a:p>
                   </a:txBody>
-                  <a:tcPr marL="82296" marR="82296" marT="82296" marB="82296" anchor="mid">
+                  <a:tcPr marL="82296" marR="82296" marT="82296" marB="82296" anchor="ctr">
                     <a:lnL w="10160" cap="flat" cmpd="sng" algn="ctr">
                       <a:solidFill>
                         <a:srgbClr val="D9DEE5"/>
@@ -22582,7 +22582,7 @@
                       </a:endParaRPr>
                     </a:p>
                   </a:txBody>
-                  <a:tcPr marL="82296" marR="82296" marT="82296" marB="82296" anchor="mid">
+                  <a:tcPr marL="82296" marR="82296" marT="82296" marB="82296" anchor="ctr">
                     <a:lnL w="10160" cap="flat" cmpd="sng" algn="ctr">
                       <a:solidFill>
                         <a:srgbClr val="D9DEE5"/>
@@ -22650,7 +22650,7 @@
                       </a:endParaRPr>
                     </a:p>
                   </a:txBody>
-                  <a:tcPr marL="82296" marR="82296" marT="82296" marB="82296" anchor="mid">
+                  <a:tcPr marL="82296" marR="82296" marT="82296" marB="82296" anchor="ctr">
                     <a:lnL w="10160" cap="flat" cmpd="sng" algn="ctr">
                       <a:solidFill>
                         <a:srgbClr val="D9DEE5"/>
@@ -23120,7 +23120,7 @@
                       </a:endParaRPr>
                     </a:p>
                   </a:txBody>
-                  <a:tcPr marL="82296" marR="82296" marT="82296" marB="82296" anchor="mid">
+                  <a:tcPr marL="82296" marR="82296" marT="82296" marB="82296" anchor="ctr">
                     <a:lnL w="10160" cap="flat" cmpd="sng" algn="ctr">
                       <a:solidFill>
                         <a:srgbClr val="D9DEE5"/>
@@ -23188,7 +23188,7 @@
                       </a:endParaRPr>
                     </a:p>
                   </a:txBody>
-                  <a:tcPr marL="82296" marR="82296" marT="82296" marB="82296" anchor="mid">
+                  <a:tcPr marL="82296" marR="82296" marT="82296" marB="82296" anchor="ctr">
                     <a:lnL w="10160" cap="flat" cmpd="sng" algn="ctr">
                       <a:solidFill>
                         <a:srgbClr val="D9DEE5"/>
@@ -23256,7 +23256,7 @@
                       </a:endParaRPr>
                     </a:p>
                   </a:txBody>
-                  <a:tcPr marL="82296" marR="82296" marT="82296" marB="82296" anchor="mid">
+                  <a:tcPr marL="82296" marR="82296" marT="82296" marB="82296" anchor="ctr">
                     <a:lnL w="10160" cap="flat" cmpd="sng" algn="ctr">
                       <a:solidFill>
                         <a:srgbClr val="D9DEE5"/>
@@ -23326,7 +23326,7 @@
                       </a:endParaRPr>
                     </a:p>
                   </a:txBody>
-                  <a:tcPr marL="82296" marR="82296" marT="82296" marB="82296" anchor="mid">
+                  <a:tcPr marL="82296" marR="82296" marT="82296" marB="82296" anchor="ctr">
                     <a:lnL w="10160" cap="flat" cmpd="sng" algn="ctr">
                       <a:solidFill>
                         <a:srgbClr val="D9DEE5"/>
@@ -23394,7 +23394,7 @@
                       </a:endParaRPr>
                     </a:p>
                   </a:txBody>
-                  <a:tcPr marL="82296" marR="82296" marT="82296" marB="82296" anchor="mid">
+                  <a:tcPr marL="82296" marR="82296" marT="82296" marB="82296" anchor="ctr">
                     <a:lnL w="10160" cap="flat" cmpd="sng" algn="ctr">
                       <a:solidFill>
                         <a:srgbClr val="D9DEE5"/>
@@ -23462,7 +23462,7 @@
                       </a:endParaRPr>
                     </a:p>
                   </a:txBody>
-                  <a:tcPr marL="82296" marR="82296" marT="82296" marB="82296" anchor="mid">
+                  <a:tcPr marL="82296" marR="82296" marT="82296" marB="82296" anchor="ctr">
                     <a:lnL w="10160" cap="flat" cmpd="sng" algn="ctr">
                       <a:solidFill>
                         <a:srgbClr val="D9DEE5"/>
@@ -23532,7 +23532,7 @@
                       </a:endParaRPr>
                     </a:p>
                   </a:txBody>
-                  <a:tcPr marL="82296" marR="82296" marT="82296" marB="82296" anchor="mid">
+                  <a:tcPr marL="82296" marR="82296" marT="82296" marB="82296" anchor="ctr">
                     <a:lnL w="10160" cap="flat" cmpd="sng" algn="ctr">
                       <a:solidFill>
                         <a:srgbClr val="D9DEE5"/>
@@ -23600,7 +23600,7 @@
                       </a:endParaRPr>
                     </a:p>
                   </a:txBody>
-                  <a:tcPr marL="82296" marR="82296" marT="82296" marB="82296" anchor="mid">
+                  <a:tcPr marL="82296" marR="82296" marT="82296" marB="82296" anchor="ctr">
                     <a:lnL w="10160" cap="flat" cmpd="sng" algn="ctr">
                       <a:solidFill>
                         <a:srgbClr val="D9DEE5"/>
@@ -23668,7 +23668,7 @@
                       </a:endParaRPr>
                     </a:p>
                   </a:txBody>
-                  <a:tcPr marL="82296" marR="82296" marT="82296" marB="82296" anchor="mid">
+                  <a:tcPr marL="82296" marR="82296" marT="82296" marB="82296" anchor="ctr">
                     <a:lnL w="10160" cap="flat" cmpd="sng" algn="ctr">
                       <a:solidFill>
                         <a:srgbClr val="D9DEE5"/>
@@ -23738,7 +23738,7 @@
                       </a:endParaRPr>
                     </a:p>
                   </a:txBody>
-                  <a:tcPr marL="82296" marR="82296" marT="82296" marB="82296" anchor="mid">
+                  <a:tcPr marL="82296" marR="82296" marT="82296" marB="82296" anchor="ctr">
                     <a:lnL w="10160" cap="flat" cmpd="sng" algn="ctr">
                       <a:solidFill>
                         <a:srgbClr val="D9DEE5"/>
@@ -23806,7 +23806,7 @@
                       </a:endParaRPr>
                     </a:p>
                   </a:txBody>
-                  <a:tcPr marL="82296" marR="82296" marT="82296" marB="82296" anchor="mid">
+                  <a:tcPr marL="82296" marR="82296" marT="82296" marB="82296" anchor="ctr">
                     <a:lnL w="10160" cap="flat" cmpd="sng" algn="ctr">
                       <a:solidFill>
                         <a:srgbClr val="D9DEE5"/>
@@ -23874,7 +23874,7 @@
                       </a:endParaRPr>
                     </a:p>
                   </a:txBody>
-                  <a:tcPr marL="82296" marR="82296" marT="82296" marB="82296" anchor="mid">
+                  <a:tcPr marL="82296" marR="82296" marT="82296" marB="82296" anchor="ctr">
                     <a:lnL w="10160" cap="flat" cmpd="sng" algn="ctr">
                       <a:solidFill>
                         <a:srgbClr val="D9DEE5"/>
@@ -23944,7 +23944,7 @@
                       </a:endParaRPr>
                     </a:p>
                   </a:txBody>
-                  <a:tcPr marL="82296" marR="82296" marT="82296" marB="82296" anchor="mid">
+                  <a:tcPr marL="82296" marR="82296" marT="82296" marB="82296" anchor="ctr">
                     <a:lnL w="10160" cap="flat" cmpd="sng" algn="ctr">
                       <a:solidFill>
                         <a:srgbClr val="D9DEE5"/>
@@ -24012,7 +24012,7 @@
                       </a:endParaRPr>
                     </a:p>
                   </a:txBody>
-                  <a:tcPr marL="82296" marR="82296" marT="82296" marB="82296" anchor="mid">
+                  <a:tcPr marL="82296" marR="82296" marT="82296" marB="82296" anchor="ctr">
                     <a:lnL w="10160" cap="flat" cmpd="sng" algn="ctr">
                       <a:solidFill>
                         <a:srgbClr val="D9DEE5"/>
@@ -24080,7 +24080,7 @@
                       </a:endParaRPr>
                     </a:p>
                   </a:txBody>
-                  <a:tcPr marL="82296" marR="82296" marT="82296" marB="82296" anchor="mid">
+                  <a:tcPr marL="82296" marR="82296" marT="82296" marB="82296" anchor="ctr">
                     <a:lnL w="10160" cap="flat" cmpd="sng" algn="ctr">
                       <a:solidFill>
                         <a:srgbClr val="D9DEE5"/>
@@ -24150,7 +24150,7 @@
                       </a:endParaRPr>
                     </a:p>
                   </a:txBody>
-                  <a:tcPr marL="82296" marR="82296" marT="82296" marB="82296" anchor="mid">
+                  <a:tcPr marL="82296" marR="82296" marT="82296" marB="82296" anchor="ctr">
                     <a:lnL w="10160" cap="flat" cmpd="sng" algn="ctr">
                       <a:solidFill>
                         <a:srgbClr val="D9DEE5"/>
@@ -24218,7 +24218,7 @@
                       </a:endParaRPr>
                     </a:p>
                   </a:txBody>
-                  <a:tcPr marL="82296" marR="82296" marT="82296" marB="82296" anchor="mid">
+                  <a:tcPr marL="82296" marR="82296" marT="82296" marB="82296" anchor="ctr">
                     <a:lnL w="10160" cap="flat" cmpd="sng" algn="ctr">
                       <a:solidFill>
                         <a:srgbClr val="D9DEE5"/>
@@ -24286,7 +24286,7 @@
                       </a:endParaRPr>
                     </a:p>
                   </a:txBody>
-                  <a:tcPr marL="82296" marR="82296" marT="82296" marB="82296" anchor="mid">
+                  <a:tcPr marL="82296" marR="82296" marT="82296" marB="82296" anchor="ctr">
                     <a:lnL w="10160" cap="flat" cmpd="sng" algn="ctr">
                       <a:solidFill>
                         <a:srgbClr val="D9DEE5"/>
@@ -24655,7 +24655,7 @@
                       </a:endParaRPr>
                     </a:p>
                   </a:txBody>
-                  <a:tcPr marL="82296" marR="82296" marT="82296" marB="82296" anchor="mid">
+                  <a:tcPr marL="82296" marR="82296" marT="82296" marB="82296" anchor="ctr">
                     <a:lnL w="10160" cap="flat" cmpd="sng" algn="ctr">
                       <a:solidFill>
                         <a:srgbClr val="D9DEE5"/>
@@ -24723,7 +24723,7 @@
                       </a:endParaRPr>
                     </a:p>
                   </a:txBody>
-                  <a:tcPr marL="82296" marR="82296" marT="82296" marB="82296" anchor="mid">
+                  <a:tcPr marL="82296" marR="82296" marT="82296" marB="82296" anchor="ctr">
                     <a:lnL w="10160" cap="flat" cmpd="sng" algn="ctr">
                       <a:solidFill>
                         <a:srgbClr val="D9DEE5"/>
@@ -24791,7 +24791,7 @@
                       </a:endParaRPr>
                     </a:p>
                   </a:txBody>
-                  <a:tcPr marL="82296" marR="82296" marT="82296" marB="82296" anchor="mid">
+                  <a:tcPr marL="82296" marR="82296" marT="82296" marB="82296" anchor="ctr">
                     <a:lnL w="10160" cap="flat" cmpd="sng" algn="ctr">
                       <a:solidFill>
                         <a:srgbClr val="D9DEE5"/>
@@ -24859,7 +24859,7 @@
                       </a:endParaRPr>
                     </a:p>
                   </a:txBody>
-                  <a:tcPr marL="82296" marR="82296" marT="82296" marB="82296" anchor="mid">
+                  <a:tcPr marL="82296" marR="82296" marT="82296" marB="82296" anchor="ctr">
                     <a:lnL w="10160" cap="flat" cmpd="sng" algn="ctr">
                       <a:solidFill>
                         <a:srgbClr val="D9DEE5"/>
@@ -24929,7 +24929,7 @@
                       </a:endParaRPr>
                     </a:p>
                   </a:txBody>
-                  <a:tcPr marL="82296" marR="82296" marT="82296" marB="82296" anchor="mid">
+                  <a:tcPr marL="82296" marR="82296" marT="82296" marB="82296" anchor="ctr">
                     <a:lnL w="10160" cap="flat" cmpd="sng" algn="ctr">
                       <a:solidFill>
                         <a:srgbClr val="D9DEE5"/>
@@ -24997,7 +24997,7 @@
                       </a:endParaRPr>
                     </a:p>
                   </a:txBody>
-                  <a:tcPr marL="82296" marR="82296" marT="82296" marB="82296" anchor="mid">
+                  <a:tcPr marL="82296" marR="82296" marT="82296" marB="82296" anchor="ctr">
                     <a:lnL w="10160" cap="flat" cmpd="sng" algn="ctr">
                       <a:solidFill>
                         <a:srgbClr val="D9DEE5"/>
@@ -25065,7 +25065,7 @@
                       </a:endParaRPr>
                     </a:p>
                   </a:txBody>
-                  <a:tcPr marL="82296" marR="82296" marT="82296" marB="82296" anchor="mid">
+                  <a:tcPr marL="82296" marR="82296" marT="82296" marB="82296" anchor="ctr">
                     <a:lnL w="10160" cap="flat" cmpd="sng" algn="ctr">
                       <a:solidFill>
                         <a:srgbClr val="D9DEE5"/>
@@ -25133,7 +25133,7 @@
                       </a:endParaRPr>
                     </a:p>
                   </a:txBody>
-                  <a:tcPr marL="82296" marR="82296" marT="82296" marB="82296" anchor="mid">
+                  <a:tcPr marL="82296" marR="82296" marT="82296" marB="82296" anchor="ctr">
                     <a:lnL w="10160" cap="flat" cmpd="sng" algn="ctr">
                       <a:solidFill>
                         <a:srgbClr val="D9DEE5"/>
@@ -25203,7 +25203,7 @@
                       </a:endParaRPr>
                     </a:p>
                   </a:txBody>
-                  <a:tcPr marL="82296" marR="82296" marT="82296" marB="82296" anchor="mid">
+                  <a:tcPr marL="82296" marR="82296" marT="82296" marB="82296" anchor="ctr">
                     <a:lnL w="10160" cap="flat" cmpd="sng" algn="ctr">
                       <a:solidFill>
                         <a:srgbClr val="D9DEE5"/>
@@ -25271,7 +25271,7 @@
                       </a:endParaRPr>
                     </a:p>
                   </a:txBody>
-                  <a:tcPr marL="82296" marR="82296" marT="82296" marB="82296" anchor="mid">
+                  <a:tcPr marL="82296" marR="82296" marT="82296" marB="82296" anchor="ctr">
                     <a:lnL w="10160" cap="flat" cmpd="sng" algn="ctr">
                       <a:solidFill>
                         <a:srgbClr val="D9DEE5"/>
@@ -25339,7 +25339,7 @@
                       </a:endParaRPr>
                     </a:p>
                   </a:txBody>
-                  <a:tcPr marL="82296" marR="82296" marT="82296" marB="82296" anchor="mid">
+                  <a:tcPr marL="82296" marR="82296" marT="82296" marB="82296" anchor="ctr">
                     <a:lnL w="10160" cap="flat" cmpd="sng" algn="ctr">
                       <a:solidFill>
                         <a:srgbClr val="D9DEE5"/>
@@ -25407,7 +25407,7 @@
                       </a:endParaRPr>
                     </a:p>
                   </a:txBody>
-                  <a:tcPr marL="82296" marR="82296" marT="82296" marB="82296" anchor="mid">
+                  <a:tcPr marL="82296" marR="82296" marT="82296" marB="82296" anchor="ctr">
                     <a:lnL w="10160" cap="flat" cmpd="sng" algn="ctr">
                       <a:solidFill>
                         <a:srgbClr val="D9DEE5"/>
@@ -25477,7 +25477,7 @@
                       </a:endParaRPr>
                     </a:p>
                   </a:txBody>
-                  <a:tcPr marL="82296" marR="82296" marT="82296" marB="82296" anchor="mid">
+                  <a:tcPr marL="82296" marR="82296" marT="82296" marB="82296" anchor="ctr">
                     <a:lnL w="10160" cap="flat" cmpd="sng" algn="ctr">
                       <a:solidFill>
                         <a:srgbClr val="D9DEE5"/>
@@ -25545,7 +25545,7 @@
                       </a:endParaRPr>
                     </a:p>
                   </a:txBody>
-                  <a:tcPr marL="82296" marR="82296" marT="82296" marB="82296" anchor="mid">
+                  <a:tcPr marL="82296" marR="82296" marT="82296" marB="82296" anchor="ctr">
                     <a:lnL w="10160" cap="flat" cmpd="sng" algn="ctr">
                       <a:solidFill>
                         <a:srgbClr val="D9DEE5"/>
@@ -25613,7 +25613,7 @@
                       </a:endParaRPr>
                     </a:p>
                   </a:txBody>
-                  <a:tcPr marL="82296" marR="82296" marT="82296" marB="82296" anchor="mid">
+                  <a:tcPr marL="82296" marR="82296" marT="82296" marB="82296" anchor="ctr">
                     <a:lnL w="10160" cap="flat" cmpd="sng" algn="ctr">
                       <a:solidFill>
                         <a:srgbClr val="D9DEE5"/>
@@ -25681,7 +25681,7 @@
                       </a:endParaRPr>
                     </a:p>
                   </a:txBody>
-                  <a:tcPr marL="82296" marR="82296" marT="82296" marB="82296" anchor="mid">
+                  <a:tcPr marL="82296" marR="82296" marT="82296" marB="82296" anchor="ctr">
                     <a:lnL w="10160" cap="flat" cmpd="sng" algn="ctr">
                       <a:solidFill>
                         <a:srgbClr val="D9DEE5"/>
@@ -25751,7 +25751,7 @@
                       </a:endParaRPr>
                     </a:p>
                   </a:txBody>
-                  <a:tcPr marL="82296" marR="82296" marT="82296" marB="82296" anchor="mid">
+                  <a:tcPr marL="82296" marR="82296" marT="82296" marB="82296" anchor="ctr">
                     <a:lnL w="10160" cap="flat" cmpd="sng" algn="ctr">
                       <a:solidFill>
                         <a:srgbClr val="D9DEE5"/>
@@ -25819,7 +25819,7 @@
                       </a:endParaRPr>
                     </a:p>
                   </a:txBody>
-                  <a:tcPr marL="82296" marR="82296" marT="82296" marB="82296" anchor="mid">
+                  <a:tcPr marL="82296" marR="82296" marT="82296" marB="82296" anchor="ctr">
                     <a:lnL w="10160" cap="flat" cmpd="sng" algn="ctr">
                       <a:solidFill>
                         <a:srgbClr val="D9DEE5"/>
@@ -25887,7 +25887,7 @@
                       </a:endParaRPr>
                     </a:p>
                   </a:txBody>
-                  <a:tcPr marL="82296" marR="82296" marT="82296" marB="82296" anchor="mid">
+                  <a:tcPr marL="82296" marR="82296" marT="82296" marB="82296" anchor="ctr">
                     <a:lnL w="10160" cap="flat" cmpd="sng" algn="ctr">
                       <a:solidFill>
                         <a:srgbClr val="D9DEE5"/>
@@ -25955,7 +25955,7 @@
                       </a:endParaRPr>
                     </a:p>
                   </a:txBody>
-                  <a:tcPr marL="82296" marR="82296" marT="82296" marB="82296" anchor="mid">
+                  <a:tcPr marL="82296" marR="82296" marT="82296" marB="82296" anchor="ctr">
                     <a:lnL w="10160" cap="flat" cmpd="sng" algn="ctr">
                       <a:solidFill>
                         <a:srgbClr val="D9DEE5"/>
@@ -26025,7 +26025,7 @@
                       </a:endParaRPr>
                     </a:p>
                   </a:txBody>
-                  <a:tcPr marL="82296" marR="82296" marT="82296" marB="82296" anchor="mid">
+                  <a:tcPr marL="82296" marR="82296" marT="82296" marB="82296" anchor="ctr">
                     <a:lnL w="10160" cap="flat" cmpd="sng" algn="ctr">
                       <a:solidFill>
                         <a:srgbClr val="D9DEE5"/>
@@ -26093,7 +26093,7 @@
                       </a:endParaRPr>
                     </a:p>
                   </a:txBody>
-                  <a:tcPr marL="82296" marR="82296" marT="82296" marB="82296" anchor="mid">
+                  <a:tcPr marL="82296" marR="82296" marT="82296" marB="82296" anchor="ctr">
                     <a:lnL w="10160" cap="flat" cmpd="sng" algn="ctr">
                       <a:solidFill>
                         <a:srgbClr val="D9DEE5"/>
@@ -26161,7 +26161,7 @@
                       </a:endParaRPr>
                     </a:p>
                   </a:txBody>
-                  <a:tcPr marL="82296" marR="82296" marT="82296" marB="82296" anchor="mid">
+                  <a:tcPr marL="82296" marR="82296" marT="82296" marB="82296" anchor="ctr">
                     <a:lnL w="10160" cap="flat" cmpd="sng" algn="ctr">
                       <a:solidFill>
                         <a:srgbClr val="D9DEE5"/>
@@ -26229,7 +26229,7 @@
                       </a:endParaRPr>
                     </a:p>
                   </a:txBody>
-                  <a:tcPr marL="82296" marR="82296" marT="82296" marB="82296" anchor="mid">
+                  <a:tcPr marL="82296" marR="82296" marT="82296" marB="82296" anchor="ctr">
                     <a:lnL w="10160" cap="flat" cmpd="sng" algn="ctr">
                       <a:solidFill>
                         <a:srgbClr val="D9DEE5"/>
@@ -26598,7 +26598,7 @@
                       </a:endParaRPr>
                     </a:p>
                   </a:txBody>
-                  <a:tcPr marL="82296" marR="82296" marT="82296" marB="82296" anchor="mid">
+                  <a:tcPr marL="82296" marR="82296" marT="82296" marB="82296" anchor="ctr">
                     <a:lnL w="10160" cap="flat" cmpd="sng" algn="ctr">
                       <a:solidFill>
                         <a:srgbClr val="D9DEE5"/>
@@ -26666,7 +26666,7 @@
                       </a:endParaRPr>
                     </a:p>
                   </a:txBody>
-                  <a:tcPr marL="82296" marR="82296" marT="82296" marB="82296" anchor="mid">
+                  <a:tcPr marL="82296" marR="82296" marT="82296" marB="82296" anchor="ctr">
                     <a:lnL w="10160" cap="flat" cmpd="sng" algn="ctr">
                       <a:solidFill>
                         <a:srgbClr val="D9DEE5"/>
@@ -26734,7 +26734,7 @@
                       </a:endParaRPr>
                     </a:p>
                   </a:txBody>
-                  <a:tcPr marL="82296" marR="82296" marT="82296" marB="82296" anchor="mid">
+                  <a:tcPr marL="82296" marR="82296" marT="82296" marB="82296" anchor="ctr">
                     <a:lnL w="10160" cap="flat" cmpd="sng" algn="ctr">
                       <a:solidFill>
                         <a:srgbClr val="D9DEE5"/>
@@ -26802,7 +26802,7 @@
                       </a:endParaRPr>
                     </a:p>
                   </a:txBody>
-                  <a:tcPr marL="82296" marR="82296" marT="82296" marB="82296" anchor="mid">
+                  <a:tcPr marL="82296" marR="82296" marT="82296" marB="82296" anchor="ctr">
                     <a:lnL w="10160" cap="flat" cmpd="sng" algn="ctr">
                       <a:solidFill>
                         <a:srgbClr val="D9DEE5"/>
@@ -26872,7 +26872,7 @@
                       </a:endParaRPr>
                     </a:p>
                   </a:txBody>
-                  <a:tcPr marL="82296" marR="82296" marT="82296" marB="82296" anchor="mid">
+                  <a:tcPr marL="82296" marR="82296" marT="82296" marB="82296" anchor="ctr">
                     <a:lnL w="10160" cap="flat" cmpd="sng" algn="ctr">
                       <a:solidFill>
                         <a:srgbClr val="D9DEE5"/>
@@ -26940,7 +26940,7 @@
                       </a:endParaRPr>
                     </a:p>
                   </a:txBody>
-                  <a:tcPr marL="82296" marR="82296" marT="82296" marB="82296" anchor="mid">
+                  <a:tcPr marL="82296" marR="82296" marT="82296" marB="82296" anchor="ctr">
                     <a:lnL w="10160" cap="flat" cmpd="sng" algn="ctr">
                       <a:solidFill>
                         <a:srgbClr val="D9DEE5"/>
@@ -27008,7 +27008,7 @@
                       </a:endParaRPr>
                     </a:p>
                   </a:txBody>
-                  <a:tcPr marL="82296" marR="82296" marT="82296" marB="82296" anchor="mid">
+                  <a:tcPr marL="82296" marR="82296" marT="82296" marB="82296" anchor="ctr">
                     <a:lnL w="10160" cap="flat" cmpd="sng" algn="ctr">
                       <a:solidFill>
                         <a:srgbClr val="D9DEE5"/>
@@ -27076,7 +27076,7 @@
                       </a:endParaRPr>
                     </a:p>
                   </a:txBody>
-                  <a:tcPr marL="82296" marR="82296" marT="82296" marB="82296" anchor="mid">
+                  <a:tcPr marL="82296" marR="82296" marT="82296" marB="82296" anchor="ctr">
                     <a:lnL w="10160" cap="flat" cmpd="sng" algn="ctr">
                       <a:solidFill>
                         <a:srgbClr val="D9DEE5"/>
@@ -27146,7 +27146,7 @@
                       </a:endParaRPr>
                     </a:p>
                   </a:txBody>
-                  <a:tcPr marL="82296" marR="82296" marT="82296" marB="82296" anchor="mid">
+                  <a:tcPr marL="82296" marR="82296" marT="82296" marB="82296" anchor="ctr">
                     <a:lnL w="10160" cap="flat" cmpd="sng" algn="ctr">
                       <a:solidFill>
                         <a:srgbClr val="D9DEE5"/>
@@ -27214,7 +27214,7 @@
                       </a:endParaRPr>
                     </a:p>
                   </a:txBody>
-                  <a:tcPr marL="82296" marR="82296" marT="82296" marB="82296" anchor="mid">
+                  <a:tcPr marL="82296" marR="82296" marT="82296" marB="82296" anchor="ctr">
                     <a:lnL w="10160" cap="flat" cmpd="sng" algn="ctr">
                       <a:solidFill>
                         <a:srgbClr val="D9DEE5"/>
@@ -27282,7 +27282,7 @@
                       </a:endParaRPr>
                     </a:p>
                   </a:txBody>
-                  <a:tcPr marL="82296" marR="82296" marT="82296" marB="82296" anchor="mid">
+                  <a:tcPr marL="82296" marR="82296" marT="82296" marB="82296" anchor="ctr">
                     <a:lnL w="10160" cap="flat" cmpd="sng" algn="ctr">
                       <a:solidFill>
                         <a:srgbClr val="D9DEE5"/>
@@ -27350,7 +27350,7 @@
                       </a:endParaRPr>
                     </a:p>
                   </a:txBody>
-                  <a:tcPr marL="82296" marR="82296" marT="82296" marB="82296" anchor="mid">
+                  <a:tcPr marL="82296" marR="82296" marT="82296" marB="82296" anchor="ctr">
                     <a:lnL w="10160" cap="flat" cmpd="sng" algn="ctr">
                       <a:solidFill>
                         <a:srgbClr val="D9DEE5"/>
@@ -27420,7 +27420,7 @@
                       </a:endParaRPr>
                     </a:p>
                   </a:txBody>
-                  <a:tcPr marL="82296" marR="82296" marT="82296" marB="82296" anchor="mid">
+                  <a:tcPr marL="82296" marR="82296" marT="82296" marB="82296" anchor="ctr">
                     <a:lnL w="10160" cap="flat" cmpd="sng" algn="ctr">
                       <a:solidFill>
                         <a:srgbClr val="D9DEE5"/>
@@ -27488,7 +27488,7 @@
                       </a:endParaRPr>
                     </a:p>
                   </a:txBody>
-                  <a:tcPr marL="82296" marR="82296" marT="82296" marB="82296" anchor="mid">
+                  <a:tcPr marL="82296" marR="82296" marT="82296" marB="82296" anchor="ctr">
                     <a:lnL w="10160" cap="flat" cmpd="sng" algn="ctr">
                       <a:solidFill>
                         <a:srgbClr val="D9DEE5"/>
@@ -27556,7 +27556,7 @@
                       </a:endParaRPr>
                     </a:p>
                   </a:txBody>
-                  <a:tcPr marL="82296" marR="82296" marT="82296" marB="82296" anchor="mid">
+                  <a:tcPr marL="82296" marR="82296" marT="82296" marB="82296" anchor="ctr">
                     <a:lnL w="10160" cap="flat" cmpd="sng" algn="ctr">
                       <a:solidFill>
                         <a:srgbClr val="D9DEE5"/>
@@ -27624,7 +27624,7 @@
                       </a:endParaRPr>
                     </a:p>
                   </a:txBody>
-                  <a:tcPr marL="82296" marR="82296" marT="82296" marB="82296" anchor="mid">
+                  <a:tcPr marL="82296" marR="82296" marT="82296" marB="82296" anchor="ctr">
                     <a:lnL w="10160" cap="flat" cmpd="sng" algn="ctr">
                       <a:solidFill>
                         <a:srgbClr val="D9DEE5"/>
@@ -27694,7 +27694,7 @@
                       </a:endParaRPr>
                     </a:p>
                   </a:txBody>
-                  <a:tcPr marL="82296" marR="82296" marT="82296" marB="82296" anchor="mid">
+                  <a:tcPr marL="82296" marR="82296" marT="82296" marB="82296" anchor="ctr">
                     <a:lnL w="10160" cap="flat" cmpd="sng" algn="ctr">
                       <a:solidFill>
                         <a:srgbClr val="D9DEE5"/>
@@ -27762,7 +27762,7 @@
                       </a:endParaRPr>
                     </a:p>
                   </a:txBody>
-                  <a:tcPr marL="82296" marR="82296" marT="82296" marB="82296" anchor="mid">
+                  <a:tcPr marL="82296" marR="82296" marT="82296" marB="82296" anchor="ctr">
                     <a:lnL w="10160" cap="flat" cmpd="sng" algn="ctr">
                       <a:solidFill>
                         <a:srgbClr val="D9DEE5"/>
@@ -27830,7 +27830,7 @@
                       </a:endParaRPr>
                     </a:p>
                   </a:txBody>
-                  <a:tcPr marL="82296" marR="82296" marT="82296" marB="82296" anchor="mid">
+                  <a:tcPr marL="82296" marR="82296" marT="82296" marB="82296" anchor="ctr">
                     <a:lnL w="10160" cap="flat" cmpd="sng" algn="ctr">
                       <a:solidFill>
                         <a:srgbClr val="D9DEE5"/>
@@ -27898,7 +27898,7 @@
                       </a:endParaRPr>
                     </a:p>
                   </a:txBody>
-                  <a:tcPr marL="82296" marR="82296" marT="82296" marB="82296" anchor="mid">
+                  <a:tcPr marL="82296" marR="82296" marT="82296" marB="82296" anchor="ctr">
                     <a:lnL w="10160" cap="flat" cmpd="sng" algn="ctr">
                       <a:solidFill>
                         <a:srgbClr val="D9DEE5"/>
@@ -27968,7 +27968,7 @@
                       </a:endParaRPr>
                     </a:p>
                   </a:txBody>
-                  <a:tcPr marL="82296" marR="82296" marT="82296" marB="82296" anchor="mid">
+                  <a:tcPr marL="82296" marR="82296" marT="82296" marB="82296" anchor="ctr">
                     <a:lnL w="10160" cap="flat" cmpd="sng" algn="ctr">
                       <a:solidFill>
                         <a:srgbClr val="D9DEE5"/>
@@ -28036,7 +28036,7 @@
                       </a:endParaRPr>
                     </a:p>
                   </a:txBody>
-                  <a:tcPr marL="82296" marR="82296" marT="82296" marB="82296" anchor="mid">
+                  <a:tcPr marL="82296" marR="82296" marT="82296" marB="82296" anchor="ctr">
                     <a:lnL w="10160" cap="flat" cmpd="sng" algn="ctr">
                       <a:solidFill>
                         <a:srgbClr val="D9DEE5"/>
@@ -28104,7 +28104,7 @@
                       </a:endParaRPr>
                     </a:p>
                   </a:txBody>
-                  <a:tcPr marL="82296" marR="82296" marT="82296" marB="82296" anchor="mid">
+                  <a:tcPr marL="82296" marR="82296" marT="82296" marB="82296" anchor="ctr">
                     <a:lnL w="10160" cap="flat" cmpd="sng" algn="ctr">
                       <a:solidFill>
                         <a:srgbClr val="D9DEE5"/>
@@ -28172,7 +28172,7 @@
                       </a:endParaRPr>
                     </a:p>
                   </a:txBody>
-                  <a:tcPr marL="82296" marR="82296" marT="82296" marB="82296" anchor="mid">
+                  <a:tcPr marL="82296" marR="82296" marT="82296" marB="82296" anchor="ctr">
                     <a:lnL w="10160" cap="flat" cmpd="sng" algn="ctr">
                       <a:solidFill>
                         <a:srgbClr val="D9DEE5"/>
@@ -28541,7 +28541,7 @@
                       </a:endParaRPr>
                     </a:p>
                   </a:txBody>
-                  <a:tcPr marL="82296" marR="82296" marT="82296" marB="82296" anchor="mid">
+                  <a:tcPr marL="82296" marR="82296" marT="82296" marB="82296" anchor="ctr">
                     <a:lnL w="10160" cap="flat" cmpd="sng" algn="ctr">
                       <a:solidFill>
                         <a:srgbClr val="D9DEE5"/>
@@ -28609,7 +28609,7 @@
                       </a:endParaRPr>
                     </a:p>
                   </a:txBody>
-                  <a:tcPr marL="82296" marR="82296" marT="82296" marB="82296" anchor="mid">
+                  <a:tcPr marL="82296" marR="82296" marT="82296" marB="82296" anchor="ctr">
                     <a:lnL w="10160" cap="flat" cmpd="sng" algn="ctr">
                       <a:solidFill>
                         <a:srgbClr val="D9DEE5"/>
@@ -28677,7 +28677,7 @@
                       </a:endParaRPr>
                     </a:p>
                   </a:txBody>
-                  <a:tcPr marL="82296" marR="82296" marT="82296" marB="82296" anchor="mid">
+                  <a:tcPr marL="82296" marR="82296" marT="82296" marB="82296" anchor="ctr">
                     <a:lnL w="10160" cap="flat" cmpd="sng" algn="ctr">
                       <a:solidFill>
                         <a:srgbClr val="D9DEE5"/>
@@ -28745,7 +28745,7 @@
                       </a:endParaRPr>
                     </a:p>
                   </a:txBody>
-                  <a:tcPr marL="82296" marR="82296" marT="82296" marB="82296" anchor="mid">
+                  <a:tcPr marL="82296" marR="82296" marT="82296" marB="82296" anchor="ctr">
                     <a:lnL w="10160" cap="flat" cmpd="sng" algn="ctr">
                       <a:solidFill>
                         <a:srgbClr val="D9DEE5"/>
@@ -28815,7 +28815,7 @@
                       </a:endParaRPr>
                     </a:p>
                   </a:txBody>
-                  <a:tcPr marL="82296" marR="82296" marT="82296" marB="82296" anchor="mid">
+                  <a:tcPr marL="82296" marR="82296" marT="82296" marB="82296" anchor="ctr">
                     <a:lnL w="10160" cap="flat" cmpd="sng" algn="ctr">
                       <a:solidFill>
                         <a:srgbClr val="D9DEE5"/>
@@ -28883,7 +28883,7 @@
                       </a:endParaRPr>
                     </a:p>
                   </a:txBody>
-                  <a:tcPr marL="82296" marR="82296" marT="82296" marB="82296" anchor="mid">
+                  <a:tcPr marL="82296" marR="82296" marT="82296" marB="82296" anchor="ctr">
                     <a:lnL w="10160" cap="flat" cmpd="sng" algn="ctr">
                       <a:solidFill>
                         <a:srgbClr val="D9DEE5"/>
@@ -28951,7 +28951,7 @@
                       </a:endParaRPr>
                     </a:p>
                   </a:txBody>
-                  <a:tcPr marL="82296" marR="82296" marT="82296" marB="82296" anchor="mid">
+                  <a:tcPr marL="82296" marR="82296" marT="82296" marB="82296" anchor="ctr">
                     <a:lnL w="10160" cap="flat" cmpd="sng" algn="ctr">
                       <a:solidFill>
                         <a:srgbClr val="D9DEE5"/>
@@ -29019,7 +29019,7 @@
                       </a:endParaRPr>
                     </a:p>
                   </a:txBody>
-                  <a:tcPr marL="82296" marR="82296" marT="82296" marB="82296" anchor="mid">
+                  <a:tcPr marL="82296" marR="82296" marT="82296" marB="82296" anchor="ctr">
                     <a:lnL w="10160" cap="flat" cmpd="sng" algn="ctr">
                       <a:solidFill>
                         <a:srgbClr val="D9DEE5"/>
@@ -29089,7 +29089,7 @@
                       </a:endParaRPr>
                     </a:p>
                   </a:txBody>
-                  <a:tcPr marL="82296" marR="82296" marT="82296" marB="82296" anchor="mid">
+                  <a:tcPr marL="82296" marR="82296" marT="82296" marB="82296" anchor="ctr">
                     <a:lnL w="10160" cap="flat" cmpd="sng" algn="ctr">
                       <a:solidFill>
                         <a:srgbClr val="D9DEE5"/>
@@ -29157,7 +29157,7 @@
                       </a:endParaRPr>
                     </a:p>
                   </a:txBody>
-                  <a:tcPr marL="82296" marR="82296" marT="82296" marB="82296" anchor="mid">
+                  <a:tcPr marL="82296" marR="82296" marT="82296" marB="82296" anchor="ctr">
                     <a:lnL w="10160" cap="flat" cmpd="sng" algn="ctr">
                       <a:solidFill>
                         <a:srgbClr val="D9DEE5"/>
@@ -29225,7 +29225,7 @@
                       </a:endParaRPr>
                     </a:p>
                   </a:txBody>
-                  <a:tcPr marL="82296" marR="82296" marT="82296" marB="82296" anchor="mid">
+                  <a:tcPr marL="82296" marR="82296" marT="82296" marB="82296" anchor="ctr">
                     <a:lnL w="10160" cap="flat" cmpd="sng" algn="ctr">
                       <a:solidFill>
                         <a:srgbClr val="D9DEE5"/>
@@ -29293,7 +29293,7 @@
                       </a:endParaRPr>
                     </a:p>
                   </a:txBody>
-                  <a:tcPr marL="82296" marR="82296" marT="82296" marB="82296" anchor="mid">
+                  <a:tcPr marL="82296" marR="82296" marT="82296" marB="82296" anchor="ctr">
                     <a:lnL w="10160" cap="flat" cmpd="sng" algn="ctr">
                       <a:solidFill>
                         <a:srgbClr val="D9DEE5"/>
@@ -29363,7 +29363,7 @@
                       </a:endParaRPr>
                     </a:p>
                   </a:txBody>
-                  <a:tcPr marL="82296" marR="82296" marT="82296" marB="82296" anchor="mid">
+                  <a:tcPr marL="82296" marR="82296" marT="82296" marB="82296" anchor="ctr">
                     <a:lnL w="10160" cap="flat" cmpd="sng" algn="ctr">
                       <a:solidFill>
                         <a:srgbClr val="D9DEE5"/>
@@ -29431,7 +29431,7 @@
                       </a:endParaRPr>
                     </a:p>
                   </a:txBody>
-                  <a:tcPr marL="82296" marR="82296" marT="82296" marB="82296" anchor="mid">
+                  <a:tcPr marL="82296" marR="82296" marT="82296" marB="82296" anchor="ctr">
                     <a:lnL w="10160" cap="flat" cmpd="sng" algn="ctr">
                       <a:solidFill>
                         <a:srgbClr val="D9DEE5"/>
@@ -29499,7 +29499,7 @@
                       </a:endParaRPr>
                     </a:p>
                   </a:txBody>
-                  <a:tcPr marL="82296" marR="82296" marT="82296" marB="82296" anchor="mid">
+                  <a:tcPr marL="82296" marR="82296" marT="82296" marB="82296" anchor="ctr">
                     <a:lnL w="10160" cap="flat" cmpd="sng" algn="ctr">
                       <a:solidFill>
                         <a:srgbClr val="D9DEE5"/>
@@ -29567,7 +29567,7 @@
                       </a:endParaRPr>
                     </a:p>
                   </a:txBody>
-                  <a:tcPr marL="82296" marR="82296" marT="82296" marB="82296" anchor="mid">
+                  <a:tcPr marL="82296" marR="82296" marT="82296" marB="82296" anchor="ctr">
                     <a:lnL w="10160" cap="flat" cmpd="sng" algn="ctr">
                       <a:solidFill>
                         <a:srgbClr val="D9DEE5"/>
@@ -29935,7 +29935,7 @@
                       </a:endParaRPr>
                     </a:p>
                   </a:txBody>
-                  <a:tcPr marL="82296" marR="82296" marT="82296" marB="82296" anchor="mid">
+                  <a:tcPr marL="82296" marR="82296" marT="82296" marB="82296" anchor="ctr">
                     <a:lnL w="10160" cap="flat" cmpd="sng" algn="ctr">
                       <a:solidFill>
                         <a:srgbClr val="D9DEE5"/>
@@ -30003,7 +30003,7 @@
                       </a:endParaRPr>
                     </a:p>
                   </a:txBody>
-                  <a:tcPr marL="82296" marR="82296" marT="82296" marB="82296" anchor="mid">
+                  <a:tcPr marL="82296" marR="82296" marT="82296" marB="82296" anchor="ctr">
                     <a:lnL w="10160" cap="flat" cmpd="sng" algn="ctr">
                       <a:solidFill>
                         <a:srgbClr val="D9DEE5"/>
@@ -30071,7 +30071,7 @@
                       </a:endParaRPr>
                     </a:p>
                   </a:txBody>
-                  <a:tcPr marL="82296" marR="82296" marT="82296" marB="82296" anchor="mid">
+                  <a:tcPr marL="82296" marR="82296" marT="82296" marB="82296" anchor="ctr">
                     <a:lnL w="10160" cap="flat" cmpd="sng" algn="ctr">
                       <a:solidFill>
                         <a:srgbClr val="D9DEE5"/>
@@ -30141,7 +30141,7 @@
                       </a:endParaRPr>
                     </a:p>
                   </a:txBody>
-                  <a:tcPr marL="82296" marR="82296" marT="82296" marB="82296" anchor="mid">
+                  <a:tcPr marL="82296" marR="82296" marT="82296" marB="82296" anchor="ctr">
                     <a:lnL w="10160" cap="flat" cmpd="sng" algn="ctr">
                       <a:solidFill>
                         <a:srgbClr val="D9DEE5"/>
@@ -30209,7 +30209,7 @@
                       </a:endParaRPr>
                     </a:p>
                   </a:txBody>
-                  <a:tcPr marL="82296" marR="82296" marT="82296" marB="82296" anchor="mid">
+                  <a:tcPr marL="82296" marR="82296" marT="82296" marB="82296" anchor="ctr">
                     <a:lnL w="10160" cap="flat" cmpd="sng" algn="ctr">
                       <a:solidFill>
                         <a:srgbClr val="D9DEE5"/>
@@ -30277,7 +30277,7 @@
                       </a:endParaRPr>
                     </a:p>
                   </a:txBody>
-                  <a:tcPr marL="82296" marR="82296" marT="82296" marB="82296" anchor="mid">
+                  <a:tcPr marL="82296" marR="82296" marT="82296" marB="82296" anchor="ctr">
                     <a:lnL w="10160" cap="flat" cmpd="sng" algn="ctr">
                       <a:solidFill>
                         <a:srgbClr val="D9DEE5"/>
@@ -30347,7 +30347,7 @@
                       </a:endParaRPr>
                     </a:p>
                   </a:txBody>
-                  <a:tcPr marL="82296" marR="82296" marT="82296" marB="82296" anchor="mid">
+                  <a:tcPr marL="82296" marR="82296" marT="82296" marB="82296" anchor="ctr">
                     <a:lnL w="10160" cap="flat" cmpd="sng" algn="ctr">
                       <a:solidFill>
                         <a:srgbClr val="D9DEE5"/>
@@ -30415,7 +30415,7 @@
                       </a:endParaRPr>
                     </a:p>
                   </a:txBody>
-                  <a:tcPr marL="82296" marR="82296" marT="82296" marB="82296" anchor="mid">
+                  <a:tcPr marL="82296" marR="82296" marT="82296" marB="82296" anchor="ctr">
                     <a:lnL w="10160" cap="flat" cmpd="sng" algn="ctr">
                       <a:solidFill>
                         <a:srgbClr val="D9DEE5"/>
@@ -30483,7 +30483,7 @@
                       </a:endParaRPr>
                     </a:p>
                   </a:txBody>
-                  <a:tcPr marL="82296" marR="82296" marT="82296" marB="82296" anchor="mid">
+                  <a:tcPr marL="82296" marR="82296" marT="82296" marB="82296" anchor="ctr">
                     <a:lnL w="10160" cap="flat" cmpd="sng" algn="ctr">
                       <a:solidFill>
                         <a:srgbClr val="D9DEE5"/>
@@ -30553,7 +30553,7 @@
                       </a:endParaRPr>
                     </a:p>
                   </a:txBody>
-                  <a:tcPr marL="82296" marR="82296" marT="82296" marB="82296" anchor="mid">
+                  <a:tcPr marL="82296" marR="82296" marT="82296" marB="82296" anchor="ctr">
                     <a:lnL w="10160" cap="flat" cmpd="sng" algn="ctr">
                       <a:solidFill>
                         <a:srgbClr val="D9DEE5"/>
@@ -30621,7 +30621,7 @@
                       </a:endParaRPr>
                     </a:p>
                   </a:txBody>
-                  <a:tcPr marL="82296" marR="82296" marT="82296" marB="82296" anchor="mid">
+                  <a:tcPr marL="82296" marR="82296" marT="82296" marB="82296" anchor="ctr">
                     <a:lnL w="10160" cap="flat" cmpd="sng" algn="ctr">
                       <a:solidFill>
                         <a:srgbClr val="D9DEE5"/>
@@ -30689,7 +30689,7 @@
                       </a:endParaRPr>
                     </a:p>
                   </a:txBody>
-                  <a:tcPr marL="82296" marR="82296" marT="82296" marB="82296" anchor="mid">
+                  <a:tcPr marL="82296" marR="82296" marT="82296" marB="82296" anchor="ctr">
                     <a:lnL w="10160" cap="flat" cmpd="sng" algn="ctr">
                       <a:solidFill>
                         <a:srgbClr val="D9DEE5"/>
@@ -30759,7 +30759,7 @@
                       </a:endParaRPr>
                     </a:p>
                   </a:txBody>
-                  <a:tcPr marL="82296" marR="82296" marT="82296" marB="82296" anchor="mid">
+                  <a:tcPr marL="82296" marR="82296" marT="82296" marB="82296" anchor="ctr">
                     <a:lnL w="10160" cap="flat" cmpd="sng" algn="ctr">
                       <a:solidFill>
                         <a:srgbClr val="D9DEE5"/>
@@ -30827,7 +30827,7 @@
                       </a:endParaRPr>
                     </a:p>
                   </a:txBody>
-                  <a:tcPr marL="82296" marR="82296" marT="82296" marB="82296" anchor="mid">
+                  <a:tcPr marL="82296" marR="82296" marT="82296" marB="82296" anchor="ctr">
                     <a:lnL w="10160" cap="flat" cmpd="sng" algn="ctr">
                       <a:solidFill>
                         <a:srgbClr val="D9DEE5"/>
@@ -30895,7 +30895,7 @@
                       </a:endParaRPr>
                     </a:p>
                   </a:txBody>
-                  <a:tcPr marL="82296" marR="82296" marT="82296" marB="82296" anchor="mid">
+                  <a:tcPr marL="82296" marR="82296" marT="82296" marB="82296" anchor="ctr">
                     <a:lnL w="10160" cap="flat" cmpd="sng" algn="ctr">
                       <a:solidFill>
                         <a:srgbClr val="D9DEE5"/>
@@ -30965,7 +30965,7 @@
                       </a:endParaRPr>
                     </a:p>
                   </a:txBody>
-                  <a:tcPr marL="82296" marR="82296" marT="82296" marB="82296" anchor="mid">
+                  <a:tcPr marL="82296" marR="82296" marT="82296" marB="82296" anchor="ctr">
                     <a:lnL w="10160" cap="flat" cmpd="sng" algn="ctr">
                       <a:solidFill>
                         <a:srgbClr val="D9DEE5"/>
@@ -31033,7 +31033,7 @@
                       </a:endParaRPr>
                     </a:p>
                   </a:txBody>
-                  <a:tcPr marL="82296" marR="82296" marT="82296" marB="82296" anchor="mid">
+                  <a:tcPr marL="82296" marR="82296" marT="82296" marB="82296" anchor="ctr">
                     <a:lnL w="10160" cap="flat" cmpd="sng" algn="ctr">
                       <a:solidFill>
                         <a:srgbClr val="D9DEE5"/>
@@ -31101,7 +31101,7 @@
                       </a:endParaRPr>
                     </a:p>
                   </a:txBody>
-                  <a:tcPr marL="82296" marR="82296" marT="82296" marB="82296" anchor="mid">
+                  <a:tcPr marL="82296" marR="82296" marT="82296" marB="82296" anchor="ctr">
                     <a:lnL w="10160" cap="flat" cmpd="sng" algn="ctr">
                       <a:solidFill>
                         <a:srgbClr val="D9DEE5"/>
@@ -31171,7 +31171,7 @@
                       </a:endParaRPr>
                     </a:p>
                   </a:txBody>
-                  <a:tcPr marL="82296" marR="82296" marT="82296" marB="82296" anchor="mid">
+                  <a:tcPr marL="82296" marR="82296" marT="82296" marB="82296" anchor="ctr">
                     <a:lnL w="10160" cap="flat" cmpd="sng" algn="ctr">
                       <a:solidFill>
                         <a:srgbClr val="D9DEE5"/>
@@ -31239,7 +31239,7 @@
                       </a:endParaRPr>
                     </a:p>
                   </a:txBody>
-                  <a:tcPr marL="82296" marR="82296" marT="82296" marB="82296" anchor="mid">
+                  <a:tcPr marL="82296" marR="82296" marT="82296" marB="82296" anchor="ctr">
                     <a:lnL w="10160" cap="flat" cmpd="sng" algn="ctr">
                       <a:solidFill>
                         <a:srgbClr val="D9DEE5"/>
@@ -31307,7 +31307,7 @@
                       </a:endParaRPr>
                     </a:p>
                   </a:txBody>
-                  <a:tcPr marL="82296" marR="82296" marT="82296" marB="82296" anchor="mid">
+                  <a:tcPr marL="82296" marR="82296" marT="82296" marB="82296" anchor="ctr">
                     <a:lnL w="10160" cap="flat" cmpd="sng" algn="ctr">
                       <a:solidFill>
                         <a:srgbClr val="D9DEE5"/>
@@ -36189,9 +36189,9 @@
           <p:nvPr/>
         </p:nvSpPr>
         <p:spPr>
-          <a:xfrm>
-            <a:off x="3703320" y="3072384"/>
-            <a:ext cx="457200" cy="-164592"/>
+          <a:xfrm flipV="1">
+            <a:off x="3703320" y="2907792"/>
+            <a:ext cx="457200" cy="164592"/>
           </a:xfrm>
           <a:prstGeom prst="line">
             <a:avLst/>
@@ -36307,9 +36307,9 @@
           <p:nvPr/>
         </p:nvSpPr>
         <p:spPr>
-          <a:xfrm>
-            <a:off x="3703320" y="4306824"/>
-            <a:ext cx="457200" cy="-1399032"/>
+          <a:xfrm flipV="1">
+            <a:off x="3703320" y="2907792"/>
+            <a:ext cx="457200" cy="1399032"/>
           </a:xfrm>
           <a:prstGeom prst="line">
             <a:avLst/>
@@ -36425,9 +36425,9 @@
           <p:nvPr/>
         </p:nvSpPr>
         <p:spPr>
-          <a:xfrm>
-            <a:off x="3703320" y="5541264"/>
-            <a:ext cx="457200" cy="-2633472"/>
+          <a:xfrm flipV="1">
+            <a:off x="3703320" y="2907792"/>
+            <a:ext cx="457200" cy="2633472"/>
           </a:xfrm>
           <a:prstGeom prst="line">
             <a:avLst/>
@@ -36543,9 +36543,9 @@
           <p:nvPr/>
         </p:nvSpPr>
         <p:spPr>
-          <a:xfrm>
-            <a:off x="8412480" y="1837944"/>
-            <a:ext cx="-457200" cy="1069848"/>
+          <a:xfrm flipH="1">
+            <a:off x="7955280" y="1837944"/>
+            <a:ext cx="457200" cy="1069848"/>
           </a:xfrm>
           <a:prstGeom prst="line">
             <a:avLst/>
@@ -36661,9 +36661,9 @@
           <p:nvPr/>
         </p:nvSpPr>
         <p:spPr>
-          <a:xfrm>
-            <a:off x="8412480" y="3072384"/>
-            <a:ext cx="-457200" cy="-164592"/>
+          <a:xfrm flipH="1" flipV="1">
+            <a:off x="7955280" y="2907792"/>
+            <a:ext cx="457200" cy="164592"/>
           </a:xfrm>
           <a:prstGeom prst="line">
             <a:avLst/>
@@ -36779,9 +36779,9 @@
           <p:nvPr/>
         </p:nvSpPr>
         <p:spPr>
-          <a:xfrm>
-            <a:off x="8412480" y="4306824"/>
-            <a:ext cx="-457200" cy="-1399032"/>
+          <a:xfrm flipH="1" flipV="1">
+            <a:off x="7955280" y="2907792"/>
+            <a:ext cx="457200" cy="1399032"/>
           </a:xfrm>
           <a:prstGeom prst="line">
             <a:avLst/>
@@ -37273,9 +37273,9 @@
           <p:nvPr/>
         </p:nvSpPr>
         <p:spPr>
-          <a:xfrm>
-            <a:off x="3246120" y="2971800"/>
-            <a:ext cx="1371600" cy="-1097280"/>
+          <a:xfrm flipV="1">
+            <a:off x="3246120" y="1874520"/>
+            <a:ext cx="1371600" cy="1097280"/>
           </a:xfrm>
           <a:prstGeom prst="line">
             <a:avLst/>

</xml_diff>

<commit_message>
fix: polish final thesis defense package
</commit_message>
<xml_diff>
--- a/Document/outputs/final-defense/G6519692_Zaw_Ye_Htut_Ko_Final_Thesis_Defense.pptx
+++ b/Document/outputs/final-defense/G6519692_Zaw_Ye_Htut_Ko_Final_Thesis_Defense.pptx
@@ -651,7 +651,7 @@
             </a:ln>
           </c:spPr>
         </c:majorGridlines>
-        <c:numFmt formatCode="0%" sourceLinked="0"/>
+        <c:numFmt formatCode="0.0&quot;%&quot;" sourceLinked="0"/>
         <c:majorTickMark val="out"/>
         <c:minorTickMark val="none"/>
         <c:tickLblPos val="nextTo"/>
@@ -33781,7 +33781,7 @@
                 <a:ea typeface="Arial" pitchFamily="34" charset="-122"/>
                 <a:cs typeface="Arial" pitchFamily="34" charset="-120"/>
               </a:rPr>
-              <a:t>Remeasurement</a:t>
+              <a:t>Tool rerun</a:t>
             </a:r>
             <a:endParaRPr lang="en-US" sz="1600" dirty="0"/>
           </a:p>
@@ -38086,12 +38086,12 @@
         </p:nvSpPr>
         <p:spPr>
           <a:xfrm>
-            <a:off x="731520" y="1325880"/>
-            <a:ext cx="10744200" cy="4480560"/>
+            <a:off x="777240" y="1325880"/>
+            <a:ext cx="5074920" cy="1874520"/>
           </a:xfrm>
           <a:prstGeom prst="roundRect">
             <a:avLst>
-              <a:gd name="adj" fmla="val 1429"/>
+              <a:gd name="adj" fmla="val 3415"/>
             </a:avLst>
           </a:prstGeom>
           <a:solidFill>
@@ -38105,40 +38105,525 @@
           </a:ln>
         </p:spPr>
       </p:sp>
-      <p:pic>
-        <p:nvPicPr>
-          <p:cNvPr id="10" name="Image 0" descr="C:\Users\Asus\.codex\worktrees\final-thesis-defense\financial-accounting\Document\paper\figures\workflow.png">    </p:cNvPr>
-          <p:cNvPicPr>
-            <a:picLocks noChangeAspect="1"/>
-          </p:cNvPicPr>
-          <p:nvPr/>
-        </p:nvPicPr>
-        <p:blipFill>
-          <a:blip r:embed="rId1"/>
-          <a:stretch>
-            <a:fillRect/>
-          </a:stretch>
-        </p:blipFill>
-        <p:spPr>
-          <a:xfrm>
-            <a:off x="3107765" y="1325880"/>
-            <a:ext cx="5991710" cy="4480560"/>
+      <p:sp>
+        <p:nvSpPr>
+          <p:cNvPr id="10" name="Shape 8"/>
+          <p:cNvSpPr/>
+          <p:nvPr/>
+        </p:nvSpPr>
+        <p:spPr>
+          <a:xfrm>
+            <a:off x="777240" y="1325880"/>
+            <a:ext cx="82296" cy="1874520"/>
           </a:xfrm>
           <a:prstGeom prst="rect">
             <a:avLst/>
           </a:prstGeom>
-        </p:spPr>
-      </p:pic>
-      <p:sp>
-        <p:nvSpPr>
-          <p:cNvPr id="11" name="Shape 8"/>
-          <p:cNvSpPr/>
-          <p:nvPr/>
-        </p:nvSpPr>
-        <p:spPr>
-          <a:xfrm>
-            <a:off x="3657600" y="5806440"/>
-            <a:ext cx="4846320" cy="329184"/>
+          <a:solidFill>
+            <a:srgbClr val="20262E"/>
+          </a:solidFill>
+          <a:ln w="12700">
+            <a:solidFill>
+              <a:srgbClr val="20262E"/>
+            </a:solidFill>
+            <a:prstDash val="solid"/>
+          </a:ln>
+        </p:spPr>
+      </p:sp>
+      <p:sp>
+        <p:nvSpPr>
+          <p:cNvPr id="11" name="Text 9"/>
+          <p:cNvSpPr/>
+          <p:nvPr/>
+        </p:nvSpPr>
+        <p:spPr>
+          <a:xfrm>
+            <a:off x="996696" y="1490472"/>
+            <a:ext cx="4709160" cy="320040"/>
+          </a:xfrm>
+          <a:prstGeom prst="rect">
+            <a:avLst/>
+          </a:prstGeom>
+          <a:noFill/>
+          <a:ln/>
+        </p:spPr>
+        <p:txBody>
+          <a:bodyPr wrap="square" lIns="0" tIns="0" rIns="0" bIns="0" rtlCol="0" anchor="ctr">
+            <a:normAutofit/>
+          </a:bodyPr>
+          <a:lstStyle/>
+          <a:p>
+            <a:pPr indent="0" marL="0">
+              <a:buNone/>
+            </a:pPr>
+            <a:r>
+              <a:rPr lang="en-US" sz="2100" b="1" dirty="0">
+                <a:solidFill>
+                  <a:srgbClr val="20262E"/>
+                </a:solidFill>
+                <a:latin typeface="Arial" pitchFamily="34" charset="0"/>
+                <a:ea typeface="Arial" pitchFamily="34" charset="-122"/>
+                <a:cs typeface="Arial" pitchFamily="34" charset="-120"/>
+              </a:rPr>
+              <a:t>01  Capture baseline</a:t>
+            </a:r>
+            <a:endParaRPr lang="en-US" sz="2100" dirty="0"/>
+          </a:p>
+        </p:txBody>
+      </p:sp>
+      <p:sp>
+        <p:nvSpPr>
+          <p:cNvPr id="12" name="Text 10"/>
+          <p:cNvSpPr/>
+          <p:nvPr/>
+        </p:nvSpPr>
+        <p:spPr>
+          <a:xfrm>
+            <a:off x="996696" y="1892808"/>
+            <a:ext cx="4681728" cy="1143000"/>
+          </a:xfrm>
+          <a:prstGeom prst="rect">
+            <a:avLst/>
+          </a:prstGeom>
+          <a:noFill/>
+          <a:ln/>
+        </p:spPr>
+        <p:txBody>
+          <a:bodyPr wrap="square" lIns="0" tIns="0" rIns="0" bIns="0" rtlCol="0" anchor="t">
+            <a:normAutofit/>
+          </a:bodyPr>
+          <a:lstStyle/>
+          <a:p>
+            <a:pPr indent="0" marL="0">
+              <a:buNone/>
+            </a:pPr>
+            <a:r>
+              <a:rPr lang="en-US" sz="1650" dirty="0">
+                <a:solidFill>
+                  <a:srgbClr val="66717E"/>
+                </a:solidFill>
+                <a:latin typeface="Arial" pitchFamily="34" charset="0"/>
+                <a:ea typeface="Arial" pitchFamily="34" charset="-122"/>
+                <a:cs typeface="Arial" pitchFamily="34" charset="-120"/>
+              </a:rPr>
+              <a:t>Preserve raw tool findings and environment state</a:t>
+            </a:r>
+            <a:endParaRPr lang="en-US" sz="1650" dirty="0"/>
+          </a:p>
+        </p:txBody>
+      </p:sp>
+      <p:sp>
+        <p:nvSpPr>
+          <p:cNvPr id="13" name="Shape 11"/>
+          <p:cNvSpPr/>
+          <p:nvPr/>
+        </p:nvSpPr>
+        <p:spPr>
+          <a:xfrm>
+            <a:off x="6263640" y="1325880"/>
+            <a:ext cx="5074920" cy="1874520"/>
+          </a:xfrm>
+          <a:prstGeom prst="roundRect">
+            <a:avLst>
+              <a:gd name="adj" fmla="val 3415"/>
+            </a:avLst>
+          </a:prstGeom>
+          <a:solidFill>
+            <a:srgbClr val="FFFFFF"/>
+          </a:solidFill>
+          <a:ln w="12700">
+            <a:solidFill>
+              <a:srgbClr val="D9DEE5"/>
+            </a:solidFill>
+            <a:prstDash val="solid"/>
+          </a:ln>
+        </p:spPr>
+      </p:sp>
+      <p:sp>
+        <p:nvSpPr>
+          <p:cNvPr id="14" name="Shape 12"/>
+          <p:cNvSpPr/>
+          <p:nvPr/>
+        </p:nvSpPr>
+        <p:spPr>
+          <a:xfrm>
+            <a:off x="6263640" y="1325880"/>
+            <a:ext cx="82296" cy="1874520"/>
+          </a:xfrm>
+          <a:prstGeom prst="rect">
+            <a:avLst/>
+          </a:prstGeom>
+          <a:solidFill>
+            <a:srgbClr val="C47B12"/>
+          </a:solidFill>
+          <a:ln w="12700">
+            <a:solidFill>
+              <a:srgbClr val="C47B12"/>
+            </a:solidFill>
+            <a:prstDash val="solid"/>
+          </a:ln>
+        </p:spPr>
+      </p:sp>
+      <p:sp>
+        <p:nvSpPr>
+          <p:cNvPr id="15" name="Text 13"/>
+          <p:cNvSpPr/>
+          <p:nvPr/>
+        </p:nvSpPr>
+        <p:spPr>
+          <a:xfrm>
+            <a:off x="6483096" y="1490472"/>
+            <a:ext cx="4709160" cy="320040"/>
+          </a:xfrm>
+          <a:prstGeom prst="rect">
+            <a:avLst/>
+          </a:prstGeom>
+          <a:noFill/>
+          <a:ln/>
+        </p:spPr>
+        <p:txBody>
+          <a:bodyPr wrap="square" lIns="0" tIns="0" rIns="0" bIns="0" rtlCol="0" anchor="ctr">
+            <a:normAutofit/>
+          </a:bodyPr>
+          <a:lstStyle/>
+          <a:p>
+            <a:pPr indent="0" marL="0">
+              <a:buNone/>
+            </a:pPr>
+            <a:r>
+              <a:rPr lang="en-US" sz="2100" b="1" dirty="0">
+                <a:solidFill>
+                  <a:srgbClr val="20262E"/>
+                </a:solidFill>
+                <a:latin typeface="Arial" pitchFamily="34" charset="0"/>
+                <a:ea typeface="Arial" pitchFamily="34" charset="-122"/>
+                <a:cs typeface="Arial" pitchFamily="34" charset="-120"/>
+              </a:rPr>
+              <a:t>02  Propose bounded fix</a:t>
+            </a:r>
+            <a:endParaRPr lang="en-US" sz="2100" dirty="0"/>
+          </a:p>
+        </p:txBody>
+      </p:sp>
+      <p:sp>
+        <p:nvSpPr>
+          <p:cNvPr id="16" name="Text 14"/>
+          <p:cNvSpPr/>
+          <p:nvPr/>
+        </p:nvSpPr>
+        <p:spPr>
+          <a:xfrm>
+            <a:off x="6483096" y="1892808"/>
+            <a:ext cx="4681728" cy="1143000"/>
+          </a:xfrm>
+          <a:prstGeom prst="rect">
+            <a:avLst/>
+          </a:prstGeom>
+          <a:noFill/>
+          <a:ln/>
+        </p:spPr>
+        <p:txBody>
+          <a:bodyPr wrap="square" lIns="0" tIns="0" rIns="0" bIns="0" rtlCol="0" anchor="t">
+            <a:normAutofit/>
+          </a:bodyPr>
+          <a:lstStyle/>
+          <a:p>
+            <a:pPr indent="0" marL="0">
+              <a:buNone/>
+            </a:pPr>
+            <a:r>
+              <a:rPr lang="en-US" sz="1650" dirty="0">
+                <a:solidFill>
+                  <a:srgbClr val="66717E"/>
+                </a:solidFill>
+                <a:latin typeface="Arial" pitchFamily="34" charset="0"/>
+                <a:ea typeface="Arial" pitchFamily="34" charset="-122"/>
+                <a:cs typeface="Arial" pitchFamily="34" charset="-120"/>
+              </a:rPr>
+              <a:t>Give the model the finding, source context, and constraints</a:t>
+            </a:r>
+            <a:endParaRPr lang="en-US" sz="1650" dirty="0"/>
+          </a:p>
+        </p:txBody>
+      </p:sp>
+      <p:sp>
+        <p:nvSpPr>
+          <p:cNvPr id="17" name="Shape 15"/>
+          <p:cNvSpPr/>
+          <p:nvPr/>
+        </p:nvSpPr>
+        <p:spPr>
+          <a:xfrm>
+            <a:off x="777240" y="3611880"/>
+            <a:ext cx="5074920" cy="1874520"/>
+          </a:xfrm>
+          <a:prstGeom prst="roundRect">
+            <a:avLst>
+              <a:gd name="adj" fmla="val 3415"/>
+            </a:avLst>
+          </a:prstGeom>
+          <a:solidFill>
+            <a:srgbClr val="FFFFFF"/>
+          </a:solidFill>
+          <a:ln w="12700">
+            <a:solidFill>
+              <a:srgbClr val="D9DEE5"/>
+            </a:solidFill>
+            <a:prstDash val="solid"/>
+          </a:ln>
+        </p:spPr>
+      </p:sp>
+      <p:sp>
+        <p:nvSpPr>
+          <p:cNvPr id="18" name="Shape 16"/>
+          <p:cNvSpPr/>
+          <p:nvPr/>
+        </p:nvSpPr>
+        <p:spPr>
+          <a:xfrm>
+            <a:off x="777240" y="3611880"/>
+            <a:ext cx="82296" cy="1874520"/>
+          </a:xfrm>
+          <a:prstGeom prst="rect">
+            <a:avLst/>
+          </a:prstGeom>
+          <a:solidFill>
+            <a:srgbClr val="B93A3A"/>
+          </a:solidFill>
+          <a:ln w="12700">
+            <a:solidFill>
+              <a:srgbClr val="B93A3A"/>
+            </a:solidFill>
+            <a:prstDash val="solid"/>
+          </a:ln>
+        </p:spPr>
+      </p:sp>
+      <p:sp>
+        <p:nvSpPr>
+          <p:cNvPr id="19" name="Text 17"/>
+          <p:cNvSpPr/>
+          <p:nvPr/>
+        </p:nvSpPr>
+        <p:spPr>
+          <a:xfrm>
+            <a:off x="996696" y="3776472"/>
+            <a:ext cx="4709160" cy="320040"/>
+          </a:xfrm>
+          <a:prstGeom prst="rect">
+            <a:avLst/>
+          </a:prstGeom>
+          <a:noFill/>
+          <a:ln/>
+        </p:spPr>
+        <p:txBody>
+          <a:bodyPr wrap="square" lIns="0" tIns="0" rIns="0" bIns="0" rtlCol="0" anchor="ctr">
+            <a:normAutofit/>
+          </a:bodyPr>
+          <a:lstStyle/>
+          <a:p>
+            <a:pPr indent="0" marL="0">
+              <a:buNone/>
+            </a:pPr>
+            <a:r>
+              <a:rPr lang="en-US" sz="2100" b="1" dirty="0">
+                <a:solidFill>
+                  <a:srgbClr val="20262E"/>
+                </a:solidFill>
+                <a:latin typeface="Arial" pitchFamily="34" charset="0"/>
+                <a:ea typeface="Arial" pitchFamily="34" charset="-122"/>
+                <a:cs typeface="Arial" pitchFamily="34" charset="-120"/>
+              </a:rPr>
+              <a:t>03  Human review and tests</a:t>
+            </a:r>
+            <a:endParaRPr lang="en-US" sz="2100" dirty="0"/>
+          </a:p>
+        </p:txBody>
+      </p:sp>
+      <p:sp>
+        <p:nvSpPr>
+          <p:cNvPr id="20" name="Text 18"/>
+          <p:cNvSpPr/>
+          <p:nvPr/>
+        </p:nvSpPr>
+        <p:spPr>
+          <a:xfrm>
+            <a:off x="996696" y="4178808"/>
+            <a:ext cx="4681728" cy="1143000"/>
+          </a:xfrm>
+          <a:prstGeom prst="rect">
+            <a:avLst/>
+          </a:prstGeom>
+          <a:noFill/>
+          <a:ln/>
+        </p:spPr>
+        <p:txBody>
+          <a:bodyPr wrap="square" lIns="0" tIns="0" rIns="0" bIns="0" rtlCol="0" anchor="t">
+            <a:normAutofit/>
+          </a:bodyPr>
+          <a:lstStyle/>
+          <a:p>
+            <a:pPr indent="0" marL="0">
+              <a:buNone/>
+            </a:pPr>
+            <a:r>
+              <a:rPr lang="en-US" sz="1650" dirty="0">
+                <a:solidFill>
+                  <a:srgbClr val="66717E"/>
+                </a:solidFill>
+                <a:latin typeface="Arial" pitchFamily="34" charset="0"/>
+                <a:ea typeface="Arial" pitchFamily="34" charset="-122"/>
+                <a:cs typeface="Arial" pitchFamily="34" charset="-120"/>
+              </a:rPr>
+              <a:t>Protect authorization, accounting invariants, and contracts</a:t>
+            </a:r>
+            <a:endParaRPr lang="en-US" sz="1650" dirty="0"/>
+          </a:p>
+        </p:txBody>
+      </p:sp>
+      <p:sp>
+        <p:nvSpPr>
+          <p:cNvPr id="21" name="Shape 19"/>
+          <p:cNvSpPr/>
+          <p:nvPr/>
+        </p:nvSpPr>
+        <p:spPr>
+          <a:xfrm>
+            <a:off x="6263640" y="3611880"/>
+            <a:ext cx="5074920" cy="1874520"/>
+          </a:xfrm>
+          <a:prstGeom prst="roundRect">
+            <a:avLst>
+              <a:gd name="adj" fmla="val 3415"/>
+            </a:avLst>
+          </a:prstGeom>
+          <a:solidFill>
+            <a:srgbClr val="FFFFFF"/>
+          </a:solidFill>
+          <a:ln w="12700">
+            <a:solidFill>
+              <a:srgbClr val="D9DEE5"/>
+            </a:solidFill>
+            <a:prstDash val="solid"/>
+          </a:ln>
+        </p:spPr>
+      </p:sp>
+      <p:sp>
+        <p:nvSpPr>
+          <p:cNvPr id="22" name="Shape 20"/>
+          <p:cNvSpPr/>
+          <p:nvPr/>
+        </p:nvSpPr>
+        <p:spPr>
+          <a:xfrm>
+            <a:off x="6263640" y="3611880"/>
+            <a:ext cx="82296" cy="1874520"/>
+          </a:xfrm>
+          <a:prstGeom prst="rect">
+            <a:avLst/>
+          </a:prstGeom>
+          <a:solidFill>
+            <a:srgbClr val="2F7D4A"/>
+          </a:solidFill>
+          <a:ln w="12700">
+            <a:solidFill>
+              <a:srgbClr val="2F7D4A"/>
+            </a:solidFill>
+            <a:prstDash val="solid"/>
+          </a:ln>
+        </p:spPr>
+      </p:sp>
+      <p:sp>
+        <p:nvSpPr>
+          <p:cNvPr id="23" name="Text 21"/>
+          <p:cNvSpPr/>
+          <p:nvPr/>
+        </p:nvSpPr>
+        <p:spPr>
+          <a:xfrm>
+            <a:off x="6483096" y="3776472"/>
+            <a:ext cx="4709160" cy="320040"/>
+          </a:xfrm>
+          <a:prstGeom prst="rect">
+            <a:avLst/>
+          </a:prstGeom>
+          <a:noFill/>
+          <a:ln/>
+        </p:spPr>
+        <p:txBody>
+          <a:bodyPr wrap="square" lIns="0" tIns="0" rIns="0" bIns="0" rtlCol="0" anchor="ctr">
+            <a:normAutofit/>
+          </a:bodyPr>
+          <a:lstStyle/>
+          <a:p>
+            <a:pPr indent="0" marL="0">
+              <a:buNone/>
+            </a:pPr>
+            <a:r>
+              <a:rPr lang="en-US" sz="2100" b="1" dirty="0">
+                <a:solidFill>
+                  <a:srgbClr val="20262E"/>
+                </a:solidFill>
+                <a:latin typeface="Arial" pitchFamily="34" charset="0"/>
+                <a:ea typeface="Arial" pitchFamily="34" charset="-122"/>
+                <a:cs typeface="Arial" pitchFamily="34" charset="-120"/>
+              </a:rPr>
+              <a:t>04  Rerun and compare</a:t>
+            </a:r>
+            <a:endParaRPr lang="en-US" sz="2100" dirty="0"/>
+          </a:p>
+        </p:txBody>
+      </p:sp>
+      <p:sp>
+        <p:nvSpPr>
+          <p:cNvPr id="24" name="Text 22"/>
+          <p:cNvSpPr/>
+          <p:nvPr/>
+        </p:nvSpPr>
+        <p:spPr>
+          <a:xfrm>
+            <a:off x="6483096" y="4178808"/>
+            <a:ext cx="4681728" cy="1143000"/>
+          </a:xfrm>
+          <a:prstGeom prst="rect">
+            <a:avLst/>
+          </a:prstGeom>
+          <a:noFill/>
+          <a:ln/>
+        </p:spPr>
+        <p:txBody>
+          <a:bodyPr wrap="square" lIns="0" tIns="0" rIns="0" bIns="0" rtlCol="0" anchor="t">
+            <a:normAutofit/>
+          </a:bodyPr>
+          <a:lstStyle/>
+          <a:p>
+            <a:pPr indent="0" marL="0">
+              <a:buNone/>
+            </a:pPr>
+            <a:r>
+              <a:rPr lang="en-US" sz="1650" dirty="0">
+                <a:solidFill>
+                  <a:srgbClr val="66717E"/>
+                </a:solidFill>
+                <a:latin typeface="Arial" pitchFamily="34" charset="0"/>
+                <a:ea typeface="Arial" pitchFamily="34" charset="-122"/>
+                <a:cs typeface="Arial" pitchFamily="34" charset="-120"/>
+              </a:rPr>
+              <a:t>Accept only changes supported by the original measurement tool</a:t>
+            </a:r>
+            <a:endParaRPr lang="en-US" sz="1650" dirty="0"/>
+          </a:p>
+        </p:txBody>
+      </p:sp>
+      <p:sp>
+        <p:nvSpPr>
+          <p:cNvPr id="25" name="Shape 23"/>
+          <p:cNvSpPr/>
+          <p:nvPr/>
+        </p:nvSpPr>
+        <p:spPr>
+          <a:xfrm>
+            <a:off x="3337560" y="5870448"/>
+            <a:ext cx="5394960" cy="329184"/>
           </a:xfrm>
           <a:prstGeom prst="roundRect">
             <a:avLst>
@@ -38158,14 +38643,14 @@
       </p:sp>
       <p:sp>
         <p:nvSpPr>
-          <p:cNvPr id="12" name="Text 9"/>
-          <p:cNvSpPr/>
-          <p:nvPr/>
-        </p:nvSpPr>
-        <p:spPr>
-          <a:xfrm>
-            <a:off x="3749040" y="5852160"/>
-            <a:ext cx="4663440" cy="201168"/>
+          <p:cNvPr id="26" name="Text 24"/>
+          <p:cNvSpPr/>
+          <p:nvPr/>
+        </p:nvSpPr>
+        <p:spPr>
+          <a:xfrm>
+            <a:off x="3429000" y="5916168"/>
+            <a:ext cx="5212080" cy="201168"/>
           </a:xfrm>
           <a:prstGeom prst="rect">
             <a:avLst/>
@@ -38197,6 +38682,30 @@
           </a:p>
         </p:txBody>
       </p:sp>
+      <p:pic>
+        <p:nvPicPr>
+          <p:cNvPr id="27" name="Image 0" descr="C:\Users\Asus\.codex\worktrees\final-thesis-defense\financial-accounting\Document\paper\figures\workflow.png">    </p:cNvPr>
+          <p:cNvPicPr>
+            <a:picLocks noChangeAspect="1"/>
+          </p:cNvPicPr>
+          <p:nvPr/>
+        </p:nvPicPr>
+        <p:blipFill>
+          <a:blip r:embed="rId1"/>
+          <a:stretch>
+            <a:fillRect/>
+          </a:stretch>
+        </p:blipFill>
+        <p:spPr>
+          <a:xfrm>
+            <a:off x="10110481" y="5605272"/>
+            <a:ext cx="855959" cy="640080"/>
+          </a:xfrm>
+          <a:prstGeom prst="rect">
+            <a:avLst/>
+          </a:prstGeom>
+        </p:spPr>
+      </p:pic>
     </p:spTree>
   </p:cSld>
   <p:clrMapOvr>

</xml_diff>

<commit_message>
fix: address defense package review findings
</commit_message>
<xml_diff>
--- a/Document/outputs/final-defense/G6519692_Zaw_Ye_Htut_Ko_Final_Thesis_Defense.pptx
+++ b/Document/outputs/final-defense/G6519692_Zaw_Ye_Htut_Ko_Final_Thesis_Defense.pptx
@@ -2602,7 +2602,7 @@
             <a:r>
               <a:rPr lang="en-US" dirty="0"/>
               <a:t>APPENDIX: Open this slide only when the committee asks for endpoint and role coverage.
-EVIDENCE: API scope, pp. 30-32</a:t>
+EVIDENCE: API controller authorization attributes | API scope, pp. 30-32</a:t>
             </a:r>
             <a:endParaRPr lang="en-US" dirty="0"/>
           </a:p>
@@ -11906,12 +11906,12 @@
             <a:tbl>
               <a:tblPr/>
               <a:tblGrid>
-                <a:gridCol w="1417320"/>
-                <a:gridCol w="3154680"/>
-                <a:gridCol w="3154680"/>
+                <a:gridCol w="1737360"/>
                 <a:gridCol w="3063240"/>
+                <a:gridCol w="3063240"/>
+                <a:gridCol w="2926080"/>
               </a:tblGrid>
-              <a:tr h="786384">
+              <a:tr h="822960">
                 <a:tc>
                   <a:txBody>
                     <a:bodyPr/>
@@ -11921,7 +11921,7 @@
                         <a:buNone/>
                       </a:pPr>
                       <a:r>
-                        <a:rPr lang="en-US" sz="1500" b="1" dirty="0">
+                        <a:rPr lang="en-US" sz="2000" b="1" dirty="0">
                           <a:solidFill>
                             <a:srgbClr val="FFFFFF"/>
                           </a:solidFill>
@@ -11931,7 +11931,7 @@
                         </a:rPr>
                         <a:t>Area</a:t>
                       </a:r>
-                      <a:endParaRPr lang="en-US" sz="1500" dirty="0">
+                      <a:endParaRPr lang="en-US" sz="2000" dirty="0">
                         <a:latin typeface="Arial" charset="0"/>
                         <a:ea typeface="Arial" charset="0"/>
                         <a:cs typeface="Arial" charset="0"/>
@@ -11989,7 +11989,7 @@
                         <a:buNone/>
                       </a:pPr>
                       <a:r>
-                        <a:rPr lang="en-US" sz="1500" b="1" dirty="0">
+                        <a:rPr lang="en-US" sz="2000" b="1" dirty="0">
                           <a:solidFill>
                             <a:srgbClr val="FFFFFF"/>
                           </a:solidFill>
@@ -11999,7 +11999,7 @@
                         </a:rPr>
                         <a:t>GPT-5.4</a:t>
                       </a:r>
-                      <a:endParaRPr lang="en-US" sz="1500" dirty="0">
+                      <a:endParaRPr lang="en-US" sz="2000" dirty="0">
                         <a:latin typeface="Arial" charset="0"/>
                         <a:ea typeface="Arial" charset="0"/>
                         <a:cs typeface="Arial" charset="0"/>
@@ -12057,7 +12057,7 @@
                         <a:buNone/>
                       </a:pPr>
                       <a:r>
-                        <a:rPr lang="en-US" sz="1500" b="1" dirty="0">
+                        <a:rPr lang="en-US" sz="2000" b="1" dirty="0">
                           <a:solidFill>
                             <a:srgbClr val="FFFFFF"/>
                           </a:solidFill>
@@ -12067,7 +12067,7 @@
                         </a:rPr>
                         <a:t>GPT-5.5</a:t>
                       </a:r>
-                      <a:endParaRPr lang="en-US" sz="1500" dirty="0">
+                      <a:endParaRPr lang="en-US" sz="2000" dirty="0">
                         <a:latin typeface="Arial" charset="0"/>
                         <a:ea typeface="Arial" charset="0"/>
                         <a:cs typeface="Arial" charset="0"/>
@@ -12125,7 +12125,7 @@
                         <a:buNone/>
                       </a:pPr>
                       <a:r>
-                        <a:rPr lang="en-US" sz="1500" b="1" dirty="0">
+                        <a:rPr lang="en-US" sz="2000" b="1" dirty="0">
                           <a:solidFill>
                             <a:srgbClr val="FFFFFF"/>
                           </a:solidFill>
@@ -12135,7 +12135,7 @@
                         </a:rPr>
                         <a:t>Reading</a:t>
                       </a:r>
-                      <a:endParaRPr lang="en-US" sz="1500" dirty="0">
+                      <a:endParaRPr lang="en-US" sz="2000" dirty="0">
                         <a:latin typeface="Arial" charset="0"/>
                         <a:ea typeface="Arial" charset="0"/>
                         <a:cs typeface="Arial" charset="0"/>
@@ -12185,7 +12185,7 @@
                   </a:tcPr>
                 </a:tc>
               </a:tr>
-              <a:tr h="786384">
+              <a:tr h="822960">
                 <a:tc>
                   <a:txBody>
                     <a:bodyPr/>
@@ -12195,7 +12195,7 @@
                         <a:buNone/>
                       </a:pPr>
                       <a:r>
-                        <a:rPr lang="en-US" sz="1500" dirty="0">
+                        <a:rPr lang="en-US" sz="2000" dirty="0">
                           <a:solidFill>
                             <a:srgbClr val="20262E"/>
                           </a:solidFill>
@@ -12205,7 +12205,7 @@
                         </a:rPr>
                         <a:t>SonarQube</a:t>
                       </a:r>
-                      <a:endParaRPr lang="en-US" sz="1500" dirty="0">
+                      <a:endParaRPr lang="en-US" sz="2000" dirty="0">
                         <a:latin typeface="Arial" charset="0"/>
                         <a:ea typeface="Arial" charset="0"/>
                         <a:cs typeface="Arial" charset="0"/>
@@ -12263,7 +12263,7 @@
                         <a:buNone/>
                       </a:pPr>
                       <a:r>
-                        <a:rPr lang="en-US" sz="1500" dirty="0">
+                        <a:rPr lang="en-US" sz="2000" dirty="0">
                           <a:solidFill>
                             <a:srgbClr val="20262E"/>
                           </a:solidFill>
@@ -12271,9 +12271,9 @@
                           <a:ea typeface="Arial" pitchFamily="34" charset="-122"/>
                           <a:cs typeface="Arial" pitchFamily="34" charset="-120"/>
                         </a:rPr>
-                        <a:t>0 code smells; 74.3% coverage</a:t>
+                        <a:t>0 smells; 74.3%</a:t>
                       </a:r>
-                      <a:endParaRPr lang="en-US" sz="1500" dirty="0">
+                      <a:endParaRPr lang="en-US" sz="2000" dirty="0">
                         <a:latin typeface="Arial" charset="0"/>
                         <a:ea typeface="Arial" charset="0"/>
                         <a:cs typeface="Arial" charset="0"/>
@@ -12331,7 +12331,7 @@
                         <a:buNone/>
                       </a:pPr>
                       <a:r>
-                        <a:rPr lang="en-US" sz="1500" dirty="0">
+                        <a:rPr lang="en-US" sz="2000" dirty="0">
                           <a:solidFill>
                             <a:srgbClr val="20262E"/>
                           </a:solidFill>
@@ -12339,9 +12339,9 @@
                           <a:ea typeface="Arial" pitchFamily="34" charset="-122"/>
                           <a:cs typeface="Arial" pitchFamily="34" charset="-120"/>
                         </a:rPr>
-                        <a:t>0 code smells; 74.3% coverage</a:t>
+                        <a:t>0 smells; 74.3%</a:t>
                       </a:r>
-                      <a:endParaRPr lang="en-US" sz="1500" dirty="0">
+                      <a:endParaRPr lang="en-US" sz="2000" dirty="0">
                         <a:latin typeface="Arial" charset="0"/>
                         <a:ea typeface="Arial" charset="0"/>
                         <a:cs typeface="Arial" charset="0"/>
@@ -12399,7 +12399,7 @@
                         <a:buNone/>
                       </a:pPr>
                       <a:r>
-                        <a:rPr lang="en-US" sz="1500" dirty="0">
+                        <a:rPr lang="en-US" sz="2000" dirty="0">
                           <a:solidFill>
                             <a:srgbClr val="20262E"/>
                           </a:solidFill>
@@ -12409,7 +12409,7 @@
                         </a:rPr>
                         <a:t>Tie</a:t>
                       </a:r>
-                      <a:endParaRPr lang="en-US" sz="1500" dirty="0">
+                      <a:endParaRPr lang="en-US" sz="2000" dirty="0">
                         <a:latin typeface="Arial" charset="0"/>
                         <a:ea typeface="Arial" charset="0"/>
                         <a:cs typeface="Arial" charset="0"/>
@@ -12459,7 +12459,7 @@
                   </a:tcPr>
                 </a:tc>
               </a:tr>
-              <a:tr h="786384">
+              <a:tr h="822960">
                 <a:tc>
                   <a:txBody>
                     <a:bodyPr/>
@@ -12469,7 +12469,7 @@
                         <a:buNone/>
                       </a:pPr>
                       <a:r>
-                        <a:rPr lang="en-US" sz="1500" dirty="0">
+                        <a:rPr lang="en-US" sz="2000" dirty="0">
                           <a:solidFill>
                             <a:srgbClr val="20262E"/>
                           </a:solidFill>
@@ -12479,7 +12479,7 @@
                         </a:rPr>
                         <a:t>ZAP</a:t>
                       </a:r>
-                      <a:endParaRPr lang="en-US" sz="1500" dirty="0">
+                      <a:endParaRPr lang="en-US" sz="2000" dirty="0">
                         <a:latin typeface="Arial" charset="0"/>
                         <a:ea typeface="Arial" charset="0"/>
                         <a:cs typeface="Arial" charset="0"/>
@@ -12537,7 +12537,7 @@
                         <a:buNone/>
                       </a:pPr>
                       <a:r>
-                        <a:rPr lang="en-US" sz="1500" dirty="0">
+                        <a:rPr lang="en-US" sz="2000" dirty="0">
                           <a:solidFill>
                             <a:srgbClr val="20262E"/>
                           </a:solidFill>
@@ -12545,9 +12545,9 @@
                           <a:ea typeface="Arial" pitchFamily="34" charset="-122"/>
                           <a:cs typeface="Arial" pitchFamily="34" charset="-120"/>
                         </a:rPr>
-                        <a:t>Cleaner residual output</a:t>
+                        <a:t>Cleaner residuals</a:t>
                       </a:r>
-                      <a:endParaRPr lang="en-US" sz="1500" dirty="0">
+                      <a:endParaRPr lang="en-US" sz="2000" dirty="0">
                         <a:latin typeface="Arial" charset="0"/>
                         <a:ea typeface="Arial" charset="0"/>
                         <a:cs typeface="Arial" charset="0"/>
@@ -12605,7 +12605,7 @@
                         <a:buNone/>
                       </a:pPr>
                       <a:r>
-                        <a:rPr lang="en-US" sz="1500" dirty="0">
+                        <a:rPr lang="en-US" sz="2000" dirty="0">
                           <a:solidFill>
                             <a:srgbClr val="20262E"/>
                           </a:solidFill>
@@ -12613,9 +12613,9 @@
                           <a:ea typeface="Arial" pitchFamily="34" charset="-122"/>
                           <a:cs typeface="Arial" pitchFamily="34" charset="-120"/>
                         </a:rPr>
-                        <a:t>Business gate passes; more residuals</a:t>
+                        <a:t>Gate pass; more residuals</a:t>
                       </a:r>
-                      <a:endParaRPr lang="en-US" sz="1500" dirty="0">
+                      <a:endParaRPr lang="en-US" sz="2000" dirty="0">
                         <a:latin typeface="Arial" charset="0"/>
                         <a:ea typeface="Arial" charset="0"/>
                         <a:cs typeface="Arial" charset="0"/>
@@ -12673,7 +12673,7 @@
                         <a:buNone/>
                       </a:pPr>
                       <a:r>
-                        <a:rPr lang="en-US" sz="1500" dirty="0">
+                        <a:rPr lang="en-US" sz="2000" dirty="0">
                           <a:solidFill>
                             <a:srgbClr val="20262E"/>
                           </a:solidFill>
@@ -12683,7 +12683,7 @@
                         </a:rPr>
                         <a:t>GPT-5.4 cleaner</a:t>
                       </a:r>
-                      <a:endParaRPr lang="en-US" sz="1500" dirty="0">
+                      <a:endParaRPr lang="en-US" sz="2000" dirty="0">
                         <a:latin typeface="Arial" charset="0"/>
                         <a:ea typeface="Arial" charset="0"/>
                         <a:cs typeface="Arial" charset="0"/>
@@ -12733,7 +12733,7 @@
                   </a:tcPr>
                 </a:tc>
               </a:tr>
-              <a:tr h="786384">
+              <a:tr h="822960">
                 <a:tc>
                   <a:txBody>
                     <a:bodyPr/>
@@ -12743,7 +12743,7 @@
                         <a:buNone/>
                       </a:pPr>
                       <a:r>
-                        <a:rPr lang="en-US" sz="1500" dirty="0">
+                        <a:rPr lang="en-US" sz="2000" dirty="0">
                           <a:solidFill>
                             <a:srgbClr val="20262E"/>
                           </a:solidFill>
@@ -12753,7 +12753,7 @@
                         </a:rPr>
                         <a:t>JMeter</a:t>
                       </a:r>
-                      <a:endParaRPr lang="en-US" sz="1500" dirty="0">
+                      <a:endParaRPr lang="en-US" sz="2000" dirty="0">
                         <a:latin typeface="Arial" charset="0"/>
                         <a:ea typeface="Arial" charset="0"/>
                         <a:cs typeface="Arial" charset="0"/>
@@ -12811,7 +12811,7 @@
                         <a:buNone/>
                       </a:pPr>
                       <a:r>
-                        <a:rPr lang="en-US" sz="1500" dirty="0">
+                        <a:rPr lang="en-US" sz="2000" dirty="0">
                           <a:solidFill>
                             <a:srgbClr val="20262E"/>
                           </a:solidFill>
@@ -12819,9 +12819,9 @@
                           <a:ea typeface="Arial" pitchFamily="34" charset="-122"/>
                           <a:cs typeface="Arial" pitchFamily="34" charset="-120"/>
                         </a:rPr>
-                        <a:t>Selected tail wins; p50 regression</a:t>
+                        <a:t>Tail wins; p50 regression</a:t>
                       </a:r>
-                      <a:endParaRPr lang="en-US" sz="1500" dirty="0">
+                      <a:endParaRPr lang="en-US" sz="2000" dirty="0">
                         <a:latin typeface="Arial" charset="0"/>
                         <a:ea typeface="Arial" charset="0"/>
                         <a:cs typeface="Arial" charset="0"/>
@@ -12879,7 +12879,7 @@
                         <a:buNone/>
                       </a:pPr>
                       <a:r>
-                        <a:rPr lang="en-US" sz="1500" dirty="0">
+                        <a:rPr lang="en-US" sz="2000" dirty="0">
                           <a:solidFill>
                             <a:srgbClr val="20262E"/>
                           </a:solidFill>
@@ -12887,9 +12887,9 @@
                           <a:ea typeface="Arial" pitchFamily="34" charset="-122"/>
                           <a:cs typeface="Arial" pitchFamily="34" charset="-120"/>
                         </a:rPr>
-                        <a:t>Balanced profiles; best spike tail</a:t>
+                        <a:t>Balanced; best spike tail</a:t>
                       </a:r>
-                      <a:endParaRPr lang="en-US" sz="1500" dirty="0">
+                      <a:endParaRPr lang="en-US" sz="2000" dirty="0">
                         <a:latin typeface="Arial" charset="0"/>
                         <a:ea typeface="Arial" charset="0"/>
                         <a:cs typeface="Arial" charset="0"/>
@@ -12947,7 +12947,7 @@
                         <a:buNone/>
                       </a:pPr>
                       <a:r>
-                        <a:rPr lang="en-US" sz="1500" dirty="0">
+                        <a:rPr lang="en-US" sz="2000" dirty="0">
                           <a:solidFill>
                             <a:srgbClr val="20262E"/>
                           </a:solidFill>
@@ -12957,7 +12957,7 @@
                         </a:rPr>
                         <a:t>GPT-5.5 balanced</a:t>
                       </a:r>
-                      <a:endParaRPr lang="en-US" sz="1500" dirty="0">
+                      <a:endParaRPr lang="en-US" sz="2000" dirty="0">
                         <a:latin typeface="Arial" charset="0"/>
                         <a:ea typeface="Arial" charset="0"/>
                         <a:cs typeface="Arial" charset="0"/>
@@ -13007,7 +13007,7 @@
                   </a:tcPr>
                 </a:tc>
               </a:tr>
-              <a:tr h="786384">
+              <a:tr h="822960">
                 <a:tc>
                   <a:txBody>
                     <a:bodyPr/>
@@ -13017,7 +13017,7 @@
                         <a:buNone/>
                       </a:pPr>
                       <a:r>
-                        <a:rPr lang="en-US" sz="1500" dirty="0">
+                        <a:rPr lang="en-US" sz="2000" dirty="0">
                           <a:solidFill>
                             <a:srgbClr val="20262E"/>
                           </a:solidFill>
@@ -13025,9 +13025,9 @@
                           <a:ea typeface="Arial" pitchFamily="34" charset="-122"/>
                           <a:cs typeface="Arial" pitchFamily="34" charset="-120"/>
                         </a:rPr>
-                        <a:t>Patch size</a:t>
+                        <a:t>Patch files</a:t>
                       </a:r>
-                      <a:endParaRPr lang="en-US" sz="1500" dirty="0">
+                      <a:endParaRPr lang="en-US" sz="2000" dirty="0">
                         <a:latin typeface="Arial" charset="0"/>
                         <a:ea typeface="Arial" charset="0"/>
                         <a:cs typeface="Arial" charset="0"/>
@@ -13085,7 +13085,7 @@
                         <a:buNone/>
                       </a:pPr>
                       <a:r>
-                        <a:rPr lang="en-US" sz="1500" dirty="0">
+                        <a:rPr lang="en-US" sz="2000" dirty="0">
                           <a:solidFill>
                             <a:srgbClr val="20262E"/>
                           </a:solidFill>
@@ -13093,9 +13093,9 @@
                           <a:ea typeface="Arial" pitchFamily="34" charset="-122"/>
                           <a:cs typeface="Arial" pitchFamily="34" charset="-120"/>
                         </a:rPr>
-                        <a:t>Larger</a:t>
+                        <a:t>13 / 7 / 13</a:t>
                       </a:r>
-                      <a:endParaRPr lang="en-US" sz="1500" dirty="0">
+                      <a:endParaRPr lang="en-US" sz="2000" dirty="0">
                         <a:latin typeface="Arial" charset="0"/>
                         <a:ea typeface="Arial" charset="0"/>
                         <a:cs typeface="Arial" charset="0"/>
@@ -13153,7 +13153,7 @@
                         <a:buNone/>
                       </a:pPr>
                       <a:r>
-                        <a:rPr lang="en-US" sz="1500" dirty="0">
+                        <a:rPr lang="en-US" sz="2000" dirty="0">
                           <a:solidFill>
                             <a:srgbClr val="20262E"/>
                           </a:solidFill>
@@ -13161,9 +13161,9 @@
                           <a:ea typeface="Arial" pitchFamily="34" charset="-122"/>
                           <a:cs typeface="Arial" pitchFamily="34" charset="-120"/>
                         </a:rPr>
-                        <a:t>Smaller</a:t>
+                        <a:t>13 / 4 / 8</a:t>
                       </a:r>
-                      <a:endParaRPr lang="en-US" sz="1500" dirty="0">
+                      <a:endParaRPr lang="en-US" sz="2000" dirty="0">
                         <a:latin typeface="Arial" charset="0"/>
                         <a:ea typeface="Arial" charset="0"/>
                         <a:cs typeface="Arial" charset="0"/>
@@ -13221,7 +13221,7 @@
                         <a:buNone/>
                       </a:pPr>
                       <a:r>
-                        <a:rPr lang="en-US" sz="1500" dirty="0">
+                        <a:rPr lang="en-US" sz="2000" dirty="0">
                           <a:solidFill>
                             <a:srgbClr val="20262E"/>
                           </a:solidFill>
@@ -13229,9 +13229,9 @@
                           <a:ea typeface="Arial" pitchFamily="34" charset="-122"/>
                           <a:cs typeface="Arial" pitchFamily="34" charset="-120"/>
                         </a:rPr>
-                        <a:t>GPT-5.5 lower change risk</a:t>
+                        <a:t>GPT-5.5 smaller</a:t>
                       </a:r>
-                      <a:endParaRPr lang="en-US" sz="1500" dirty="0">
+                      <a:endParaRPr lang="en-US" sz="2000" dirty="0">
                         <a:latin typeface="Arial" charset="0"/>
                         <a:ea typeface="Arial" charset="0"/>
                         <a:cs typeface="Arial" charset="0"/>
@@ -13579,7 +13579,7 @@
                 <a:gridCol w="3337560"/>
                 <a:gridCol w="3337560"/>
               </a:tblGrid>
-              <a:tr h="658368">
+              <a:tr h="713232">
                 <a:tc>
                   <a:txBody>
                     <a:bodyPr/>
@@ -13589,7 +13589,7 @@
                         <a:buNone/>
                       </a:pPr>
                       <a:r>
-                        <a:rPr lang="en-US" sz="1600" b="1" dirty="0">
+                        <a:rPr lang="en-US" sz="2000" b="1" dirty="0">
                           <a:solidFill>
                             <a:srgbClr val="FFFFFF"/>
                           </a:solidFill>
@@ -13599,7 +13599,7 @@
                         </a:rPr>
                         <a:t>Measure</a:t>
                       </a:r>
-                      <a:endParaRPr lang="en-US" sz="1600" dirty="0">
+                      <a:endParaRPr lang="en-US" sz="2000" dirty="0">
                         <a:latin typeface="Arial" charset="0"/>
                         <a:ea typeface="Arial" charset="0"/>
                         <a:cs typeface="Arial" charset="0"/>
@@ -13657,7 +13657,7 @@
                         <a:buNone/>
                       </a:pPr>
                       <a:r>
-                        <a:rPr lang="en-US" sz="1600" b="1" dirty="0">
+                        <a:rPr lang="en-US" sz="2000" b="1" dirty="0">
                           <a:solidFill>
                             <a:srgbClr val="FFFFFF"/>
                           </a:solidFill>
@@ -13667,7 +13667,7 @@
                         </a:rPr>
                         <a:t>GPT-5.4</a:t>
                       </a:r>
-                      <a:endParaRPr lang="en-US" sz="1600" dirty="0">
+                      <a:endParaRPr lang="en-US" sz="2000" dirty="0">
                         <a:latin typeface="Arial" charset="0"/>
                         <a:ea typeface="Arial" charset="0"/>
                         <a:cs typeface="Arial" charset="0"/>
@@ -13725,7 +13725,7 @@
                         <a:buNone/>
                       </a:pPr>
                       <a:r>
-                        <a:rPr lang="en-US" sz="1600" b="1" dirty="0">
+                        <a:rPr lang="en-US" sz="2000" b="1" dirty="0">
                           <a:solidFill>
                             <a:srgbClr val="FFFFFF"/>
                           </a:solidFill>
@@ -13735,7 +13735,7 @@
                         </a:rPr>
                         <a:t>GPT-5.5</a:t>
                       </a:r>
-                      <a:endParaRPr lang="en-US" sz="1600" dirty="0">
+                      <a:endParaRPr lang="en-US" sz="2000" dirty="0">
                         <a:latin typeface="Arial" charset="0"/>
                         <a:ea typeface="Arial" charset="0"/>
                         <a:cs typeface="Arial" charset="0"/>
@@ -13785,7 +13785,7 @@
                   </a:tcPr>
                 </a:tc>
               </a:tr>
-              <a:tr h="658368">
+              <a:tr h="713232">
                 <a:tc>
                   <a:txBody>
                     <a:bodyPr/>
@@ -13795,7 +13795,7 @@
                         <a:buNone/>
                       </a:pPr>
                       <a:r>
-                        <a:rPr lang="en-US" sz="1600" dirty="0">
+                        <a:rPr lang="en-US" sz="2000" dirty="0">
                           <a:solidFill>
                             <a:srgbClr val="20262E"/>
                           </a:solidFill>
@@ -13805,7 +13805,7 @@
                         </a:rPr>
                         <a:t>Sonar issues</a:t>
                       </a:r>
-                      <a:endParaRPr lang="en-US" sz="1600" dirty="0">
+                      <a:endParaRPr lang="en-US" sz="2000" dirty="0">
                         <a:latin typeface="Arial" charset="0"/>
                         <a:ea typeface="Arial" charset="0"/>
                         <a:cs typeface="Arial" charset="0"/>
@@ -13863,7 +13863,7 @@
                         <a:buNone/>
                       </a:pPr>
                       <a:r>
-                        <a:rPr lang="en-US" sz="1600" dirty="0">
+                        <a:rPr lang="en-US" sz="2000" dirty="0">
                           <a:solidFill>
                             <a:srgbClr val="20262E"/>
                           </a:solidFill>
@@ -13873,7 +13873,7 @@
                         </a:rPr>
                         <a:t>0</a:t>
                       </a:r>
-                      <a:endParaRPr lang="en-US" sz="1600" dirty="0">
+                      <a:endParaRPr lang="en-US" sz="2000" dirty="0">
                         <a:latin typeface="Arial" charset="0"/>
                         <a:ea typeface="Arial" charset="0"/>
                         <a:cs typeface="Arial" charset="0"/>
@@ -13931,7 +13931,7 @@
                         <a:buNone/>
                       </a:pPr>
                       <a:r>
-                        <a:rPr lang="en-US" sz="1600" dirty="0">
+                        <a:rPr lang="en-US" sz="2000" dirty="0">
                           <a:solidFill>
                             <a:srgbClr val="20262E"/>
                           </a:solidFill>
@@ -13941,7 +13941,7 @@
                         </a:rPr>
                         <a:t>0</a:t>
                       </a:r>
-                      <a:endParaRPr lang="en-US" sz="1600" dirty="0">
+                      <a:endParaRPr lang="en-US" sz="2000" dirty="0">
                         <a:latin typeface="Arial" charset="0"/>
                         <a:ea typeface="Arial" charset="0"/>
                         <a:cs typeface="Arial" charset="0"/>
@@ -13991,7 +13991,7 @@
                   </a:tcPr>
                 </a:tc>
               </a:tr>
-              <a:tr h="658368">
+              <a:tr h="713232">
                 <a:tc>
                   <a:txBody>
                     <a:bodyPr/>
@@ -14001,7 +14001,7 @@
                         <a:buNone/>
                       </a:pPr>
                       <a:r>
-                        <a:rPr lang="en-US" sz="1600" dirty="0">
+                        <a:rPr lang="en-US" sz="2000" dirty="0">
                           <a:solidFill>
                             <a:srgbClr val="20262E"/>
                           </a:solidFill>
@@ -14011,7 +14011,7 @@
                         </a:rPr>
                         <a:t>Coverage</a:t>
                       </a:r>
-                      <a:endParaRPr lang="en-US" sz="1600" dirty="0">
+                      <a:endParaRPr lang="en-US" sz="2000" dirty="0">
                         <a:latin typeface="Arial" charset="0"/>
                         <a:ea typeface="Arial" charset="0"/>
                         <a:cs typeface="Arial" charset="0"/>
@@ -14069,7 +14069,7 @@
                         <a:buNone/>
                       </a:pPr>
                       <a:r>
-                        <a:rPr lang="en-US" sz="1600" dirty="0">
+                        <a:rPr lang="en-US" sz="2000" dirty="0">
                           <a:solidFill>
                             <a:srgbClr val="20262E"/>
                           </a:solidFill>
@@ -14079,7 +14079,7 @@
                         </a:rPr>
                         <a:t>76.2%</a:t>
                       </a:r>
-                      <a:endParaRPr lang="en-US" sz="1600" dirty="0">
+                      <a:endParaRPr lang="en-US" sz="2000" dirty="0">
                         <a:latin typeface="Arial" charset="0"/>
                         <a:ea typeface="Arial" charset="0"/>
                         <a:cs typeface="Arial" charset="0"/>
@@ -14137,7 +14137,7 @@
                         <a:buNone/>
                       </a:pPr>
                       <a:r>
-                        <a:rPr lang="en-US" sz="1600" dirty="0">
+                        <a:rPr lang="en-US" sz="2000" dirty="0">
                           <a:solidFill>
                             <a:srgbClr val="20262E"/>
                           </a:solidFill>
@@ -14147,7 +14147,7 @@
                         </a:rPr>
                         <a:t>74.8%</a:t>
                       </a:r>
-                      <a:endParaRPr lang="en-US" sz="1600" dirty="0">
+                      <a:endParaRPr lang="en-US" sz="2000" dirty="0">
                         <a:latin typeface="Arial" charset="0"/>
                         <a:ea typeface="Arial" charset="0"/>
                         <a:cs typeface="Arial" charset="0"/>
@@ -14197,7 +14197,7 @@
                   </a:tcPr>
                 </a:tc>
               </a:tr>
-              <a:tr h="658368">
+              <a:tr h="713232">
                 <a:tc>
                   <a:txBody>
                     <a:bodyPr/>
@@ -14207,7 +14207,7 @@
                         <a:buNone/>
                       </a:pPr>
                       <a:r>
-                        <a:rPr lang="en-US" sz="1600" dirty="0">
+                        <a:rPr lang="en-US" sz="2000" dirty="0">
                           <a:solidFill>
                             <a:srgbClr val="20262E"/>
                           </a:solidFill>
@@ -14217,7 +14217,7 @@
                         </a:rPr>
                         <a:t>ZAP verified alerts</a:t>
                       </a:r>
-                      <a:endParaRPr lang="en-US" sz="1600" dirty="0">
+                      <a:endParaRPr lang="en-US" sz="2000" dirty="0">
                         <a:latin typeface="Arial" charset="0"/>
                         <a:ea typeface="Arial" charset="0"/>
                         <a:cs typeface="Arial" charset="0"/>
@@ -14275,7 +14275,7 @@
                         <a:buNone/>
                       </a:pPr>
                       <a:r>
-                        <a:rPr lang="en-US" sz="1600" dirty="0">
+                        <a:rPr lang="en-US" sz="2000" dirty="0">
                           <a:solidFill>
                             <a:srgbClr val="20262E"/>
                           </a:solidFill>
@@ -14285,7 +14285,7 @@
                         </a:rPr>
                         <a:t>12</a:t>
                       </a:r>
-                      <a:endParaRPr lang="en-US" sz="1600" dirty="0">
+                      <a:endParaRPr lang="en-US" sz="2000" dirty="0">
                         <a:latin typeface="Arial" charset="0"/>
                         <a:ea typeface="Arial" charset="0"/>
                         <a:cs typeface="Arial" charset="0"/>
@@ -14343,7 +14343,7 @@
                         <a:buNone/>
                       </a:pPr>
                       <a:r>
-                        <a:rPr lang="en-US" sz="1600" dirty="0">
+                        <a:rPr lang="en-US" sz="2000" dirty="0">
                           <a:solidFill>
                             <a:srgbClr val="20262E"/>
                           </a:solidFill>
@@ -14353,7 +14353,7 @@
                         </a:rPr>
                         <a:t>12</a:t>
                       </a:r>
-                      <a:endParaRPr lang="en-US" sz="1600" dirty="0">
+                      <a:endParaRPr lang="en-US" sz="2000" dirty="0">
                         <a:latin typeface="Arial" charset="0"/>
                         <a:ea typeface="Arial" charset="0"/>
                         <a:cs typeface="Arial" charset="0"/>
@@ -14403,7 +14403,7 @@
                   </a:tcPr>
                 </a:tc>
               </a:tr>
-              <a:tr h="658368">
+              <a:tr h="713232">
                 <a:tc>
                   <a:txBody>
                     <a:bodyPr/>
@@ -14413,7 +14413,7 @@
                         <a:buNone/>
                       </a:pPr>
                       <a:r>
-                        <a:rPr lang="en-US" sz="1600" dirty="0">
+                        <a:rPr lang="en-US" sz="2000" dirty="0">
                           <a:solidFill>
                             <a:srgbClr val="20262E"/>
                           </a:solidFill>
@@ -14423,7 +14423,7 @@
                         </a:rPr>
                         <a:t>Public tests</a:t>
                       </a:r>
-                      <a:endParaRPr lang="en-US" sz="1600" dirty="0">
+                      <a:endParaRPr lang="en-US" sz="2000" dirty="0">
                         <a:latin typeface="Arial" charset="0"/>
                         <a:ea typeface="Arial" charset="0"/>
                         <a:cs typeface="Arial" charset="0"/>
@@ -14481,7 +14481,7 @@
                         <a:buNone/>
                       </a:pPr>
                       <a:r>
-                        <a:rPr lang="en-US" sz="1600" dirty="0">
+                        <a:rPr lang="en-US" sz="2000" dirty="0">
                           <a:solidFill>
                             <a:srgbClr val="20262E"/>
                           </a:solidFill>
@@ -14491,7 +14491,7 @@
                         </a:rPr>
                         <a:t>152 passed</a:t>
                       </a:r>
-                      <a:endParaRPr lang="en-US" sz="1600" dirty="0">
+                      <a:endParaRPr lang="en-US" sz="2000" dirty="0">
                         <a:latin typeface="Arial" charset="0"/>
                         <a:ea typeface="Arial" charset="0"/>
                         <a:cs typeface="Arial" charset="0"/>
@@ -14549,7 +14549,7 @@
                         <a:buNone/>
                       </a:pPr>
                       <a:r>
-                        <a:rPr lang="en-US" sz="1600" dirty="0">
+                        <a:rPr lang="en-US" sz="2000" dirty="0">
                           <a:solidFill>
                             <a:srgbClr val="20262E"/>
                           </a:solidFill>
@@ -14559,7 +14559,7 @@
                         </a:rPr>
                         <a:t>151 passed</a:t>
                       </a:r>
-                      <a:endParaRPr lang="en-US" sz="1600" dirty="0">
+                      <a:endParaRPr lang="en-US" sz="2000" dirty="0">
                         <a:latin typeface="Arial" charset="0"/>
                         <a:ea typeface="Arial" charset="0"/>
                         <a:cs typeface="Arial" charset="0"/>
@@ -14609,7 +14609,7 @@
                   </a:tcPr>
                 </a:tc>
               </a:tr>
-              <a:tr h="658368">
+              <a:tr h="713232">
                 <a:tc>
                   <a:txBody>
                     <a:bodyPr/>
@@ -14619,7 +14619,7 @@
                         <a:buNone/>
                       </a:pPr>
                       <a:r>
-                        <a:rPr lang="en-US" sz="1600" dirty="0">
+                        <a:rPr lang="en-US" sz="2000" dirty="0">
                           <a:solidFill>
                             <a:srgbClr val="20262E"/>
                           </a:solidFill>
@@ -14629,7 +14629,7 @@
                         </a:rPr>
                         <a:t>JMeter</a:t>
                       </a:r>
-                      <a:endParaRPr lang="en-US" sz="1600" dirty="0">
+                      <a:endParaRPr lang="en-US" sz="2000" dirty="0">
                         <a:latin typeface="Arial" charset="0"/>
                         <a:ea typeface="Arial" charset="0"/>
                         <a:cs typeface="Arial" charset="0"/>
@@ -14687,7 +14687,7 @@
                         <a:buNone/>
                       </a:pPr>
                       <a:r>
-                        <a:rPr lang="en-US" sz="1600" dirty="0">
+                        <a:rPr lang="en-US" sz="2000" dirty="0">
                           <a:solidFill>
                             <a:srgbClr val="20262E"/>
                           </a:solidFill>
@@ -14697,7 +14697,7 @@
                         </a:rPr>
                         <a:t>No valid candidate</a:t>
                       </a:r>
-                      <a:endParaRPr lang="en-US" sz="1600" dirty="0">
+                      <a:endParaRPr lang="en-US" sz="2000" dirty="0">
                         <a:latin typeface="Arial" charset="0"/>
                         <a:ea typeface="Arial" charset="0"/>
                         <a:cs typeface="Arial" charset="0"/>
@@ -14755,7 +14755,7 @@
                         <a:buNone/>
                       </a:pPr>
                       <a:r>
-                        <a:rPr lang="en-US" sz="1600" dirty="0">
+                        <a:rPr lang="en-US" sz="2000" dirty="0">
                           <a:solidFill>
                             <a:srgbClr val="20262E"/>
                           </a:solidFill>
@@ -14765,7 +14765,7 @@
                         </a:rPr>
                         <a:t>Frozen candidate</a:t>
                       </a:r>
-                      <a:endParaRPr lang="en-US" sz="1600" dirty="0">
+                      <a:endParaRPr lang="en-US" sz="2000" dirty="0">
                         <a:latin typeface="Arial" charset="0"/>
                         <a:ea typeface="Arial" charset="0"/>
                         <a:cs typeface="Arial" charset="0"/>
@@ -16584,7 +16584,7 @@
               <a:buNone/>
             </a:pPr>
             <a:r>
-              <a:rPr lang="en-US" sz="1550" b="1" dirty="0">
+              <a:rPr lang="en-US" sz="2000" b="1" dirty="0">
                 <a:solidFill>
                   <a:srgbClr val="B93A3A"/>
                 </a:solidFill>
@@ -16594,7 +16594,7 @@
               </a:rPr>
               <a:t>One C# API and local SQL Server</a:t>
             </a:r>
-            <a:endParaRPr lang="en-US" sz="1550" dirty="0"/>
+            <a:endParaRPr lang="en-US" sz="2000" dirty="0"/>
           </a:p>
         </p:txBody>
       </p:sp>
@@ -16650,7 +16650,7 @@
               <a:buNone/>
             </a:pPr>
             <a:r>
-              <a:rPr lang="en-US" sz="1550" b="1" dirty="0">
+              <a:rPr lang="en-US" sz="2000" b="1" dirty="0">
                 <a:solidFill>
                   <a:srgbClr val="2F7D4A"/>
                 </a:solidFill>
@@ -16658,9 +16658,9 @@
                 <a:ea typeface="Arial" pitchFamily="34" charset="-122"/>
                 <a:cs typeface="Arial" pitchFamily="34" charset="-120"/>
               </a:rPr>
-              <a:t>Replicate across frameworks, domains, and cloud environments</a:t>
+              <a:t>Replicate other stacks and clouds</a:t>
             </a:r>
-            <a:endParaRPr lang="en-US" sz="1550" dirty="0"/>
+            <a:endParaRPr lang="en-US" sz="2000" dirty="0"/>
           </a:p>
         </p:txBody>
       </p:sp>
@@ -16745,7 +16745,7 @@
               <a:buNone/>
             </a:pPr>
             <a:r>
-              <a:rPr lang="en-US" sz="1550" b="1" dirty="0">
+              <a:rPr lang="en-US" sz="2000" b="1" dirty="0">
                 <a:solidFill>
                   <a:srgbClr val="B93A3A"/>
                 </a:solidFill>
@@ -16753,9 +16753,9 @@
                 <a:ea typeface="Arial" pitchFamily="34" charset="-122"/>
                 <a:cs typeface="Arial" pitchFamily="34" charset="-120"/>
               </a:rPr>
-              <a:t>No repeated stochastic model runs</a:t>
+              <a:t>No repeated stochastic runs</a:t>
             </a:r>
-            <a:endParaRPr lang="en-US" sz="1550" dirty="0"/>
+            <a:endParaRPr lang="en-US" sz="2000" dirty="0"/>
           </a:p>
         </p:txBody>
       </p:sp>
@@ -16811,7 +16811,7 @@
               <a:buNone/>
             </a:pPr>
             <a:r>
-              <a:rPr lang="en-US" sz="1550" b="1" dirty="0">
+              <a:rPr lang="en-US" sz="2000" b="1" dirty="0">
                 <a:solidFill>
                   <a:srgbClr val="2F7D4A"/>
                 </a:solidFill>
@@ -16819,9 +16819,9 @@
                 <a:ea typeface="Arial" pitchFamily="34" charset="-122"/>
                 <a:cs typeface="Arial" pitchFamily="34" charset="-120"/>
               </a:rPr>
-              <a:t>Estimate output variance across repeated prompts</a:t>
+              <a:t>Repeat prompts and estimate variance</a:t>
             </a:r>
-            <a:endParaRPr lang="en-US" sz="1550" dirty="0"/>
+            <a:endParaRPr lang="en-US" sz="2000" dirty="0"/>
           </a:p>
         </p:txBody>
       </p:sp>
@@ -16906,7 +16906,7 @@
               <a:buNone/>
             </a:pPr>
             <a:r>
-              <a:rPr lang="en-US" sz="1550" b="1" dirty="0">
+              <a:rPr lang="en-US" sz="2000" b="1" dirty="0">
                 <a:solidFill>
                   <a:srgbClr val="B93A3A"/>
                 </a:solidFill>
@@ -16916,7 +16916,7 @@
               </a:rPr>
               <a:t>Tool-specific detection limits</a:t>
             </a:r>
-            <a:endParaRPr lang="en-US" sz="1550" dirty="0"/>
+            <a:endParaRPr lang="en-US" sz="2000" dirty="0"/>
           </a:p>
         </p:txBody>
       </p:sp>
@@ -16972,7 +16972,7 @@
               <a:buNone/>
             </a:pPr>
             <a:r>
-              <a:rPr lang="en-US" sz="1550" b="1" dirty="0">
+              <a:rPr lang="en-US" sz="2000" b="1" dirty="0">
                 <a:solidFill>
                   <a:srgbClr val="2F7D4A"/>
                 </a:solidFill>
@@ -16980,9 +16980,9 @@
                 <a:ea typeface="Arial" pitchFamily="34" charset="-122"/>
                 <a:cs typeface="Arial" pitchFamily="34" charset="-120"/>
               </a:rPr>
-              <a:t>Add manual penetration and profiling methods</a:t>
+              <a:t>Add manual security and profiling</a:t>
             </a:r>
-            <a:endParaRPr lang="en-US" sz="1550" dirty="0"/>
+            <a:endParaRPr lang="en-US" sz="2000" dirty="0"/>
           </a:p>
         </p:txBody>
       </p:sp>
@@ -17067,7 +17067,7 @@
               <a:buNone/>
             </a:pPr>
             <a:r>
-              <a:rPr lang="en-US" sz="1550" b="1" dirty="0">
+              <a:rPr lang="en-US" sz="2000" b="1" dirty="0">
                 <a:solidFill>
                   <a:srgbClr val="B93A3A"/>
                 </a:solidFill>
@@ -17075,9 +17075,9 @@
                 <a:ea typeface="Arial" pitchFamily="34" charset="-122"/>
                 <a:cs typeface="Arial" pitchFamily="34" charset="-120"/>
               </a:rPr>
-              <a:t>Mixed-workload drift confounding</a:t>
+              <a:t>Drift mixes workload and time</a:t>
             </a:r>
-            <a:endParaRPr lang="en-US" sz="1550" dirty="0"/>
+            <a:endParaRPr lang="en-US" sz="2000" dirty="0"/>
           </a:p>
         </p:txBody>
       </p:sp>
@@ -17133,7 +17133,7 @@
               <a:buNone/>
             </a:pPr>
             <a:r>
-              <a:rPr lang="en-US" sz="1550" b="1" dirty="0">
+              <a:rPr lang="en-US" sz="2000" b="1" dirty="0">
                 <a:solidFill>
                   <a:srgbClr val="2F7D4A"/>
                 </a:solidFill>
@@ -17141,9 +17141,9 @@
                 <a:ea typeface="Arial" pitchFamily="34" charset="-122"/>
                 <a:cs typeface="Arial" pitchFamily="34" charset="-120"/>
               </a:rPr>
-              <a:t>Separate workload composition from time degradation</a:t>
+              <a:t>Separate workload from degradation</a:t>
             </a:r>
-            <a:endParaRPr lang="en-US" sz="1550" dirty="0"/>
+            <a:endParaRPr lang="en-US" sz="2000" dirty="0"/>
           </a:p>
         </p:txBody>
       </p:sp>
@@ -17228,7 +17228,7 @@
               <a:buNone/>
             </a:pPr>
             <a:r>
-              <a:rPr lang="en-US" sz="1550" b="1" dirty="0">
+              <a:rPr lang="en-US" sz="2000" b="1" dirty="0">
                 <a:solidFill>
                   <a:srgbClr val="B93A3A"/>
                 </a:solidFill>
@@ -17236,9 +17236,9 @@
                 <a:ea typeface="Arial" pitchFamily="34" charset="-122"/>
                 <a:cs typeface="Arial" pitchFamily="34" charset="-120"/>
               </a:rPr>
-              <a:t>Incomplete GPT-5.4 v2 JMeter track</a:t>
+              <a:t>No GPT-5.4 v2 JMeter fix</a:t>
             </a:r>
-            <a:endParaRPr lang="en-US" sz="1550" dirty="0"/>
+            <a:endParaRPr lang="en-US" sz="2000" dirty="0"/>
           </a:p>
         </p:txBody>
       </p:sp>
@@ -17294,7 +17294,7 @@
               <a:buNone/>
             </a:pPr>
             <a:r>
-              <a:rPr lang="en-US" sz="1550" b="1" dirty="0">
+              <a:rPr lang="en-US" sz="2000" b="1" dirty="0">
                 <a:solidFill>
                   <a:srgbClr val="2F7D4A"/>
                 </a:solidFill>
@@ -17302,9 +17302,9 @@
                 <a:ea typeface="Arial" pitchFamily="34" charset="-122"/>
                 <a:cs typeface="Arial" pitchFamily="34" charset="-120"/>
               </a:rPr>
-              <a:t>Run a fresh paired remediation candidate</a:t>
+              <a:t>Run paired GPT-5.4 remediation</a:t>
             </a:r>
-            <a:endParaRPr lang="en-US" sz="1550" dirty="0"/>
+            <a:endParaRPr lang="en-US" sz="2000" dirty="0"/>
           </a:p>
         </p:txBody>
       </p:sp>
@@ -18409,19 +18409,19 @@
           </p:nvPr>
         </p:nvGraphicFramePr>
         <p:xfrm>
-          <a:off x="822960" y="1463040"/>
-          <a:ext cx="10515600" cy="4114800"/>
+          <a:off x="822960" y="1280160"/>
+          <a:ext cx="10515600" cy="4800600"/>
         </p:xfrm>
         <a:graphic>
           <a:graphicData uri="http://schemas.openxmlformats.org/drawingml/2006/table">
             <a:tbl>
               <a:tblPr/>
               <a:tblGrid>
-                <a:gridCol w="2286000"/>
-                <a:gridCol w="3840480"/>
-                <a:gridCol w="4389120"/>
+                <a:gridCol w="2468880"/>
+                <a:gridCol w="4937760"/>
+                <a:gridCol w="3108960"/>
               </a:tblGrid>
-              <a:tr h="640080">
+              <a:tr h="502920">
                 <a:tc>
                   <a:txBody>
                     <a:bodyPr/>
@@ -18431,7 +18431,7 @@
                         <a:buNone/>
                       </a:pPr>
                       <a:r>
-                        <a:rPr lang="en-US" sz="1500" b="1" dirty="0">
+                        <a:rPr lang="en-US" sz="1350" b="1" dirty="0">
                           <a:solidFill>
                             <a:srgbClr val="FFFFFF"/>
                           </a:solidFill>
@@ -18441,7 +18441,7 @@
                         </a:rPr>
                         <a:t>Track</a:t>
                       </a:r>
-                      <a:endParaRPr lang="en-US" sz="1500" dirty="0">
+                      <a:endParaRPr lang="en-US" sz="1350" dirty="0">
                         <a:latin typeface="Arial" charset="0"/>
                         <a:ea typeface="Arial" charset="0"/>
                         <a:cs typeface="Arial" charset="0"/>
@@ -18499,7 +18499,7 @@
                         <a:buNone/>
                       </a:pPr>
                       <a:r>
-                        <a:rPr lang="en-US" sz="1500" b="1" dirty="0">
+                        <a:rPr lang="en-US" sz="1350" b="1" dirty="0">
                           <a:solidFill>
                             <a:srgbClr val="FFFFFF"/>
                           </a:solidFill>
@@ -18509,7 +18509,7 @@
                         </a:rPr>
                         <a:t>Branch</a:t>
                       </a:r>
-                      <a:endParaRPr lang="en-US" sz="1500" dirty="0">
+                      <a:endParaRPr lang="en-US" sz="1350" dirty="0">
                         <a:latin typeface="Arial" charset="0"/>
                         <a:ea typeface="Arial" charset="0"/>
                         <a:cs typeface="Arial" charset="0"/>
@@ -18567,7 +18567,7 @@
                         <a:buNone/>
                       </a:pPr>
                       <a:r>
-                        <a:rPr lang="en-US" sz="1500" b="1" dirty="0">
+                        <a:rPr lang="en-US" sz="1350" b="1" dirty="0">
                           <a:solidFill>
                             <a:srgbClr val="FFFFFF"/>
                           </a:solidFill>
@@ -18575,9 +18575,9 @@
                           <a:ea typeface="Arial" pitchFamily="34" charset="-122"/>
                           <a:cs typeface="Arial" pitchFamily="34" charset="-120"/>
                         </a:rPr>
-                        <a:t>Evidence</a:t>
+                        <a:t>Commit</a:t>
                       </a:r>
-                      <a:endParaRPr lang="en-US" sz="1500" dirty="0">
+                      <a:endParaRPr lang="en-US" sz="1350" dirty="0">
                         <a:latin typeface="Arial" charset="0"/>
                         <a:ea typeface="Arial" charset="0"/>
                         <a:cs typeface="Arial" charset="0"/>
@@ -18627,7 +18627,7 @@
                   </a:tcPr>
                 </a:tc>
               </a:tr>
-              <a:tr h="640080">
+              <a:tr h="502920">
                 <a:tc>
                   <a:txBody>
                     <a:bodyPr/>
@@ -18637,7 +18637,7 @@
                         <a:buNone/>
                       </a:pPr>
                       <a:r>
-                        <a:rPr lang="en-US" sz="1500" dirty="0">
+                        <a:rPr lang="en-US" sz="1350" dirty="0">
                           <a:solidFill>
                             <a:srgbClr val="20262E"/>
                           </a:solidFill>
@@ -18645,9 +18645,9 @@
                           <a:ea typeface="Arial" pitchFamily="34" charset="-122"/>
                           <a:cs typeface="Arial" pitchFamily="34" charset="-120"/>
                         </a:rPr>
-                        <a:t>Original baseline</a:t>
+                        <a:t>GPT-5.4 Sonar</a:t>
                       </a:r>
-                      <a:endParaRPr lang="en-US" sz="1500" dirty="0">
+                      <a:endParaRPr lang="en-US" sz="1350" dirty="0">
                         <a:latin typeface="Arial" charset="0"/>
                         <a:ea typeface="Arial" charset="0"/>
                         <a:cs typeface="Arial" charset="0"/>
@@ -18705,7 +18705,7 @@
                         <a:buNone/>
                       </a:pPr>
                       <a:r>
-                        <a:rPr lang="en-US" sz="1500" dirty="0">
+                        <a:rPr lang="en-US" sz="1350" dirty="0">
                           <a:solidFill>
                             <a:srgbClr val="20262E"/>
                           </a:solidFill>
@@ -18713,9 +18713,9 @@
                           <a:ea typeface="Arial" pitchFamily="34" charset="-122"/>
                           <a:cs typeface="Arial" pitchFamily="34" charset="-120"/>
                         </a:rPr>
-                        <a:t>baseline-v0.1</a:t>
+                        <a:t>baseline-sonarqube-v1</a:t>
                       </a:r>
-                      <a:endParaRPr lang="en-US" sz="1500" dirty="0">
+                      <a:endParaRPr lang="en-US" sz="1350" dirty="0">
                         <a:latin typeface="Arial" charset="0"/>
                         <a:ea typeface="Arial" charset="0"/>
                         <a:cs typeface="Arial" charset="0"/>
@@ -18773,7 +18773,7 @@
                         <a:buNone/>
                       </a:pPr>
                       <a:r>
-                        <a:rPr lang="en-US" sz="1500" dirty="0">
+                        <a:rPr lang="en-US" sz="1350" dirty="0">
                           <a:solidFill>
                             <a:srgbClr val="20262E"/>
                           </a:solidFill>
@@ -18781,9 +18781,9 @@
                           <a:ea typeface="Arial" pitchFamily="34" charset="-122"/>
                           <a:cs typeface="Arial" pitchFamily="34" charset="-120"/>
                         </a:rPr>
-                        <a:t>Shared starting point</a:t>
+                        <a:t>a2279bc</a:t>
                       </a:r>
-                      <a:endParaRPr lang="en-US" sz="1500" dirty="0">
+                      <a:endParaRPr lang="en-US" sz="1350" dirty="0">
                         <a:latin typeface="Arial" charset="0"/>
                         <a:ea typeface="Arial" charset="0"/>
                         <a:cs typeface="Arial" charset="0"/>
@@ -18833,7 +18833,7 @@
                   </a:tcPr>
                 </a:tc>
               </a:tr>
-              <a:tr h="640080">
+              <a:tr h="502920">
                 <a:tc>
                   <a:txBody>
                     <a:bodyPr/>
@@ -18843,7 +18843,7 @@
                         <a:buNone/>
                       </a:pPr>
                       <a:r>
-                        <a:rPr lang="en-US" sz="1500" dirty="0">
+                        <a:rPr lang="en-US" sz="1350" dirty="0">
                           <a:solidFill>
                             <a:srgbClr val="20262E"/>
                           </a:solidFill>
@@ -18851,9 +18851,9 @@
                           <a:ea typeface="Arial" pitchFamily="34" charset="-122"/>
                           <a:cs typeface="Arial" pitchFamily="34" charset="-120"/>
                         </a:rPr>
-                        <a:t>Original Sonar</a:t>
+                        <a:t>GPT-5.4 ZAP</a:t>
                       </a:r>
-                      <a:endParaRPr lang="en-US" sz="1500" dirty="0">
+                      <a:endParaRPr lang="en-US" sz="1350" dirty="0">
                         <a:latin typeface="Arial" charset="0"/>
                         <a:ea typeface="Arial" charset="0"/>
                         <a:cs typeface="Arial" charset="0"/>
@@ -18911,7 +18911,7 @@
                         <a:buNone/>
                       </a:pPr>
                       <a:r>
-                        <a:rPr lang="en-US" sz="1500" dirty="0">
+                        <a:rPr lang="en-US" sz="1350" dirty="0">
                           <a:solidFill>
                             <a:srgbClr val="20262E"/>
                           </a:solidFill>
@@ -18919,9 +18919,9 @@
                           <a:ea typeface="Arial" pitchFamily="34" charset="-122"/>
                           <a:cs typeface="Arial" pitchFamily="34" charset="-120"/>
                         </a:rPr>
-                        <a:t>baseline-sonarqube-v1</a:t>
+                        <a:t>baseline-zap-v1</a:t>
                       </a:r>
-                      <a:endParaRPr lang="en-US" sz="1500" dirty="0">
+                      <a:endParaRPr lang="en-US" sz="1350" dirty="0">
                         <a:latin typeface="Arial" charset="0"/>
                         <a:ea typeface="Arial" charset="0"/>
                         <a:cs typeface="Arial" charset="0"/>
@@ -18979,7 +18979,7 @@
                         <a:buNone/>
                       </a:pPr>
                       <a:r>
-                        <a:rPr lang="en-US" sz="1500" dirty="0">
+                        <a:rPr lang="en-US" sz="1350" dirty="0">
                           <a:solidFill>
                             <a:srgbClr val="20262E"/>
                           </a:solidFill>
@@ -18987,9 +18987,9 @@
                           <a:ea typeface="Arial" pitchFamily="34" charset="-122"/>
                           <a:cs typeface="Arial" pitchFamily="34" charset="-120"/>
                         </a:rPr>
-                        <a:t>Static-quality rerun</a:t>
+                        <a:t>5f3bd3c</a:t>
                       </a:r>
-                      <a:endParaRPr lang="en-US" sz="1500" dirty="0">
+                      <a:endParaRPr lang="en-US" sz="1350" dirty="0">
                         <a:latin typeface="Arial" charset="0"/>
                         <a:ea typeface="Arial" charset="0"/>
                         <a:cs typeface="Arial" charset="0"/>
@@ -19039,7 +19039,7 @@
                   </a:tcPr>
                 </a:tc>
               </a:tr>
-              <a:tr h="640080">
+              <a:tr h="502920">
                 <a:tc>
                   <a:txBody>
                     <a:bodyPr/>
@@ -19049,7 +19049,7 @@
                         <a:buNone/>
                       </a:pPr>
                       <a:r>
-                        <a:rPr lang="en-US" sz="1500" dirty="0">
+                        <a:rPr lang="en-US" sz="1350" dirty="0">
                           <a:solidFill>
                             <a:srgbClr val="20262E"/>
                           </a:solidFill>
@@ -19057,9 +19057,9 @@
                           <a:ea typeface="Arial" pitchFamily="34" charset="-122"/>
                           <a:cs typeface="Arial" pitchFamily="34" charset="-120"/>
                         </a:rPr>
-                        <a:t>Original ZAP</a:t>
+                        <a:t>GPT-5.4 JMeter</a:t>
                       </a:r>
-                      <a:endParaRPr lang="en-US" sz="1500" dirty="0">
+                      <a:endParaRPr lang="en-US" sz="1350" dirty="0">
                         <a:latin typeface="Arial" charset="0"/>
                         <a:ea typeface="Arial" charset="0"/>
                         <a:cs typeface="Arial" charset="0"/>
@@ -19117,7 +19117,7 @@
                         <a:buNone/>
                       </a:pPr>
                       <a:r>
-                        <a:rPr lang="en-US" sz="1500" dirty="0">
+                        <a:rPr lang="en-US" sz="1350" dirty="0">
                           <a:solidFill>
                             <a:srgbClr val="20262E"/>
                           </a:solidFill>
@@ -19125,9 +19125,9 @@
                           <a:ea typeface="Arial" pitchFamily="34" charset="-122"/>
                           <a:cs typeface="Arial" pitchFamily="34" charset="-120"/>
                         </a:rPr>
-                        <a:t>baseline-zap-v1</a:t>
+                        <a:t>baseline-jmeter-v1</a:t>
                       </a:r>
-                      <a:endParaRPr lang="en-US" sz="1500" dirty="0">
+                      <a:endParaRPr lang="en-US" sz="1350" dirty="0">
                         <a:latin typeface="Arial" charset="0"/>
                         <a:ea typeface="Arial" charset="0"/>
                         <a:cs typeface="Arial" charset="0"/>
@@ -19185,7 +19185,7 @@
                         <a:buNone/>
                       </a:pPr>
                       <a:r>
-                        <a:rPr lang="en-US" sz="1500" dirty="0">
+                        <a:rPr lang="en-US" sz="1350" dirty="0">
                           <a:solidFill>
                             <a:srgbClr val="20262E"/>
                           </a:solidFill>
@@ -19193,9 +19193,9 @@
                           <a:ea typeface="Arial" pitchFamily="34" charset="-122"/>
                           <a:cs typeface="Arial" pitchFamily="34" charset="-120"/>
                         </a:rPr>
-                        <a:t>Baseline and authenticated scans</a:t>
+                        <a:t>78b08b6</a:t>
                       </a:r>
-                      <a:endParaRPr lang="en-US" sz="1500" dirty="0">
+                      <a:endParaRPr lang="en-US" sz="1350" dirty="0">
                         <a:latin typeface="Arial" charset="0"/>
                         <a:ea typeface="Arial" charset="0"/>
                         <a:cs typeface="Arial" charset="0"/>
@@ -19245,7 +19245,7 @@
                   </a:tcPr>
                 </a:tc>
               </a:tr>
-              <a:tr h="640080">
+              <a:tr h="502920">
                 <a:tc>
                   <a:txBody>
                     <a:bodyPr/>
@@ -19255,7 +19255,7 @@
                         <a:buNone/>
                       </a:pPr>
                       <a:r>
-                        <a:rPr lang="en-US" sz="1500" dirty="0">
+                        <a:rPr lang="en-US" sz="1350" dirty="0">
                           <a:solidFill>
                             <a:srgbClr val="20262E"/>
                           </a:solidFill>
@@ -19263,9 +19263,9 @@
                           <a:ea typeface="Arial" pitchFamily="34" charset="-122"/>
                           <a:cs typeface="Arial" pitchFamily="34" charset="-120"/>
                         </a:rPr>
-                        <a:t>Original JMeter</a:t>
+                        <a:t>GPT-5.5 baseline</a:t>
                       </a:r>
-                      <a:endParaRPr lang="en-US" sz="1500" dirty="0">
+                      <a:endParaRPr lang="en-US" sz="1350" dirty="0">
                         <a:latin typeface="Arial" charset="0"/>
                         <a:ea typeface="Arial" charset="0"/>
                         <a:cs typeface="Arial" charset="0"/>
@@ -19323,7 +19323,7 @@
                         <a:buNone/>
                       </a:pPr>
                       <a:r>
-                        <a:rPr lang="en-US" sz="1500" dirty="0">
+                        <a:rPr lang="en-US" sz="1350" dirty="0">
                           <a:solidFill>
                             <a:srgbClr val="20262E"/>
                           </a:solidFill>
@@ -19331,9 +19331,9 @@
                           <a:ea typeface="Arial" pitchFamily="34" charset="-122"/>
                           <a:cs typeface="Arial" pitchFamily="34" charset="-120"/>
                         </a:rPr>
-                        <a:t>baseline-jmeter-v1</a:t>
+                        <a:t>codex/gpt-5.5-baseline</a:t>
                       </a:r>
-                      <a:endParaRPr lang="en-US" sz="1500" dirty="0">
+                      <a:endParaRPr lang="en-US" sz="1350" dirty="0">
                         <a:latin typeface="Arial" charset="0"/>
                         <a:ea typeface="Arial" charset="0"/>
                         <a:cs typeface="Arial" charset="0"/>
@@ -19391,7 +19391,7 @@
                         <a:buNone/>
                       </a:pPr>
                       <a:r>
-                        <a:rPr lang="en-US" sz="1500" dirty="0">
+                        <a:rPr lang="en-US" sz="1350" dirty="0">
                           <a:solidFill>
                             <a:srgbClr val="20262E"/>
                           </a:solidFill>
@@ -19399,9 +19399,9 @@
                           <a:ea typeface="Arial" pitchFamily="34" charset="-122"/>
                           <a:cs typeface="Arial" pitchFamily="34" charset="-120"/>
                         </a:rPr>
-                        <a:t>Five workload profiles</a:t>
+                        <a:t>ec03403</a:t>
                       </a:r>
-                      <a:endParaRPr lang="en-US" sz="1500" dirty="0">
+                      <a:endParaRPr lang="en-US" sz="1350" dirty="0">
                         <a:latin typeface="Arial" charset="0"/>
                         <a:ea typeface="Arial" charset="0"/>
                         <a:cs typeface="Arial" charset="0"/>
@@ -19451,7 +19451,7 @@
                   </a:tcPr>
                 </a:tc>
               </a:tr>
-              <a:tr h="640080">
+              <a:tr h="502920">
                 <a:tc>
                   <a:txBody>
                     <a:bodyPr/>
@@ -19461,7 +19461,7 @@
                         <a:buNone/>
                       </a:pPr>
                       <a:r>
-                        <a:rPr lang="en-US" sz="1500" dirty="0">
+                        <a:rPr lang="en-US" sz="1350" dirty="0">
                           <a:solidFill>
                             <a:srgbClr val="20262E"/>
                           </a:solidFill>
@@ -19469,9 +19469,9 @@
                           <a:ea typeface="Arial" pitchFamily="34" charset="-122"/>
                           <a:cs typeface="Arial" pitchFamily="34" charset="-120"/>
                         </a:rPr>
-                        <a:t>GPT-5.5 comparison</a:t>
+                        <a:t>GPT-5.5 Sonar</a:t>
                       </a:r>
-                      <a:endParaRPr lang="en-US" sz="1500" dirty="0">
+                      <a:endParaRPr lang="en-US" sz="1350" dirty="0">
                         <a:latin typeface="Arial" charset="0"/>
                         <a:ea typeface="Arial" charset="0"/>
                         <a:cs typeface="Arial" charset="0"/>
@@ -19529,7 +19529,7 @@
                         <a:buNone/>
                       </a:pPr>
                       <a:r>
-                        <a:rPr lang="en-US" sz="1500" dirty="0">
+                        <a:rPr lang="en-US" sz="1350" dirty="0">
                           <a:solidFill>
                             <a:srgbClr val="20262E"/>
                           </a:solidFill>
@@ -19537,9 +19537,9 @@
                           <a:ea typeface="Arial" pitchFamily="34" charset="-122"/>
                           <a:cs typeface="Arial" pitchFamily="34" charset="-120"/>
                         </a:rPr>
-                        <a:t>codex/gpt-5.5-comparison</a:t>
+                        <a:t>codex/gpt-5.5-sonarqube-v1</a:t>
                       </a:r>
-                      <a:endParaRPr lang="en-US" sz="1500" dirty="0">
+                      <a:endParaRPr lang="en-US" sz="1350" dirty="0">
                         <a:latin typeface="Arial" charset="0"/>
                         <a:ea typeface="Arial" charset="0"/>
                         <a:cs typeface="Arial" charset="0"/>
@@ -19597,7 +19597,7 @@
                         <a:buNone/>
                       </a:pPr>
                       <a:r>
-                        <a:rPr lang="en-US" sz="1500" dirty="0">
+                        <a:rPr lang="en-US" sz="1350" dirty="0">
                           <a:solidFill>
                             <a:srgbClr val="20262E"/>
                           </a:solidFill>
@@ -19605,9 +19605,627 @@
                           <a:ea typeface="Arial" pitchFamily="34" charset="-122"/>
                           <a:cs typeface="Arial" pitchFamily="34" charset="-120"/>
                         </a:rPr>
-                        <a:t>Paired model evidence</a:t>
+                        <a:t>19763f1</a:t>
                       </a:r>
-                      <a:endParaRPr lang="en-US" sz="1500" dirty="0">
+                      <a:endParaRPr lang="en-US" sz="1350" dirty="0">
+                        <a:latin typeface="Arial" charset="0"/>
+                        <a:ea typeface="Arial" charset="0"/>
+                        <a:cs typeface="Arial" charset="0"/>
+                      </a:endParaRPr>
+                    </a:p>
+                  </a:txBody>
+                  <a:tcPr marL="82296" marR="82296" marT="82296" marB="82296" anchor="ctr">
+                    <a:lnL w="10160" cap="flat" cmpd="sng" algn="ctr">
+                      <a:solidFill>
+                        <a:srgbClr val="D9DEE5"/>
+                      </a:solidFill>
+                      <a:prstDash val="solid"/>
+                      <a:round/>
+                      <a:headEnd type="none" w="med" len="med"/>
+                      <a:tailEnd type="none" w="med" len="med"/>
+                    </a:lnL>
+                    <a:lnR w="10160" cap="flat" cmpd="sng" algn="ctr">
+                      <a:solidFill>
+                        <a:srgbClr val="D9DEE5"/>
+                      </a:solidFill>
+                      <a:prstDash val="solid"/>
+                      <a:round/>
+                      <a:headEnd type="none" w="med" len="med"/>
+                      <a:tailEnd type="none" w="med" len="med"/>
+                    </a:lnR>
+                    <a:lnT w="10160" cap="flat" cmpd="sng" algn="ctr">
+                      <a:solidFill>
+                        <a:srgbClr val="D9DEE5"/>
+                      </a:solidFill>
+                      <a:prstDash val="solid"/>
+                      <a:round/>
+                      <a:headEnd type="none" w="med" len="med"/>
+                      <a:tailEnd type="none" w="med" len="med"/>
+                    </a:lnT>
+                    <a:lnB w="10160" cap="flat" cmpd="sng" algn="ctr">
+                      <a:solidFill>
+                        <a:srgbClr val="D9DEE5"/>
+                      </a:solidFill>
+                      <a:prstDash val="solid"/>
+                      <a:round/>
+                      <a:headEnd type="none" w="med" len="med"/>
+                      <a:tailEnd type="none" w="med" len="med"/>
+                    </a:lnB>
+                    <a:solidFill>
+                      <a:srgbClr val="FFFFFF"/>
+                    </a:solidFill>
+                  </a:tcPr>
+                </a:tc>
+              </a:tr>
+              <a:tr h="502920">
+                <a:tc>
+                  <a:txBody>
+                    <a:bodyPr/>
+                    <a:lstStyle/>
+                    <a:p>
+                      <a:pPr indent="0" marL="0">
+                        <a:buNone/>
+                      </a:pPr>
+                      <a:r>
+                        <a:rPr lang="en-US" sz="1350" dirty="0">
+                          <a:solidFill>
+                            <a:srgbClr val="20262E"/>
+                          </a:solidFill>
+                          <a:latin typeface="Arial" pitchFamily="34" charset="0"/>
+                          <a:ea typeface="Arial" pitchFamily="34" charset="-122"/>
+                          <a:cs typeface="Arial" pitchFamily="34" charset="-120"/>
+                        </a:rPr>
+                        <a:t>GPT-5.5 ZAP</a:t>
+                      </a:r>
+                      <a:endParaRPr lang="en-US" sz="1350" dirty="0">
+                        <a:latin typeface="Arial" charset="0"/>
+                        <a:ea typeface="Arial" charset="0"/>
+                        <a:cs typeface="Arial" charset="0"/>
+                      </a:endParaRPr>
+                    </a:p>
+                  </a:txBody>
+                  <a:tcPr marL="82296" marR="82296" marT="82296" marB="82296" anchor="ctr">
+                    <a:lnL w="10160" cap="flat" cmpd="sng" algn="ctr">
+                      <a:solidFill>
+                        <a:srgbClr val="D9DEE5"/>
+                      </a:solidFill>
+                      <a:prstDash val="solid"/>
+                      <a:round/>
+                      <a:headEnd type="none" w="med" len="med"/>
+                      <a:tailEnd type="none" w="med" len="med"/>
+                    </a:lnL>
+                    <a:lnR w="10160" cap="flat" cmpd="sng" algn="ctr">
+                      <a:solidFill>
+                        <a:srgbClr val="D9DEE5"/>
+                      </a:solidFill>
+                      <a:prstDash val="solid"/>
+                      <a:round/>
+                      <a:headEnd type="none" w="med" len="med"/>
+                      <a:tailEnd type="none" w="med" len="med"/>
+                    </a:lnR>
+                    <a:lnT w="10160" cap="flat" cmpd="sng" algn="ctr">
+                      <a:solidFill>
+                        <a:srgbClr val="D9DEE5"/>
+                      </a:solidFill>
+                      <a:prstDash val="solid"/>
+                      <a:round/>
+                      <a:headEnd type="none" w="med" len="med"/>
+                      <a:tailEnd type="none" w="med" len="med"/>
+                    </a:lnT>
+                    <a:lnB w="10160" cap="flat" cmpd="sng" algn="ctr">
+                      <a:solidFill>
+                        <a:srgbClr val="D9DEE5"/>
+                      </a:solidFill>
+                      <a:prstDash val="solid"/>
+                      <a:round/>
+                      <a:headEnd type="none" w="med" len="med"/>
+                      <a:tailEnd type="none" w="med" len="med"/>
+                    </a:lnB>
+                    <a:solidFill>
+                      <a:srgbClr val="FFFFFF"/>
+                    </a:solidFill>
+                  </a:tcPr>
+                </a:tc>
+                <a:tc>
+                  <a:txBody>
+                    <a:bodyPr/>
+                    <a:lstStyle/>
+                    <a:p>
+                      <a:pPr indent="0" marL="0">
+                        <a:buNone/>
+                      </a:pPr>
+                      <a:r>
+                        <a:rPr lang="en-US" sz="1350" dirty="0">
+                          <a:solidFill>
+                            <a:srgbClr val="20262E"/>
+                          </a:solidFill>
+                          <a:latin typeface="Arial" pitchFamily="34" charset="0"/>
+                          <a:ea typeface="Arial" pitchFamily="34" charset="-122"/>
+                          <a:cs typeface="Arial" pitchFamily="34" charset="-120"/>
+                        </a:rPr>
+                        <a:t>codex/gpt-5.5-zap-v1</a:t>
+                      </a:r>
+                      <a:endParaRPr lang="en-US" sz="1350" dirty="0">
+                        <a:latin typeface="Arial" charset="0"/>
+                        <a:ea typeface="Arial" charset="0"/>
+                        <a:cs typeface="Arial" charset="0"/>
+                      </a:endParaRPr>
+                    </a:p>
+                  </a:txBody>
+                  <a:tcPr marL="82296" marR="82296" marT="82296" marB="82296" anchor="ctr">
+                    <a:lnL w="10160" cap="flat" cmpd="sng" algn="ctr">
+                      <a:solidFill>
+                        <a:srgbClr val="D9DEE5"/>
+                      </a:solidFill>
+                      <a:prstDash val="solid"/>
+                      <a:round/>
+                      <a:headEnd type="none" w="med" len="med"/>
+                      <a:tailEnd type="none" w="med" len="med"/>
+                    </a:lnL>
+                    <a:lnR w="10160" cap="flat" cmpd="sng" algn="ctr">
+                      <a:solidFill>
+                        <a:srgbClr val="D9DEE5"/>
+                      </a:solidFill>
+                      <a:prstDash val="solid"/>
+                      <a:round/>
+                      <a:headEnd type="none" w="med" len="med"/>
+                      <a:tailEnd type="none" w="med" len="med"/>
+                    </a:lnR>
+                    <a:lnT w="10160" cap="flat" cmpd="sng" algn="ctr">
+                      <a:solidFill>
+                        <a:srgbClr val="D9DEE5"/>
+                      </a:solidFill>
+                      <a:prstDash val="solid"/>
+                      <a:round/>
+                      <a:headEnd type="none" w="med" len="med"/>
+                      <a:tailEnd type="none" w="med" len="med"/>
+                    </a:lnT>
+                    <a:lnB w="10160" cap="flat" cmpd="sng" algn="ctr">
+                      <a:solidFill>
+                        <a:srgbClr val="D9DEE5"/>
+                      </a:solidFill>
+                      <a:prstDash val="solid"/>
+                      <a:round/>
+                      <a:headEnd type="none" w="med" len="med"/>
+                      <a:tailEnd type="none" w="med" len="med"/>
+                    </a:lnB>
+                    <a:solidFill>
+                      <a:srgbClr val="FFFFFF"/>
+                    </a:solidFill>
+                  </a:tcPr>
+                </a:tc>
+                <a:tc>
+                  <a:txBody>
+                    <a:bodyPr/>
+                    <a:lstStyle/>
+                    <a:p>
+                      <a:pPr indent="0" marL="0">
+                        <a:buNone/>
+                      </a:pPr>
+                      <a:r>
+                        <a:rPr lang="en-US" sz="1350" dirty="0">
+                          <a:solidFill>
+                            <a:srgbClr val="20262E"/>
+                          </a:solidFill>
+                          <a:latin typeface="Arial" pitchFamily="34" charset="0"/>
+                          <a:ea typeface="Arial" pitchFamily="34" charset="-122"/>
+                          <a:cs typeface="Arial" pitchFamily="34" charset="-120"/>
+                        </a:rPr>
+                        <a:t>aa1a9bd</a:t>
+                      </a:r>
+                      <a:endParaRPr lang="en-US" sz="1350" dirty="0">
+                        <a:latin typeface="Arial" charset="0"/>
+                        <a:ea typeface="Arial" charset="0"/>
+                        <a:cs typeface="Arial" charset="0"/>
+                      </a:endParaRPr>
+                    </a:p>
+                  </a:txBody>
+                  <a:tcPr marL="82296" marR="82296" marT="82296" marB="82296" anchor="ctr">
+                    <a:lnL w="10160" cap="flat" cmpd="sng" algn="ctr">
+                      <a:solidFill>
+                        <a:srgbClr val="D9DEE5"/>
+                      </a:solidFill>
+                      <a:prstDash val="solid"/>
+                      <a:round/>
+                      <a:headEnd type="none" w="med" len="med"/>
+                      <a:tailEnd type="none" w="med" len="med"/>
+                    </a:lnL>
+                    <a:lnR w="10160" cap="flat" cmpd="sng" algn="ctr">
+                      <a:solidFill>
+                        <a:srgbClr val="D9DEE5"/>
+                      </a:solidFill>
+                      <a:prstDash val="solid"/>
+                      <a:round/>
+                      <a:headEnd type="none" w="med" len="med"/>
+                      <a:tailEnd type="none" w="med" len="med"/>
+                    </a:lnR>
+                    <a:lnT w="10160" cap="flat" cmpd="sng" algn="ctr">
+                      <a:solidFill>
+                        <a:srgbClr val="D9DEE5"/>
+                      </a:solidFill>
+                      <a:prstDash val="solid"/>
+                      <a:round/>
+                      <a:headEnd type="none" w="med" len="med"/>
+                      <a:tailEnd type="none" w="med" len="med"/>
+                    </a:lnT>
+                    <a:lnB w="10160" cap="flat" cmpd="sng" algn="ctr">
+                      <a:solidFill>
+                        <a:srgbClr val="D9DEE5"/>
+                      </a:solidFill>
+                      <a:prstDash val="solid"/>
+                      <a:round/>
+                      <a:headEnd type="none" w="med" len="med"/>
+                      <a:tailEnd type="none" w="med" len="med"/>
+                    </a:lnB>
+                    <a:solidFill>
+                      <a:srgbClr val="FFFFFF"/>
+                    </a:solidFill>
+                  </a:tcPr>
+                </a:tc>
+              </a:tr>
+              <a:tr h="502920">
+                <a:tc>
+                  <a:txBody>
+                    <a:bodyPr/>
+                    <a:lstStyle/>
+                    <a:p>
+                      <a:pPr indent="0" marL="0">
+                        <a:buNone/>
+                      </a:pPr>
+                      <a:r>
+                        <a:rPr lang="en-US" sz="1350" dirty="0">
+                          <a:solidFill>
+                            <a:srgbClr val="20262E"/>
+                          </a:solidFill>
+                          <a:latin typeface="Arial" pitchFamily="34" charset="0"/>
+                          <a:ea typeface="Arial" pitchFamily="34" charset="-122"/>
+                          <a:cs typeface="Arial" pitchFamily="34" charset="-120"/>
+                        </a:rPr>
+                        <a:t>GPT-5.5 JMeter</a:t>
+                      </a:r>
+                      <a:endParaRPr lang="en-US" sz="1350" dirty="0">
+                        <a:latin typeface="Arial" charset="0"/>
+                        <a:ea typeface="Arial" charset="0"/>
+                        <a:cs typeface="Arial" charset="0"/>
+                      </a:endParaRPr>
+                    </a:p>
+                  </a:txBody>
+                  <a:tcPr marL="82296" marR="82296" marT="82296" marB="82296" anchor="ctr">
+                    <a:lnL w="10160" cap="flat" cmpd="sng" algn="ctr">
+                      <a:solidFill>
+                        <a:srgbClr val="D9DEE5"/>
+                      </a:solidFill>
+                      <a:prstDash val="solid"/>
+                      <a:round/>
+                      <a:headEnd type="none" w="med" len="med"/>
+                      <a:tailEnd type="none" w="med" len="med"/>
+                    </a:lnL>
+                    <a:lnR w="10160" cap="flat" cmpd="sng" algn="ctr">
+                      <a:solidFill>
+                        <a:srgbClr val="D9DEE5"/>
+                      </a:solidFill>
+                      <a:prstDash val="solid"/>
+                      <a:round/>
+                      <a:headEnd type="none" w="med" len="med"/>
+                      <a:tailEnd type="none" w="med" len="med"/>
+                    </a:lnR>
+                    <a:lnT w="10160" cap="flat" cmpd="sng" algn="ctr">
+                      <a:solidFill>
+                        <a:srgbClr val="D9DEE5"/>
+                      </a:solidFill>
+                      <a:prstDash val="solid"/>
+                      <a:round/>
+                      <a:headEnd type="none" w="med" len="med"/>
+                      <a:tailEnd type="none" w="med" len="med"/>
+                    </a:lnT>
+                    <a:lnB w="10160" cap="flat" cmpd="sng" algn="ctr">
+                      <a:solidFill>
+                        <a:srgbClr val="D9DEE5"/>
+                      </a:solidFill>
+                      <a:prstDash val="solid"/>
+                      <a:round/>
+                      <a:headEnd type="none" w="med" len="med"/>
+                      <a:tailEnd type="none" w="med" len="med"/>
+                    </a:lnB>
+                    <a:solidFill>
+                      <a:srgbClr val="FFFFFF"/>
+                    </a:solidFill>
+                  </a:tcPr>
+                </a:tc>
+                <a:tc>
+                  <a:txBody>
+                    <a:bodyPr/>
+                    <a:lstStyle/>
+                    <a:p>
+                      <a:pPr indent="0" marL="0">
+                        <a:buNone/>
+                      </a:pPr>
+                      <a:r>
+                        <a:rPr lang="en-US" sz="1350" dirty="0">
+                          <a:solidFill>
+                            <a:srgbClr val="20262E"/>
+                          </a:solidFill>
+                          <a:latin typeface="Arial" pitchFamily="34" charset="0"/>
+                          <a:ea typeface="Arial" pitchFamily="34" charset="-122"/>
+                          <a:cs typeface="Arial" pitchFamily="34" charset="-120"/>
+                        </a:rPr>
+                        <a:t>codex/gpt-5.5-jmeter-v1</a:t>
+                      </a:r>
+                      <a:endParaRPr lang="en-US" sz="1350" dirty="0">
+                        <a:latin typeface="Arial" charset="0"/>
+                        <a:ea typeface="Arial" charset="0"/>
+                        <a:cs typeface="Arial" charset="0"/>
+                      </a:endParaRPr>
+                    </a:p>
+                  </a:txBody>
+                  <a:tcPr marL="82296" marR="82296" marT="82296" marB="82296" anchor="ctr">
+                    <a:lnL w="10160" cap="flat" cmpd="sng" algn="ctr">
+                      <a:solidFill>
+                        <a:srgbClr val="D9DEE5"/>
+                      </a:solidFill>
+                      <a:prstDash val="solid"/>
+                      <a:round/>
+                      <a:headEnd type="none" w="med" len="med"/>
+                      <a:tailEnd type="none" w="med" len="med"/>
+                    </a:lnL>
+                    <a:lnR w="10160" cap="flat" cmpd="sng" algn="ctr">
+                      <a:solidFill>
+                        <a:srgbClr val="D9DEE5"/>
+                      </a:solidFill>
+                      <a:prstDash val="solid"/>
+                      <a:round/>
+                      <a:headEnd type="none" w="med" len="med"/>
+                      <a:tailEnd type="none" w="med" len="med"/>
+                    </a:lnR>
+                    <a:lnT w="10160" cap="flat" cmpd="sng" algn="ctr">
+                      <a:solidFill>
+                        <a:srgbClr val="D9DEE5"/>
+                      </a:solidFill>
+                      <a:prstDash val="solid"/>
+                      <a:round/>
+                      <a:headEnd type="none" w="med" len="med"/>
+                      <a:tailEnd type="none" w="med" len="med"/>
+                    </a:lnT>
+                    <a:lnB w="10160" cap="flat" cmpd="sng" algn="ctr">
+                      <a:solidFill>
+                        <a:srgbClr val="D9DEE5"/>
+                      </a:solidFill>
+                      <a:prstDash val="solid"/>
+                      <a:round/>
+                      <a:headEnd type="none" w="med" len="med"/>
+                      <a:tailEnd type="none" w="med" len="med"/>
+                    </a:lnB>
+                    <a:solidFill>
+                      <a:srgbClr val="FFFFFF"/>
+                    </a:solidFill>
+                  </a:tcPr>
+                </a:tc>
+                <a:tc>
+                  <a:txBody>
+                    <a:bodyPr/>
+                    <a:lstStyle/>
+                    <a:p>
+                      <a:pPr indent="0" marL="0">
+                        <a:buNone/>
+                      </a:pPr>
+                      <a:r>
+                        <a:rPr lang="en-US" sz="1350" dirty="0">
+                          <a:solidFill>
+                            <a:srgbClr val="20262E"/>
+                          </a:solidFill>
+                          <a:latin typeface="Arial" pitchFamily="34" charset="0"/>
+                          <a:ea typeface="Arial" pitchFamily="34" charset="-122"/>
+                          <a:cs typeface="Arial" pitchFamily="34" charset="-120"/>
+                        </a:rPr>
+                        <a:t>8d0be3b</a:t>
+                      </a:r>
+                      <a:endParaRPr lang="en-US" sz="1350" dirty="0">
+                        <a:latin typeface="Arial" charset="0"/>
+                        <a:ea typeface="Arial" charset="0"/>
+                        <a:cs typeface="Arial" charset="0"/>
+                      </a:endParaRPr>
+                    </a:p>
+                  </a:txBody>
+                  <a:tcPr marL="82296" marR="82296" marT="82296" marB="82296" anchor="ctr">
+                    <a:lnL w="10160" cap="flat" cmpd="sng" algn="ctr">
+                      <a:solidFill>
+                        <a:srgbClr val="D9DEE5"/>
+                      </a:solidFill>
+                      <a:prstDash val="solid"/>
+                      <a:round/>
+                      <a:headEnd type="none" w="med" len="med"/>
+                      <a:tailEnd type="none" w="med" len="med"/>
+                    </a:lnL>
+                    <a:lnR w="10160" cap="flat" cmpd="sng" algn="ctr">
+                      <a:solidFill>
+                        <a:srgbClr val="D9DEE5"/>
+                      </a:solidFill>
+                      <a:prstDash val="solid"/>
+                      <a:round/>
+                      <a:headEnd type="none" w="med" len="med"/>
+                      <a:tailEnd type="none" w="med" len="med"/>
+                    </a:lnR>
+                    <a:lnT w="10160" cap="flat" cmpd="sng" algn="ctr">
+                      <a:solidFill>
+                        <a:srgbClr val="D9DEE5"/>
+                      </a:solidFill>
+                      <a:prstDash val="solid"/>
+                      <a:round/>
+                      <a:headEnd type="none" w="med" len="med"/>
+                      <a:tailEnd type="none" w="med" len="med"/>
+                    </a:lnT>
+                    <a:lnB w="10160" cap="flat" cmpd="sng" algn="ctr">
+                      <a:solidFill>
+                        <a:srgbClr val="D9DEE5"/>
+                      </a:solidFill>
+                      <a:prstDash val="solid"/>
+                      <a:round/>
+                      <a:headEnd type="none" w="med" len="med"/>
+                      <a:tailEnd type="none" w="med" len="med"/>
+                    </a:lnB>
+                    <a:solidFill>
+                      <a:srgbClr val="FFFFFF"/>
+                    </a:solidFill>
+                  </a:tcPr>
+                </a:tc>
+              </a:tr>
+              <a:tr h="502920">
+                <a:tc>
+                  <a:txBody>
+                    <a:bodyPr/>
+                    <a:lstStyle/>
+                    <a:p>
+                      <a:pPr indent="0" marL="0">
+                        <a:buNone/>
+                      </a:pPr>
+                      <a:r>
+                        <a:rPr lang="en-US" sz="1350" dirty="0">
+                          <a:solidFill>
+                            <a:srgbClr val="20262E"/>
+                          </a:solidFill>
+                          <a:latin typeface="Arial" pitchFamily="34" charset="0"/>
+                          <a:ea typeface="Arial" pitchFamily="34" charset="-122"/>
+                          <a:cs typeface="Arial" pitchFamily="34" charset="-120"/>
+                        </a:rPr>
+                        <a:t>Comparison report</a:t>
+                      </a:r>
+                      <a:endParaRPr lang="en-US" sz="1350" dirty="0">
+                        <a:latin typeface="Arial" charset="0"/>
+                        <a:ea typeface="Arial" charset="0"/>
+                        <a:cs typeface="Arial" charset="0"/>
+                      </a:endParaRPr>
+                    </a:p>
+                  </a:txBody>
+                  <a:tcPr marL="82296" marR="82296" marT="82296" marB="82296" anchor="ctr">
+                    <a:lnL w="10160" cap="flat" cmpd="sng" algn="ctr">
+                      <a:solidFill>
+                        <a:srgbClr val="D9DEE5"/>
+                      </a:solidFill>
+                      <a:prstDash val="solid"/>
+                      <a:round/>
+                      <a:headEnd type="none" w="med" len="med"/>
+                      <a:tailEnd type="none" w="med" len="med"/>
+                    </a:lnL>
+                    <a:lnR w="10160" cap="flat" cmpd="sng" algn="ctr">
+                      <a:solidFill>
+                        <a:srgbClr val="D9DEE5"/>
+                      </a:solidFill>
+                      <a:prstDash val="solid"/>
+                      <a:round/>
+                      <a:headEnd type="none" w="med" len="med"/>
+                      <a:tailEnd type="none" w="med" len="med"/>
+                    </a:lnR>
+                    <a:lnT w="10160" cap="flat" cmpd="sng" algn="ctr">
+                      <a:solidFill>
+                        <a:srgbClr val="D9DEE5"/>
+                      </a:solidFill>
+                      <a:prstDash val="solid"/>
+                      <a:round/>
+                      <a:headEnd type="none" w="med" len="med"/>
+                      <a:tailEnd type="none" w="med" len="med"/>
+                    </a:lnT>
+                    <a:lnB w="10160" cap="flat" cmpd="sng" algn="ctr">
+                      <a:solidFill>
+                        <a:srgbClr val="D9DEE5"/>
+                      </a:solidFill>
+                      <a:prstDash val="solid"/>
+                      <a:round/>
+                      <a:headEnd type="none" w="med" len="med"/>
+                      <a:tailEnd type="none" w="med" len="med"/>
+                    </a:lnB>
+                    <a:solidFill>
+                      <a:srgbClr val="FFFFFF"/>
+                    </a:solidFill>
+                  </a:tcPr>
+                </a:tc>
+                <a:tc>
+                  <a:txBody>
+                    <a:bodyPr/>
+                    <a:lstStyle/>
+                    <a:p>
+                      <a:pPr indent="0" marL="0">
+                        <a:buNone/>
+                      </a:pPr>
+                      <a:r>
+                        <a:rPr lang="en-US" sz="1350" dirty="0">
+                          <a:solidFill>
+                            <a:srgbClr val="20262E"/>
+                          </a:solidFill>
+                          <a:latin typeface="Arial" pitchFamily="34" charset="0"/>
+                          <a:ea typeface="Arial" pitchFamily="34" charset="-122"/>
+                          <a:cs typeface="Arial" pitchFamily="34" charset="-120"/>
+                        </a:rPr>
+                        <a:t>codex/gpt-5.5-comparison</a:t>
+                      </a:r>
+                      <a:endParaRPr lang="en-US" sz="1350" dirty="0">
+                        <a:latin typeface="Arial" charset="0"/>
+                        <a:ea typeface="Arial" charset="0"/>
+                        <a:cs typeface="Arial" charset="0"/>
+                      </a:endParaRPr>
+                    </a:p>
+                  </a:txBody>
+                  <a:tcPr marL="82296" marR="82296" marT="82296" marB="82296" anchor="ctr">
+                    <a:lnL w="10160" cap="flat" cmpd="sng" algn="ctr">
+                      <a:solidFill>
+                        <a:srgbClr val="D9DEE5"/>
+                      </a:solidFill>
+                      <a:prstDash val="solid"/>
+                      <a:round/>
+                      <a:headEnd type="none" w="med" len="med"/>
+                      <a:tailEnd type="none" w="med" len="med"/>
+                    </a:lnL>
+                    <a:lnR w="10160" cap="flat" cmpd="sng" algn="ctr">
+                      <a:solidFill>
+                        <a:srgbClr val="D9DEE5"/>
+                      </a:solidFill>
+                      <a:prstDash val="solid"/>
+                      <a:round/>
+                      <a:headEnd type="none" w="med" len="med"/>
+                      <a:tailEnd type="none" w="med" len="med"/>
+                    </a:lnR>
+                    <a:lnT w="10160" cap="flat" cmpd="sng" algn="ctr">
+                      <a:solidFill>
+                        <a:srgbClr val="D9DEE5"/>
+                      </a:solidFill>
+                      <a:prstDash val="solid"/>
+                      <a:round/>
+                      <a:headEnd type="none" w="med" len="med"/>
+                      <a:tailEnd type="none" w="med" len="med"/>
+                    </a:lnT>
+                    <a:lnB w="10160" cap="flat" cmpd="sng" algn="ctr">
+                      <a:solidFill>
+                        <a:srgbClr val="D9DEE5"/>
+                      </a:solidFill>
+                      <a:prstDash val="solid"/>
+                      <a:round/>
+                      <a:headEnd type="none" w="med" len="med"/>
+                      <a:tailEnd type="none" w="med" len="med"/>
+                    </a:lnB>
+                    <a:solidFill>
+                      <a:srgbClr val="FFFFFF"/>
+                    </a:solidFill>
+                  </a:tcPr>
+                </a:tc>
+                <a:tc>
+                  <a:txBody>
+                    <a:bodyPr/>
+                    <a:lstStyle/>
+                    <a:p>
+                      <a:pPr indent="0" marL="0">
+                        <a:buNone/>
+                      </a:pPr>
+                      <a:r>
+                        <a:rPr lang="en-US" sz="1350" dirty="0">
+                          <a:solidFill>
+                            <a:srgbClr val="20262E"/>
+                          </a:solidFill>
+                          <a:latin typeface="Arial" pitchFamily="34" charset="0"/>
+                          <a:ea typeface="Arial" pitchFamily="34" charset="-122"/>
+                          <a:cs typeface="Arial" pitchFamily="34" charset="-120"/>
+                        </a:rPr>
+                        <a:t>d1baa7a</a:t>
+                      </a:r>
+                      <a:endParaRPr lang="en-US" sz="1350" dirty="0">
                         <a:latin typeface="Arial" charset="0"/>
                         <a:ea typeface="Arial" charset="0"/>
                         <a:cs typeface="Arial" charset="0"/>
@@ -19881,7 +20499,7 @@
                 <a:ea typeface="Arial" pitchFamily="34" charset="-122"/>
                 <a:cs typeface="Arial" pitchFamily="34" charset="-120"/>
               </a:rPr>
-              <a:t>API scope, pp. 30-32</a:t>
+              <a:t>API controller authorization attributes | API scope, pp. 30-32</a:t>
             </a:r>
             <a:endParaRPr lang="en-US" sz="850" dirty="0"/>
           </a:p>
@@ -19951,11 +20569,11 @@
             <a:tbl>
               <a:tblPr/>
               <a:tblGrid>
-                <a:gridCol w="2103120"/>
+                <a:gridCol w="1874520"/>
+                <a:gridCol w="1417320"/>
+                <a:gridCol w="1508760"/>
                 <a:gridCol w="1325880"/>
                 <a:gridCol w="1508760"/>
-                <a:gridCol w="1280160"/>
-                <a:gridCol w="1417320"/>
               </a:tblGrid>
               <a:tr h="502920">
                 <a:tc>
@@ -19975,7 +20593,7 @@
                           <a:ea typeface="Arial" pitchFamily="34" charset="-122"/>
                           <a:cs typeface="Arial" pitchFamily="34" charset="-120"/>
                         </a:rPr>
-                        <a:t>Endpoint group</a:t>
+                        <a:t>Endpoint</a:t>
                       </a:r>
                       <a:endParaRPr lang="en-US" sz="1250" dirty="0">
                         <a:latin typeface="Arial" charset="0"/>
@@ -20111,7 +20729,7 @@
                           <a:ea typeface="Arial" pitchFamily="34" charset="-122"/>
                           <a:cs typeface="Arial" pitchFamily="34" charset="-120"/>
                         </a:rPr>
-                        <a:t>FinanceManager</a:t>
+                        <a:t>Finance</a:t>
                       </a:r>
                       <a:endParaRPr lang="en-US" sz="1250" dirty="0">
                         <a:latin typeface="Arial" charset="0"/>
@@ -20385,7 +21003,7 @@
                           <a:ea typeface="Arial" pitchFamily="34" charset="-122"/>
                           <a:cs typeface="Arial" pitchFamily="34" charset="-120"/>
                         </a:rPr>
-                        <a:t>Full</a:t>
+                        <a:t>Login</a:t>
                       </a:r>
                       <a:endParaRPr lang="en-US" sz="1250" dirty="0">
                         <a:latin typeface="Arial" charset="0"/>
@@ -20453,7 +21071,7 @@
                           <a:ea typeface="Arial" pitchFamily="34" charset="-122"/>
                           <a:cs typeface="Arial" pitchFamily="34" charset="-120"/>
                         </a:rPr>
-                        <a:t>Role-based</a:t>
+                        <a:t>Login</a:t>
                       </a:r>
                       <a:endParaRPr lang="en-US" sz="1250" dirty="0">
                         <a:latin typeface="Arial" charset="0"/>
@@ -20521,7 +21139,7 @@
                           <a:ea typeface="Arial" pitchFamily="34" charset="-122"/>
                           <a:cs typeface="Arial" pitchFamily="34" charset="-120"/>
                         </a:rPr>
-                        <a:t>Own scope</a:t>
+                        <a:t>Login</a:t>
                       </a:r>
                       <a:endParaRPr lang="en-US" sz="1250" dirty="0">
                         <a:latin typeface="Arial" charset="0"/>
@@ -20589,7 +21207,7 @@
                           <a:ea typeface="Arial" pitchFamily="34" charset="-122"/>
                           <a:cs typeface="Arial" pitchFamily="34" charset="-120"/>
                         </a:rPr>
-                        <a:t>Limited</a:t>
+                        <a:t>Login</a:t>
                       </a:r>
                       <a:endParaRPr lang="en-US" sz="1250" dirty="0">
                         <a:latin typeface="Arial" charset="0"/>
@@ -20727,7 +21345,7 @@
                           <a:ea typeface="Arial" pitchFamily="34" charset="-122"/>
                           <a:cs typeface="Arial" pitchFamily="34" charset="-120"/>
                         </a:rPr>
-                        <a:t>Full</a:t>
+                        <a:t>Manage/self</a:t>
                       </a:r>
                       <a:endParaRPr lang="en-US" sz="1250" dirty="0">
                         <a:latin typeface="Arial" charset="0"/>
@@ -20795,7 +21413,7 @@
                           <a:ea typeface="Arial" pitchFamily="34" charset="-122"/>
                           <a:cs typeface="Arial" pitchFamily="34" charset="-120"/>
                         </a:rPr>
-                        <a:t>Role-based</a:t>
+                        <a:t>Self</a:t>
                       </a:r>
                       <a:endParaRPr lang="en-US" sz="1250" dirty="0">
                         <a:latin typeface="Arial" charset="0"/>
@@ -20863,7 +21481,7 @@
                           <a:ea typeface="Arial" pitchFamily="34" charset="-122"/>
                           <a:cs typeface="Arial" pitchFamily="34" charset="-120"/>
                         </a:rPr>
-                        <a:t>Own scope</a:t>
+                        <a:t>Self</a:t>
                       </a:r>
                       <a:endParaRPr lang="en-US" sz="1250" dirty="0">
                         <a:latin typeface="Arial" charset="0"/>
@@ -20931,7 +21549,7 @@
                           <a:ea typeface="Arial" pitchFamily="34" charset="-122"/>
                           <a:cs typeface="Arial" pitchFamily="34" charset="-120"/>
                         </a:rPr>
-                        <a:t>Limited</a:t>
+                        <a:t>Self</a:t>
                       </a:r>
                       <a:endParaRPr lang="en-US" sz="1250" dirty="0">
                         <a:latin typeface="Arial" charset="0"/>
@@ -21069,7 +21687,7 @@
                           <a:ea typeface="Arial" pitchFamily="34" charset="-122"/>
                           <a:cs typeface="Arial" pitchFamily="34" charset="-120"/>
                         </a:rPr>
-                        <a:t>Full</a:t>
+                        <a:t>Manage</a:t>
                       </a:r>
                       <a:endParaRPr lang="en-US" sz="1250" dirty="0">
                         <a:latin typeface="Arial" charset="0"/>
@@ -21137,7 +21755,7 @@
                           <a:ea typeface="Arial" pitchFamily="34" charset="-122"/>
                           <a:cs typeface="Arial" pitchFamily="34" charset="-120"/>
                         </a:rPr>
-                        <a:t>Role-based</a:t>
+                        <a:t>Read</a:t>
                       </a:r>
                       <a:endParaRPr lang="en-US" sz="1250" dirty="0">
                         <a:latin typeface="Arial" charset="0"/>
@@ -21205,7 +21823,7 @@
                           <a:ea typeface="Arial" pitchFamily="34" charset="-122"/>
                           <a:cs typeface="Arial" pitchFamily="34" charset="-120"/>
                         </a:rPr>
-                        <a:t>Own scope</a:t>
+                        <a:t>Read</a:t>
                       </a:r>
                       <a:endParaRPr lang="en-US" sz="1250" dirty="0">
                         <a:latin typeface="Arial" charset="0"/>
@@ -21479,7 +22097,7 @@
                           <a:ea typeface="Arial" pitchFamily="34" charset="-122"/>
                           <a:cs typeface="Arial" pitchFamily="34" charset="-120"/>
                         </a:rPr>
-                        <a:t>Role-based</a:t>
+                        <a:t>Create/post</a:t>
                       </a:r>
                       <a:endParaRPr lang="en-US" sz="1250" dirty="0">
                         <a:latin typeface="Arial" charset="0"/>
@@ -21547,7 +22165,7 @@
                           <a:ea typeface="Arial" pitchFamily="34" charset="-122"/>
                           <a:cs typeface="Arial" pitchFamily="34" charset="-120"/>
                         </a:rPr>
-                        <a:t>Own scope</a:t>
+                        <a:t>Create/read</a:t>
                       </a:r>
                       <a:endParaRPr lang="en-US" sz="1250" dirty="0">
                         <a:latin typeface="Arial" charset="0"/>
@@ -21753,7 +22371,7 @@
                           <a:ea typeface="Arial" pitchFamily="34" charset="-122"/>
                           <a:cs typeface="Arial" pitchFamily="34" charset="-120"/>
                         </a:rPr>
-                        <a:t>Full</a:t>
+                        <a:t>Manage/close</a:t>
                       </a:r>
                       <a:endParaRPr lang="en-US" sz="1250" dirty="0">
                         <a:latin typeface="Arial" charset="0"/>
@@ -21821,7 +22439,7 @@
                           <a:ea typeface="Arial" pitchFamily="34" charset="-122"/>
                           <a:cs typeface="Arial" pitchFamily="34" charset="-120"/>
                         </a:rPr>
-                        <a:t>Role-based</a:t>
+                        <a:t>Read/close</a:t>
                       </a:r>
                       <a:endParaRPr lang="en-US" sz="1250" dirty="0">
                         <a:latin typeface="Arial" charset="0"/>
@@ -21889,7 +22507,7 @@
                           <a:ea typeface="Arial" pitchFamily="34" charset="-122"/>
                           <a:cs typeface="Arial" pitchFamily="34" charset="-120"/>
                         </a:rPr>
-                        <a:t>Own scope</a:t>
+                        <a:t>Read</a:t>
                       </a:r>
                       <a:endParaRPr lang="en-US" sz="1250" dirty="0">
                         <a:latin typeface="Arial" charset="0"/>
@@ -22095,7 +22713,7 @@
                           <a:ea typeface="Arial" pitchFamily="34" charset="-122"/>
                           <a:cs typeface="Arial" pitchFamily="34" charset="-120"/>
                         </a:rPr>
-                        <a:t>Full</a:t>
+                        <a:t>Read</a:t>
                       </a:r>
                       <a:endParaRPr lang="en-US" sz="1250" dirty="0">
                         <a:latin typeface="Arial" charset="0"/>
@@ -22163,7 +22781,7 @@
                           <a:ea typeface="Arial" pitchFamily="34" charset="-122"/>
                           <a:cs typeface="Arial" pitchFamily="34" charset="-120"/>
                         </a:rPr>
-                        <a:t>Role-based</a:t>
+                        <a:t>Read</a:t>
                       </a:r>
                       <a:endParaRPr lang="en-US" sz="1250" dirty="0">
                         <a:latin typeface="Arial" charset="0"/>
@@ -22231,7 +22849,7 @@
                           <a:ea typeface="Arial" pitchFamily="34" charset="-122"/>
                           <a:cs typeface="Arial" pitchFamily="34" charset="-120"/>
                         </a:rPr>
-                        <a:t>Own scope</a:t>
+                        <a:t>-</a:t>
                       </a:r>
                       <a:endParaRPr lang="en-US" sz="1250" dirty="0">
                         <a:latin typeface="Arial" charset="0"/>
@@ -22437,7 +23055,7 @@
                           <a:ea typeface="Arial" pitchFamily="34" charset="-122"/>
                           <a:cs typeface="Arial" pitchFamily="34" charset="-120"/>
                         </a:rPr>
-                        <a:t>Admin</a:t>
+                        <a:t>Read</a:t>
                       </a:r>
                       <a:endParaRPr lang="en-US" sz="1250" dirty="0">
                         <a:latin typeface="Arial" charset="0"/>
@@ -22505,7 +23123,7 @@
                           <a:ea typeface="Arial" pitchFamily="34" charset="-122"/>
                           <a:cs typeface="Arial" pitchFamily="34" charset="-120"/>
                         </a:rPr>
-                        <a:t>Read</a:t>
+                        <a:t>-</a:t>
                       </a:r>
                       <a:endParaRPr lang="en-US" sz="1250" dirty="0">
                         <a:latin typeface="Arial" charset="0"/>
@@ -22573,7 +23191,7 @@
                           <a:ea typeface="Arial" pitchFamily="34" charset="-122"/>
                           <a:cs typeface="Arial" pitchFamily="34" charset="-120"/>
                         </a:rPr>
-                        <a:t>Own scope</a:t>
+                        <a:t>-</a:t>
                       </a:r>
                       <a:endParaRPr lang="en-US" sz="1250" dirty="0">
                         <a:latin typeface="Arial" charset="0"/>

</xml_diff>

<commit_message>
docs: distinguish JMeter virtual users from latency percentiles
</commit_message>
<xml_diff>
--- a/Document/outputs/final-defense/G6519692_Zaw_Ye_Htut_Ko_Final_Thesis_Defense.pptx
+++ b/Document/outputs/final-defense/G6519692_Zaw_Ye_Htut_Ko_Final_Thesis_Defense.pptx
@@ -1213,7 +1213,7 @@
           </a:p>
           <a:p>
             <a:r>
-              <a:t>The p50, p100, and p500 profiles exercise increasingly heavy core load. Soak and spike add sustained and sudden-load evidence. We report p95 latency, throughput, and errors for each. The research decision rule treats p50, p100, and p500 as primary; soak and spike are additional interpretation, not a substitute.</a:t>
+              <a:t>The 50, 100, and 500 virtual-user profiles exercise increasingly heavy core load. These are workload sizes, whereas p50, p90, p95, and p99 are response-time percentiles measured in milliseconds. Archived JMeter folder IDs retain p50, p100, and p500 for traceability. Soak and spike add sustained and sudden-load evidence; they are additional interpretation, not a substitute for the primary core gate.</a:t>
             </a:r>
           </a:p>
           <a:p/>
@@ -1305,7 +1305,7 @@
           </a:p>
           <a:p>
             <a:r>
-              <a:t>All three fresh core total-p95 values increased. p50 rose from thirty-three to about two hundred milliseconds, p100 from about two hundred fifty-six to one thousand one hundred forty-seven, and p500 from one hundred six to one thousand five hundred forty-eight. Errors stayed at zero, but p100 exceeded the five-hundred-millisecond limit and p500 exceeded twelve hundred, so the remediation core gate failed.</a:t>
+              <a:t>All three fresh core total-p95 values increased. At 50 VU, p95 rose from thirty-three to about two hundred milliseconds; at 100 VU, from about two hundred fifty-six to one thousand one hundred forty-seven; at 500 VU, from one hundred six to one thousand five hundred forty-eight. Errors stayed at zero, but the 100 VU and 500 VU limits were exceeded, so the remediation core gate failed.</a:t>
             </a:r>
           </a:p>
           <a:p/>
@@ -1402,7 +1402,7 @@
           </a:p>
           <a:p>
             <a:r>
-              <a:t>The soak aggregate p95 fell from 443.95 to 171 milliseconds. Spike aggregate p95 fell from about 33.4 seconds to 4.73 seconds, and spike errors fell to zero. These are meaningful fresh stress-profile gains, but the core p100 and p500 gate remains failed. I therefore call performance mixed, not generally improved.</a:t>
+              <a:t>The soak aggregate p95 fell from 443.95 to 171 milliseconds. Spike aggregate p95 fell from about 33.4 seconds to 4.73 seconds, and spike errors fell to zero. These are meaningful fresh stress-profile gains, but the core 100 VU and 500 VU gate remains failed. I therefore call performance mixed, not generally improved.</a:t>
             </a:r>
           </a:p>
           <a:p/>
@@ -1586,7 +1586,7 @@
           </a:p>
           <a:p>
             <a:r>
-              <a:t>I want to give the result before the details. The fresh September reproduction reduced SonarQube issues from seventeen to zero. ZAP passed the configured rule gate, but one raw Medium HTTP-only observation remained in the authenticated scan. JMeter's primary core gate failed on p100 and p500. Improvements in soak and spike do not cancel that failure.</a:t>
+              <a:t>I want to give the result before the details. The fresh September reproduction reduced SonarQube issues from seventeen to zero. ZAP passed the configured rule gate, but one raw Medium HTTP-only observation remained in the authenticated scan. JMeter's primary core gate failed at the 100 and 500 VU workloads. Improvements in soak and spike do not cancel that failure.</a:t>
             </a:r>
           </a:p>
           <a:p/>
@@ -3174,7 +3174,7 @@
           </a:p>
           <a:p>
             <a:r>
-              <a:t>KEY MESSAGE: Backup evidence: JMeter p50 · baseline vs remediation.</a:t>
+              <a:t>KEY MESSAGE: Backup evidence: JMeter 50 VU · baseline vs remediation.</a:t>
             </a:r>
           </a:p>
           <a:p/>
@@ -3271,7 +3271,7 @@
           </a:p>
           <a:p>
             <a:r>
-              <a:t>KEY MESSAGE: Backup evidence: JMeter p100 · baseline vs remediation.</a:t>
+              <a:t>KEY MESSAGE: Backup evidence: JMeter 100 VU · baseline vs remediation.</a:t>
             </a:r>
           </a:p>
           <a:p/>
@@ -3368,7 +3368,7 @@
           </a:p>
           <a:p>
             <a:r>
-              <a:t>KEY MESSAGE: Backup evidence: JMeter p500 · baseline vs remediation.</a:t>
+              <a:t>KEY MESSAGE: Backup evidence: JMeter 500 VU · baseline vs remediation.</a:t>
             </a:r>
           </a:p>
           <a:p/>
@@ -4421,7 +4421,7 @@
           </a:p>
           <a:p>
             <a:r>
-              <a:t>Static analysis has an issue count and a Quality Gate, but coverage and complexity also matter. ZAP has a configured gate, while raw observations still have to be disclosed. JMeter has primary p50, p100, and p500 core checks; p100 must stay at or below five hundred milliseconds and p500 at or below twelve hundred. We also require tests and role behavior to stay intact.</a:t>
+              <a:t>Static analysis has an issue count and a Quality Gate, but coverage and complexity also matter. ZAP has a configured gate, while raw observations still have to be disclosed. JMeter has primary 50, 100, and 500 VU core checks; 100 VU must stay at or below five hundred milliseconds and 500 VU at or below twelve hundred. We also require tests and role behavior to stay intact.</a:t>
             </a:r>
           </a:p>
           <a:p/>
@@ -13213,7 +13213,7 @@
                 </a:solidFill>
                 <a:latin typeface="Arial"/>
               </a:rPr>
-              <a:t>P50</a:t>
+              <a:t>50 VU</a:t>
             </a:r>
           </a:p>
         </p:txBody>
@@ -13384,7 +13384,7 @@
                 </a:solidFill>
                 <a:latin typeface="Arial"/>
               </a:rPr>
-              <a:t>P100</a:t>
+              <a:t>100 VU</a:t>
             </a:r>
           </a:p>
         </p:txBody>
@@ -13555,7 +13555,7 @@
                 </a:solidFill>
                 <a:latin typeface="Arial"/>
               </a:rPr>
-              <a:t>P500</a:t>
+              <a:t>500 VU</a:t>
             </a:r>
           </a:p>
         </p:txBody>
@@ -14023,7 +14023,7 @@
                 </a:solidFill>
                 <a:latin typeface="Arial"/>
               </a:rPr>
-              <a:t>The core p50/p100/p500 gate is the primary performance decision.</a:t>
+              <a:t>50/100/500 VU are workload sizes; p95 is a latency percentile.</a:t>
             </a:r>
           </a:p>
         </p:txBody>
@@ -14487,7 +14487,7 @@
                           </a:solidFill>
                           <a:latin typeface="Arial"/>
                         </a:rPr>
-                        <a:t>p50</a:t>
+                        <a:t>50 VU</a:t>
                       </a:r>
                     </a:p>
                   </a:txBody>
@@ -14597,7 +14597,7 @@
                           </a:solidFill>
                           <a:latin typeface="Arial"/>
                         </a:rPr>
-                        <a:t>p100</a:t>
+                        <a:t>100 VU</a:t>
                       </a:r>
                     </a:p>
                   </a:txBody>
@@ -14707,7 +14707,7 @@
                           </a:solidFill>
                           <a:latin typeface="Arial"/>
                         </a:rPr>
-                        <a:t>p500</a:t>
+                        <a:t>500 VU</a:t>
                       </a:r>
                     </a:p>
                   </a:txBody>
@@ -14883,7 +14883,7 @@
                 </a:solidFill>
                 <a:latin typeface="Arial"/>
               </a:rPr>
-              <a:t>FAIL: p100 1,146.9 &gt; 500 ms; p500 1,547.95 &gt; 1,200 ms</a:t>
+              <a:t>FAIL: 100 VU 1,146.9 &gt; 500 ms; 500 VU 1,547.95 &gt; 1,200 ms</a:t>
             </a:r>
           </a:p>
         </p:txBody>
@@ -15574,7 +15574,7 @@
                 </a:solidFill>
                 <a:latin typeface="Arial"/>
               </a:rPr>
-              <a:t>The core p100 and p500 failures still determine the overall performance judgment.</a:t>
+              <a:t>The core 100 VU and 500 VU failures still determine the overall performance judgment.</a:t>
             </a:r>
           </a:p>
         </p:txBody>
@@ -17188,7 +17188,7 @@
                 </a:solidFill>
                 <a:latin typeface="Arial"/>
               </a:rPr>
-              <a:t>p100 and p500 exceed limits</a:t>
+              <a:t>100 and 500 VU exceed limits</a:t>
             </a:r>
           </a:p>
         </p:txBody>
@@ -18584,7 +18584,7 @@
                           </a:solidFill>
                           <a:latin typeface="Arial"/>
                         </a:rPr>
-                        <a:t>p100 and p500 p95 exceeded thresholds</a:t>
+                        <a:t>100 VU and 500 VU p95 exceeded thresholds</a:t>
                       </a:r>
                     </a:p>
                   </a:txBody>
@@ -24935,7 +24935,7 @@
                           </a:solidFill>
                           <a:latin typeface="Arial"/>
                         </a:rPr>
-                        <a:t>p50</a:t>
+                        <a:t>50 VU</a:t>
                       </a:r>
                     </a:p>
                   </a:txBody>
@@ -25099,7 +25099,7 @@
                           </a:solidFill>
                           <a:latin typeface="Arial"/>
                         </a:rPr>
-                        <a:t>p100</a:t>
+                        <a:t>100 VU</a:t>
                       </a:r>
                     </a:p>
                   </a:txBody>
@@ -25263,7 +25263,7 @@
                           </a:solidFill>
                           <a:latin typeface="Arial"/>
                         </a:rPr>
-                        <a:t>p500</a:t>
+                        <a:t>500 VU</a:t>
                       </a:r>
                     </a:p>
                   </a:txBody>
@@ -25778,7 +25778,7 @@
                 </a:solidFill>
                 <a:latin typeface="Arial"/>
               </a:rPr>
-              <a:t>Baseline core gate PASS; remediation core gate FAIL (p100 and p500 thresholds).</a:t>
+              <a:t>Baseline core gate PASS; remediation core gate FAIL (100 VU and 500 VU thresholds).</a:t>
             </a:r>
           </a:p>
         </p:txBody>
@@ -31210,7 +31210,7 @@
                 </a:solidFill>
                 <a:latin typeface="Arial"/>
               </a:rPr>
-              <a:t>JMeter p50 · baseline vs remediation</a:t>
+              <a:t>JMeter 50 VU · baseline vs remediation</a:t>
             </a:r>
           </a:p>
         </p:txBody>
@@ -31820,7 +31820,7 @@
                 </a:solidFill>
                 <a:latin typeface="Arial"/>
               </a:rPr>
-              <a:t>JMeter p100 · baseline vs remediation</a:t>
+              <a:t>JMeter 100 VU · baseline vs remediation</a:t>
             </a:r>
           </a:p>
         </p:txBody>
@@ -32430,7 +32430,7 @@
                 </a:solidFill>
                 <a:latin typeface="Arial"/>
               </a:rPr>
-              <a:t>JMeter p500 · baseline vs remediation</a:t>
+              <a:t>JMeter 500 VU · baseline vs remediation</a:t>
             </a:r>
           </a:p>
         </p:txBody>
@@ -41420,7 +41420,7 @@
                           </a:solidFill>
                           <a:latin typeface="Arial"/>
                         </a:rPr>
-                        <a:t>p50/p100/p500 core gate</a:t>
+                        <a:t>50/100/500 VU core gate</a:t>
                       </a:r>
                     </a:p>
                   </a:txBody>
@@ -41447,7 +41447,7 @@
                           </a:solidFill>
                           <a:latin typeface="Arial"/>
                         </a:rPr>
-                        <a:t>p100 ≤500 ms; p500 ≤1200 ms</a:t>
+                        <a:t>100 VU ≤500 ms; 500 VU ≤1200 ms</a:t>
                       </a:r>
                     </a:p>
                   </a:txBody>

</xml_diff>

<commit_message>
docs: disclose hardware and service tier limits
</commit_message>
<xml_diff>
--- a/Document/outputs/final-defense/G6519692_Zaw_Ye_Htut_Ko_Final_Thesis_Defense.pptx
+++ b/Document/outputs/final-defense/G6519692_Zaw_Ye_Htut_Ko_Final_Thesis_Defense.pptx
@@ -1775,7 +1775,7 @@
           </a:p>
           <a:p>
             <a:r>
-              <a:t>Code quality met its primary criterion while coverage and cyclomatic complexity had small regressions. ZAP's configured rule gate passed, but the raw HTTP-only Medium remained. JMeter core performance did not meet its gate, though stress aggregates improved. This is one API on one host with one fresh run per branch, so the results are bounded and should be replicated before broader generalization.</a:t>
+              <a:t>Code quality met its primary criterion while coverage and cyclomatic complexity had small regressions. ZAP's configured rule gate passed, but the raw HTTP-only Medium remained. JMeter core performance did not meet its gate, though stress aggregates improved. This is one API on one host with one fresh run per branch. The dated evidence does not preserve CPU and RAM specifications or utilization, application and database resource limits, or a managed service tier. These results should be replicated under recorded and matched capacity before broader generalization.</a:t>
             </a:r>
           </a:p>
           <a:p/>
@@ -18719,7 +18719,7 @@
                 </a:solidFill>
                 <a:latin typeface="Arial"/>
               </a:rPr>
-              <a:t>Limits: one API · one host · one fresh run per branch · tool-specific coverage</a:t>
+              <a:t>Limits: one API · one host · one run per branch · CPU/RAM and service tiers not controlled</a:t>
             </a:r>
           </a:p>
         </p:txBody>

</xml_diff>

<commit_message>
docs: remove finding calendar dates from thesis narrative
</commit_message>
<xml_diff>
--- a/Document/outputs/final-defense/G6519692_Zaw_Ye_Htut_Ko_Final_Thesis_Defense.pptx
+++ b/Document/outputs/final-defense/G6519692_Zaw_Ye_Htut_Ko_Final_Thesis_Defense.pptx
@@ -932,7 +932,7 @@
           </a:p>
           <a:p>
             <a:r>
-              <a:t>These are native SonarQube captures from the fresh September reproduction, not a chart invented for the presentation. The baseline overview shows Security, Reliability, and Maintainability impacts plus 74.4 percent coverage. The remediation overview shows zero open issues and 74.3 percent coverage. Appendix L also includes the issue-list views if the committee asks for rule-level detail.</a:t>
+              <a:t>These are native SonarQube captures from the fresh reproduction, not a chart invented for the presentation. The baseline overview shows Security, Reliability, and Maintainability impacts plus 74.4 percent coverage. The remediation overview shows zero open issues and 74.3 percent coverage. Appendix L also includes the issue-list views if the committee asks for rule-level detail.</a:t>
             </a:r>
           </a:p>
           <a:p/>
@@ -1035,7 +1035,7 @@
           </a:p>
           <a:p>
             <a:r>
-              <a:t>CAUTION: Do not use the older March dashboard screenshot as proof of zero fresh API Medium alerts.</a:t>
+              <a:t>CAUTION: Do not use the historical dashboard screenshot as proof of zero fresh API Medium alerts.</a:t>
             </a:r>
           </a:p>
         </p:txBody>
@@ -1121,7 +1121,7 @@
           </a:p>
           <a:p>
             <a:r>
-              <a:t>The side-by-side ZAP screenshots were rendered from earlier March scan reports, and I label them historical on purpose. They show the tool's native alert summary and evidence layout. The current numerical claim comes from September's machine-readable scan JSON: one raw authenticated API Medium remains. This is why the thesis separates visual captures from fresh gate judgments.</a:t>
+              <a:t>The side-by-side ZAP screenshots were rendered from earlier scan reports, and I label them historical on purpose. They show the tool's native alert summary and evidence layout. The current numerical claim comes from the fresh machine-readable scan JSON: one raw authenticated API Medium remains. This is why the thesis separates visual captures from current gate judgments.</a:t>
             </a:r>
           </a:p>
           <a:p/>
@@ -1316,7 +1316,7 @@
           </a:p>
           <a:p>
             <a:r>
-              <a:t>CAUTION: Do not carry the older March core-gate PASS into this fresh result.</a:t>
+              <a:t>CAUTION: Do not carry the historical core-gate PASS into this fresh result.</a:t>
             </a:r>
           </a:p>
         </p:txBody>
@@ -1586,7 +1586,7 @@
           </a:p>
           <a:p>
             <a:r>
-              <a:t>I want to give the result before the details. The fresh September reproduction reduced SonarQube issues from seventeen to zero. ZAP passed the configured rule gate, but one raw Medium HTTP-only observation remained in the authenticated scan. JMeter's primary core gate failed at the 100 and 500 VU workloads. Improvements in soak and spike do not cancel that failure.</a:t>
+              <a:t>I want to give the result before the details. The fresh reproduction reduced SonarQube issues from seventeen to zero. ZAP passed the configured rule gate, but one raw Medium HTTP-only observation remained in the authenticated scan. JMeter's primary core gate failed at the 100 and 500 VU workloads. Improvements in soak and spike do not cancel that failure.</a:t>
             </a:r>
           </a:p>
           <a:p/>
@@ -2251,7 +2251,7 @@
           </a:p>
           <a:p>
             <a:r>
-              <a:t>CAUTION: Do not infer fresh zero-Medium API outcome from historical March dashboards.</a:t>
+              <a:t>CAUTION: Do not infer fresh zero-Medium API outcome from historical dashboards.</a:t>
             </a:r>
           </a:p>
         </p:txBody>
@@ -10121,7 +10121,7 @@
                 </a:solidFill>
                 <a:latin typeface="Arial"/>
               </a:rPr>
-              <a:t>Fresh September run</a:t>
+              <a:t>Current run</a:t>
             </a:r>
           </a:p>
         </p:txBody>
@@ -12819,7 +12819,7 @@
                 </a:solidFill>
                 <a:latin typeface="Arial"/>
               </a:rPr>
-              <a:t>Fresh September JSON is authoritative: the API still has 1 raw Medium after remediation.</a:t>
+              <a:t>Current scan JSON is authoritative: the API still has 1 raw Medium after remediation.</a:t>
             </a:r>
           </a:p>
         </p:txBody>
@@ -40707,7 +40707,7 @@
                 </a:solidFill>
                 <a:latin typeface="Arial"/>
               </a:rPr>
-              <a:t>Tool versions in the fresh September reproduction</a:t>
+              <a:t>Tool versions in the fresh reproduction</a:t>
             </a:r>
           </a:p>
         </p:txBody>

</xml_diff>

<commit_message>
docs: phrase core performance as unmet target in defense
</commit_message>
<xml_diff>
--- a/Document/outputs/final-defense/G6519692_Zaw_Ye_Htut_Ko_Final_Thesis_Defense.pptx
+++ b/Document/outputs/final-defense/G6519692_Zaw_Ye_Htut_Ko_Final_Thesis_Defense.pptx
@@ -651,7 +651,7 @@
           </a:p>
           <a:p>
             <a:r>
-              <a:t>The prompt contains the scanner or benchmark finding, a small relevant source excerpt, and constraints such as keeping tests and contracts intact. Codex suggests a patch. A human reviews it, the focused test suite runs, and the original tool is rerun. A patch can still fail its measured target; the JMeter result is the clearest example of that boundary.</a:t>
+              <a:t>The prompt contains the scanner or benchmark finding, a small relevant source excerpt, and constraints such as keeping tests and contracts intact. Codex suggests a patch. A human reviews it, the focused test suite runs, and the original tool is rerun. A patch can still miss its measured target; the JMeter result is the clearest example of that boundary.</a:t>
             </a:r>
           </a:p>
           <a:p/>
@@ -1305,7 +1305,7 @@
           </a:p>
           <a:p>
             <a:r>
-              <a:t>All three fresh core total-p95 values increased. At 50 VU, p95 rose from thirty-three to about two hundred milliseconds; at 100 VU, from about two hundred fifty-six to one thousand one hundred forty-seven; at 500 VU, from one hundred six to one thousand five hundred forty-eight. Errors stayed at zero, but the 100 VU and 500 VU limits were exceeded, so the remediation core gate failed.</a:t>
+              <a:t>All three fresh core total-p95 values increased. At 50 VU, p95 rose from thirty-three to about two hundred milliseconds; at 100 VU, from about two hundred fifty-six to one thousand one hundred forty-seven; at 500 VU, from one hundred six to one thousand five hundred forty-eight. Errors stayed at zero, but the 100 VU and 500 VU limits were exceeded, so the predefined core performance target was not met. The raw machine-readable gate status is FAIL.</a:t>
             </a:r>
           </a:p>
           <a:p/>
@@ -1391,7 +1391,7 @@
           </a:p>
           <a:p>
             <a:r>
-              <a:t>KEY MESSAGE: Stress gains are real but do not reverse the failed primary gate.</a:t>
+              <a:t>KEY MESSAGE: Stress gains are real but do not meet the primary core target.</a:t>
             </a:r>
           </a:p>
           <a:p/>
@@ -1402,7 +1402,7 @@
           </a:p>
           <a:p>
             <a:r>
-              <a:t>The soak aggregate p95 fell from 443.95 to 171 milliseconds. Spike aggregate p95 fell from about 33.4 seconds to 4.73 seconds, and spike errors fell to zero. These are meaningful fresh stress-profile gains, but the core 100 VU and 500 VU gate remains failed. I therefore call performance mixed, not generally improved.</a:t>
+              <a:t>The soak aggregate p95 fell from 443.95 to 171 milliseconds. Spike aggregate p95 fell from about 33.4 seconds to 4.73 seconds, and spike errors fell to zero. These are meaningful fresh stress-profile gains, but the core 100 VU and 500 VU target remains unmet. I therefore call performance mixed, not generally improved.</a:t>
             </a:r>
           </a:p>
           <a:p/>
@@ -1575,7 +1575,7 @@
           </a:p>
           <a:p>
             <a:r>
-              <a:t>KEY MESSAGE: Static quality succeeded; security has a disclosed residual; core performance failed.</a:t>
+              <a:t>KEY MESSAGE: Static quality succeeded; security has a disclosed residual; the core performance target was not met.</a:t>
             </a:r>
           </a:p>
           <a:p/>
@@ -1586,7 +1586,7 @@
           </a:p>
           <a:p>
             <a:r>
-              <a:t>I want to give the result before the details. The fresh reproduction reduced SonarQube issues from seventeen to zero. ZAP passed the configured rule gate, but one raw Medium HTTP-only observation remained in the authenticated scan. JMeter's primary core gate failed at the 100 and 500 VU workloads. Improvements in soak and spike do not cancel that failure.</a:t>
+              <a:t>I want to give the result before the details. The fresh reproduction reduced SonarQube issues from seventeen to zero. ZAP passed the configured rule gate, but one raw Medium HTTP-only observation remained in the authenticated scan. JMeter's primary core performance target was not met at the 100 and 500 VU workloads. Improvements in soak and spike do not change that conclusion.</a:t>
             </a:r>
           </a:p>
           <a:p/>
@@ -1867,7 +1867,7 @@
           </a:p>
           <a:p>
             <a:r>
-              <a:t>My answer is qualified. ChatGPT through Codex 5.4 helped close fresh static issues and pass the configured security gate. The same controlled workflow also showed a failed primary performance result rather than hiding it behind better stress charts. The contribution is a traceable method for asking the model to improve existing code and then allowing independent evidence to accept, limit, or reject the claim. Thank you; I welcome questions.</a:t>
+              <a:t>My answer is qualified. ChatGPT through Codex 5.4 helped close fresh static issues and pass the configured security gate. The same structured workflow also showed that the primary performance target was not met, rather than hiding it behind better stress charts. The contribution is a traceable method for asking the model to improve existing code and then allowing independent evidence to accept, limit, or reject the claim. Thank you; I welcome questions.</a:t>
             </a:r>
           </a:p>
           <a:p/>
@@ -14176,7 +14176,7 @@
                 </a:solidFill>
                 <a:latin typeface="Arial"/>
               </a:rPr>
-              <a:t>The fresh JMeter core gate failed</a:t>
+              <a:t>Core performance target was not met</a:t>
             </a:r>
           </a:p>
         </p:txBody>
@@ -14883,7 +14883,7 @@
                 </a:solidFill>
                 <a:latin typeface="Arial"/>
               </a:rPr>
-              <a:t>FAIL: 100 VU 1,146.9 &gt; 500 ms; 500 VU 1,547.95 &gt; 1,200 ms</a:t>
+              <a:t>NOT MET: 100 VU 1,146.9 &gt; 500 ms; 500 VU 1,547.95 &gt; 1,200 ms</a:t>
             </a:r>
           </a:p>
         </p:txBody>
@@ -15574,7 +15574,7 @@
                 </a:solidFill>
                 <a:latin typeface="Arial"/>
               </a:rPr>
-              <a:t>The core 100 VU and 500 VU failures still determine the overall performance judgment.</a:t>
+              <a:t>Core 100 and 500 VU limits were exceeded; stress gains do not change the decision.</a:t>
             </a:r>
           </a:p>
         </p:txBody>
@@ -17146,7 +17146,7 @@
                 </a:solidFill>
                 <a:latin typeface="Arial"/>
               </a:rPr>
-              <a:t>Core FAIL</a:t>
+              <a:t>Target not met</a:t>
             </a:r>
           </a:p>
         </p:txBody>
@@ -17317,7 +17317,7 @@
                 </a:solidFill>
                 <a:latin typeface="Arial"/>
               </a:rPr>
-              <a:t>ChatGPT-guided remediation closed the fresh static issues and passed the configured ZAP gate. It did not meet the primary JMeter core performance gate, despite better soak and spike aggregates.</a:t>
+              <a:t>ChatGPT-guided remediation closed the fresh static issues and passed the configured ZAP gate. It did not meet the predefined core performance target, despite better soak and spike aggregates.</a:t>
             </a:r>
           </a:p>
         </p:txBody>
@@ -19368,7 +19368,7 @@
                 </a:solidFill>
                 <a:latin typeface="Arial"/>
               </a:rPr>
-              <a:t>The fresh primary JMeter core gate failed despite stress gains.</a:t>
+              <a:t>The primary JMeter target was not met despite stress gains.</a:t>
             </a:r>
           </a:p>
         </p:txBody>
@@ -39758,7 +39758,7 @@
                 </a:solidFill>
                 <a:latin typeface="Arial"/>
               </a:rPr>
-              <a:t>Apply gates; disclose residuals and failures</a:t>
+              <a:t>Apply gates; disclose residuals and unmet targets</a:t>
             </a:r>
           </a:p>
         </p:txBody>
@@ -41625,7 +41625,7 @@
                 </a:solidFill>
                 <a:latin typeface="Arial"/>
               </a:rPr>
-              <a:t>A better stress-profile number cannot override a failed core performance gate.</a:t>
+              <a:t>A better stress-profile number cannot override an unmet core performance target.</a:t>
             </a:r>
           </a:p>
         </p:txBody>

</xml_diff>

<commit_message>
docs: explain JMeter peak and stress limits in defense
</commit_message>
<xml_diff>
--- a/Document/outputs/final-defense/G6519692_Zaw_Ye_Htut_Ko_Final_Thesis_Defense.pptx
+++ b/Document/outputs/final-defense/G6519692_Zaw_Ye_Htut_Ko_Final_Thesis_Defense.pptx
@@ -1305,13 +1305,13 @@
           </a:p>
           <a:p>
             <a:r>
-              <a:t>All three fresh core total-p95 values increased. At 50 VU, p95 rose from thirty-three to about two hundred milliseconds; at 100 VU, from about two hundred fifty-six to one thousand one hundred forty-seven; at 500 VU, from one hundred six to one thousand five hundred forty-eight. Errors stayed at zero, but the 100 VU and 500 VU limits were exceeded, so the predefined core performance target was not met. The raw machine-readable gate status is FAIL.</a:t>
+              <a:t>All three fresh core total-p95 values increased. At 50 VU, p95 rose from thirty-three to about two hundred milliseconds; at 100 VU, from about two hundred fifty-six to one thousand one hundred forty-seven; at 500 VU, from one hundred six to one thousand five hundred forty-eight. The different limits are engineering acceptance choices: 100 VU represents peak use, where the study asks for p95 within half a second; 500 VU is stress, where up to 1.2 seconds is allowed. They are not universal standards or a validated production SLA. Errors stayed at zero, but the measured p95 values exceeded both limits, so the predefined core performance target was not met. The raw machine-readable gate status is FAIL.</a:t>
             </a:r>
           </a:p>
           <a:p/>
           <a:p>
             <a:r>
-              <a:t>SOURCE: Fresh JMeter baseline/remediation summary.json; current report §4.4 and Table 4.5.</a:t>
+              <a:t>SOURCE: Document/JMETER_ZAP_TEST_PLAN.md §4.6; fresh JMeter baseline/remediation summary.json; current report §4.4 and Table 4.5.</a:t>
             </a:r>
           </a:p>
           <a:p>
@@ -4421,13 +4421,13 @@
           </a:p>
           <a:p>
             <a:r>
-              <a:t>Static analysis has an issue count and a Quality Gate, but coverage and complexity also matter. ZAP has a configured gate, while raw observations still have to be disclosed. JMeter has primary 50, 100, and 500 VU core checks; 100 VU must stay at or below five hundred milliseconds and 500 VU at or below twelve hundred. We also require tests and role behavior to stay intact.</a:t>
+              <a:t>Static analysis has an issue count and a Quality Gate, but coverage and complexity also matter. ZAP has a configured gate, while raw observations still have to be disclosed. JMeter has primary 50, 100, and 500 VU core checks. The 100 VU profile represents peak use, so the study sets a p95 target of five hundred milliseconds: 95 percent of requests should complete within half a second. The 500 VU profile is stress beyond normal use, so the study permits a longer p95 of twelve hundred milliseconds while still requiring bounded degradation. These are engineering acceptance choices set in the test plan before the retest, not universal industry standards or a validated production SLA. We report the raw response times as well as the gate judgment.</a:t>
             </a:r>
           </a:p>
           <a:p/>
           <a:p>
             <a:r>
-              <a:t>SOURCE: Current report Table 4.1 and §4.1.</a:t>
+              <a:t>SOURCE: Current report Table 4.1 and §4.1; Document/JMETER_ZAP_TEST_PLAN.md §4.6.</a:t>
             </a:r>
           </a:p>
         </p:txBody>
@@ -14884,6 +14884,48 @@
                 <a:latin typeface="Arial"/>
               </a:rPr>
               <a:t>NOT MET: 100 VU 1,146.9 &gt; 500 ms; 500 VU 1,547.95 &gt; 1,200 ms</a:t>
+            </a:r>
+          </a:p>
+        </p:txBody>
+      </p:sp>
+      <p:sp>
+        <p:nvSpPr>
+          <p:cNvPr id="12" name="TextBox 11"/>
+          <p:cNvSpPr txBox="1"/>
+          <p:nvPr/>
+        </p:nvSpPr>
+        <p:spPr>
+          <a:xfrm>
+            <a:off x="950976" y="5961888"/>
+            <a:ext cx="10195560" cy="466344"/>
+          </a:xfrm>
+          <a:prstGeom prst="rect">
+            <a:avLst/>
+          </a:prstGeom>
+          <a:noFill/>
+        </p:spPr>
+        <p:txBody>
+          <a:bodyPr wrap="square" lIns="18288" rIns="18288" tIns="18288" bIns="18288" anchor="ctr">
+            <a:spAutoFit/>
+          </a:bodyPr>
+          <a:lstStyle/>
+          <a:p>
+            <a:pPr algn="l">
+              <a:spcBef>
+                <a:spcPts val="0"/>
+              </a:spcBef>
+              <a:spcAft>
+                <a:spcPts val="0"/>
+              </a:spcAft>
+            </a:pPr>
+            <a:r>
+              <a:rPr sz="1600" b="0">
+                <a:solidFill>
+                  <a:srgbClr val="5B6874"/>
+                </a:solidFill>
+                <a:latin typeface="Arial"/>
+              </a:rPr>
+              <a:t>100 VU = peak responsiveness; 500 VU = stress tolerance. Study-defined, not universal.</a:t>
             </a:r>
           </a:p>
         </p:txBody>
@@ -41553,8 +41595,8 @@
         </p:nvSpPr>
         <p:spPr>
           <a:xfrm>
-            <a:off x="731520" y="5230368"/>
-            <a:ext cx="10716768" cy="603504"/>
+            <a:off x="731520" y="5138928"/>
+            <a:ext cx="10716768" cy="877824"/>
           </a:xfrm>
           <a:prstGeom prst="roundRect">
             <a:avLst/>
@@ -41596,8 +41638,8 @@
         </p:nvSpPr>
         <p:spPr>
           <a:xfrm>
-            <a:off x="960120" y="5303520"/>
-            <a:ext cx="10195560" cy="448056"/>
+            <a:off x="950976" y="5266944"/>
+            <a:ext cx="10222992" cy="640080"/>
           </a:xfrm>
           <a:prstGeom prst="rect">
             <a:avLst/>
@@ -41619,13 +41661,13 @@
               </a:spcAft>
             </a:pPr>
             <a:r>
-              <a:rPr sz="1900" b="1">
+              <a:rPr sz="1800" b="1">
                 <a:solidFill>
                   <a:srgbClr val="BE7414"/>
                 </a:solidFill>
                 <a:latin typeface="Arial"/>
               </a:rPr>
-              <a:t>A better stress-profile number cannot override an unmet core performance target.</a:t>
+              <a:t>100 VU is peak use—keep p95 within 0.5 s; 500 VU is stress—allow up to 1.2 s. Study-defined targets.</a:t>
             </a:r>
           </a:p>
         </p:txBody>

</xml_diff>

<commit_message>
docs: simplify defense notes and link evidence slides
</commit_message>
<xml_diff>
--- a/Document/outputs/final-defense/G6519692_Zaw_Ye_Htut_Ko_Final_Thesis_Defense.pptx
+++ b/Document/outputs/final-defense/G6519692_Zaw_Ye_Htut_Ko_Final_Thesis_Defense.pptx
@@ -551,6 +551,16 @@
               <a:t>KEY MESSAGE: This is an evidence-based evaluation of Codex 5.4 as an advisor.</a:t>
             </a:r>
           </a:p>
+          <a:p>
+            <a:r>
+              <a:t>SHOW IF ASKED: backup slide 23 (claim-to-evidence map)</a:t>
+            </a:r>
+          </a:p>
+          <a:p>
+            <a:r>
+              <a:t>APPENDIX: Appendix M</a:t>
+            </a:r>
+          </a:p>
           <a:p/>
           <a:p>
             <a:r>
@@ -640,7 +650,17 @@
           </a:p>
           <a:p>
             <a:r>
-              <a:t>KEY MESSAGE: The model is an advisor under a human-controlled test loop.</a:t>
+              <a:t>KEY MESSAGE: Codex suggested changes; I checked and measured them.</a:t>
+            </a:r>
+          </a:p>
+          <a:p>
+            <a:r>
+              <a:t>SHOW IF ASKED: backup slides 28-29 (before/after code)</a:t>
+            </a:r>
+          </a:p>
+          <a:p>
+            <a:r>
+              <a:t>APPENDIX: Appendices E-G, I, and K</a:t>
             </a:r>
           </a:p>
           <a:p/>
@@ -651,7 +671,7 @@
           </a:p>
           <a:p>
             <a:r>
-              <a:t>The prompt contains the scanner or benchmark finding, a small relevant source excerpt, and constraints such as keeping tests and contracts intact. Codex suggests a patch. A human reviews it, the focused test suite runs, and the original tool is rerun. A patch can still miss its measured target; the JMeter result is the clearest example of that boundary.</a:t>
+              <a:t>Here is one example. SonarQube flagged a controller with eight query parameters. I showed Codex that warning and the relevant code. It suggested a request DTO. I reviewed the edit, ran tests, and scanned the changed branch again. SonarQube issues went from 17 to zero. I followed the same check-again process for ZAP and JMeter, including the JMeter target that was not met.</a:t>
             </a:r>
           </a:p>
           <a:p/>
@@ -732,7 +752,17 @@
           </a:p>
           <a:p>
             <a:r>
-              <a:t>KEY MESSAGE: Similar-looking code changes can have very different measured outcomes.</a:t>
+              <a:t>KEY MESSAGE: The three branches changed different parts of the API.</a:t>
+            </a:r>
+          </a:p>
+          <a:p>
+            <a:r>
+              <a:t>SHOW IF ASKED: backup slides 28-29 (actual code changes)</a:t>
+            </a:r>
+          </a:p>
+          <a:p>
+            <a:r>
+              <a:t>APPENDIX: Appendices E-G</a:t>
             </a:r>
           </a:p>
           <a:p/>
@@ -743,7 +773,7 @@
           </a:p>
           <a:p>
             <a:r>
-              <a:t>For maintainability, a request DTO replaced a controller action with eight query parameters. For security, header middleware moved ahead of Swagger and UI exposure was constrained. For performance, the JMeter branch added ledger caching and reduced report persistence work. These are mechanisms, not proof of success by themselves; the tool results on the next slides show what actually happened.</a:t>
+              <a:t>For code quality, I replaced eight controller parameters with one request object. For security, I put security headers before Swagger. For performance, I added ledger caching and stopped saving a new report snapshot on that read path. These are the code changes I made; the next slides show whether the measurements improved.</a:t>
             </a:r>
           </a:p>
           <a:p/>
@@ -824,7 +854,17 @@
           </a:p>
           <a:p>
             <a:r>
-              <a:t>KEY MESSAGE: The fresh issue count reached zero, with small control-metric regressions disclosed.</a:t>
+              <a:t>KEY MESSAGE: The measurable SonarQube improvement is 17 distinct issues to zero.</a:t>
+            </a:r>
+          </a:p>
+          <a:p>
+            <a:r>
+              <a:t>SHOW IF ASKED: backup slides 25 and 31-32 (SonarQube data)</a:t>
+            </a:r>
+          </a:p>
+          <a:p>
+            <a:r>
+              <a:t>APPENDIX: Appendices E, L, and M</a:t>
             </a:r>
           </a:p>
           <a:p/>
@@ -835,18 +875,18 @@
           </a:p>
           <a:p>
             <a:r>
-              <a:t>SonarQube found seventeen distinct issues on the shared baseline and none on the SonarQube remediation branch. Both Quality Gates were OK. Coverage slipped from 74.4 to 74.3 percent and cyclomatic complexity rose by three, so I do not call those measures unchanged. The newer Reliability, Security, and Maintainability impact counts overlap; they are not nineteen separate issues.</a:t>
+              <a:t>SonarQube reported 17 distinct issues before the code change and zero after it. The gate status says OK for both scans, but the saved gate records contain no conditions, so I do not use OK alone as proof that the original code had no problems. Coverage fell slightly from 74.4 to 74.3 percent and complexity rose by three. The reliability, security, and maintainability labels can overlap; they are not extra issues to add to 17.</a:t>
             </a:r>
           </a:p>
           <a:p/>
           <a:p>
             <a:r>
-              <a:t>SOURCE: Current report Table 4.2, Appendix E, Figures L.1-L.4.</a:t>
-            </a:r>
-          </a:p>
-          <a:p>
-            <a:r>
-              <a:t>CAUTION: Legacy Bugs and Vulnerabilities are both zero; the MQR Security impact is a different classification.</a:t>
+              <a:t>SOURCE: Backup slides 25 and 31-32; SonarQube quality-gate.json and summary.json; current report Table 4.2, Appendices E and L.</a:t>
+            </a:r>
+          </a:p>
+          <a:p>
+            <a:r>
+              <a:t>CAUTION: The full report lists OK/OK; explain that the captured gate response has an empty conditions list.</a:t>
             </a:r>
           </a:p>
         </p:txBody>
@@ -921,7 +961,17 @@
           </a:p>
           <a:p>
             <a:r>
-              <a:t>KEY MESSAGE: The tool views correspond to the pinned baseline and remediation commits.</a:t>
+              <a:t>KEY MESSAGE: Both dashboards say OK, but the issue count is the useful comparison.</a:t>
+            </a:r>
+          </a:p>
+          <a:p>
+            <a:r>
+              <a:t>SHOW IF ASKED: backup slides 25 and 31-32 (SonarQube detail)</a:t>
+            </a:r>
+          </a:p>
+          <a:p>
+            <a:r>
+              <a:t>APPENDIX: Appendix L, Figures L.1-L.4</a:t>
             </a:r>
           </a:p>
           <a:p/>
@@ -932,13 +982,13 @@
           </a:p>
           <a:p>
             <a:r>
-              <a:t>These are native SonarQube captures from the fresh reproduction, not a chart invented for the presentation. The baseline overview shows Security, Reliability, and Maintainability impacts plus 74.4 percent coverage. The remediation overview shows zero open issues and 74.3 percent coverage. Appendix L also includes the issue-list views if the committee asks for rule-level detail.</a:t>
+              <a:t>If asked why both Quality Gates passed, point out that the saved gate files show OK with an empty list of conditions on each branch. That status therefore did not distinguish the scans. The baseline had 17 distinct issues; the changed branch had zero. Coverage moved from 74.4 to 74.3 percent, so I show that small decrease too. These are screenshots of the tool, not a new chart I made.</a:t>
             </a:r>
           </a:p>
           <a:p/>
           <a:p>
             <a:r>
-              <a:t>SOURCE: Appendix L Figures L.1-L.4 and dashboard-capture manifest.</a:t>
+              <a:t>SOURCE: Backup slides 25 and 31-32; Appendix L Figures L.1-L.4; sonar/baseline and remediation quality-gate.json.</a:t>
             </a:r>
           </a:p>
         </p:txBody>
@@ -1013,7 +1063,17 @@
           </a:p>
           <a:p>
             <a:r>
-              <a:t>KEY MESSAGE: The configured ZAP rule gate passed, but one raw Medium alert remains.</a:t>
+              <a:t>KEY MESSAGE: The remaining Medium alert is about the test connection.</a:t>
+            </a:r>
+          </a:p>
+          <a:p>
+            <a:r>
+              <a:t>SHOW IF ASKED: backup slide 26 (current ZAP counts)</a:t>
+            </a:r>
+          </a:p>
+          <a:p>
+            <a:r>
+              <a:t>APPENDIX: Appendices F and M</a:t>
             </a:r>
           </a:p>
           <a:p/>
@@ -1024,18 +1084,18 @@
           </a:p>
           <a:p>
             <a:r>
-              <a:t>In the fresh passive scan, Medium went from three to zero and Low from six to zero. In the authenticated API scan, Low went from three to zero, but Medium remained one. That observation is HTTP Only Site on the local HTTP transport. The configured business-endpoint rule set passed on both branches, but I do not say every raw Medium alert was eliminated.</a:t>
+              <a:t>ZAP saw that this local API was served over HTTP, not HTTPS, and named the alert HTTP Only Site. The other low-level API alerts went from three to zero. I cannot say the Medium alert was fixed, because I did not run this scan against a working HTTPS endpoint. It is not impossible to fix: set up HTTPS and repeat the scan. The configured rule gate passed, but the raw Medium alert remains visible.</a:t>
             </a:r>
           </a:p>
           <a:p/>
           <a:p>
             <a:r>
-              <a:t>SOURCE: Current report §4.3, fresh ZAP baseline/remediation summary.json, Appendix F.</a:t>
-            </a:r>
-          </a:p>
-          <a:p>
-            <a:r>
-              <a:t>CAUTION: Do not use the historical dashboard screenshot as proof of zero fresh API Medium alerts.</a:t>
+              <a:t>SOURCE: Backup slide 26; current report §4.3, Appendices F and M; ZAP remediation raw API JSON alert 10106.</a:t>
+            </a:r>
+          </a:p>
+          <a:p>
+            <a:r>
+              <a:t>CAUTION: The screenshots on backup slides 33-34 are historical; use slide 26 for current alert counts.</a:t>
             </a:r>
           </a:p>
         </p:txBody>
@@ -1113,6 +1173,16 @@
               <a:t>KEY MESSAGE: A dashboard screenshot and a fresh measurement can have different provenance.</a:t>
             </a:r>
           </a:p>
+          <a:p>
+            <a:r>
+              <a:t>SHOW IF ASKED: backup slide 26 for current counts; slides 33-34 for historical images</a:t>
+            </a:r>
+          </a:p>
+          <a:p>
+            <a:r>
+              <a:t>APPENDIX: Appendix L, Figures L.5-L.8</a:t>
+            </a:r>
+          </a:p>
           <a:p/>
           <a:p>
             <a:r>
@@ -1202,7 +1272,17 @@
           </a:p>
           <a:p>
             <a:r>
-              <a:t>KEY MESSAGE: Stress improvements cannot stand in for the core gate.</a:t>
+              <a:t>KEY MESSAGE: User count and response-time percentile are different things.</a:t>
+            </a:r>
+          </a:p>
+          <a:p>
+            <a:r>
+              <a:t>SHOW IF ASKED: backup slides 27 and 35-39 (JMeter profiles)</a:t>
+            </a:r>
+          </a:p>
+          <a:p>
+            <a:r>
+              <a:t>APPENDIX: Appendices K and L</a:t>
             </a:r>
           </a:p>
           <a:p/>
@@ -1213,7 +1293,7 @@
           </a:p>
           <a:p>
             <a:r>
-              <a:t>The 50, 100, and 500 virtual-user profiles exercise increasingly heavy core load. These are workload sizes, whereas p50, p90, p95, and p99 are response-time percentiles measured in milliseconds. Archived JMeter folder IDs retain p50, p100, and p500 for traceability. Soak and spike add sustained and sudden-load evidence; they are additional interpretation, not a substitute for the primary core gate.</a:t>
+              <a:t>VU means simulated users. The 50, 100, and 500 VU tests use different user counts; 100 VU is only the planned peak scenario, not a measured customer peak. Soak keeps traffic going for a long time. Spike sends a sudden burst. p95 is a time in milliseconds: 95 percent of requests finish at or below it. Soak and spike are extra tests; they do not replace the three core user-count checks.</a:t>
             </a:r>
           </a:p>
           <a:p/>
@@ -1294,7 +1374,17 @@
           </a:p>
           <a:p>
             <a:r>
-              <a:t>KEY MESSAGE: The primary performance criterion was not achieved.</a:t>
+              <a:t>KEY MESSAGE: The code changes did not meet the core speed target; the precise cause is unknown.</a:t>
+            </a:r>
+          </a:p>
+          <a:p>
+            <a:r>
+              <a:t>SHOW IF ASKED: backup slides 27, 29, and 36-37 (result, code, dashboards)</a:t>
+            </a:r>
+          </a:p>
+          <a:p>
+            <a:r>
+              <a:t>APPENDIX: Appendices G, K, L, and N</a:t>
             </a:r>
           </a:p>
           <a:p/>
@@ -1305,18 +1395,18 @@
           </a:p>
           <a:p>
             <a:r>
-              <a:t>All three fresh core total-p95 values increased. At 50 VU, p95 rose from thirty-three to about two hundred milliseconds; at 100 VU, from about two hundred fifty-six to one thousand one hundred forty-seven; at 500 VU, from one hundred six to one thousand five hundred forty-eight. The different limits are engineering acceptance choices: 100 VU represents peak use, where the study asks for p95 within half a second; 500 VU is stress, where up to 1.2 seconds is allowed. They are not universal standards or a validated production SLA. Errors stayed at zero, but the measured p95 values exceeded both limits, so the predefined core performance target was not met. The raw machine-readable gate status is FAIL.</a:t>
+              <a:t>The performance branch cached account-ledger data and stopped saving a new report snapshot on that read path. These changes were meant to reduce repeated work. In the fresh run, 100-user p95 rose from 255.9 to 1,146.9 milliseconds and 500-user p95 rose from 106 to 1,547.95 milliseconds. Both exceeded our study limits, although request errors stayed at zero. I cannot identify one cause for the slowdown: we have one run and no saved CPU, memory, database-query, or cache-hit measurements. I would repeat the tests with those measurements before blaming the code or the test computer.</a:t>
             </a:r>
           </a:p>
           <a:p/>
           <a:p>
             <a:r>
-              <a:t>SOURCE: Document/JMETER_ZAP_TEST_PLAN.md §4.6; fresh JMeter baseline/remediation summary.json; current report §4.4 and Table 4.5.</a:t>
-            </a:r>
-          </a:p>
-          <a:p>
-            <a:r>
-              <a:t>CAUTION: Do not carry the historical core-gate PASS into this fresh result.</a:t>
+              <a:t>SOURCE: Backup slide 29 and Appendix G for the code; slide 27 and slides 36-37 for the numbers and dashboards; Appendices K, L, and N for controls and limits.</a:t>
+            </a:r>
+          </a:p>
+          <a:p>
+            <a:r>
+              <a:t>CAUTION: Do not say caching or the host caused the slowdown; the evidence does not isolate either cause.</a:t>
             </a:r>
           </a:p>
         </p:txBody>
@@ -1391,7 +1481,17 @@
           </a:p>
           <a:p>
             <a:r>
-              <a:t>KEY MESSAGE: Stress gains are real but do not meet the primary core target.</a:t>
+              <a:t>KEY MESSAGE: Two additional tests improved, but the main user-count checks did not.</a:t>
+            </a:r>
+          </a:p>
+          <a:p>
+            <a:r>
+              <a:t>SHOW IF ASKED: backup slides 27 and 38-39 (soak and spike)</a:t>
+            </a:r>
+          </a:p>
+          <a:p>
+            <a:r>
+              <a:t>APPENDIX: Appendix L, Figures L.12-L.13 and L.17-L.18</a:t>
             </a:r>
           </a:p>
           <a:p/>
@@ -1402,7 +1502,7 @@
           </a:p>
           <a:p>
             <a:r>
-              <a:t>The soak aggregate p95 fell from 443.95 to 171 milliseconds. Spike aggregate p95 fell from about 33.4 seconds to 4.73 seconds, and spike errors fell to zero. These are meaningful fresh stress-profile gains, but the core 100 VU and 500 VU target remains unmet. I therefore call performance mixed, not generally improved.</a:t>
+              <a:t>Soak kept traffic going steadily; its total p95 fell from 443.95 to 171 milliseconds. Spike sent a sudden burst; its total p95 fell from about 33.4 seconds to 4.73 seconds. These are better results for those two tests. They are not the same thing as the 500-VU user-count test, and they do not erase the slower 100- and 500-VU core results. That is why I say the performance evidence is mixed.</a:t>
             </a:r>
           </a:p>
           <a:p/>
@@ -1483,7 +1583,17 @@
           </a:p>
           <a:p>
             <a:r>
-              <a:t>KEY MESSAGE: The account-ledger endpoint is a concrete counterexample to a universal speedup claim.</a:t>
+              <a:t>KEY MESSAGE: One report endpoint improved in one test and slowed in another.</a:t>
+            </a:r>
+          </a:p>
+          <a:p>
+            <a:r>
+              <a:t>SHOW IF ASKED: backup slides 27, 29, and 38-39 (mixed endpoint behavior)</a:t>
+            </a:r>
+          </a:p>
+          <a:p>
+            <a:r>
+              <a:t>APPENDIX: Appendix G; Table 4.4</a:t>
             </a:r>
           </a:p>
           <a:p/>
@@ -1494,7 +1604,7 @@
           </a:p>
           <a:p>
             <a:r>
-              <a:t>Under the fresh soak run, account-ledger p95 rose from about 742 to 3,826 milliseconds. Under spike it fell from about 50.3 seconds to 12.9 seconds. The summary report endpoints also improved under spike, but this one endpoint shows why a code mechanism or one workload cannot be generalized to all load conditions.</a:t>
+              <a:t>The account-ledger endpoint got slower during the long soak test: p95 rose from about 742 to 3,826 milliseconds. During the sudden spike test it improved, from about 50.3 seconds to 12.9 seconds. This does not tell us why. It shows that I cannot claim every report request became faster under every workload.</a:t>
             </a:r>
           </a:p>
           <a:p/>
@@ -1575,7 +1685,17 @@
           </a:p>
           <a:p>
             <a:r>
-              <a:t>KEY MESSAGE: Static quality succeeded; security has a disclosed residual; the core performance target was not met.</a:t>
+              <a:t>KEY MESSAGE: The results are mixed: code quality improved, security has one remaining alert, and core speed missed its target.</a:t>
+            </a:r>
+          </a:p>
+          <a:p>
+            <a:r>
+              <a:t>SHOW IF ASKED: backup slides 25-27 (three measured outcomes)</a:t>
+            </a:r>
+          </a:p>
+          <a:p>
+            <a:r>
+              <a:t>APPENDIX: Appendices E-G and M</a:t>
             </a:r>
           </a:p>
           <a:p/>
@@ -1586,7 +1706,7 @@
           </a:p>
           <a:p>
             <a:r>
-              <a:t>I want to give the result before the details. The fresh reproduction reduced SonarQube issues from seventeen to zero. ZAP passed the configured rule gate, but one raw Medium HTTP-only observation remained in the authenticated scan. JMeter's primary core performance target was not met at the 100 and 500 VU workloads. Improvements in soak and spike do not change that conclusion.</a:t>
+              <a:t>Here is the result first. SonarQube issues fell from 17 to zero. ZAP's selected checks passed, but the API scan still had one Medium alert because the local site used HTTP. JMeter response times at 100 and 500 simulated users were above our study limits. Soak and spike improved, but they are separate tests.</a:t>
             </a:r>
           </a:p>
           <a:p/>
@@ -1672,7 +1792,17 @@
           </a:p>
           <a:p>
             <a:r>
-              <a:t>KEY MESSAGE: The application evidence demonstrates the user-visible API path.</a:t>
+              <a:t>KEY MESSAGE: These are app screens, not speed-test results.</a:t>
+            </a:r>
+          </a:p>
+          <a:p>
+            <a:r>
+              <a:t>SHOW IF ASKED: backup slides 40-42 (browser views)</a:t>
+            </a:r>
+          </a:p>
+          <a:p>
+            <a:r>
+              <a:t>APPENDIX: Appendix J; Figures 4.2-4.7</a:t>
             </a:r>
           </a:p>
           <a:p/>
@@ -1683,7 +1813,7 @@
           </a:p>
           <a:p>
             <a:r>
-              <a:t>A React client signs in with JWT, shows roles, calls the accounting API, and presents reports and journal-entry lines. The dashboard and expanded journal detail shown here are captured from that workflow. They are not performance measurements, and their live displayed counts should not be confused with the fixed JMeter seed dataset. Other browser views, including auditor restrictions, are in the appendix.</a:t>
+              <a:t>The pictures show the admin dashboard and a journal entry whose debit and credit lines balance. They help demonstrate that a person can use the API through the web app. They do not show how fast the API is. For performance evidence, use backup slide 27 or the JMeter dashboards on slides 35-39.</a:t>
             </a:r>
           </a:p>
           <a:p/>
@@ -1764,7 +1894,17 @@
           </a:p>
           <a:p>
             <a:r>
-              <a:t>KEY MESSAGE: The thesis supports some improvements, not a blanket success claim.</a:t>
+              <a:t>KEY MESSAGE: The study does not support a blanket claim that everything improved.</a:t>
+            </a:r>
+          </a:p>
+          <a:p>
+            <a:r>
+              <a:t>SHOW IF ASKED: backup slides 25-27 (outcome details)</a:t>
+            </a:r>
+          </a:p>
+          <a:p>
+            <a:r>
+              <a:t>APPENDIX: Appendices M and N</a:t>
             </a:r>
           </a:p>
           <a:p/>
@@ -1775,7 +1915,7 @@
           </a:p>
           <a:p>
             <a:r>
-              <a:t>Code quality met its primary criterion while coverage and cyclomatic complexity had small regressions. ZAP's configured rule gate passed, but the raw HTTP-only Medium remained. JMeter core performance did not meet its gate, though stress aggregates improved. This is one API on one host with one fresh run per branch. The dated evidence does not preserve CPU and RAM specifications or utilization, application and database resource limits, or a managed service tier. These results should be replicated under recorded and matched capacity before broader generalization.</a:t>
+              <a:t>Code warnings fell from 17 to zero, although coverage fell a little and complexity rose. ZAP's selected checks passed, but the local HTTP alert stayed. JMeter missed the main 100- and 500-user speed targets even though soak and spike improved. This is one API on one computer with one fresh run per branch. We did not save CPU and memory readings for those runs, so I would repeat the tests before claiming the result applies elsewhere.</a:t>
             </a:r>
           </a:p>
           <a:p/>
@@ -1856,7 +1996,17 @@
           </a:p>
           <a:p>
             <a:r>
-              <a:t>KEY MESSAGE: Human review and repeatable tools decide which AI suggestions count.</a:t>
+              <a:t>KEY MESSAGE: The contribution is a way to check AI suggestions, including when they do not work.</a:t>
+            </a:r>
+          </a:p>
+          <a:p>
+            <a:r>
+              <a:t>SHOW IF ASKED: backup slide 23 (where every claim is checked)</a:t>
+            </a:r>
+          </a:p>
+          <a:p>
+            <a:r>
+              <a:t>APPENDIX: Appendices A, M, and N</a:t>
             </a:r>
           </a:p>
           <a:p/>
@@ -1867,7 +2017,7 @@
           </a:p>
           <a:p>
             <a:r>
-              <a:t>My answer is qualified. ChatGPT through Codex 5.4 helped close fresh static issues and pass the configured security gate. The same structured workflow also showed that the primary performance target was not met, rather than hiding it behind better stress charts. The contribution is a traceable method for asking the model to improve existing code and then allowing independent evidence to accept, limit, or reject the claim. Thank you; I welcome questions.</a:t>
+              <a:t>Codex helped me propose code changes. A person reviewed them, and the original tools measured the results. Code warnings reached zero and selected security checks passed, but the main performance target was not met. My contribution is the traceable process and this honest mixed result, not a claim that ChatGPT always improves an API. Thank you; I welcome questions.</a:t>
             </a:r>
           </a:p>
           <a:p/>
@@ -1959,13 +2109,13 @@
           </a:p>
           <a:p>
             <a:r>
-              <a:t>Open this slide only if the committee asks for the underlying records. Read the classification and source line before interpreting the screenshot or table.</a:t>
+              <a:t>Start with the claim in the left column. The middle column names the raw result file; the right column names the report section. The first row confirms the 120 seeded accounts used by the tests.</a:t>
             </a:r>
           </a:p>
           <a:p/>
           <a:p>
             <a:r>
-              <a:t>SOURCE: Current report Appendices A-N and dashboard-capture manifest.</a:t>
+              <a:t>SOURCE: branch-verification.json dataset counts; current report Appendices A-N.</a:t>
             </a:r>
           </a:p>
         </p:txBody>
@@ -2051,7 +2201,7 @@
           </a:p>
           <a:p>
             <a:r>
-              <a:t>Open this slide only if the committee asks for the underlying records. Read the classification and source line before interpreting the screenshot or table.</a:t>
+              <a:t>Open this slide if asked for proof. Point to the relevant number or code change, then name the source shown on the slide.</a:t>
             </a:r>
           </a:p>
           <a:p/>
@@ -2143,18 +2293,18 @@
           </a:p>
           <a:p>
             <a:r>
-              <a:t>Open this slide only if the committee asks for the underlying records. Read the classification and source line before interpreting the screenshot or table.</a:t>
+              <a:t>Point to Total unique issues: 17 before, zero after. The gate status is OK on both, but no gate conditions were saved, so do not use that status alone to claim improvement. Coverage slipped by 0.1 percentage point.</a:t>
             </a:r>
           </a:p>
           <a:p/>
           <a:p>
             <a:r>
-              <a:t>SOURCE: Current report Table 4.2; fresh SonarQube summary.json.</a:t>
-            </a:r>
-          </a:p>
-          <a:p>
-            <a:r>
-              <a:t>CAUTION: * MQR impacts overlap; do not sum them as unique issues.</a:t>
+              <a:t>SOURCE: Current report Table 4.2; fresh SonarQube summary.json and quality-gate.json.</a:t>
+            </a:r>
+          </a:p>
+          <a:p>
+            <a:r>
+              <a:t>CAUTION: * MQR impacts overlap; do not sum them as unique issues. Both saved gate files have an empty conditions list.</a:t>
             </a:r>
           </a:p>
         </p:txBody>
@@ -2240,7 +2390,7 @@
           </a:p>
           <a:p>
             <a:r>
-              <a:t>Open this slide only if the committee asks for the underlying records. Read the classification and source line before interpreting the screenshot or table.</a:t>
+              <a:t>Point to the Auth API after-fix row: Medium is still one, while Low is zero. The Medium is HTTP Only Site because the local scan used HTTP. The configured rule gate passed, but this raw alert was not cleared; an HTTPS retest is needed.</a:t>
             </a:r>
           </a:p>
           <a:p/>
@@ -2337,7 +2487,7 @@
           </a:p>
           <a:p>
             <a:r>
-              <a:t>Open this slide only if the committee asks for the underlying records. Read the classification and source line before interpreting the screenshot or table.</a:t>
+              <a:t>Point to the 100- and 500-VU rows. Their after-fix p95 values are higher than before and exceed the study limits, so the core target was not met. Soak and spike have lower p95 after the fix, but those are separate tests.</a:t>
             </a:r>
           </a:p>
           <a:p/>
@@ -2429,7 +2579,7 @@
           </a:p>
           <a:p>
             <a:r>
-              <a:t>Open this slide only if the committee asks for the underlying records. Read the classification and source line before interpreting the screenshot or table.</a:t>
+              <a:t>Open this slide if asked for proof. Point to the relevant number or code change, then name the source shown on the slide.</a:t>
             </a:r>
           </a:p>
           <a:p/>
@@ -2521,7 +2671,7 @@
           </a:p>
           <a:p>
             <a:r>
-              <a:t>Open this slide only if the committee asks for the underlying records. Read the classification and source line before interpreting the screenshot or table.</a:t>
+              <a:t>The left side shows the security-header change. The right side shows the performance attempt: cache ledger data and avoid a report snapshot write on this read path. This proves the change was made, not that it made the API faster. For speed numbers, open backup slide 27 and dashboards 36-37.</a:t>
             </a:r>
           </a:p>
           <a:p/>
@@ -2602,7 +2752,17 @@
           </a:p>
           <a:p>
             <a:r>
-              <a:t>KEY MESSAGE: The three risks need different measurements.</a:t>
+              <a:t>KEY MESSAGE: Code, security, and speed need different checks.</a:t>
+            </a:r>
+          </a:p>
+          <a:p>
+            <a:r>
+              <a:t>SHOW IF ASKED: backup slides 25-27 (the three risks)</a:t>
+            </a:r>
+          </a:p>
+          <a:p>
+            <a:r>
+              <a:t>APPENDIX: Appendices E-G</a:t>
             </a:r>
           </a:p>
           <a:p/>
@@ -2613,7 +2773,7 @@
           </a:p>
           <a:p>
             <a:r>
-              <a:t>A financial API can have source-code warnings, runtime security observations, and slow responses at the same time. These failures have different causes. That is why the study uses three independent tools and checks that remediation does not break the accounting behavior.</a:t>
+              <a:t>A program can have confusing code, unsafe web settings, and slow requests at the same time. One tool cannot check all three. I used SonarQube to read code, ZAP to test the running API, and JMeter to send load. I also ran tests to check that accounting behavior still worked.</a:t>
             </a:r>
           </a:p>
           <a:p/>
@@ -2705,7 +2865,7 @@
           </a:p>
           <a:p>
             <a:r>
-              <a:t>Open this slide only if the committee asks for the underlying records. Read the classification and source line before interpreting the screenshot or table.</a:t>
+              <a:t>Open this slide if asked for proof. Point to the relevant number or code change, then name the source shown on the slide.</a:t>
             </a:r>
           </a:p>
           <a:p/>
@@ -2797,7 +2957,7 @@
           </a:p>
           <a:p>
             <a:r>
-              <a:t>Open this slide only if the committee asks for the underlying records. Read the classification and source line before interpreting the screenshot or table.</a:t>
+              <a:t>The two current screenshots show different issue counts: 17 before and zero after. Both show Quality Gate OK, but the saved gate files contain no conditions. Do not present OK/OK as the evidence of improvement; use the issue counts and disclose that coverage fell slightly.</a:t>
             </a:r>
           </a:p>
           <a:p/>
@@ -2894,7 +3054,7 @@
           </a:p>
           <a:p>
             <a:r>
-              <a:t>Open this slide only if the committee asks for the underlying records. Read the classification and source line before interpreting the screenshot or table.</a:t>
+              <a:t>Point to the issue list: the baseline has 17 distinct findings and the changed branch has zero. These are the direct issue-count views; the gate status is separate.</a:t>
             </a:r>
           </a:p>
           <a:p/>
@@ -2991,7 +3151,7 @@
           </a:p>
           <a:p>
             <a:r>
-              <a:t>Open this slide only if the committee asks for the underlying records. Read the classification and source line before interpreting the screenshot or table.</a:t>
+              <a:t>These images came from earlier scans and show the native ZAP view. For the current passive counts, open backup slide 26. Do not read these old pictures as the fresh result.</a:t>
             </a:r>
           </a:p>
           <a:p/>
@@ -3088,7 +3248,7 @@
           </a:p>
           <a:p>
             <a:r>
-              <a:t>Open this slide only if the committee asks for the underlying records. Read the classification and source line before interpreting the screenshot or table.</a:t>
+              <a:t>These images are historical. The current authenticated API scan still has one Medium HTTP Only Site alert. Show backup slide 26 for current counts, not this older picture.</a:t>
             </a:r>
           </a:p>
           <a:p/>
@@ -3185,7 +3345,7 @@
           </a:p>
           <a:p>
             <a:r>
-              <a:t>Open this slide only if the committee asks for the underlying records. Read the classification and source line before interpreting the screenshot or table.</a:t>
+              <a:t>At 50 simulated users, total p95 rose from 33 to 199.9 milliseconds. It is slower after the code change, even though it stayed below this study's 300-millisecond limit.</a:t>
             </a:r>
           </a:p>
           <a:p/>
@@ -3282,7 +3442,7 @@
           </a:p>
           <a:p>
             <a:r>
-              <a:t>Open this slide only if the committee asks for the underlying records. Read the classification and source line before interpreting the screenshot or table.</a:t>
+              <a:t>In the Total row, find the 95th-percentile response time. At 100 VU, it rose from 255.9 to 1146.9 milliseconds. The after-fix value is above this study's 500-millisecond limit, so the core target was not met. This is a measurement, not proof of what caused the slowdown.</a:t>
             </a:r>
           </a:p>
           <a:p/>
@@ -3379,7 +3539,7 @@
           </a:p>
           <a:p>
             <a:r>
-              <a:t>Open this slide only if the committee asks for the underlying records. Read the classification and source line before interpreting the screenshot or table.</a:t>
+              <a:t>In the Total row, find the 95th-percentile response time. At 500 VU, it rose from 106 to 1547.95 milliseconds. The after-fix value is above this study's 1200-millisecond limit, so the core target was not met. This is a measurement, not proof of what caused the slowdown.</a:t>
             </a:r>
           </a:p>
           <a:p/>
@@ -3476,7 +3636,7 @@
           </a:p>
           <a:p>
             <a:r>
-              <a:t>Open this slide only if the committee asks for the underlying records. Read the classification and source line before interpreting the screenshot or table.</a:t>
+              <a:t>This long steady soak test had a lower total p95 after the change: 443.95 to 171 milliseconds. That is an improvement for this test only. It does not change the unmet 100- and 500-user core targets on slide 27.</a:t>
             </a:r>
           </a:p>
           <a:p/>
@@ -3573,7 +3733,7 @@
           </a:p>
           <a:p>
             <a:r>
-              <a:t>Open this slide only if the committee asks for the underlying records. Read the classification and source line before interpreting the screenshot or table.</a:t>
+              <a:t>This sudden spike test had a lower total p95 after the change: 33401.8 to 4730.85 milliseconds. That is an improvement for this test only. It does not change the unmet 100- and 500-user core targets on slide 27.</a:t>
             </a:r>
           </a:p>
           <a:p/>
@@ -3659,7 +3819,17 @@
           </a:p>
           <a:p>
             <a:r>
-              <a:t>KEY MESSAGE: Each research question has an acceptance rule.</a:t>
+              <a:t>KEY MESSAGE: I ask one measurable question for each tool.</a:t>
+            </a:r>
+          </a:p>
+          <a:p>
+            <a:r>
+              <a:t>SHOW IF ASKED: backup slides 25-27 (one answer per tool)</a:t>
+            </a:r>
+          </a:p>
+          <a:p>
+            <a:r>
+              <a:t>APPENDIX: Appendix M</a:t>
             </a:r>
           </a:p>
           <a:p/>
@@ -3670,7 +3840,7 @@
           </a:p>
           <a:p>
             <a:r>
-              <a:t>The first question is about code quality: can the issue count fall without overlooking coverage and complexity? The second is about security: can configured scanner rules pass while raw observations remain visible? The third is about performance: do the primary load gates pass, not just selected stress profiles? These rules were used to judge the results in Chapter Four.</a:t>
+              <a:t>First, did the code warnings decrease, and did coverage or complexity get worse? Second, did security alerts decrease, and what remained? Third, did the API stay within the response-time limits at the three user counts? I answer each question with the tool's before-and-after result, not with an AI opinion.</a:t>
             </a:r>
           </a:p>
           <a:p/>
@@ -3751,7 +3921,7 @@
           </a:p>
           <a:p>
             <a:r>
-              <a:t>KEY MESSAGE: Backup evidence: Application: administration and reporting.</a:t>
+              <a:t>KEY MESSAGE: Backup evidence: App screens—not load-test data.</a:t>
             </a:r>
           </a:p>
           <a:p/>
@@ -3762,7 +3932,7 @@
           </a:p>
           <a:p>
             <a:r>
-              <a:t>Open this slide only if the committee asks for the underlying records. Read the classification and source line before interpreting the screenshot or table.</a:t>
+              <a:t>These pictures show that a person can use the application and see its accounting screens. They do not measure speed. For JMeter response times, open backup slide 27 or dashboards 35-39.</a:t>
             </a:r>
           </a:p>
           <a:p/>
@@ -3859,7 +4029,7 @@
           </a:p>
           <a:p>
             <a:r>
-              <a:t>Open this slide only if the committee asks for the underlying records. Read the classification and source line before interpreting the screenshot or table.</a:t>
+              <a:t>These pictures show that a person can use the application and see its accounting screens. They do not measure speed. For JMeter response times, open backup slide 27 or dashboards 35-39.</a:t>
             </a:r>
           </a:p>
           <a:p/>
@@ -3956,7 +4126,7 @@
           </a:p>
           <a:p>
             <a:r>
-              <a:t>Open this slide only if the committee asks for the underlying records. Read the classification and source line before interpreting the screenshot or table.</a:t>
+              <a:t>These pictures show that a person can use the application and see its accounting screens. They do not measure speed. For JMeter response times, open backup slide 27 or dashboards 35-39.</a:t>
             </a:r>
           </a:p>
           <a:p/>
@@ -4042,7 +4212,17 @@
           </a:p>
           <a:p>
             <a:r>
-              <a:t>KEY MESSAGE: This is one nontrivial API, not a set of unrelated projects.</a:t>
+              <a:t>KEY MESSAGE: All comparisons use the same accounting API.</a:t>
+            </a:r>
+          </a:p>
+          <a:p>
+            <a:r>
+              <a:t>SHOW IF ASKED: backup slides 30 and 40-42 (API behavior)</a:t>
+            </a:r>
+          </a:p>
+          <a:p>
+            <a:r>
+              <a:t>APPENDIX: Appendices B-D, H, and J</a:t>
             </a:r>
           </a:p>
           <a:p/>
@@ -4053,7 +4233,7 @@
           </a:p>
           <a:p>
             <a:r>
-              <a:t>The evaluated system has accounting workflows, a SQL Server database, JWT authentication, four exact role names, protected write operations, report generation, and audit logging. The same API is measured before and after each tool-specific branch. The dashboard later in this talk is a demonstration client, not the benchmark dataset itself.</a:t>
+              <a:t>This API has login, four user roles, accounts, journal entries, reports, and an audit log. It uses a local SQL Server database. I compared a baseline with changed versions of this same API. The web screenshots later show that the app can be used; those screenshots are not JMeter performance measurements.</a:t>
             </a:r>
           </a:p>
           <a:p/>
@@ -4134,7 +4314,17 @@
           </a:p>
           <a:p>
             <a:r>
-              <a:t>KEY MESSAGE: Branch isolation makes each before-and-after comparison traceable.</a:t>
+              <a:t>KEY MESSAGE: Each tool's change has its own branch.</a:t>
+            </a:r>
+          </a:p>
+          <a:p>
+            <a:r>
+              <a:t>SHOW IF ASKED: backup slide 24 (tested commits)</a:t>
+            </a:r>
+          </a:p>
+          <a:p>
+            <a:r>
+              <a:t>APPENDIX: Appendix A</a:t>
             </a:r>
           </a:p>
           <a:p/>
@@ -4145,7 +4335,7 @@
           </a:p>
           <a:p>
             <a:r>
-              <a:t>We froze a common baseline at commit 7a0469d9. The SonarQube, ZAP, and JMeter changes were assessed on separate refs. The exact tested commits are recorded, so a later change to a branch name cannot silently change the result. I compare each remediation branch to that same baseline, one tool at a time.</a:t>
+              <a:t>I used one saved baseline version as the starting point. I put the code-quality, security, and performance changes on separate branches. That lets me compare each changed version with the same starting code. I also recorded the exact commits so the code being compared cannot silently change later.</a:t>
             </a:r>
           </a:p>
           <a:p/>
@@ -4226,7 +4416,17 @@
           </a:p>
           <a:p>
             <a:r>
-              <a:t>KEY MESSAGE: The model's suggestion is a candidate, not the result.</a:t>
+              <a:t>KEY MESSAGE: A suggestion must be checked before it becomes a result.</a:t>
+            </a:r>
+          </a:p>
+          <a:p>
+            <a:r>
+              <a:t>SHOW IF ASKED: backup slides 24 and 28-29 (source and tests)</a:t>
+            </a:r>
+          </a:p>
+          <a:p>
+            <a:r>
+              <a:t>APPENDIX: Appendices A, E-G, I, and K</a:t>
             </a:r>
           </a:p>
           <a:p/>
@@ -4237,7 +4437,7 @@
           </a:p>
           <a:p>
             <a:r>
-              <a:t>Phase one captures the baseline. Phase two supplies a tool finding, relevant code, and a narrow instruction to the model. Phase three is human review, tests, and a fresh run of the same measuring tool. Phase four compares the branch result with the baseline using the original decision rule. This prevents an attractive patch from being called successful just because it looks plausible.</a:t>
+              <a:t>First I saved the baseline result. Next I gave Codex a specific tool warning and the relevant code. Then I reviewed the suggested edit, ran tests, and ran the same tool again. Finally I compared the new number with the baseline and the study rule. A patch that looks good is not automatically a success.</a:t>
             </a:r>
           </a:p>
           <a:p/>
@@ -4318,7 +4518,17 @@
           </a:p>
           <a:p>
             <a:r>
-              <a:t>KEY MESSAGE: The comparison uses a reproducible local setup but only one host.</a:t>
+              <a:t>KEY MESSAGE: The 120 accounts are seeded test data, not customer records.</a:t>
+            </a:r>
+          </a:p>
+          <a:p>
+            <a:r>
+              <a:t>SHOW IF ASKED: backup slide 23 (120-account run record)</a:t>
+            </a:r>
+          </a:p>
+          <a:p>
+            <a:r>
+              <a:t>APPENDIX: Appendix H; Tables 3.10-3.11</a:t>
             </a:r>
           </a:p>
           <a:p/>
@@ -4329,13 +4539,13 @@
           </a:p>
           <a:p>
             <a:r>
-              <a:t>The seeded database contains 120 accounts and thirty thousand journal entries, with at least five thousand posted entries. The benchmark used one Windows 11 host, ASP.NET Core 8, local SQL Server, and pinned tool versions. These controls help repeat the run, but one host and one fresh run per branch are still important limitations.</a:t>
+              <a:t>The test scripts created 120 accounts and 30,000 journal entries. At least 5,000 entries were posted, so the report endpoints had data to process. This is not a screenshot of 120 individual accounts: the count is recorded in the run record. We used one local computer and one fresh run per branch, so the result is limited to this setup.</a:t>
             </a:r>
           </a:p>
           <a:p/>
           <a:p>
             <a:r>
-              <a:t>SOURCE: Current report Tables 3.2 and 3.11, Appendix H and verification summaries.</a:t>
+              <a:t>SOURCE: Backup slide 23; branch-verification.json dataset counts; current report Tables 3.10-3.11 and Appendix H.</a:t>
             </a:r>
           </a:p>
         </p:txBody>
@@ -4410,7 +4620,17 @@
           </a:p>
           <a:p>
             <a:r>
-              <a:t>KEY MESSAGE: A result is not called successful because one chart looks better.</a:t>
+              <a:t>KEY MESSAGE: Each tool has a rule, but the measured numbers still matter.</a:t>
+            </a:r>
+          </a:p>
+          <a:p>
+            <a:r>
+              <a:t>SHOW IF ASKED: backup slides 25-27 (results checked against the rules)</a:t>
+            </a:r>
+          </a:p>
+          <a:p>
+            <a:r>
+              <a:t>APPENDIX: Appendices K and M</a:t>
             </a:r>
           </a:p>
           <a:p/>
@@ -4421,7 +4641,7 @@
           </a:p>
           <a:p>
             <a:r>
-              <a:t>Static analysis has an issue count and a Quality Gate, but coverage and complexity also matter. ZAP has a configured gate, while raw observations still have to be disclosed. JMeter has primary 50, 100, and 500 VU core checks. The 100 VU profile represents peak use, so the study sets a p95 target of five hundred milliseconds: 95 percent of requests should complete within half a second. The 500 VU profile is stress beyond normal use, so the study permits a longer p95 of twelve hundred milliseconds while still requiring bounded degradation. These are engineering acceptance choices set in the test plan before the retest, not universal industry standards or a validated production SLA. We report the raw response times as well as the gate judgment.</a:t>
+              <a:t>I named 100 simulated users the peak scenario and 500 the heavier-load scenario in the test plan. This was not a measured peak from real customers. The study set p95 targets of 500 milliseconds and 1,200 milliseconds respectively. Those numbers are study choices, not universal standards. I compare the after-fix result with each target and still report the actual time, so the committee can see more than a pass/fail label.</a:t>
             </a:r>
           </a:p>
           <a:p/>
@@ -7962,7 +8182,7 @@
                 </a:solidFill>
                 <a:latin typeface="Arial"/>
               </a:rPr>
-              <a:t>Codex proposed; humans and tools decided</a:t>
+              <a:t>From a tool warning to a measured result</a:t>
             </a:r>
           </a:p>
         </p:txBody>
@@ -8203,7 +8423,7 @@
                 </a:solidFill>
                 <a:latin typeface="Arial"/>
               </a:rPr>
-              <a:t>Native tool finding</a:t>
+              <a:t>Tool finding</a:t>
             </a:r>
           </a:p>
         </p:txBody>
@@ -8332,7 +8552,7 @@
                 </a:solidFill>
                 <a:latin typeface="Arial"/>
               </a:rPr>
-              <a:t>Bounded code context</a:t>
+              <a:t>Relevant code</a:t>
             </a:r>
           </a:p>
         </p:txBody>
@@ -8461,7 +8681,7 @@
                 </a:solidFill>
                 <a:latin typeface="Arial"/>
               </a:rPr>
-              <a:t>Candidate patch</a:t>
+              <a:t>Suggested edit</a:t>
             </a:r>
           </a:p>
         </p:txBody>
@@ -8590,7 +8810,7 @@
                 </a:solidFill>
                 <a:latin typeface="Arial"/>
               </a:rPr>
-              <a:t>Human review</a:t>
+              <a:t>Human check</a:t>
             </a:r>
           </a:p>
         </p:txBody>
@@ -8719,7 +8939,7 @@
                 </a:solidFill>
                 <a:latin typeface="Arial"/>
               </a:rPr>
-              <a:t>Tests</a:t>
+              <a:t>Run tests</a:t>
             </a:r>
           </a:p>
         </p:txBody>
@@ -8848,7 +9068,7 @@
                 </a:solidFill>
                 <a:latin typeface="Arial"/>
               </a:rPr>
-              <a:t>Tool rerun</a:t>
+              <a:t>Measure again</a:t>
             </a:r>
           </a:p>
         </p:txBody>
@@ -8935,7 +9155,7 @@
                 </a:solidFill>
                 <a:latin typeface="Arial"/>
               </a:rPr>
-              <a:t>Every accepted interpretation is linked to a branch, a tested commit, and a machine-readable run.</a:t>
+              <a:t>An AI suggestion is not proof: a person checks it, then the same tool measures the result.</a:t>
             </a:r>
           </a:p>
         </p:txBody>
@@ -9564,7 +9784,7 @@
                           </a:solidFill>
                           <a:latin typeface="Arial"/>
                         </a:rPr>
-                        <a:t>Ledger caching; avoid report write amplification</a:t>
+                        <a:t>Cache ledger data; avoid repeated report snapshot writes</a:t>
                       </a:r>
                     </a:p>
                   </a:txBody>
@@ -9591,7 +9811,7 @@
                           </a:solidFill>
                           <a:latin typeface="Arial"/>
                         </a:rPr>
-                        <a:t>Repeated report calculation and database pressure</a:t>
+                        <a:t>Reduce repeated report and database work</a:t>
                       </a:r>
                     </a:p>
                   </a:txBody>
@@ -10292,7 +10512,7 @@
                 </a:solidFill>
                 <a:latin typeface="Arial"/>
               </a:rPr>
-              <a:t>Both branches pass</a:t>
+              <a:t>No gate conditions recorded</a:t>
             </a:r>
           </a:p>
         </p:txBody>
@@ -10745,7 +10965,7 @@
                 </a:solidFill>
                 <a:latin typeface="Arial"/>
               </a:rPr>
-              <a:t>Native SonarQube views support the metric table</a:t>
+              <a:t>SonarQube issues changed; gate status did not</a:t>
             </a:r>
           </a:p>
         </p:txBody>
@@ -10857,7 +11077,7 @@
                 </a:solidFill>
                 <a:latin typeface="Arial"/>
               </a:rPr>
-              <a:t>Fresh Sep 22 capture · Appendix L, Figures L.1 and L.3</a:t>
+              <a:t>Current capture · Appendix L, Figures L.1 and L.3</a:t>
             </a:r>
           </a:p>
         </p:txBody>
@@ -11130,8 +11350,8 @@
         </p:nvSpPr>
         <p:spPr>
           <a:xfrm>
-            <a:off x="768096" y="5477256"/>
-            <a:ext cx="10643616" cy="539496"/>
+            <a:off x="768096" y="5413248"/>
+            <a:ext cx="10643616" cy="685800"/>
           </a:xfrm>
           <a:prstGeom prst="roundRect">
             <a:avLst/>
@@ -11173,8 +11393,8 @@
         </p:nvSpPr>
         <p:spPr>
           <a:xfrm>
-            <a:off x="978408" y="5550408"/>
-            <a:ext cx="10232136" cy="374904"/>
+            <a:off x="978408" y="5495544"/>
+            <a:ext cx="10232136" cy="502920"/>
           </a:xfrm>
           <a:prstGeom prst="rect">
             <a:avLst/>
@@ -11202,7 +11422,7 @@
                 </a:solidFill>
                 <a:latin typeface="Arial"/>
               </a:rPr>
-              <a:t>Fresh source screenshots; use Appendix L for the larger overview and issue views.</a:t>
+              <a:t>Gate OK/OK has no recorded conditions; the measured improvement is 17 issues → 0.</a:t>
             </a:r>
           </a:p>
         </p:txBody>
@@ -12214,6 +12434,48 @@
           </a:p>
         </p:txBody>
       </p:sp>
+      <p:sp>
+        <p:nvSpPr>
+          <p:cNvPr id="18" name="TextBox 17"/>
+          <p:cNvSpPr txBox="1"/>
+          <p:nvPr/>
+        </p:nvSpPr>
+        <p:spPr>
+          <a:xfrm>
+            <a:off x="777240" y="5751576"/>
+            <a:ext cx="10652760" cy="420624"/>
+          </a:xfrm>
+          <a:prstGeom prst="rect">
+            <a:avLst/>
+          </a:prstGeom>
+          <a:noFill/>
+        </p:spPr>
+        <p:txBody>
+          <a:bodyPr wrap="square" lIns="18288" rIns="18288" tIns="18288" bIns="18288" anchor="ctr">
+            <a:spAutoFit/>
+          </a:bodyPr>
+          <a:lstStyle/>
+          <a:p>
+            <a:pPr algn="l">
+              <a:spcBef>
+                <a:spcPts val="0"/>
+              </a:spcBef>
+              <a:spcAft>
+                <a:spcPts val="0"/>
+              </a:spcAft>
+            </a:pPr>
+            <a:r>
+              <a:rPr sz="1600" b="1">
+                <a:solidFill>
+                  <a:srgbClr val="BE7414"/>
+                </a:solidFill>
+                <a:latin typeface="Arial"/>
+              </a:rPr>
+              <a:t>Local HTTP caused the alert; an HTTPS retest is needed before claiming it is cleared.</a:t>
+            </a:r>
+          </a:p>
+        </p:txBody>
+      </p:sp>
     </p:spTree>
   </p:cSld>
   <p:clrMapOvr>
@@ -12972,7 +13234,7 @@
                 </a:solidFill>
                 <a:latin typeface="Arial"/>
               </a:rPr>
-              <a:t>JMeter measured three core profiles and two stress profiles</a:t>
+              <a:t>JMeter tested three user counts, plus soak and spike</a:t>
             </a:r>
           </a:p>
         </p:txBody>
@@ -13297,7 +13559,7 @@
                 </a:solidFill>
                 <a:latin typeface="Arial"/>
               </a:rPr>
-              <a:t>Normal load</a:t>
+              <a:t>Normal scenario</a:t>
             </a:r>
           </a:p>
         </p:txBody>
@@ -13468,7 +13730,7 @@
                 </a:solidFill>
                 <a:latin typeface="Arial"/>
               </a:rPr>
-              <a:t>Higher concurrency</a:t>
+              <a:t>Planned peak scenario</a:t>
             </a:r>
           </a:p>
         </p:txBody>
@@ -13639,7 +13901,7 @@
                 </a:solidFill>
                 <a:latin typeface="Arial"/>
               </a:rPr>
-              <a:t>Heavy concurrency</a:t>
+              <a:t>Heavier-load scenario</a:t>
             </a:r>
           </a:p>
         </p:txBody>
@@ -13768,7 +14030,7 @@
                 </a:solidFill>
                 <a:latin typeface="Arial"/>
               </a:rPr>
-              <a:t>sustained</a:t>
+              <a:t>steady</a:t>
             </a:r>
           </a:p>
         </p:txBody>
@@ -13810,7 +14072,7 @@
                 </a:solidFill>
                 <a:latin typeface="Arial"/>
               </a:rPr>
-              <a:t>Long-running behavior</a:t>
+              <a:t>Long-running test</a:t>
             </a:r>
           </a:p>
         </p:txBody>
@@ -13981,7 +14243,7 @@
                 </a:solidFill>
                 <a:latin typeface="Arial"/>
               </a:rPr>
-              <a:t>Surge and recovery</a:t>
+              <a:t>Sudden-load test</a:t>
             </a:r>
           </a:p>
         </p:txBody>
@@ -14017,13 +14279,13 @@
               </a:spcAft>
             </a:pPr>
             <a:r>
-              <a:rPr sz="2400" b="1">
+              <a:rPr sz="2200" b="1">
                 <a:solidFill>
                   <a:srgbClr val="BE7414"/>
                 </a:solidFill>
                 <a:latin typeface="Arial"/>
               </a:rPr>
-              <a:t>50/100/500 VU are workload sizes; p95 is a latency percentile.</a:t>
+              <a:t>VU means simulated users; p95 is the time within which 95% of requests finish.</a:t>
             </a:r>
           </a:p>
         </p:txBody>
@@ -14896,7 +15158,7 @@
         </p:nvSpPr>
         <p:spPr>
           <a:xfrm>
-            <a:off x="950976" y="5961888"/>
+            <a:off x="950976" y="5833872"/>
             <a:ext cx="10195560" cy="466344"/>
           </a:xfrm>
           <a:prstGeom prst="rect">
@@ -14925,7 +15187,7 @@
                 </a:solidFill>
                 <a:latin typeface="Arial"/>
               </a:rPr>
-              <a:t>100 VU = peak responsiveness; 500 VU = stress tolerance. Study-defined, not universal.</a:t>
+              <a:t>Fixes: cache ledger data; avoid report snapshot writes. Exact cause of slowdown not isolated.</a:t>
             </a:r>
           </a:p>
         </p:txBody>
@@ -15078,7 +15340,7 @@
                 </a:solidFill>
                 <a:latin typeface="Arial"/>
               </a:rPr>
-              <a:t>Soak and spike improved, but they are secondary</a:t>
+              <a:t>Soak and spike improved; core targets did not</a:t>
             </a:r>
           </a:p>
         </p:txBody>
@@ -15610,13 +15872,13 @@
               </a:spcAft>
             </a:pPr>
             <a:r>
-              <a:rPr sz="2000" b="1">
+              <a:rPr sz="1900" b="1">
                 <a:solidFill>
                   <a:srgbClr val="B3373D"/>
                 </a:solidFill>
                 <a:latin typeface="Arial"/>
               </a:rPr>
-              <a:t>Core 100 and 500 VU limits were exceeded; stress gains do not change the decision.</a:t>
+              <a:t>Soak = long steady run; spike = sudden burst. Neither replaces the 100/500 VU core checks.</a:t>
             </a:r>
           </a:p>
         </p:txBody>
@@ -16410,7 +16672,7 @@
                 </a:solidFill>
                 <a:latin typeface="Arial"/>
               </a:rPr>
-              <a:t>Caching and query changes can help one workload while making another worse. Endpoint results and core aggregate gates must both be read.</a:t>
+              <a:t>The same endpoint behaved differently under two workloads. These results do not identify one cause.</a:t>
             </a:r>
           </a:p>
         </p:txBody>
@@ -18123,7 +18385,7 @@
                 </a:solidFill>
                 <a:latin typeface="Arial"/>
               </a:rPr>
-              <a:t>The decision is deliberately asymmetric</a:t>
+              <a:t>The three results are different</a:t>
             </a:r>
           </a:p>
         </p:txBody>
@@ -18914,7 +19176,7 @@
                 </a:solidFill>
                 <a:latin typeface="Arial"/>
               </a:rPr>
-              <a:t>The strongest result is the controlled audit-to-fix method</a:t>
+              <a:t>The strongest contribution is the traceable check-and-fix method</a:t>
             </a:r>
           </a:p>
         </p:txBody>
@@ -19410,7 +19672,7 @@
                 </a:solidFill>
                 <a:latin typeface="Arial"/>
               </a:rPr>
-              <a:t>The primary JMeter target was not met despite stress gains.</a:t>
+              <a:t>The primary JMeter target was not met despite better soak and spike results.</a:t>
             </a:r>
           </a:p>
         </p:txBody>
@@ -19945,7 +20207,7 @@
         </p:nvGraphicFramePr>
         <p:xfrm>
           <a:off x="731520" y="1389888"/>
-          <a:ext cx="10716766" cy="3895344"/>
+          <a:ext cx="10716766" cy="4187952"/>
         </p:xfrm>
         <a:graphic>
           <a:graphicData uri="http://schemas.openxmlformats.org/drawingml/2006/table">
@@ -19958,7 +20220,7 @@
                 <a:gridCol w="3215030"/>
                 <a:gridCol w="5036880"/>
               </a:tblGrid>
-              <a:tr h="779068">
+              <a:tr h="697992">
                 <a:tc>
                   <a:txBody>
                     <a:bodyPr/>
@@ -20041,7 +20303,7 @@
                   </a:tcPr>
                 </a:tc>
               </a:tr>
-              <a:tr h="779068">
+              <a:tr h="697992">
                 <a:tc>
                   <a:txBody>
                     <a:bodyPr/>
@@ -20059,7 +20321,7 @@
                           </a:solidFill>
                           <a:latin typeface="Arial"/>
                         </a:rPr>
-                        <a:t>Static issues</a:t>
+                        <a:t>Dataset: 120 accounts</a:t>
                       </a:r>
                     </a:p>
                   </a:txBody>
@@ -20086,7 +20348,7 @@
                           </a:solidFill>
                           <a:latin typeface="Arial"/>
                         </a:rPr>
-                        <a:t>sonar/*/summary.json</a:t>
+                        <a:t>branch-verification.json</a:t>
                       </a:r>
                     </a:p>
                   </a:txBody>
@@ -20113,7 +20375,7 @@
                           </a:solidFill>
                           <a:latin typeface="Arial"/>
                         </a:rPr>
-                        <a:t>Table 4.2 · Appendix E · Figures L.1-L.4</a:t>
+                        <a:t>Tables 3.10-3.11 · Appendix H</a:t>
                       </a:r>
                     </a:p>
                   </a:txBody>
@@ -20124,7 +20386,7 @@
                   </a:tcPr>
                 </a:tc>
               </a:tr>
-              <a:tr h="779068">
+              <a:tr h="697992">
                 <a:tc>
                   <a:txBody>
                     <a:bodyPr/>
@@ -20142,7 +20404,7 @@
                           </a:solidFill>
                           <a:latin typeface="Arial"/>
                         </a:rPr>
-                        <a:t>ZAP raw/gate</a:t>
+                        <a:t>Static issues</a:t>
                       </a:r>
                     </a:p>
                   </a:txBody>
@@ -20169,7 +20431,7 @@
                           </a:solidFill>
                           <a:latin typeface="Arial"/>
                         </a:rPr>
-                        <a:t>zap/*/summary.json</a:t>
+                        <a:t>sonar/*/summary.json</a:t>
                       </a:r>
                     </a:p>
                   </a:txBody>
@@ -20196,7 +20458,7 @@
                           </a:solidFill>
                           <a:latin typeface="Arial"/>
                         </a:rPr>
-                        <a:t>§4.3 · Appendix F · Figures L.5-L.8</a:t>
+                        <a:t>Table 4.2 · Appendix E · Figures L.1-L.4</a:t>
                       </a:r>
                     </a:p>
                   </a:txBody>
@@ -20207,7 +20469,7 @@
                   </a:tcPr>
                 </a:tc>
               </a:tr>
-              <a:tr h="779068">
+              <a:tr h="697992">
                 <a:tc>
                   <a:txBody>
                     <a:bodyPr/>
@@ -20225,7 +20487,7 @@
                           </a:solidFill>
                           <a:latin typeface="Arial"/>
                         </a:rPr>
-                        <a:t>JMeter p95/gate</a:t>
+                        <a:t>ZAP raw/gate</a:t>
                       </a:r>
                     </a:p>
                   </a:txBody>
@@ -20252,7 +20514,7 @@
                           </a:solidFill>
                           <a:latin typeface="Arial"/>
                         </a:rPr>
-                        <a:t>jmeter/*/summary.json</a:t>
+                        <a:t>zap/*/summary.json</a:t>
                       </a:r>
                     </a:p>
                   </a:txBody>
@@ -20279,7 +20541,7 @@
                           </a:solidFill>
                           <a:latin typeface="Arial"/>
                         </a:rPr>
-                        <a:t>§4.4 · Appendix G · Figures L.9-L.18</a:t>
+                        <a:t>§4.3 · Appendix F · Figures L.5-L.8</a:t>
                       </a:r>
                     </a:p>
                   </a:txBody>
@@ -20290,7 +20552,7 @@
                   </a:tcPr>
                 </a:tc>
               </a:tr>
-              <a:tr h="779072">
+              <a:tr h="697992">
                 <a:tc>
                   <a:txBody>
                     <a:bodyPr/>
@@ -20308,7 +20570,7 @@
                           </a:solidFill>
                           <a:latin typeface="Arial"/>
                         </a:rPr>
-                        <a:t>Working API</a:t>
+                        <a:t>JMeter p95/gate</a:t>
                       </a:r>
                     </a:p>
                   </a:txBody>
@@ -20335,7 +20597,7 @@
                           </a:solidFill>
                           <a:latin typeface="Arial"/>
                         </a:rPr>
-                        <a:t>role/browser run records</a:t>
+                        <a:t>jmeter/*/summary.json</a:t>
                       </a:r>
                     </a:p>
                   </a:txBody>
@@ -20362,13 +20624,96 @@
                           </a:solidFill>
                           <a:latin typeface="Arial"/>
                         </a:rPr>
+                        <a:t>§4.4 · Appendix G · Figures L.9-L.18</a:t>
+                      </a:r>
+                    </a:p>
+                  </a:txBody>
+                  <a:tcPr marL="109728" marR="91440" marT="36576" marB="36576">
+                    <a:solidFill>
+                      <a:srgbClr val="F7F9FC"/>
+                    </a:solidFill>
+                  </a:tcPr>
+                </a:tc>
+              </a:tr>
+              <a:tr h="697992">
+                <a:tc>
+                  <a:txBody>
+                    <a:bodyPr/>
+                    <a:lstStyle/>
+                    <a:p>
+                      <a:pPr algn="l">
+                        <a:spcAft>
+                          <a:spcPts val="0"/>
+                        </a:spcAft>
+                      </a:pPr>
+                      <a:r>
+                        <a:rPr sz="1600" b="0">
+                          <a:solidFill>
+                            <a:srgbClr val="252B33"/>
+                          </a:solidFill>
+                          <a:latin typeface="Arial"/>
+                        </a:rPr>
+                        <a:t>Working API</a:t>
+                      </a:r>
+                    </a:p>
+                  </a:txBody>
+                  <a:tcPr marL="109728" marR="91440" marT="36576" marB="36576">
+                    <a:solidFill>
+                      <a:srgbClr val="FFFFFF"/>
+                    </a:solidFill>
+                  </a:tcPr>
+                </a:tc>
+                <a:tc>
+                  <a:txBody>
+                    <a:bodyPr/>
+                    <a:lstStyle/>
+                    <a:p>
+                      <a:pPr algn="l">
+                        <a:spcAft>
+                          <a:spcPts val="0"/>
+                        </a:spcAft>
+                      </a:pPr>
+                      <a:r>
+                        <a:rPr sz="1600" b="0">
+                          <a:solidFill>
+                            <a:srgbClr val="252B33"/>
+                          </a:solidFill>
+                          <a:latin typeface="Arial"/>
+                        </a:rPr>
+                        <a:t>role/browser run records</a:t>
+                      </a:r>
+                    </a:p>
+                  </a:txBody>
+                  <a:tcPr marL="109728" marR="91440" marT="36576" marB="36576">
+                    <a:solidFill>
+                      <a:srgbClr val="FFFFFF"/>
+                    </a:solidFill>
+                  </a:tcPr>
+                </a:tc>
+                <a:tc>
+                  <a:txBody>
+                    <a:bodyPr/>
+                    <a:lstStyle/>
+                    <a:p>
+                      <a:pPr algn="l">
+                        <a:spcAft>
+                          <a:spcPts val="0"/>
+                        </a:spcAft>
+                      </a:pPr>
+                      <a:r>
+                        <a:rPr sz="1600" b="0">
+                          <a:solidFill>
+                            <a:srgbClr val="252B33"/>
+                          </a:solidFill>
+                          <a:latin typeface="Arial"/>
+                        </a:rPr>
                         <a:t>§4.6 · Figures 4.2-4.7</a:t>
                       </a:r>
                     </a:p>
                   </a:txBody>
                   <a:tcPr marL="109728" marR="91440" marT="36576" marB="36576">
                     <a:solidFill>
-                      <a:srgbClr val="F7F9FC"/>
+                      <a:srgbClr val="FFFFFF"/>
                     </a:solidFill>
                   </a:tcPr>
                 </a:tc>
@@ -23069,7 +23414,7 @@
                           </a:solidFill>
                           <a:latin typeface="Arial"/>
                         </a:rPr>
-                        <a:t>OK on both</a:t>
+                        <a:t>OK/OK; no conditions saved</a:t>
                       </a:r>
                     </a:p>
                   </a:txBody>
@@ -27001,9 +27346,9 @@
                 </a:solidFill>
                 <a:latin typeface="Arial"/>
               </a:rPr>
-              <a:t>Account-ledger payload cache
-+ avoid snapshot write pressure
-Fresh load behavior remains mixed; core gate FAIL.</a:t>
+              <a:t>Cache account-ledger data
++ stop report snapshot writes on this read path
+The core speed target was not met.</a:t>
             </a:r>
           </a:p>
         </p:txBody>
@@ -27045,7 +27390,7 @@
                 </a:solidFill>
                 <a:latin typeface="Arial"/>
               </a:rPr>
-              <a:t>A code-level mechanism is evidence of implementation, not evidence that a load gate passed.</a:t>
+              <a:t>This shows what changed in code; slide 27 shows whether performance improved.</a:t>
             </a:r>
           </a:p>
         </p:txBody>
@@ -29269,7 +29614,7 @@
                 </a:solidFill>
                 <a:latin typeface="Arial"/>
               </a:rPr>
-              <a:t>Fresh: 17 unique issues → 0; Quality Gate OK/OK; coverage 74.4% → 74.3%.</a:t>
+              <a:t>17 issues → 0; gate OK/OK (no conditions recorded); coverage 74.4% → 74.3%.</a:t>
             </a:r>
           </a:p>
         </p:txBody>
@@ -32319,7 +32664,7 @@
                 </a:solidFill>
                 <a:latin typeface="Arial"/>
               </a:rPr>
-              <a:t>Fresh total p95 255.9 → 1146.9 ms · CORE FAIL.</a:t>
+              <a:t>Fresh total p95 255.9 → 1146.9 ms · CORE TARGET NOT MET.</a:t>
             </a:r>
           </a:p>
         </p:txBody>
@@ -32929,7 +33274,7 @@
                 </a:solidFill>
                 <a:latin typeface="Arial"/>
               </a:rPr>
-              <a:t>Fresh total p95 106 → 1547.95 ms · CORE FAIL.</a:t>
+              <a:t>Fresh total p95 106 → 1547.95 ms · CORE TARGET NOT MET.</a:t>
             </a:r>
           </a:p>
         </p:txBody>
@@ -33539,7 +33884,7 @@
                 </a:solidFill>
                 <a:latin typeface="Arial"/>
               </a:rPr>
-              <a:t>Fresh total p95 443.95 → 171 ms · STRESS GAIN.</a:t>
+              <a:t>Fresh total p95 443.95 → 171 ms · SOAK p95 LOWER.</a:t>
             </a:r>
           </a:p>
         </p:txBody>
@@ -34149,7 +34494,7 @@
                 </a:solidFill>
                 <a:latin typeface="Arial"/>
               </a:rPr>
-              <a:t>Fresh total p95 33401.8 → 4730.85 ms · STRESS GAIN.</a:t>
+              <a:t>Fresh total p95 33401.8 → 4730.85 ms · SPIKE p95 LOWER.</a:t>
             </a:r>
           </a:p>
         </p:txBody>
@@ -35125,7 +35470,7 @@
                 </a:solidFill>
                 <a:latin typeface="Arial"/>
               </a:rPr>
-              <a:t>Application: administration and reporting</a:t>
+              <a:t>App screens—not load-test data</a:t>
             </a:r>
           </a:p>
         </p:txBody>
@@ -36703,7 +37048,7 @@
                 </a:solidFill>
                 <a:latin typeface="Arial"/>
               </a:rPr>
-              <a:t>The unit of analysis is an existing accounting API</a:t>
+              <a:t>The study tested one existing accounting API</a:t>
             </a:r>
           </a:p>
         </p:txBody>
@@ -39995,7 +40340,7 @@
                 </a:solidFill>
                 <a:latin typeface="Arial"/>
               </a:rPr>
-              <a:t>One controlled environment and a seeded dataset</a:t>
+              <a:t>One local setup and a seeded dataset</a:t>
             </a:r>
           </a:p>
         </p:txBody>
@@ -40320,7 +40665,7 @@
                 </a:solidFill>
                 <a:latin typeface="Arial"/>
               </a:rPr>
-              <a:t>Deterministic seed</a:t>
+              <a:t>Seeded count in run record</a:t>
             </a:r>
           </a:p>
         </p:txBody>
@@ -40833,7 +41178,7 @@
                 </a:solidFill>
                 <a:latin typeface="Arial"/>
               </a:rPr>
-              <a:t>A single host and one fresh run per branch limit generalization.</a:t>
+              <a:t>120 accounts are recorded in the run evidence (backup slide 23; Appendix H).</a:t>
             </a:r>
           </a:p>
         </p:txBody>
@@ -40986,7 +41331,7 @@
                 </a:solidFill>
                 <a:latin typeface="Arial"/>
               </a:rPr>
-              <a:t>Success was decided by tool-specific gates</a:t>
+              <a:t>Outcomes were judged by tool-specific measures</a:t>
             </a:r>
           </a:p>
         </p:txBody>
@@ -41296,7 +41641,7 @@
                           </a:solidFill>
                           <a:latin typeface="Arial"/>
                         </a:rPr>
-                        <a:t>Close fresh issues; Quality Gate OK</a:t>
+                        <a:t>Compare unique issues; show gate status</a:t>
                       </a:r>
                     </a:p>
                   </a:txBody>
@@ -41667,7 +42012,7 @@
                 </a:solidFill>
                 <a:latin typeface="Arial"/>
               </a:rPr>
-              <a:t>100 VU is peak use—keep p95 within 0.5 s; 500 VU is stress—allow up to 1.2 s. Study-defined targets.</a:t>
+              <a:t>Study scenarios: 100 VU = planned peak; 500 VU = heavier load. These are not measured production traffic.</a:t>
             </a:r>
           </a:p>
         </p:txBody>

</xml_diff>

<commit_message>
docs: restore current ZAP screenshots to defense slides
</commit_message>
<xml_diff>
--- a/Document/outputs/final-defense/G6519692_Zaw_Ye_Htut_Ko_Final_Thesis_Defense.pptx
+++ b/Document/outputs/final-defense/G6519692_Zaw_Ye_Htut_Ko_Final_Thesis_Defense.pptx
@@ -1264,12 +1264,12 @@
           <a:lstStyle/>
           <a:p>
             <a:r>
-              <a:t>TIMING: 80 seconds</a:t>
-            </a:r>
-          </a:p>
-          <a:p>
-            <a:r>
-              <a:t>KEY MESSAGE: The remaining Medium alert is about the test connection.</a:t>
+              <a:t>TIMING: 55 seconds</a:t>
+            </a:r>
+          </a:p>
+          <a:p>
+            <a:r>
+              <a:t>KEY MESSAGE: The passive scan improved, but it is only one view of security.</a:t>
             </a:r>
           </a:p>
           <a:p>
@@ -1290,13 +1290,13 @@
           </a:p>
           <a:p>
             <a:r>
-              <a:t>The passive scan watches normal responses and headers; Medium and Low alerts fell from three and six to zero. The authenticated API scan signs in and exercises protected routes; its Low alerts fell from three to zero, but one Medium remained. ZAP named it HTTP Only Site because this local test used HTTP. I cannot call it cleared without setting up HTTPS and repeating the scan. The configured rules passed, but that is a separate judgment from the raw alert count.</a:t>
+              <a:t>I am showing the passive scan before and after the changes. This scan observes normal responses and their headers; it does not sign in. In the upper screenshot, ZAP reports three Medium and six Low alert types. In the lower screenshot, both counts are zero. These are screenshots of report cards rendered from my current raw ZAP scan data. They are not a claim that the protected API is free of alerts. I will show that separate scan on the next slide.</a:t>
             </a:r>
           </a:p>
           <a:p/>
           <a:p>
             <a:r>
-              <a:t>SOURCE: Next slide 17; backup slide 30; current report §4.3, Appendices F and M; ZAP raw API alert 10106.</a:t>
+              <a:t>SOURCE: Next slide 17; backup slide 30; current report §4.3; Appendix F; fresh passive raw ZAP JSON and summaries.</a:t>
             </a:r>
           </a:p>
         </p:txBody>
@@ -1366,12 +1366,12 @@
           <a:lstStyle/>
           <a:p>
             <a:r>
-              <a:t>TIMING: 50 seconds</a:t>
-            </a:r>
-          </a:p>
-          <a:p>
-            <a:r>
-              <a:t>KEY MESSAGE: Passive and signed-in API scans test different parts of the running service.</a:t>
+              <a:t>TIMING: 65 seconds</a:t>
+            </a:r>
+          </a:p>
+          <a:p>
+            <a:r>
+              <a:t>KEY MESSAGE: The signed-in scan improved, but it did not clear every raw alert.</a:t>
             </a:r>
           </a:p>
           <a:p>
@@ -1392,13 +1392,13 @@
           </a:p>
           <a:p>
             <a:r>
-              <a:t>On the left, the passive scan observed regular responses and their headers. Its Medium and Low counts both fell to zero. On the right, the API scan signed in and tested protected routes. Its Low count fell to zero, but one Medium stayed. The raw alert calls it HTTP Only Site because our local scan target used HTTP. I did not evaluate that alert under HTTPS, so I cannot call it cleared; a working HTTPS endpoint and another scan would be needed.</a:t>
+              <a:t>I am showing the signed-in API scan before and after the changes. Unlike the passive scan, this test signs in and exercises protected routes. Low alert types fell from three to zero, while Medium stayed at one. The remaining alert is called HTTP Only Site: my local scan target was served over HTTP. The selected security rules passed, but that pass result is different from saying every raw alert disappeared. I would need a working HTTPS endpoint and another scan before calling this Medium alert cleared. These screenshots were rendered from the current raw ZAP scan data; the raw counts and the alert are in Appendix F.</a:t>
             </a:r>
           </a:p>
           <a:p/>
           <a:p>
             <a:r>
-              <a:t>SOURCE: Current ZAP baseline/remediation summary.json; raw API alert 10106; Appendix F and Appendix M.</a:t>
+              <a:t>SOURCE: Backup slide 30; current report §4.3; Appendix F and Appendix M; fresh API raw ZAP JSON, summaries, alert 10106.</a:t>
             </a:r>
           </a:p>
         </p:txBody>
@@ -13526,7 +13526,7 @@
                 </a:solidFill>
                 <a:latin typeface="Arial"/>
               </a:rPr>
-              <a:t>ZAP passed the configured gate; raw API Medium remains</a:t>
+              <a:t>ZAP passive alerts cleared; raw API Medium remains</a:t>
             </a:r>
           </a:p>
         </p:txBody>
@@ -13638,7 +13638,7 @@
                 </a:solidFill>
                 <a:latin typeface="Arial"/>
               </a:rPr>
-              <a:t>Current report §4.3; fresh ZAP summaries; Appendix F</a:t>
+              <a:t>Current report §4.3; ZAP raw scan JSON; Appendix F</a:t>
             </a:r>
           </a:p>
         </p:txBody>
@@ -13685,381 +13685,87 @@
           </a:p>
         </p:txBody>
       </p:sp>
-      <p:graphicFrame>
-        <p:nvGraphicFramePr>
-          <p:cNvPr id="9" name="Table 8"/>
-          <p:cNvGraphicFramePr>
-            <a:graphicFrameLocks noGrp="1"/>
-          </p:cNvGraphicFramePr>
-          <p:nvPr/>
-        </p:nvGraphicFramePr>
-        <p:xfrm>
-          <a:off x="731520" y="1490472"/>
-          <a:ext cx="10716766" cy="2377440"/>
-        </p:xfrm>
-        <a:graphic>
-          <a:graphicData uri="http://schemas.openxmlformats.org/drawingml/2006/table">
-            <a:tbl>
-              <a:tblPr firstRow="1" bandRow="1">
-                <a:tableStyleId>{5C22544A-7EE6-4342-B048-85BDC9FD1C3A}</a:tableStyleId>
-              </a:tblPr>
-              <a:tblGrid>
-                <a:gridCol w="2143353"/>
-                <a:gridCol w="2464856"/>
-                <a:gridCol w="2464856"/>
-                <a:gridCol w="3643701"/>
-              </a:tblGrid>
-              <a:tr h="792480">
-                <a:tc>
-                  <a:txBody>
-                    <a:bodyPr/>
-                    <a:lstStyle/>
-                    <a:p>
-                      <a:pPr algn="l">
-                        <a:spcAft>
-                          <a:spcPts val="0"/>
-                        </a:spcAft>
-                      </a:pPr>
-                      <a:r>
-                        <a:rPr sz="1800" b="1">
-                          <a:solidFill>
-                            <a:srgbClr val="FFFFFF"/>
-                          </a:solidFill>
-                          <a:latin typeface="Arial"/>
-                        </a:rPr>
-                        <a:t>Fresh scan</a:t>
-                      </a:r>
-                    </a:p>
-                  </a:txBody>
-                  <a:tcPr marL="109728" marR="91440" marT="36576" marB="36576">
-                    <a:solidFill>
-                      <a:srgbClr val="252B33"/>
-                    </a:solidFill>
-                  </a:tcPr>
-                </a:tc>
-                <a:tc>
-                  <a:txBody>
-                    <a:bodyPr/>
-                    <a:lstStyle/>
-                    <a:p>
-                      <a:pPr algn="l">
-                        <a:spcAft>
-                          <a:spcPts val="0"/>
-                        </a:spcAft>
-                      </a:pPr>
-                      <a:r>
-                        <a:rPr sz="1800" b="1">
-                          <a:solidFill>
-                            <a:srgbClr val="FFFFFF"/>
-                          </a:solidFill>
-                          <a:latin typeface="Arial"/>
-                        </a:rPr>
-                        <a:t>Baseline Medium / Low</a:t>
-                      </a:r>
-                    </a:p>
-                  </a:txBody>
-                  <a:tcPr marL="109728" marR="91440" marT="36576" marB="36576">
-                    <a:solidFill>
-                      <a:srgbClr val="252B33"/>
-                    </a:solidFill>
-                  </a:tcPr>
-                </a:tc>
-                <a:tc>
-                  <a:txBody>
-                    <a:bodyPr/>
-                    <a:lstStyle/>
-                    <a:p>
-                      <a:pPr algn="l">
-                        <a:spcAft>
-                          <a:spcPts val="0"/>
-                        </a:spcAft>
-                      </a:pPr>
-                      <a:r>
-                        <a:rPr sz="1800" b="1">
-                          <a:solidFill>
-                            <a:srgbClr val="FFFFFF"/>
-                          </a:solidFill>
-                          <a:latin typeface="Arial"/>
-                        </a:rPr>
-                        <a:t>After Medium / Low</a:t>
-                      </a:r>
-                    </a:p>
-                  </a:txBody>
-                  <a:tcPr marL="109728" marR="91440" marT="36576" marB="36576">
-                    <a:solidFill>
-                      <a:srgbClr val="252B33"/>
-                    </a:solidFill>
-                  </a:tcPr>
-                </a:tc>
-                <a:tc>
-                  <a:txBody>
-                    <a:bodyPr/>
-                    <a:lstStyle/>
-                    <a:p>
-                      <a:pPr algn="l">
-                        <a:spcAft>
-                          <a:spcPts val="0"/>
-                        </a:spcAft>
-                      </a:pPr>
-                      <a:r>
-                        <a:rPr sz="1800" b="1">
-                          <a:solidFill>
-                            <a:srgbClr val="FFFFFF"/>
-                          </a:solidFill>
-                          <a:latin typeface="Arial"/>
-                        </a:rPr>
-                        <a:t>Interpretation</a:t>
-                      </a:r>
-                    </a:p>
-                  </a:txBody>
-                  <a:tcPr marL="109728" marR="91440" marT="36576" marB="36576">
-                    <a:solidFill>
-                      <a:srgbClr val="252B33"/>
-                    </a:solidFill>
-                  </a:tcPr>
-                </a:tc>
-              </a:tr>
-              <a:tr h="792480">
-                <a:tc>
-                  <a:txBody>
-                    <a:bodyPr/>
-                    <a:lstStyle/>
-                    <a:p>
-                      <a:pPr algn="l">
-                        <a:spcAft>
-                          <a:spcPts val="0"/>
-                        </a:spcAft>
-                      </a:pPr>
-                      <a:r>
-                        <a:rPr sz="1800" b="0">
-                          <a:solidFill>
-                            <a:srgbClr val="252B33"/>
-                          </a:solidFill>
-                          <a:latin typeface="Arial"/>
-                        </a:rPr>
-                        <a:t>Passive</a:t>
-                      </a:r>
-                    </a:p>
-                  </a:txBody>
-                  <a:tcPr marL="109728" marR="91440" marT="36576" marB="36576">
-                    <a:solidFill>
-                      <a:srgbClr val="FFFFFF"/>
-                    </a:solidFill>
-                  </a:tcPr>
-                </a:tc>
-                <a:tc>
-                  <a:txBody>
-                    <a:bodyPr/>
-                    <a:lstStyle/>
-                    <a:p>
-                      <a:pPr algn="l">
-                        <a:spcAft>
-                          <a:spcPts val="0"/>
-                        </a:spcAft>
-                      </a:pPr>
-                      <a:r>
-                        <a:rPr sz="1800" b="0">
-                          <a:solidFill>
-                            <a:srgbClr val="252B33"/>
-                          </a:solidFill>
-                          <a:latin typeface="Arial"/>
-                        </a:rPr>
-                        <a:t>3 / 6</a:t>
-                      </a:r>
-                    </a:p>
-                  </a:txBody>
-                  <a:tcPr marL="109728" marR="91440" marT="36576" marB="36576">
-                    <a:solidFill>
-                      <a:srgbClr val="FFFFFF"/>
-                    </a:solidFill>
-                  </a:tcPr>
-                </a:tc>
-                <a:tc>
-                  <a:txBody>
-                    <a:bodyPr/>
-                    <a:lstStyle/>
-                    <a:p>
-                      <a:pPr algn="l">
-                        <a:spcAft>
-                          <a:spcPts val="0"/>
-                        </a:spcAft>
-                      </a:pPr>
-                      <a:r>
-                        <a:rPr sz="1800" b="0">
-                          <a:solidFill>
-                            <a:srgbClr val="252B33"/>
-                          </a:solidFill>
-                          <a:latin typeface="Arial"/>
-                        </a:rPr>
-                        <a:t>0 / 0</a:t>
-                      </a:r>
-                    </a:p>
-                  </a:txBody>
-                  <a:tcPr marL="109728" marR="91440" marT="36576" marB="36576">
-                    <a:solidFill>
-                      <a:srgbClr val="FFFFFF"/>
-                    </a:solidFill>
-                  </a:tcPr>
-                </a:tc>
-                <a:tc>
-                  <a:txBody>
-                    <a:bodyPr/>
-                    <a:lstStyle/>
-                    <a:p>
-                      <a:pPr algn="l">
-                        <a:spcAft>
-                          <a:spcPts val="0"/>
-                        </a:spcAft>
-                      </a:pPr>
-                      <a:r>
-                        <a:rPr sz="1800" b="0">
-                          <a:solidFill>
-                            <a:srgbClr val="252B33"/>
-                          </a:solidFill>
-                          <a:latin typeface="Arial"/>
-                        </a:rPr>
-                        <a:t>Both severities cleared</a:t>
-                      </a:r>
-                    </a:p>
-                  </a:txBody>
-                  <a:tcPr marL="109728" marR="91440" marT="36576" marB="36576">
-                    <a:solidFill>
-                      <a:srgbClr val="FFFFFF"/>
-                    </a:solidFill>
-                  </a:tcPr>
-                </a:tc>
-              </a:tr>
-              <a:tr h="792480">
-                <a:tc>
-                  <a:txBody>
-                    <a:bodyPr/>
-                    <a:lstStyle/>
-                    <a:p>
-                      <a:pPr algn="l">
-                        <a:spcAft>
-                          <a:spcPts val="0"/>
-                        </a:spcAft>
-                      </a:pPr>
-                      <a:r>
-                        <a:rPr sz="1800" b="0">
-                          <a:solidFill>
-                            <a:srgbClr val="252B33"/>
-                          </a:solidFill>
-                          <a:latin typeface="Arial"/>
-                        </a:rPr>
-                        <a:t>Authenticated API</a:t>
-                      </a:r>
-                    </a:p>
-                  </a:txBody>
-                  <a:tcPr marL="109728" marR="91440" marT="36576" marB="36576">
-                    <a:solidFill>
-                      <a:srgbClr val="F7F9FC"/>
-                    </a:solidFill>
-                  </a:tcPr>
-                </a:tc>
-                <a:tc>
-                  <a:txBody>
-                    <a:bodyPr/>
-                    <a:lstStyle/>
-                    <a:p>
-                      <a:pPr algn="l">
-                        <a:spcAft>
-                          <a:spcPts val="0"/>
-                        </a:spcAft>
-                      </a:pPr>
-                      <a:r>
-                        <a:rPr sz="1800" b="0">
-                          <a:solidFill>
-                            <a:srgbClr val="252B33"/>
-                          </a:solidFill>
-                          <a:latin typeface="Arial"/>
-                        </a:rPr>
-                        <a:t>1 / 3</a:t>
-                      </a:r>
-                    </a:p>
-                  </a:txBody>
-                  <a:tcPr marL="109728" marR="91440" marT="36576" marB="36576">
-                    <a:solidFill>
-                      <a:srgbClr val="F7F9FC"/>
-                    </a:solidFill>
-                  </a:tcPr>
-                </a:tc>
-                <a:tc>
-                  <a:txBody>
-                    <a:bodyPr/>
-                    <a:lstStyle/>
-                    <a:p>
-                      <a:pPr algn="l">
-                        <a:spcAft>
-                          <a:spcPts val="0"/>
-                        </a:spcAft>
-                      </a:pPr>
-                      <a:r>
-                        <a:rPr sz="1800" b="0">
-                          <a:solidFill>
-                            <a:srgbClr val="252B33"/>
-                          </a:solidFill>
-                          <a:latin typeface="Arial"/>
-                        </a:rPr>
-                        <a:t>1 / 0</a:t>
-                      </a:r>
-                    </a:p>
-                  </a:txBody>
-                  <a:tcPr marL="109728" marR="91440" marT="36576" marB="36576">
-                    <a:solidFill>
-                      <a:srgbClr val="F7F9FC"/>
-                    </a:solidFill>
-                  </a:tcPr>
-                </a:tc>
-                <a:tc>
-                  <a:txBody>
-                    <a:bodyPr/>
-                    <a:lstStyle/>
-                    <a:p>
-                      <a:pPr algn="l">
-                        <a:spcAft>
-                          <a:spcPts val="0"/>
-                        </a:spcAft>
-                      </a:pPr>
-                      <a:r>
-                        <a:rPr sz="1800" b="0">
-                          <a:solidFill>
-                            <a:srgbClr val="252B33"/>
-                          </a:solidFill>
-                          <a:latin typeface="Arial"/>
-                        </a:rPr>
-                        <a:t>One raw Medium disclosed</a:t>
-                      </a:r>
-                    </a:p>
-                  </a:txBody>
-                  <a:tcPr marL="109728" marR="91440" marT="36576" marB="36576">
-                    <a:solidFill>
-                      <a:srgbClr val="F7F9FC"/>
-                    </a:solidFill>
-                  </a:tcPr>
-                </a:tc>
-              </a:tr>
-            </a:tbl>
-          </a:graphicData>
-        </a:graphic>
-      </p:graphicFrame>
-      <p:sp>
-        <p:nvSpPr>
-          <p:cNvPr id="10" name="Rounded Rectangle 9"/>
+      <p:sp>
+        <p:nvSpPr>
+          <p:cNvPr id="9" name="TextBox 8"/>
+          <p:cNvSpPr txBox="1"/>
+          <p:nvPr/>
+        </p:nvSpPr>
+        <p:spPr>
+          <a:xfrm>
+            <a:off x="758952" y="1298448"/>
+            <a:ext cx="10698480" cy="265176"/>
+          </a:xfrm>
+          <a:prstGeom prst="rect">
+            <a:avLst/>
+          </a:prstGeom>
+          <a:noFill/>
+        </p:spPr>
+        <p:txBody>
+          <a:bodyPr wrap="square" lIns="18288" rIns="18288" tIns="18288" bIns="18288" anchor="ctr">
+            <a:spAutoFit/>
+          </a:bodyPr>
+          <a:lstStyle/>
+          <a:p>
+            <a:pPr algn="l">
+              <a:spcBef>
+                <a:spcPts val="0"/>
+              </a:spcBef>
+              <a:spcAft>
+                <a:spcPts val="0"/>
+              </a:spcAft>
+            </a:pPr>
+            <a:r>
+              <a:rPr sz="1700" b="1">
+                <a:solidFill>
+                  <a:srgbClr val="24466C"/>
+                </a:solidFill>
+                <a:latin typeface="Arial"/>
+              </a:rPr>
+              <a:t>PASSIVE SCAN · BASELINE</a:t>
+            </a:r>
+          </a:p>
+        </p:txBody>
+      </p:sp>
+      <p:pic>
+        <p:nvPicPr>
+          <p:cNvPr id="10" name="Picture 9" descr="zap-fresh-passive-before-summary.png"/>
+          <p:cNvPicPr>
+            <a:picLocks noChangeAspect="1"/>
+          </p:cNvPicPr>
+          <p:nvPr/>
+        </p:nvPicPr>
+        <p:blipFill>
+          <a:blip r:embed="rId2"/>
+          <a:stretch>
+            <a:fillRect/>
+          </a:stretch>
+        </p:blipFill>
+        <p:spPr>
+          <a:xfrm>
+            <a:off x="784374" y="1636776"/>
+            <a:ext cx="10611059" cy="804672"/>
+          </a:xfrm>
+          <a:prstGeom prst="rect">
+            <a:avLst/>
+          </a:prstGeom>
+        </p:spPr>
+      </p:pic>
+      <p:sp>
+        <p:nvSpPr>
+          <p:cNvPr id="11" name="Rectangle 10"/>
           <p:cNvSpPr/>
           <p:nvPr/>
         </p:nvSpPr>
         <p:spPr>
           <a:xfrm>
-            <a:off x="731520" y="4261104"/>
-            <a:ext cx="5175504" cy="1115568"/>
-          </a:xfrm>
-          <a:prstGeom prst="roundRect">
-            <a:avLst/>
-          </a:prstGeom>
-          <a:solidFill>
-            <a:srgbClr val="E8F7EE"/>
-          </a:solidFill>
+            <a:off x="784374" y="1636776"/>
+            <a:ext cx="10611059" cy="804672"/>
+          </a:xfrm>
+          <a:prstGeom prst="rect">
+            <a:avLst/>
+          </a:prstGeom>
+          <a:noFill/>
           <a:ln w="12700">
             <a:solidFill>
               <a:srgbClr val="D8E0E9"/>
@@ -14090,14 +13796,14 @@
       </p:sp>
       <p:sp>
         <p:nvSpPr>
-          <p:cNvPr id="11" name="TextBox 10"/>
+          <p:cNvPr id="12" name="TextBox 11"/>
           <p:cNvSpPr txBox="1"/>
           <p:nvPr/>
         </p:nvSpPr>
         <p:spPr>
           <a:xfrm>
-            <a:off x="896112" y="4370832"/>
-            <a:ext cx="4846320" cy="201168"/>
+            <a:off x="758952" y="2706624"/>
+            <a:ext cx="10698480" cy="265176"/>
           </a:xfrm>
           <a:prstGeom prst="rect">
             <a:avLst/>
@@ -14119,27 +13825,179 @@
               </a:spcAft>
             </a:pPr>
             <a:r>
-              <a:rPr sz="1100" b="1">
+              <a:rPr sz="1700" b="1">
+                <a:solidFill>
+                  <a:srgbClr val="246F46"/>
+                </a:solidFill>
+                <a:latin typeface="Arial"/>
+              </a:rPr>
+              <a:t>PASSIVE SCAN · AFTER FIXES</a:t>
+            </a:r>
+          </a:p>
+        </p:txBody>
+      </p:sp>
+      <p:pic>
+        <p:nvPicPr>
+          <p:cNvPr id="13" name="Picture 12" descr="zap-fresh-passive-after-summary.png"/>
+          <p:cNvPicPr>
+            <a:picLocks noChangeAspect="1"/>
+          </p:cNvPicPr>
+          <p:nvPr/>
+        </p:nvPicPr>
+        <p:blipFill>
+          <a:blip r:embed="rId3"/>
+          <a:stretch>
+            <a:fillRect/>
+          </a:stretch>
+        </p:blipFill>
+        <p:spPr>
+          <a:xfrm>
+            <a:off x="784374" y="3035808"/>
+            <a:ext cx="10611059" cy="804672"/>
+          </a:xfrm>
+          <a:prstGeom prst="rect">
+            <a:avLst/>
+          </a:prstGeom>
+        </p:spPr>
+      </p:pic>
+      <p:sp>
+        <p:nvSpPr>
+          <p:cNvPr id="14" name="Rectangle 13"/>
+          <p:cNvSpPr/>
+          <p:nvPr/>
+        </p:nvSpPr>
+        <p:spPr>
+          <a:xfrm>
+            <a:off x="784374" y="3035808"/>
+            <a:ext cx="10611059" cy="804672"/>
+          </a:xfrm>
+          <a:prstGeom prst="rect">
+            <a:avLst/>
+          </a:prstGeom>
+          <a:noFill/>
+          <a:ln w="12700">
+            <a:solidFill>
+              <a:srgbClr val="D8E0E9"/>
+            </a:solidFill>
+          </a:ln>
+        </p:spPr>
+        <p:style>
+          <a:lnRef idx="1">
+            <a:schemeClr val="accent1"/>
+          </a:lnRef>
+          <a:fillRef idx="3">
+            <a:schemeClr val="accent1"/>
+          </a:fillRef>
+          <a:effectRef idx="2">
+            <a:schemeClr val="accent1"/>
+          </a:effectRef>
+          <a:fontRef idx="minor">
+            <a:schemeClr val="lt1"/>
+          </a:fontRef>
+        </p:style>
+        <p:txBody>
+          <a:bodyPr rtlCol="0" anchor="ctr"/>
+          <a:lstStyle/>
+          <a:p>
+            <a:pPr algn="ctr"/>
+          </a:p>
+        </p:txBody>
+      </p:sp>
+      <p:sp>
+        <p:nvSpPr>
+          <p:cNvPr id="15" name="TextBox 14"/>
+          <p:cNvSpPr txBox="1"/>
+          <p:nvPr/>
+        </p:nvSpPr>
+        <p:spPr>
+          <a:xfrm>
+            <a:off x="768096" y="3995928"/>
+            <a:ext cx="10643616" cy="329184"/>
+          </a:xfrm>
+          <a:prstGeom prst="rect">
+            <a:avLst/>
+          </a:prstGeom>
+          <a:noFill/>
+        </p:spPr>
+        <p:txBody>
+          <a:bodyPr wrap="square" lIns="18288" rIns="18288" tIns="18288" bIns="18288" anchor="ctr">
+            <a:spAutoFit/>
+          </a:bodyPr>
+          <a:lstStyle/>
+          <a:p>
+            <a:pPr algn="l">
+              <a:spcBef>
+                <a:spcPts val="0"/>
+              </a:spcBef>
+              <a:spcAft>
+                <a:spcPts val="0"/>
+              </a:spcAft>
+            </a:pPr>
+            <a:r>
+              <a:rPr sz="1500" b="0">
                 <a:solidFill>
                   <a:srgbClr val="5B6874"/>
                 </a:solidFill>
                 <a:latin typeface="Arial"/>
               </a:rPr>
-              <a:t>CONFIGURED RULES</a:t>
-            </a:r>
-          </a:p>
-        </p:txBody>
-      </p:sp>
-      <p:sp>
-        <p:nvSpPr>
-          <p:cNvPr id="12" name="TextBox 11"/>
+              <a:t>Severity-card screenshots rendered from the current ZAP scan JSON.</a:t>
+            </a:r>
+          </a:p>
+        </p:txBody>
+      </p:sp>
+      <p:sp>
+        <p:nvSpPr>
+          <p:cNvPr id="16" name="Rounded Rectangle 15"/>
+          <p:cNvSpPr/>
+          <p:nvPr/>
+        </p:nvSpPr>
+        <p:spPr>
+          <a:xfrm>
+            <a:off x="768096" y="4507992"/>
+            <a:ext cx="10643616" cy="1408176"/>
+          </a:xfrm>
+          <a:prstGeom prst="roundRect">
+            <a:avLst/>
+          </a:prstGeom>
+          <a:solidFill>
+            <a:srgbClr val="E8F7EE"/>
+          </a:solidFill>
+          <a:ln>
+            <a:noFill/>
+          </a:ln>
+        </p:spPr>
+        <p:style>
+          <a:lnRef idx="1">
+            <a:schemeClr val="accent1"/>
+          </a:lnRef>
+          <a:fillRef idx="3">
+            <a:schemeClr val="accent1"/>
+          </a:fillRef>
+          <a:effectRef idx="2">
+            <a:schemeClr val="accent1"/>
+          </a:effectRef>
+          <a:fontRef idx="minor">
+            <a:schemeClr val="lt1"/>
+          </a:fontRef>
+        </p:style>
+        <p:txBody>
+          <a:bodyPr rtlCol="0" anchor="ctr"/>
+          <a:lstStyle/>
+          <a:p>
+            <a:pPr algn="ctr"/>
+          </a:p>
+        </p:txBody>
+      </p:sp>
+      <p:sp>
+        <p:nvSpPr>
+          <p:cNvPr id="17" name="TextBox 16"/>
           <p:cNvSpPr txBox="1"/>
           <p:nvPr/>
         </p:nvSpPr>
         <p:spPr>
           <a:xfrm>
-            <a:off x="896112" y="4617720"/>
-            <a:ext cx="4846320" cy="411480"/>
+            <a:off x="1005840" y="4700016"/>
+            <a:ext cx="10168128" cy="438912"/>
           </a:xfrm>
           <a:prstGeom prst="rect">
             <a:avLst/>
@@ -14161,27 +14019,27 @@
               </a:spcAft>
             </a:pPr>
             <a:r>
-              <a:rPr sz="2500" b="1">
+              <a:rPr sz="2700" b="1">
                 <a:solidFill>
                   <a:srgbClr val="246F46"/>
                 </a:solidFill>
                 <a:latin typeface="Arial"/>
               </a:rPr>
-              <a:t>PASS</a:t>
-            </a:r>
-          </a:p>
-        </p:txBody>
-      </p:sp>
-      <p:sp>
-        <p:nvSpPr>
-          <p:cNvPr id="13" name="TextBox 12"/>
+              <a:t>Medium 3 → 0    |    Low 6 → 0</a:t>
+            </a:r>
+          </a:p>
+        </p:txBody>
+      </p:sp>
+      <p:sp>
+        <p:nvSpPr>
+          <p:cNvPr id="18" name="TextBox 17"/>
           <p:cNvSpPr txBox="1"/>
           <p:nvPr/>
         </p:nvSpPr>
         <p:spPr>
           <a:xfrm>
-            <a:off x="896112" y="5111496"/>
-            <a:ext cx="4846320" cy="164592"/>
+            <a:off x="1005840" y="5340096"/>
+            <a:ext cx="10131552" cy="365760"/>
           </a:xfrm>
           <a:prstGeom prst="rect">
             <a:avLst/>
@@ -14203,226 +14061,13 @@
               </a:spcAft>
             </a:pPr>
             <a:r>
-              <a:rPr sz="1100" b="0">
+              <a:rPr sz="1700" b="0">
                 <a:solidFill>
-                  <a:srgbClr val="5B6874"/>
+                  <a:srgbClr val="252B33"/>
                 </a:solidFill>
                 <a:latin typeface="Arial"/>
               </a:rPr>
-              <a:t>Both branches</a:t>
-            </a:r>
-          </a:p>
-        </p:txBody>
-      </p:sp>
-      <p:sp>
-        <p:nvSpPr>
-          <p:cNvPr id="14" name="Rounded Rectangle 13"/>
-          <p:cNvSpPr/>
-          <p:nvPr/>
-        </p:nvSpPr>
-        <p:spPr>
-          <a:xfrm>
-            <a:off x="6263640" y="4261104"/>
-            <a:ext cx="5175504" cy="1115568"/>
-          </a:xfrm>
-          <a:prstGeom prst="roundRect">
-            <a:avLst/>
-          </a:prstGeom>
-          <a:solidFill>
-            <a:srgbClr val="FFF6E7"/>
-          </a:solidFill>
-          <a:ln w="12700">
-            <a:solidFill>
-              <a:srgbClr val="D8E0E9"/>
-            </a:solidFill>
-          </a:ln>
-        </p:spPr>
-        <p:style>
-          <a:lnRef idx="1">
-            <a:schemeClr val="accent1"/>
-          </a:lnRef>
-          <a:fillRef idx="3">
-            <a:schemeClr val="accent1"/>
-          </a:fillRef>
-          <a:effectRef idx="2">
-            <a:schemeClr val="accent1"/>
-          </a:effectRef>
-          <a:fontRef idx="minor">
-            <a:schemeClr val="lt1"/>
-          </a:fontRef>
-        </p:style>
-        <p:txBody>
-          <a:bodyPr rtlCol="0" anchor="ctr"/>
-          <a:lstStyle/>
-          <a:p>
-            <a:pPr algn="ctr"/>
-          </a:p>
-        </p:txBody>
-      </p:sp>
-      <p:sp>
-        <p:nvSpPr>
-          <p:cNvPr id="15" name="TextBox 14"/>
-          <p:cNvSpPr txBox="1"/>
-          <p:nvPr/>
-        </p:nvSpPr>
-        <p:spPr>
-          <a:xfrm>
-            <a:off x="6428231" y="4370832"/>
-            <a:ext cx="4846320" cy="201168"/>
-          </a:xfrm>
-          <a:prstGeom prst="rect">
-            <a:avLst/>
-          </a:prstGeom>
-          <a:noFill/>
-        </p:spPr>
-        <p:txBody>
-          <a:bodyPr wrap="square" lIns="18288" rIns="18288" tIns="18288" bIns="18288" anchor="ctr">
-            <a:spAutoFit/>
-          </a:bodyPr>
-          <a:lstStyle/>
-          <a:p>
-            <a:pPr algn="l">
-              <a:spcBef>
-                <a:spcPts val="0"/>
-              </a:spcBef>
-              <a:spcAft>
-                <a:spcPts val="0"/>
-              </a:spcAft>
-            </a:pPr>
-            <a:r>
-              <a:rPr sz="1100" b="1">
-                <a:solidFill>
-                  <a:srgbClr val="5B6874"/>
-                </a:solidFill>
-                <a:latin typeface="Arial"/>
-              </a:rPr>
-              <a:t>RESIDUAL RAW ALERT</a:t>
-            </a:r>
-          </a:p>
-        </p:txBody>
-      </p:sp>
-      <p:sp>
-        <p:nvSpPr>
-          <p:cNvPr id="16" name="TextBox 15"/>
-          <p:cNvSpPr txBox="1"/>
-          <p:nvPr/>
-        </p:nvSpPr>
-        <p:spPr>
-          <a:xfrm>
-            <a:off x="6428231" y="4617720"/>
-            <a:ext cx="4846320" cy="411480"/>
-          </a:xfrm>
-          <a:prstGeom prst="rect">
-            <a:avLst/>
-          </a:prstGeom>
-          <a:noFill/>
-        </p:spPr>
-        <p:txBody>
-          <a:bodyPr wrap="square" lIns="18288" rIns="18288" tIns="18288" bIns="18288" anchor="ctr">
-            <a:spAutoFit/>
-          </a:bodyPr>
-          <a:lstStyle/>
-          <a:p>
-            <a:pPr algn="l">
-              <a:spcBef>
-                <a:spcPts val="0"/>
-              </a:spcBef>
-              <a:spcAft>
-                <a:spcPts val="0"/>
-              </a:spcAft>
-            </a:pPr>
-            <a:r>
-              <a:rPr sz="2500" b="1">
-                <a:solidFill>
-                  <a:srgbClr val="BE7414"/>
-                </a:solidFill>
-                <a:latin typeface="Arial"/>
-              </a:rPr>
-              <a:t>HTTP Only Site</a:t>
-            </a:r>
-          </a:p>
-        </p:txBody>
-      </p:sp>
-      <p:sp>
-        <p:nvSpPr>
-          <p:cNvPr id="17" name="TextBox 16"/>
-          <p:cNvSpPr txBox="1"/>
-          <p:nvPr/>
-        </p:nvSpPr>
-        <p:spPr>
-          <a:xfrm>
-            <a:off x="6428231" y="5111496"/>
-            <a:ext cx="4846320" cy="164592"/>
-          </a:xfrm>
-          <a:prstGeom prst="rect">
-            <a:avLst/>
-          </a:prstGeom>
-          <a:noFill/>
-        </p:spPr>
-        <p:txBody>
-          <a:bodyPr wrap="square" lIns="18288" rIns="18288" tIns="18288" bIns="18288" anchor="ctr">
-            <a:spAutoFit/>
-          </a:bodyPr>
-          <a:lstStyle/>
-          <a:p>
-            <a:pPr algn="l">
-              <a:spcBef>
-                <a:spcPts val="0"/>
-              </a:spcBef>
-              <a:spcAft>
-                <a:spcPts val="0"/>
-              </a:spcAft>
-            </a:pPr>
-            <a:r>
-              <a:rPr sz="1100" b="0">
-                <a:solidFill>
-                  <a:srgbClr val="5B6874"/>
-                </a:solidFill>
-                <a:latin typeface="Arial"/>
-              </a:rPr>
-              <a:t>Local HTTP transport · CWE-311</a:t>
-            </a:r>
-          </a:p>
-        </p:txBody>
-      </p:sp>
-      <p:sp>
-        <p:nvSpPr>
-          <p:cNvPr id="18" name="TextBox 17"/>
-          <p:cNvSpPr txBox="1"/>
-          <p:nvPr/>
-        </p:nvSpPr>
-        <p:spPr>
-          <a:xfrm>
-            <a:off x="777240" y="5751576"/>
-            <a:ext cx="10652760" cy="420624"/>
-          </a:xfrm>
-          <a:prstGeom prst="rect">
-            <a:avLst/>
-          </a:prstGeom>
-          <a:noFill/>
-        </p:spPr>
-        <p:txBody>
-          <a:bodyPr wrap="square" lIns="18288" rIns="18288" tIns="18288" bIns="18288" anchor="ctr">
-            <a:spAutoFit/>
-          </a:bodyPr>
-          <a:lstStyle/>
-          <a:p>
-            <a:pPr algn="l">
-              <a:spcBef>
-                <a:spcPts val="0"/>
-              </a:spcBef>
-              <a:spcAft>
-                <a:spcPts val="0"/>
-              </a:spcAft>
-            </a:pPr>
-            <a:r>
-              <a:rPr sz="1600" b="1">
-                <a:solidFill>
-                  <a:srgbClr val="BE7414"/>
-                </a:solidFill>
-                <a:latin typeface="Arial"/>
-              </a:rPr>
-              <a:t>Local HTTP caused the alert; an HTTPS retest is needed before claiming it is cleared.</a:t>
+              <a:t>This scan observes ordinary responses and headers. The signed-in API scan follows on slide 17.</a:t>
             </a:r>
           </a:p>
         </p:txBody>
@@ -14575,7 +14220,7 @@
                 </a:solidFill>
                 <a:latin typeface="Arial"/>
               </a:rPr>
-              <a:t>Fresh ZAP records: two different scans</a:t>
+              <a:t>Signed-in API scan: Low cleared; one Medium remains</a:t>
             </a:r>
           </a:p>
         </p:txBody>
@@ -14687,7 +14332,7 @@
                 </a:solidFill>
                 <a:latin typeface="Arial"/>
               </a:rPr>
-              <a:t>Current ZAP summary.json and API alert 10106; Appendix F</a:t>
+              <a:t>Current report §4.3; ZAP raw scan JSON and alert 10106; Appendix F</a:t>
             </a:r>
           </a:p>
         </p:txBody>
@@ -14736,21 +14381,85 @@
       </p:sp>
       <p:sp>
         <p:nvSpPr>
-          <p:cNvPr id="9" name="Rounded Rectangle 8"/>
+          <p:cNvPr id="9" name="TextBox 8"/>
+          <p:cNvSpPr txBox="1"/>
+          <p:nvPr/>
+        </p:nvSpPr>
+        <p:spPr>
+          <a:xfrm>
+            <a:off x="758952" y="1298448"/>
+            <a:ext cx="10698480" cy="265176"/>
+          </a:xfrm>
+          <a:prstGeom prst="rect">
+            <a:avLst/>
+          </a:prstGeom>
+          <a:noFill/>
+        </p:spPr>
+        <p:txBody>
+          <a:bodyPr wrap="square" lIns="18288" rIns="18288" tIns="18288" bIns="18288" anchor="ctr">
+            <a:spAutoFit/>
+          </a:bodyPr>
+          <a:lstStyle/>
+          <a:p>
+            <a:pPr algn="l">
+              <a:spcBef>
+                <a:spcPts val="0"/>
+              </a:spcBef>
+              <a:spcAft>
+                <a:spcPts val="0"/>
+              </a:spcAft>
+            </a:pPr>
+            <a:r>
+              <a:rPr sz="1700" b="1">
+                <a:solidFill>
+                  <a:srgbClr val="24466C"/>
+                </a:solidFill>
+                <a:latin typeface="Arial"/>
+              </a:rPr>
+              <a:t>AUTHENTICATED API SCAN · BASELINE</a:t>
+            </a:r>
+          </a:p>
+        </p:txBody>
+      </p:sp>
+      <p:pic>
+        <p:nvPicPr>
+          <p:cNvPr id="10" name="Picture 9" descr="zap-fresh-api-before-summary.png"/>
+          <p:cNvPicPr>
+            <a:picLocks noChangeAspect="1"/>
+          </p:cNvPicPr>
+          <p:nvPr/>
+        </p:nvPicPr>
+        <p:blipFill>
+          <a:blip r:embed="rId2"/>
+          <a:stretch>
+            <a:fillRect/>
+          </a:stretch>
+        </p:blipFill>
+        <p:spPr>
+          <a:xfrm>
+            <a:off x="784374" y="1636776"/>
+            <a:ext cx="10611059" cy="804672"/>
+          </a:xfrm>
+          <a:prstGeom prst="rect">
+            <a:avLst/>
+          </a:prstGeom>
+        </p:spPr>
+      </p:pic>
+      <p:sp>
+        <p:nvSpPr>
+          <p:cNvPr id="11" name="Rectangle 10"/>
           <p:cNvSpPr/>
           <p:nvPr/>
         </p:nvSpPr>
         <p:spPr>
           <a:xfrm>
-            <a:off x="731520" y="1453896"/>
-            <a:ext cx="5175504" cy="4123944"/>
-          </a:xfrm>
-          <a:prstGeom prst="roundRect">
-            <a:avLst/>
-          </a:prstGeom>
-          <a:solidFill>
-            <a:srgbClr val="FFFFFF"/>
-          </a:solidFill>
+            <a:off x="784374" y="1636776"/>
+            <a:ext cx="10611059" cy="804672"/>
+          </a:xfrm>
+          <a:prstGeom prst="rect">
+            <a:avLst/>
+          </a:prstGeom>
+          <a:noFill/>
           <a:ln w="12700">
             <a:solidFill>
               <a:srgbClr val="D8E0E9"/>
@@ -14781,21 +14490,85 @@
       </p:sp>
       <p:sp>
         <p:nvSpPr>
-          <p:cNvPr id="10" name="Rounded Rectangle 9"/>
+          <p:cNvPr id="12" name="TextBox 11"/>
+          <p:cNvSpPr txBox="1"/>
+          <p:nvPr/>
+        </p:nvSpPr>
+        <p:spPr>
+          <a:xfrm>
+            <a:off x="758952" y="2706624"/>
+            <a:ext cx="10698480" cy="265176"/>
+          </a:xfrm>
+          <a:prstGeom prst="rect">
+            <a:avLst/>
+          </a:prstGeom>
+          <a:noFill/>
+        </p:spPr>
+        <p:txBody>
+          <a:bodyPr wrap="square" lIns="18288" rIns="18288" tIns="18288" bIns="18288" anchor="ctr">
+            <a:spAutoFit/>
+          </a:bodyPr>
+          <a:lstStyle/>
+          <a:p>
+            <a:pPr algn="l">
+              <a:spcBef>
+                <a:spcPts val="0"/>
+              </a:spcBef>
+              <a:spcAft>
+                <a:spcPts val="0"/>
+              </a:spcAft>
+            </a:pPr>
+            <a:r>
+              <a:rPr sz="1700" b="1">
+                <a:solidFill>
+                  <a:srgbClr val="BE7414"/>
+                </a:solidFill>
+                <a:latin typeface="Arial"/>
+              </a:rPr>
+              <a:t>AUTHENTICATED API SCAN · AFTER FIXES</a:t>
+            </a:r>
+          </a:p>
+        </p:txBody>
+      </p:sp>
+      <p:pic>
+        <p:nvPicPr>
+          <p:cNvPr id="13" name="Picture 12" descr="zap-fresh-api-after-summary.png"/>
+          <p:cNvPicPr>
+            <a:picLocks noChangeAspect="1"/>
+          </p:cNvPicPr>
+          <p:nvPr/>
+        </p:nvPicPr>
+        <p:blipFill>
+          <a:blip r:embed="rId3"/>
+          <a:stretch>
+            <a:fillRect/>
+          </a:stretch>
+        </p:blipFill>
+        <p:spPr>
+          <a:xfrm>
+            <a:off x="784374" y="3035808"/>
+            <a:ext cx="10611059" cy="804672"/>
+          </a:xfrm>
+          <a:prstGeom prst="rect">
+            <a:avLst/>
+          </a:prstGeom>
+        </p:spPr>
+      </p:pic>
+      <p:sp>
+        <p:nvSpPr>
+          <p:cNvPr id="14" name="Rectangle 13"/>
           <p:cNvSpPr/>
           <p:nvPr/>
         </p:nvSpPr>
         <p:spPr>
           <a:xfrm>
-            <a:off x="6245352" y="1453896"/>
-            <a:ext cx="5175504" cy="4123944"/>
-          </a:xfrm>
-          <a:prstGeom prst="roundRect">
-            <a:avLst/>
-          </a:prstGeom>
-          <a:solidFill>
-            <a:srgbClr val="FFFFFF"/>
-          </a:solidFill>
+            <a:off x="784374" y="3035808"/>
+            <a:ext cx="10611059" cy="804672"/>
+          </a:xfrm>
+          <a:prstGeom prst="rect">
+            <a:avLst/>
+          </a:prstGeom>
+          <a:noFill/>
           <a:ln w="12700">
             <a:solidFill>
               <a:srgbClr val="D8E0E9"/>
@@ -14826,14 +14599,14 @@
       </p:sp>
       <p:sp>
         <p:nvSpPr>
-          <p:cNvPr id="11" name="TextBox 10"/>
+          <p:cNvPr id="15" name="TextBox 14"/>
           <p:cNvSpPr txBox="1"/>
           <p:nvPr/>
         </p:nvSpPr>
         <p:spPr>
           <a:xfrm>
-            <a:off x="978408" y="1746504"/>
-            <a:ext cx="4663440" cy="356616"/>
+            <a:off x="768096" y="3995928"/>
+            <a:ext cx="10643616" cy="329184"/>
           </a:xfrm>
           <a:prstGeom prst="rect">
             <a:avLst/>
@@ -14855,239 +14628,27 @@
               </a:spcAft>
             </a:pPr>
             <a:r>
-              <a:rPr sz="1900" b="1">
+              <a:rPr sz="1500" b="0">
                 <a:solidFill>
-                  <a:srgbClr val="B3373D"/>
+                  <a:srgbClr val="5B6874"/>
                 </a:solidFill>
                 <a:latin typeface="Arial"/>
               </a:rPr>
-              <a:t>PASSIVE SCAN</a:t>
-            </a:r>
-          </a:p>
-        </p:txBody>
-      </p:sp>
-      <p:sp>
-        <p:nvSpPr>
-          <p:cNvPr id="12" name="TextBox 11"/>
-          <p:cNvSpPr txBox="1"/>
-          <p:nvPr/>
-        </p:nvSpPr>
-        <p:spPr>
-          <a:xfrm>
-            <a:off x="978408" y="2267712"/>
-            <a:ext cx="4663440" cy="777240"/>
-          </a:xfrm>
-          <a:prstGeom prst="rect">
-            <a:avLst/>
-          </a:prstGeom>
-          <a:noFill/>
-        </p:spPr>
-        <p:txBody>
-          <a:bodyPr wrap="square" lIns="18288" rIns="18288" tIns="18288" bIns="18288" anchor="ctr">
-            <a:spAutoFit/>
-          </a:bodyPr>
-          <a:lstStyle/>
-          <a:p>
-            <a:pPr algn="l">
-              <a:spcBef>
-                <a:spcPts val="0"/>
-              </a:spcBef>
-              <a:spcAft>
-                <a:spcPts val="0"/>
-              </a:spcAft>
-            </a:pPr>
-            <a:r>
-              <a:rPr sz="1900" b="0">
-                <a:solidFill>
-                  <a:srgbClr val="252B33"/>
-                </a:solidFill>
-                <a:latin typeface="Arial"/>
-              </a:rPr>
-              <a:t>Observes ordinary responses and headers; it does not sign in.</a:t>
-            </a:r>
-          </a:p>
-        </p:txBody>
-      </p:sp>
-      <p:sp>
-        <p:nvSpPr>
-          <p:cNvPr id="13" name="TextBox 12"/>
-          <p:cNvSpPr txBox="1"/>
-          <p:nvPr/>
-        </p:nvSpPr>
-        <p:spPr>
-          <a:xfrm>
-            <a:off x="978408" y="3300984"/>
-            <a:ext cx="4663440" cy="1252728"/>
-          </a:xfrm>
-          <a:prstGeom prst="rect">
-            <a:avLst/>
-          </a:prstGeom>
-          <a:noFill/>
-        </p:spPr>
-        <p:txBody>
-          <a:bodyPr wrap="square" lIns="18288" rIns="18288" tIns="18288" bIns="18288" anchor="ctr">
-            <a:spAutoFit/>
-          </a:bodyPr>
-          <a:lstStyle/>
-          <a:p>
-            <a:pPr algn="l">
-              <a:spcBef>
-                <a:spcPts val="0"/>
-              </a:spcBef>
-              <a:spcAft>
-                <a:spcPts val="0"/>
-              </a:spcAft>
-            </a:pPr>
-            <a:r>
-              <a:rPr sz="2800" b="1">
-                <a:solidFill>
-                  <a:srgbClr val="246F46"/>
-                </a:solidFill>
-                <a:latin typeface="Arial"/>
-              </a:rPr>
-              <a:t>Medium 3 → 0
-Low 6 → 0</a:t>
-            </a:r>
-          </a:p>
-        </p:txBody>
-      </p:sp>
-      <p:sp>
-        <p:nvSpPr>
-          <p:cNvPr id="14" name="TextBox 13"/>
-          <p:cNvSpPr txBox="1"/>
-          <p:nvPr/>
-        </p:nvSpPr>
-        <p:spPr>
-          <a:xfrm>
-            <a:off x="6492240" y="1746504"/>
-            <a:ext cx="4663440" cy="356616"/>
-          </a:xfrm>
-          <a:prstGeom prst="rect">
-            <a:avLst/>
-          </a:prstGeom>
-          <a:noFill/>
-        </p:spPr>
-        <p:txBody>
-          <a:bodyPr wrap="square" lIns="18288" rIns="18288" tIns="18288" bIns="18288" anchor="ctr">
-            <a:spAutoFit/>
-          </a:bodyPr>
-          <a:lstStyle/>
-          <a:p>
-            <a:pPr algn="l">
-              <a:spcBef>
-                <a:spcPts val="0"/>
-              </a:spcBef>
-              <a:spcAft>
-                <a:spcPts val="0"/>
-              </a:spcAft>
-            </a:pPr>
-            <a:r>
-              <a:rPr sz="1900" b="1">
-                <a:solidFill>
-                  <a:srgbClr val="B3373D"/>
-                </a:solidFill>
-                <a:latin typeface="Arial"/>
-              </a:rPr>
-              <a:t>AUTHENTICATED API SCAN</a:t>
-            </a:r>
-          </a:p>
-        </p:txBody>
-      </p:sp>
-      <p:sp>
-        <p:nvSpPr>
-          <p:cNvPr id="15" name="TextBox 14"/>
-          <p:cNvSpPr txBox="1"/>
-          <p:nvPr/>
-        </p:nvSpPr>
-        <p:spPr>
-          <a:xfrm>
-            <a:off x="6492240" y="2267712"/>
-            <a:ext cx="4663440" cy="777240"/>
-          </a:xfrm>
-          <a:prstGeom prst="rect">
-            <a:avLst/>
-          </a:prstGeom>
-          <a:noFill/>
-        </p:spPr>
-        <p:txBody>
-          <a:bodyPr wrap="square" lIns="18288" rIns="18288" tIns="18288" bIns="18288" anchor="ctr">
-            <a:spAutoFit/>
-          </a:bodyPr>
-          <a:lstStyle/>
-          <a:p>
-            <a:pPr algn="l">
-              <a:spcBef>
-                <a:spcPts val="0"/>
-              </a:spcBef>
-              <a:spcAft>
-                <a:spcPts val="0"/>
-              </a:spcAft>
-            </a:pPr>
-            <a:r>
-              <a:rPr sz="1900" b="0">
-                <a:solidFill>
-                  <a:srgbClr val="252B33"/>
-                </a:solidFill>
-                <a:latin typeface="Arial"/>
-              </a:rPr>
-              <a:t>Signs in and tests protected API routes.</a:t>
-            </a:r>
-          </a:p>
-        </p:txBody>
-      </p:sp>
-      <p:sp>
-        <p:nvSpPr>
-          <p:cNvPr id="16" name="TextBox 15"/>
-          <p:cNvSpPr txBox="1"/>
-          <p:nvPr/>
-        </p:nvSpPr>
-        <p:spPr>
-          <a:xfrm>
-            <a:off x="6492240" y="3300984"/>
-            <a:ext cx="4663440" cy="1252728"/>
-          </a:xfrm>
-          <a:prstGeom prst="rect">
-            <a:avLst/>
-          </a:prstGeom>
-          <a:noFill/>
-        </p:spPr>
-        <p:txBody>
-          <a:bodyPr wrap="square" lIns="18288" rIns="18288" tIns="18288" bIns="18288" anchor="ctr">
-            <a:spAutoFit/>
-          </a:bodyPr>
-          <a:lstStyle/>
-          <a:p>
-            <a:pPr algn="l">
-              <a:spcBef>
-                <a:spcPts val="0"/>
-              </a:spcBef>
-              <a:spcAft>
-                <a:spcPts val="0"/>
-              </a:spcAft>
-            </a:pPr>
-            <a:r>
-              <a:rPr sz="2800" b="1">
-                <a:solidFill>
-                  <a:srgbClr val="BE7414"/>
-                </a:solidFill>
-                <a:latin typeface="Arial"/>
-              </a:rPr>
-              <a:t>Medium 1 → 1
-Low 3 → 0</a:t>
-            </a:r>
-          </a:p>
-        </p:txBody>
-      </p:sp>
-      <p:sp>
-        <p:nvSpPr>
-          <p:cNvPr id="17" name="Rounded Rectangle 16"/>
+              <a:t>Severity-card screenshots rendered from the current ZAP scan JSON.</a:t>
+            </a:r>
+          </a:p>
+        </p:txBody>
+      </p:sp>
+      <p:sp>
+        <p:nvSpPr>
+          <p:cNvPr id="16" name="Rounded Rectangle 15"/>
           <p:cNvSpPr/>
           <p:nvPr/>
         </p:nvSpPr>
         <p:spPr>
           <a:xfrm>
-            <a:off x="768096" y="5715000"/>
-            <a:ext cx="10643616" cy="502920"/>
+            <a:off x="768096" y="4507992"/>
+            <a:ext cx="10643616" cy="1408176"/>
           </a:xfrm>
           <a:prstGeom prst="roundRect">
             <a:avLst/>
@@ -15123,14 +14684,14 @@
       </p:sp>
       <p:sp>
         <p:nvSpPr>
-          <p:cNvPr id="18" name="TextBox 17"/>
+          <p:cNvPr id="17" name="TextBox 16"/>
           <p:cNvSpPr txBox="1"/>
           <p:nvPr/>
         </p:nvSpPr>
         <p:spPr>
           <a:xfrm>
-            <a:off x="932688" y="5760720"/>
-            <a:ext cx="10305288" cy="384048"/>
+            <a:off x="1005840" y="4700016"/>
+            <a:ext cx="10168128" cy="438912"/>
           </a:xfrm>
           <a:prstGeom prst="rect">
             <a:avLst/>
@@ -15152,13 +14713,55 @@
               </a:spcAft>
             </a:pPr>
             <a:r>
-              <a:rPr sz="1600" b="1">
+              <a:rPr sz="2700" b="1">
                 <a:solidFill>
                   <a:srgbClr val="BE7414"/>
                 </a:solidFill>
                 <a:latin typeface="Arial"/>
               </a:rPr>
-              <a:t>Remaining Medium: HTTP Only Site. Local scan used HTTP; an HTTPS retest is needed.</a:t>
+              <a:t>Medium 1 → 1    |    Low 3 → 0</a:t>
+            </a:r>
+          </a:p>
+        </p:txBody>
+      </p:sp>
+      <p:sp>
+        <p:nvSpPr>
+          <p:cNvPr id="18" name="TextBox 17"/>
+          <p:cNvSpPr txBox="1"/>
+          <p:nvPr/>
+        </p:nvSpPr>
+        <p:spPr>
+          <a:xfrm>
+            <a:off x="1005840" y="5340096"/>
+            <a:ext cx="10131552" cy="365760"/>
+          </a:xfrm>
+          <a:prstGeom prst="rect">
+            <a:avLst/>
+          </a:prstGeom>
+          <a:noFill/>
+        </p:spPr>
+        <p:txBody>
+          <a:bodyPr wrap="square" lIns="18288" rIns="18288" tIns="18288" bIns="18288" anchor="ctr">
+            <a:spAutoFit/>
+          </a:bodyPr>
+          <a:lstStyle/>
+          <a:p>
+            <a:pPr algn="l">
+              <a:spcBef>
+                <a:spcPts val="0"/>
+              </a:spcBef>
+              <a:spcAft>
+                <a:spcPts val="0"/>
+              </a:spcAft>
+            </a:pPr>
+            <a:r>
+              <a:rPr sz="1700" b="0">
+                <a:solidFill>
+                  <a:srgbClr val="252B33"/>
+                </a:solidFill>
+                <a:latin typeface="Arial"/>
+              </a:rPr>
+              <a:t>Remaining Medium: HTTP Only Site. Configured rules passed; HTTPS needs a separate retest.</a:t>
             </a:r>
           </a:p>
         </p:txBody>

</xml_diff>

<commit_message>
docs: explain soak and spike in defense speaker notes
</commit_message>
<xml_diff>
--- a/Document/outputs/final-defense/G6519692_Zaw_Ye_Htut_Ko_Final_Thesis_Defense.pptx
+++ b/Document/outputs/final-defense/G6519692_Zaw_Ye_Htut_Ko_Final_Thesis_Defense.pptx
@@ -2014,13 +2014,18 @@
           </a:p>
           <a:p>
             <a:r>
-              <a:t>At 50, 100, and 500 simulated users, the total p95 response time got worse after the change; none of those core p95 results improved. In the long soak test, total p95 and p99 were lower, but average response time rose and throughput fell. In the sudden spike test, p95, p99, and average response time were lower, throughput increased, and the error rate fell to zero. I call the evidence mixed because these gains are specific to soak and spike, while the primary user-count speed targets were not met.</a:t>
+              <a:t>Soak means repeated traffic over time; I look for performance getting worse as requests continue. Spike means many users arrive quickly; I look at the burst and whether response times recover afterward. In these runs, total p95 fell from 443.95 to 171 milliseconds for soak and from about 33.4 to 4.7 seconds for spike. These whole-run numbers are not direct proof of no soak drift or spike recovery. The core 50, 100, and 500 VU p95 results worsened, so I cannot claim overall performance success.</a:t>
             </a:r>
           </a:p>
           <a:p/>
           <a:p>
             <a:r>
-              <a:t>SOURCE: Fresh JMeter baseline/remediation summary.json; current report §4.4.</a:t>
+              <a:t>SOURCE: Fresh JMeter baseline/remediation summary.json; current report §4.4; Appendix L Figures L.12-L.13 and L.17-L.18.</a:t>
+            </a:r>
+          </a:p>
+          <a:p>
+            <a:r>
+              <a:t>CAUTION: Do not claim a fixed three-hour soak or exactly 100 total threads: the runner configures 100 core plus 30 report threads and has no fixed-duration scheduler.</a:t>
             </a:r>
           </a:p>
         </p:txBody>

</xml_diff>

<commit_message>
docs: explain evidence flow on defense slide 11
</commit_message>
<xml_diff>
--- a/Document/outputs/final-defense/G6519692_Zaw_Ye_Htut_Ko_Final_Thesis_Defense.pptx
+++ b/Document/outputs/final-defense/G6519692_Zaw_Ye_Htut_Ko_Final_Thesis_Defense.pptx
@@ -749,12 +749,12 @@
           <a:lstStyle/>
           <a:p>
             <a:r>
-              <a:t>TIMING: 70 seconds</a:t>
-            </a:r>
-          </a:p>
-          <a:p>
-            <a:r>
-              <a:t>KEY MESSAGE: Codex suggested changes; I checked and measured them.</a:t>
+              <a:t>TIMING: 80 seconds</a:t>
+            </a:r>
+          </a:p>
+          <a:p>
+            <a:r>
+              <a:t>KEY MESSAGE: A proposal passes through my review and independent measurement.</a:t>
             </a:r>
           </a:p>
           <a:p>
@@ -775,7 +775,7 @@
           </a:p>
           <a:p>
             <a:r>
-              <a:t>Here is one example. SonarQube flagged a controller with eight query parameters. I showed Codex that warning and the relevant code. It suggested a request DTO. I reviewed the edit, ran tests, and scanned the changed branch again. SonarQube issues went from 17 to zero. I followed the same check-again process for ZAP and JMeter, including the JMeter target that was not met.</a:t>
+              <a:t>Read this diagram from left to right. On the left, I start with a real tool finding and the source code needed to understand it. For example, SonarQube flagged eight controller parameters. In the middle, Codex proposes a change, but it does not decide whether that change is correct. I reviewed the request DTO for accounting behavior and access control before using it. On the right, I run focused tests and rerun the same tool on the changed branch. I compare that result with the saved baseline and the study target. SonarQube's unique issue count went from 17 to zero; JMeter did not meet its main speed target. The arrows represent checks, not automatic acceptance of an AI suggestion.</a:t>
             </a:r>
           </a:p>
           <a:p/>
@@ -9399,8 +9399,8 @@
         </p:nvSpPr>
         <p:spPr>
           <a:xfrm>
-            <a:off x="713232" y="2148840"/>
-            <a:ext cx="1709928" cy="1133856"/>
+            <a:off x="731520" y="1591056"/>
+            <a:ext cx="3429000" cy="2871216"/>
           </a:xfrm>
           <a:prstGeom prst="roundRect">
             <a:avLst/>
@@ -9444,8 +9444,8 @@
         </p:nvSpPr>
         <p:spPr>
           <a:xfrm>
-            <a:off x="832104" y="2313432"/>
-            <a:ext cx="1472184" cy="813816"/>
+            <a:off x="914400" y="1810512"/>
+            <a:ext cx="3044952" cy="256032"/>
           </a:xfrm>
           <a:prstGeom prst="rect">
             <a:avLst/>
@@ -9458,7 +9458,7 @@
           </a:bodyPr>
           <a:lstStyle/>
           <a:p>
-            <a:pPr algn="ctr">
+            <a:pPr algn="l">
               <a:spcBef>
                 <a:spcPts val="0"/>
               </a:spcBef>
@@ -9467,13 +9467,13 @@
               </a:spcAft>
             </a:pPr>
             <a:r>
-              <a:rPr sz="1700" b="1">
+              <a:rPr sz="1400" b="1">
                 <a:solidFill>
                   <a:srgbClr val="0F676D"/>
                 </a:solidFill>
                 <a:latin typeface="Arial"/>
               </a:rPr>
-              <a:t>Tool finding</a:t>
+              <a:t>01  INPUT</a:t>
             </a:r>
           </a:p>
         </p:txBody>
@@ -9486,8 +9486,8 @@
         </p:nvSpPr>
         <p:spPr>
           <a:xfrm>
-            <a:off x="2432304" y="2432304"/>
-            <a:ext cx="182880" cy="274320"/>
+            <a:off x="914400" y="2203704"/>
+            <a:ext cx="3044952" cy="694944"/>
           </a:xfrm>
           <a:prstGeom prst="rect">
             <a:avLst/>
@@ -9511,31 +9511,115 @@
             <a:r>
               <a:rPr sz="2100" b="1">
                 <a:solidFill>
-                  <a:srgbClr val="5B6874"/>
+                  <a:srgbClr val="0F676D"/>
                 </a:solidFill>
                 <a:latin typeface="Arial"/>
               </a:rPr>
-              <a:t>→</a:t>
-            </a:r>
-          </a:p>
-        </p:txBody>
-      </p:sp>
-      <p:sp>
-        <p:nvSpPr>
-          <p:cNvPr id="12" name="Rounded Rectangle 11"/>
+              <a:t>Start with evidence</a:t>
+            </a:r>
+          </a:p>
+        </p:txBody>
+      </p:sp>
+      <p:sp>
+        <p:nvSpPr>
+          <p:cNvPr id="12" name="TextBox 11"/>
+          <p:cNvSpPr txBox="1"/>
+          <p:nvPr/>
+        </p:nvSpPr>
+        <p:spPr>
+          <a:xfrm>
+            <a:off x="914400" y="2935224"/>
+            <a:ext cx="3044952" cy="457200"/>
+          </a:xfrm>
+          <a:prstGeom prst="rect">
+            <a:avLst/>
+          </a:prstGeom>
+          <a:noFill/>
+        </p:spPr>
+        <p:txBody>
+          <a:bodyPr wrap="square" lIns="18288" rIns="18288" tIns="18288" bIns="18288" anchor="ctr">
+            <a:spAutoFit/>
+          </a:bodyPr>
+          <a:lstStyle/>
+          <a:p>
+            <a:pPr algn="l">
+              <a:spcBef>
+                <a:spcPts val="0"/>
+              </a:spcBef>
+              <a:spcAft>
+                <a:spcPts val="0"/>
+              </a:spcAft>
+            </a:pPr>
+            <a:r>
+              <a:rPr sz="1700" b="1">
+                <a:solidFill>
+                  <a:srgbClr val="252B33"/>
+                </a:solidFill>
+                <a:latin typeface="Arial"/>
+              </a:rPr>
+              <a:t>Tool finding + relevant code</a:t>
+            </a:r>
+          </a:p>
+        </p:txBody>
+      </p:sp>
+      <p:sp>
+        <p:nvSpPr>
+          <p:cNvPr id="13" name="TextBox 12"/>
+          <p:cNvSpPr txBox="1"/>
+          <p:nvPr/>
+        </p:nvSpPr>
+        <p:spPr>
+          <a:xfrm>
+            <a:off x="914400" y="3529584"/>
+            <a:ext cx="3044952" cy="658368"/>
+          </a:xfrm>
+          <a:prstGeom prst="rect">
+            <a:avLst/>
+          </a:prstGeom>
+          <a:noFill/>
+        </p:spPr>
+        <p:txBody>
+          <a:bodyPr wrap="square" lIns="18288" rIns="18288" tIns="18288" bIns="18288" anchor="ctr">
+            <a:spAutoFit/>
+          </a:bodyPr>
+          <a:lstStyle/>
+          <a:p>
+            <a:pPr algn="l">
+              <a:spcBef>
+                <a:spcPts val="0"/>
+              </a:spcBef>
+              <a:spcAft>
+                <a:spcPts val="0"/>
+              </a:spcAft>
+            </a:pPr>
+            <a:r>
+              <a:rPr sz="1600" b="0">
+                <a:solidFill>
+                  <a:srgbClr val="252B33"/>
+                </a:solidFill>
+                <a:latin typeface="Arial"/>
+              </a:rPr>
+              <a:t>Example: SonarQube flags eight controller parameters.</a:t>
+            </a:r>
+          </a:p>
+        </p:txBody>
+      </p:sp>
+      <p:sp>
+        <p:nvSpPr>
+          <p:cNvPr id="14" name="Rounded Rectangle 13"/>
           <p:cNvSpPr/>
           <p:nvPr/>
         </p:nvSpPr>
         <p:spPr>
           <a:xfrm>
-            <a:off x="2615184" y="2148840"/>
-            <a:ext cx="1709928" cy="1133856"/>
+            <a:off x="4379976" y="1591056"/>
+            <a:ext cx="3429000" cy="2871216"/>
           </a:xfrm>
           <a:prstGeom prst="roundRect">
             <a:avLst/>
           </a:prstGeom>
           <a:solidFill>
-            <a:srgbClr val="E7F6F6"/>
+            <a:srgbClr val="EBF3FB"/>
           </a:solidFill>
           <a:ln w="12700">
             <a:solidFill>
@@ -9567,14 +9651,14 @@
       </p:sp>
       <p:sp>
         <p:nvSpPr>
-          <p:cNvPr id="13" name="TextBox 12"/>
+          <p:cNvPr id="15" name="TextBox 14"/>
           <p:cNvSpPr txBox="1"/>
           <p:nvPr/>
         </p:nvSpPr>
         <p:spPr>
           <a:xfrm>
-            <a:off x="2734056" y="2313432"/>
-            <a:ext cx="1472184" cy="813816"/>
+            <a:off x="4562856" y="1810512"/>
+            <a:ext cx="3044952" cy="256032"/>
           </a:xfrm>
           <a:prstGeom prst="rect">
             <a:avLst/>
@@ -9587,7 +9671,7 @@
           </a:bodyPr>
           <a:lstStyle/>
           <a:p>
-            <a:pPr algn="ctr">
+            <a:pPr algn="l">
               <a:spcBef>
                 <a:spcPts val="0"/>
               </a:spcBef>
@@ -9596,27 +9680,27 @@
               </a:spcAft>
             </a:pPr>
             <a:r>
-              <a:rPr sz="1700" b="1">
+              <a:rPr sz="1400" b="1">
                 <a:solidFill>
-                  <a:srgbClr val="0F676D"/>
+                  <a:srgbClr val="24466C"/>
                 </a:solidFill>
                 <a:latin typeface="Arial"/>
               </a:rPr>
-              <a:t>Relevant code</a:t>
-            </a:r>
-          </a:p>
-        </p:txBody>
-      </p:sp>
-      <p:sp>
-        <p:nvSpPr>
-          <p:cNvPr id="14" name="TextBox 13"/>
+              <a:t>02  HUMAN DECISION</a:t>
+            </a:r>
+          </a:p>
+        </p:txBody>
+      </p:sp>
+      <p:sp>
+        <p:nvSpPr>
+          <p:cNvPr id="16" name="TextBox 15"/>
           <p:cNvSpPr txBox="1"/>
           <p:nvPr/>
         </p:nvSpPr>
         <p:spPr>
           <a:xfrm>
-            <a:off x="4334256" y="2432304"/>
-            <a:ext cx="182880" cy="274320"/>
+            <a:off x="4562856" y="2203704"/>
+            <a:ext cx="3044952" cy="694944"/>
           </a:xfrm>
           <a:prstGeom prst="rect">
             <a:avLst/>
@@ -9640,70 +9724,25 @@
             <a:r>
               <a:rPr sz="2100" b="1">
                 <a:solidFill>
-                  <a:srgbClr val="5B6874"/>
+                  <a:srgbClr val="24466C"/>
                 </a:solidFill>
                 <a:latin typeface="Arial"/>
               </a:rPr>
-              <a:t>→</a:t>
-            </a:r>
-          </a:p>
-        </p:txBody>
-      </p:sp>
-      <p:sp>
-        <p:nvSpPr>
-          <p:cNvPr id="15" name="Rounded Rectangle 14"/>
-          <p:cNvSpPr/>
-          <p:nvPr/>
-        </p:nvSpPr>
-        <p:spPr>
-          <a:xfrm>
-            <a:off x="4517136" y="2148840"/>
-            <a:ext cx="1709928" cy="1133856"/>
-          </a:xfrm>
-          <a:prstGeom prst="roundRect">
-            <a:avLst/>
-          </a:prstGeom>
-          <a:solidFill>
-            <a:srgbClr val="E7F6F6"/>
-          </a:solidFill>
-          <a:ln w="12700">
-            <a:solidFill>
-              <a:srgbClr val="D8E0E9"/>
-            </a:solidFill>
-          </a:ln>
-        </p:spPr>
-        <p:style>
-          <a:lnRef idx="1">
-            <a:schemeClr val="accent1"/>
-          </a:lnRef>
-          <a:fillRef idx="3">
-            <a:schemeClr val="accent1"/>
-          </a:fillRef>
-          <a:effectRef idx="2">
-            <a:schemeClr val="accent1"/>
-          </a:effectRef>
-          <a:fontRef idx="minor">
-            <a:schemeClr val="lt1"/>
-          </a:fontRef>
-        </p:style>
-        <p:txBody>
-          <a:bodyPr rtlCol="0" anchor="ctr"/>
-          <a:lstStyle/>
-          <a:p>
-            <a:pPr algn="ctr"/>
-          </a:p>
-        </p:txBody>
-      </p:sp>
-      <p:sp>
-        <p:nvSpPr>
-          <p:cNvPr id="16" name="TextBox 15"/>
+              <a:t>Review the proposed fix</a:t>
+            </a:r>
+          </a:p>
+        </p:txBody>
+      </p:sp>
+      <p:sp>
+        <p:nvSpPr>
+          <p:cNvPr id="17" name="TextBox 16"/>
           <p:cNvSpPr txBox="1"/>
           <p:nvPr/>
         </p:nvSpPr>
         <p:spPr>
           <a:xfrm>
-            <a:off x="4636008" y="2313432"/>
-            <a:ext cx="1472184" cy="813816"/>
+            <a:off x="4562856" y="2935224"/>
+            <a:ext cx="3044952" cy="457200"/>
           </a:xfrm>
           <a:prstGeom prst="rect">
             <a:avLst/>
@@ -9716,7 +9755,7 @@
           </a:bodyPr>
           <a:lstStyle/>
           <a:p>
-            <a:pPr algn="ctr">
+            <a:pPr algn="l">
               <a:spcBef>
                 <a:spcPts val="0"/>
               </a:spcBef>
@@ -9727,25 +9766,25 @@
             <a:r>
               <a:rPr sz="1700" b="1">
                 <a:solidFill>
-                  <a:srgbClr val="0F676D"/>
+                  <a:srgbClr val="252B33"/>
                 </a:solidFill>
                 <a:latin typeface="Arial"/>
               </a:rPr>
-              <a:t>Suggested edit</a:t>
-            </a:r>
-          </a:p>
-        </p:txBody>
-      </p:sp>
-      <p:sp>
-        <p:nvSpPr>
-          <p:cNvPr id="17" name="TextBox 16"/>
+              <a:t>Codex suggests; I decide.</a:t>
+            </a:r>
+          </a:p>
+        </p:txBody>
+      </p:sp>
+      <p:sp>
+        <p:nvSpPr>
+          <p:cNvPr id="18" name="TextBox 17"/>
           <p:cNvSpPr txBox="1"/>
           <p:nvPr/>
         </p:nvSpPr>
         <p:spPr>
           <a:xfrm>
-            <a:off x="6236208" y="2432304"/>
-            <a:ext cx="182880" cy="274320"/>
+            <a:off x="4562856" y="3529584"/>
+            <a:ext cx="3044952" cy="658368"/>
           </a:xfrm>
           <a:prstGeom prst="rect">
             <a:avLst/>
@@ -9767,27 +9806,27 @@
               </a:spcAft>
             </a:pPr>
             <a:r>
-              <a:rPr sz="2100" b="1">
+              <a:rPr sz="1600" b="0">
                 <a:solidFill>
-                  <a:srgbClr val="5B6874"/>
+                  <a:srgbClr val="252B33"/>
                 </a:solidFill>
                 <a:latin typeface="Arial"/>
               </a:rPr>
-              <a:t>→</a:t>
-            </a:r>
-          </a:p>
-        </p:txBody>
-      </p:sp>
-      <p:sp>
-        <p:nvSpPr>
-          <p:cNvPr id="18" name="Rounded Rectangle 17"/>
+              <a:t>I check correctness, accounting behavior, and access control.</a:t>
+            </a:r>
+          </a:p>
+        </p:txBody>
+      </p:sp>
+      <p:sp>
+        <p:nvSpPr>
+          <p:cNvPr id="19" name="Rounded Rectangle 18"/>
           <p:cNvSpPr/>
           <p:nvPr/>
         </p:nvSpPr>
         <p:spPr>
           <a:xfrm>
-            <a:off x="6419088" y="2148840"/>
-            <a:ext cx="1709928" cy="1133856"/>
+            <a:off x="8028431" y="1591056"/>
+            <a:ext cx="3429000" cy="2871216"/>
           </a:xfrm>
           <a:prstGeom prst="roundRect">
             <a:avLst/>
@@ -9825,14 +9864,14 @@
       </p:sp>
       <p:sp>
         <p:nvSpPr>
-          <p:cNvPr id="19" name="TextBox 18"/>
+          <p:cNvPr id="20" name="TextBox 19"/>
           <p:cNvSpPr txBox="1"/>
           <p:nvPr/>
         </p:nvSpPr>
         <p:spPr>
           <a:xfrm>
-            <a:off x="6537960" y="2313432"/>
-            <a:ext cx="1472184" cy="813816"/>
+            <a:off x="8211311" y="1810512"/>
+            <a:ext cx="3044952" cy="256032"/>
           </a:xfrm>
           <a:prstGeom prst="rect">
             <a:avLst/>
@@ -9845,7 +9884,7 @@
           </a:bodyPr>
           <a:lstStyle/>
           <a:p>
-            <a:pPr algn="ctr">
+            <a:pPr algn="l">
               <a:spcBef>
                 <a:spcPts val="0"/>
               </a:spcBef>
@@ -9854,27 +9893,27 @@
               </a:spcAft>
             </a:pPr>
             <a:r>
-              <a:rPr sz="1700" b="1">
+              <a:rPr sz="1400" b="1">
                 <a:solidFill>
                   <a:srgbClr val="246F46"/>
                 </a:solidFill>
                 <a:latin typeface="Arial"/>
               </a:rPr>
-              <a:t>I check</a:t>
-            </a:r>
-          </a:p>
-        </p:txBody>
-      </p:sp>
-      <p:sp>
-        <p:nvSpPr>
-          <p:cNvPr id="20" name="TextBox 19"/>
+              <a:t>03  INDEPENDENT CHECK</a:t>
+            </a:r>
+          </a:p>
+        </p:txBody>
+      </p:sp>
+      <p:sp>
+        <p:nvSpPr>
+          <p:cNvPr id="21" name="TextBox 20"/>
           <p:cNvSpPr txBox="1"/>
           <p:nvPr/>
         </p:nvSpPr>
         <p:spPr>
           <a:xfrm>
-            <a:off x="8138160" y="2432304"/>
-            <a:ext cx="182880" cy="274320"/>
+            <a:off x="8211311" y="2203704"/>
+            <a:ext cx="3044952" cy="694944"/>
           </a:xfrm>
           <a:prstGeom prst="rect">
             <a:avLst/>
@@ -9897,6 +9936,132 @@
             </a:pPr>
             <a:r>
               <a:rPr sz="2100" b="1">
+                <a:solidFill>
+                  <a:srgbClr val="246F46"/>
+                </a:solidFill>
+                <a:latin typeface="Arial"/>
+              </a:rPr>
+              <a:t>Verify the outcome</a:t>
+            </a:r>
+          </a:p>
+        </p:txBody>
+      </p:sp>
+      <p:sp>
+        <p:nvSpPr>
+          <p:cNvPr id="22" name="TextBox 21"/>
+          <p:cNvSpPr txBox="1"/>
+          <p:nvPr/>
+        </p:nvSpPr>
+        <p:spPr>
+          <a:xfrm>
+            <a:off x="8211311" y="2935224"/>
+            <a:ext cx="3044952" cy="457200"/>
+          </a:xfrm>
+          <a:prstGeom prst="rect">
+            <a:avLst/>
+          </a:prstGeom>
+          <a:noFill/>
+        </p:spPr>
+        <p:txBody>
+          <a:bodyPr wrap="square" lIns="18288" rIns="18288" tIns="18288" bIns="18288" anchor="ctr">
+            <a:spAutoFit/>
+          </a:bodyPr>
+          <a:lstStyle/>
+          <a:p>
+            <a:pPr algn="l">
+              <a:spcBef>
+                <a:spcPts val="0"/>
+              </a:spcBef>
+              <a:spcAft>
+                <a:spcPts val="0"/>
+              </a:spcAft>
+            </a:pPr>
+            <a:r>
+              <a:rPr sz="1700" b="1">
+                <a:solidFill>
+                  <a:srgbClr val="252B33"/>
+                </a:solidFill>
+                <a:latin typeface="Arial"/>
+              </a:rPr>
+              <a:t>Run tests; rerun the same tool.</a:t>
+            </a:r>
+          </a:p>
+        </p:txBody>
+      </p:sp>
+      <p:sp>
+        <p:nvSpPr>
+          <p:cNvPr id="23" name="TextBox 22"/>
+          <p:cNvSpPr txBox="1"/>
+          <p:nvPr/>
+        </p:nvSpPr>
+        <p:spPr>
+          <a:xfrm>
+            <a:off x="8211311" y="3529584"/>
+            <a:ext cx="3044952" cy="658368"/>
+          </a:xfrm>
+          <a:prstGeom prst="rect">
+            <a:avLst/>
+          </a:prstGeom>
+          <a:noFill/>
+        </p:spPr>
+        <p:txBody>
+          <a:bodyPr wrap="square" lIns="18288" rIns="18288" tIns="18288" bIns="18288" anchor="ctr">
+            <a:spAutoFit/>
+          </a:bodyPr>
+          <a:lstStyle/>
+          <a:p>
+            <a:pPr algn="l">
+              <a:spcBef>
+                <a:spcPts val="0"/>
+              </a:spcBef>
+              <a:spcAft>
+                <a:spcPts val="0"/>
+              </a:spcAft>
+            </a:pPr>
+            <a:r>
+              <a:rPr sz="1600" b="0">
+                <a:solidFill>
+                  <a:srgbClr val="252B33"/>
+                </a:solidFill>
+                <a:latin typeface="Arial"/>
+              </a:rPr>
+              <a:t>Compare with the saved baseline and the study target.</a:t>
+            </a:r>
+          </a:p>
+        </p:txBody>
+      </p:sp>
+      <p:sp>
+        <p:nvSpPr>
+          <p:cNvPr id="24" name="TextBox 23"/>
+          <p:cNvSpPr txBox="1"/>
+          <p:nvPr/>
+        </p:nvSpPr>
+        <p:spPr>
+          <a:xfrm>
+            <a:off x="4169663" y="2788920"/>
+            <a:ext cx="201168" cy="384048"/>
+          </a:xfrm>
+          <a:prstGeom prst="rect">
+            <a:avLst/>
+          </a:prstGeom>
+          <a:noFill/>
+        </p:spPr>
+        <p:txBody>
+          <a:bodyPr wrap="square" lIns="18288" rIns="18288" tIns="18288" bIns="18288" anchor="ctr">
+            <a:spAutoFit/>
+          </a:bodyPr>
+          <a:lstStyle/>
+          <a:p>
+            <a:pPr algn="l">
+              <a:spcBef>
+                <a:spcPts val="0"/>
+              </a:spcBef>
+              <a:spcAft>
+                <a:spcPts val="0"/>
+              </a:spcAft>
+            </a:pPr>
+            <a:r>
+              <a:rPr sz="2600" b="1">
                 <a:solidFill>
                   <a:srgbClr val="5B6874"/>
                 </a:solidFill>
@@ -9909,59 +10074,14 @@
       </p:sp>
       <p:sp>
         <p:nvSpPr>
-          <p:cNvPr id="21" name="Rounded Rectangle 20"/>
-          <p:cNvSpPr/>
-          <p:nvPr/>
-        </p:nvSpPr>
-        <p:spPr>
-          <a:xfrm>
-            <a:off x="8321040" y="2148840"/>
-            <a:ext cx="1709928" cy="1133856"/>
-          </a:xfrm>
-          <a:prstGeom prst="roundRect">
-            <a:avLst/>
-          </a:prstGeom>
-          <a:solidFill>
-            <a:srgbClr val="E8F7EE"/>
-          </a:solidFill>
-          <a:ln w="12700">
-            <a:solidFill>
-              <a:srgbClr val="D8E0E9"/>
-            </a:solidFill>
-          </a:ln>
-        </p:spPr>
-        <p:style>
-          <a:lnRef idx="1">
-            <a:schemeClr val="accent1"/>
-          </a:lnRef>
-          <a:fillRef idx="3">
-            <a:schemeClr val="accent1"/>
-          </a:fillRef>
-          <a:effectRef idx="2">
-            <a:schemeClr val="accent1"/>
-          </a:effectRef>
-          <a:fontRef idx="minor">
-            <a:schemeClr val="lt1"/>
-          </a:fontRef>
-        </p:style>
-        <p:txBody>
-          <a:bodyPr rtlCol="0" anchor="ctr"/>
-          <a:lstStyle/>
-          <a:p>
-            <a:pPr algn="ctr"/>
-          </a:p>
-        </p:txBody>
-      </p:sp>
-      <p:sp>
-        <p:nvSpPr>
-          <p:cNvPr id="22" name="TextBox 21"/>
+          <p:cNvPr id="25" name="TextBox 24"/>
           <p:cNvSpPr txBox="1"/>
           <p:nvPr/>
         </p:nvSpPr>
         <p:spPr>
           <a:xfrm>
-            <a:off x="8439912" y="2313432"/>
-            <a:ext cx="1472184" cy="813816"/>
+            <a:off x="7818120" y="2788920"/>
+            <a:ext cx="201168" cy="384048"/>
           </a:xfrm>
           <a:prstGeom prst="rect">
             <a:avLst/>
@@ -9974,7 +10094,7 @@
           </a:bodyPr>
           <a:lstStyle/>
           <a:p>
-            <a:pPr algn="ctr">
+            <a:pPr algn="l">
               <a:spcBef>
                 <a:spcPts val="0"/>
               </a:spcBef>
@@ -9983,49 +10103,7 @@
               </a:spcAft>
             </a:pPr>
             <a:r>
-              <a:rPr sz="1700" b="1">
-                <a:solidFill>
-                  <a:srgbClr val="246F46"/>
-                </a:solidFill>
-                <a:latin typeface="Arial"/>
-              </a:rPr>
-              <a:t>I run tests</a:t>
-            </a:r>
-          </a:p>
-        </p:txBody>
-      </p:sp>
-      <p:sp>
-        <p:nvSpPr>
-          <p:cNvPr id="23" name="TextBox 22"/>
-          <p:cNvSpPr txBox="1"/>
-          <p:nvPr/>
-        </p:nvSpPr>
-        <p:spPr>
-          <a:xfrm>
-            <a:off x="10040112" y="2432304"/>
-            <a:ext cx="182880" cy="274320"/>
-          </a:xfrm>
-          <a:prstGeom prst="rect">
-            <a:avLst/>
-          </a:prstGeom>
-          <a:noFill/>
-        </p:spPr>
-        <p:txBody>
-          <a:bodyPr wrap="square" lIns="18288" rIns="18288" tIns="18288" bIns="18288" anchor="ctr">
-            <a:spAutoFit/>
-          </a:bodyPr>
-          <a:lstStyle/>
-          <a:p>
-            <a:pPr algn="l">
-              <a:spcBef>
-                <a:spcPts val="0"/>
-              </a:spcBef>
-              <a:spcAft>
-                <a:spcPts val="0"/>
-              </a:spcAft>
-            </a:pPr>
-            <a:r>
-              <a:rPr sz="2100" b="1">
+              <a:rPr sz="2600" b="1">
                 <a:solidFill>
                   <a:srgbClr val="5B6874"/>
                 </a:solidFill>
@@ -10038,101 +10116,14 @@
       </p:sp>
       <p:sp>
         <p:nvSpPr>
-          <p:cNvPr id="24" name="Rounded Rectangle 23"/>
-          <p:cNvSpPr/>
-          <p:nvPr/>
-        </p:nvSpPr>
-        <p:spPr>
-          <a:xfrm>
-            <a:off x="10222992" y="2148840"/>
-            <a:ext cx="1709928" cy="1133856"/>
-          </a:xfrm>
-          <a:prstGeom prst="roundRect">
-            <a:avLst/>
-          </a:prstGeom>
-          <a:solidFill>
-            <a:srgbClr val="E8F7EE"/>
-          </a:solidFill>
-          <a:ln w="12700">
-            <a:solidFill>
-              <a:srgbClr val="D8E0E9"/>
-            </a:solidFill>
-          </a:ln>
-        </p:spPr>
-        <p:style>
-          <a:lnRef idx="1">
-            <a:schemeClr val="accent1"/>
-          </a:lnRef>
-          <a:fillRef idx="3">
-            <a:schemeClr val="accent1"/>
-          </a:fillRef>
-          <a:effectRef idx="2">
-            <a:schemeClr val="accent1"/>
-          </a:effectRef>
-          <a:fontRef idx="minor">
-            <a:schemeClr val="lt1"/>
-          </a:fontRef>
-        </p:style>
-        <p:txBody>
-          <a:bodyPr rtlCol="0" anchor="ctr"/>
-          <a:lstStyle/>
-          <a:p>
-            <a:pPr algn="ctr"/>
-          </a:p>
-        </p:txBody>
-      </p:sp>
-      <p:sp>
-        <p:nvSpPr>
-          <p:cNvPr id="25" name="TextBox 24"/>
-          <p:cNvSpPr txBox="1"/>
-          <p:nvPr/>
-        </p:nvSpPr>
-        <p:spPr>
-          <a:xfrm>
-            <a:off x="10341864" y="2313432"/>
-            <a:ext cx="1472184" cy="813816"/>
-          </a:xfrm>
-          <a:prstGeom prst="rect">
-            <a:avLst/>
-          </a:prstGeom>
-          <a:noFill/>
-        </p:spPr>
-        <p:txBody>
-          <a:bodyPr wrap="square" lIns="18288" rIns="18288" tIns="18288" bIns="18288" anchor="ctr">
-            <a:spAutoFit/>
-          </a:bodyPr>
-          <a:lstStyle/>
-          <a:p>
-            <a:pPr algn="ctr">
-              <a:spcBef>
-                <a:spcPts val="0"/>
-              </a:spcBef>
-              <a:spcAft>
-                <a:spcPts val="0"/>
-              </a:spcAft>
-            </a:pPr>
-            <a:r>
-              <a:rPr sz="1700" b="1">
-                <a:solidFill>
-                  <a:srgbClr val="246F46"/>
-                </a:solidFill>
-                <a:latin typeface="Arial"/>
-              </a:rPr>
-              <a:t>Measure again</a:t>
-            </a:r>
-          </a:p>
-        </p:txBody>
-      </p:sp>
-      <p:sp>
-        <p:nvSpPr>
           <p:cNvPr id="26" name="Rounded Rectangle 25"/>
           <p:cNvSpPr/>
           <p:nvPr/>
         </p:nvSpPr>
         <p:spPr>
           <a:xfrm>
-            <a:off x="1097280" y="3822191"/>
-            <a:ext cx="9985248" cy="1225296"/>
+            <a:off x="768096" y="4718304"/>
+            <a:ext cx="10643616" cy="621792"/>
           </a:xfrm>
           <a:prstGeom prst="roundRect">
             <a:avLst/>
@@ -10176,8 +10167,8 @@
         </p:nvSpPr>
         <p:spPr>
           <a:xfrm>
-            <a:off x="1408176" y="4087368"/>
-            <a:ext cx="9363456" cy="704088"/>
+            <a:off x="1024128" y="4846320"/>
+            <a:ext cx="10131552" cy="347472"/>
           </a:xfrm>
           <a:prstGeom prst="rect">
             <a:avLst/>
@@ -10190,7 +10181,7 @@
           </a:bodyPr>
           <a:lstStyle/>
           <a:p>
-            <a:pPr algn="ctr">
+            <a:pPr algn="l">
               <a:spcBef>
                 <a:spcPts val="0"/>
               </a:spcBef>
@@ -10199,13 +10190,98 @@
               </a:spcAft>
             </a:pPr>
             <a:r>
-              <a:rPr sz="2200" b="1">
+              <a:rPr sz="1900" b="1">
                 <a:solidFill>
-                  <a:srgbClr val="252B33"/>
+                  <a:srgbClr val="0F676D"/>
                 </a:solidFill>
                 <a:latin typeface="Arial"/>
               </a:rPr>
-              <a:t>An AI suggestion is not proof: I check it, then the same tool measures the result.</a:t>
+              <a:t>Concrete result: request DTO adopted; SonarQube unique issues 17 → 0.</a:t>
+            </a:r>
+          </a:p>
+        </p:txBody>
+      </p:sp>
+      <p:sp>
+        <p:nvSpPr>
+          <p:cNvPr id="28" name="Rounded Rectangle 27"/>
+          <p:cNvSpPr/>
+          <p:nvPr/>
+        </p:nvSpPr>
+        <p:spPr>
+          <a:xfrm>
+            <a:off x="768096" y="5495544"/>
+            <a:ext cx="10643616" cy="612648"/>
+          </a:xfrm>
+          <a:prstGeom prst="roundRect">
+            <a:avLst/>
+          </a:prstGeom>
+          <a:solidFill>
+            <a:srgbClr val="FFF6E7"/>
+          </a:solidFill>
+          <a:ln>
+            <a:noFill/>
+          </a:ln>
+        </p:spPr>
+        <p:style>
+          <a:lnRef idx="1">
+            <a:schemeClr val="accent1"/>
+          </a:lnRef>
+          <a:fillRef idx="3">
+            <a:schemeClr val="accent1"/>
+          </a:fillRef>
+          <a:effectRef idx="2">
+            <a:schemeClr val="accent1"/>
+          </a:effectRef>
+          <a:fontRef idx="minor">
+            <a:schemeClr val="lt1"/>
+          </a:fontRef>
+        </p:style>
+        <p:txBody>
+          <a:bodyPr rtlCol="0" anchor="ctr"/>
+          <a:lstStyle/>
+          <a:p>
+            <a:pPr algn="ctr"/>
+          </a:p>
+        </p:txBody>
+      </p:sp>
+      <p:sp>
+        <p:nvSpPr>
+          <p:cNvPr id="29" name="TextBox 28"/>
+          <p:cNvSpPr txBox="1"/>
+          <p:nvPr/>
+        </p:nvSpPr>
+        <p:spPr>
+          <a:xfrm>
+            <a:off x="1024128" y="5623560"/>
+            <a:ext cx="10131552" cy="338328"/>
+          </a:xfrm>
+          <a:prstGeom prst="rect">
+            <a:avLst/>
+          </a:prstGeom>
+          <a:noFill/>
+        </p:spPr>
+        <p:txBody>
+          <a:bodyPr wrap="square" lIns="18288" rIns="18288" tIns="18288" bIns="18288" anchor="ctr">
+            <a:spAutoFit/>
+          </a:bodyPr>
+          <a:lstStyle/>
+          <a:p>
+            <a:pPr algn="l">
+              <a:spcBef>
+                <a:spcPts val="0"/>
+              </a:spcBef>
+              <a:spcAft>
+                <a:spcPts val="0"/>
+              </a:spcAft>
+            </a:pPr>
+            <a:r>
+              <a:rPr sz="1800" b="1">
+                <a:solidFill>
+                  <a:srgbClr val="BE7414"/>
+                </a:solidFill>
+                <a:latin typeface="Arial"/>
+              </a:rPr>
+              <a:t>An AI proposal is not proof: the JMeter branch did not meet its main speed target.</a:t>
             </a:r>
           </a:p>
         </p:txBody>

</xml_diff>

<commit_message>
docs: explain applied case study and SonarQube zero metrics
</commit_message>
<xml_diff>
--- a/Document/outputs/final-defense/G6519692_Zaw_Ye_Htut_Ko_Final_Thesis_Defense.pptx
+++ b/Document/outputs/final-defense/G6519692_Zaw_Ye_Htut_Ko_Final_Thesis_Defense.pptx
@@ -953,12 +953,12 @@
           <a:lstStyle/>
           <a:p>
             <a:r>
-              <a:t>TIMING: 80 seconds</a:t>
-            </a:r>
-          </a:p>
-          <a:p>
-            <a:r>
-              <a:t>KEY MESSAGE: The measurable SonarQube improvement is 17 distinct issues to zero.</a:t>
+              <a:t>TIMING: 100 seconds</a:t>
+            </a:r>
+          </a:p>
+          <a:p>
+            <a:r>
+              <a:t>KEY MESSAGE: The zeros and the small coverage decrease have different meanings.</a:t>
             </a:r>
           </a:p>
           <a:p>
@@ -979,7 +979,7 @@
           </a:p>
           <a:p>
             <a:r>
-              <a:t>SonarQube reported 17 distinct issues before the code change and zero after it. Cyclomatic complexity is a rough count of the different decision paths through code, such as branches. Its total rose from 886 to 889, a small increase; that is not an improvement. Coverage also fell slightly from 74.4 to 74.3 percent. Both gate statuses say OK, but the saved gate records list no conditions, so I rely mainly on the issue count. The reliability, security, and maintainability labels overlap and are not extra issues to add to 17.</a:t>
+              <a:t>SonarQube reported 17 unique baseline issues and zero after the changes. Why do Bugs and Vulnerabilities show zero even at baseline? In the legacy issue-type field, all 17 were classified as code smells. SonarQube's newer impact labels also marked some of those same issues as Reliability or Security concerns. Those labels overlap; they are not additional unique bugs or vulnerabilities. Duplicated-line density was 0.0 percent in both scans: the tool did not report duplicated lines at its displayed precision in this analyzed scope. It does not prove the whole codebase has no repeated logic. Coverage moved from 74.4 to 74.3 percent, a decrease of 0.1 percentage point. The saved summaries give the percentages but not the underlying covered and uncovered counts, so I cannot identify the exact cause. Cyclomatic complexity roughly counts decision paths through code; it rose from 886 to 889. I report both changes as small regressions. The Quality Gate said OK on both branches but its saved conditions list was empty, so the issue count is the clearer comparison.</a:t>
             </a:r>
           </a:p>
           <a:p/>
@@ -2427,7 +2427,7 @@
           </a:p>
           <a:p>
             <a:r>
-              <a:t>Codex helped me propose code changes. I reviewed them, and the original tools measured the results. Code warnings reached zero and selected security checks passed, but the main performance target was not met. My contribution is the traceable process and this honest mixed result, not a claim that ChatGPT always improves an API. Thank you; I welcome questions.</a:t>
+              <a:t>This was an applied case study, not a new algorithm, scoring matrix, or comparison of AI assistants. Codex helped me propose code changes. I reviewed them, and the original tools measured the results. Code warnings reached zero and selected security checks passed, but the main performance target was not met. My contribution is the traceable process and this honest mixed result, not a claim that ChatGPT always improves an API. Thank you; I welcome questions.</a:t>
             </a:r>
           </a:p>
           <a:p/>
@@ -4423,12 +4423,12 @@
           <a:lstStyle/>
           <a:p>
             <a:r>
-              <a:t>TIMING: 70 seconds</a:t>
-            </a:r>
-          </a:p>
-          <a:p>
-            <a:r>
-              <a:t>KEY MESSAGE: All comparisons use the same accounting API.</a:t>
+              <a:t>TIMING: 75 seconds</a:t>
+            </a:r>
+          </a:p>
+          <a:p>
+            <a:r>
+              <a:t>KEY MESSAGE: This is an applied single-case evaluation, not a new algorithm.</a:t>
             </a:r>
           </a:p>
           <a:p>
@@ -4449,13 +4449,13 @@
           </a:p>
           <a:p>
             <a:r>
-              <a:t>This API has login, four user roles, accounts, journal entries, reports, and an audit log. It uses a local SQL Server database. I compared a baseline with changed versions of this same API. The web screenshots later show that the app can be used; those screenshots are not JMeter performance measurements.</a:t>
+              <a:t>This is applied research: I study one existing financial accounting API and ask what happens when ChatGPT helps me address measured problems. I am not inventing a new algorithm or a scoring matrix. Why ChatGPT? It is the one assistant named in my research question, and through Codex 5.4 I can give it an actual scanner finding plus repository code and ask for a candidate change. I keep that one assistant fixed so I can examine this workflow in depth; I am not comparing AI assistants or claiming ChatGPT is the best one. I review the proposed edits, while tests and the three independent tools decide the outcomes.</a:t>
             </a:r>
           </a:p>
           <a:p/>
           <a:p>
             <a:r>
-              <a:t>SOURCE: Current report §§3.1-3.2, Table 3.3, Figures 4.2-4.7.</a:t>
+              <a:t>SOURCE: Current report §§1.6 and 3.1-3.3, Table 3.3 and §3.6.</a:t>
             </a:r>
           </a:p>
         </p:txBody>
@@ -11822,8 +11822,8 @@
         </p:nvSpPr>
         <p:spPr>
           <a:xfrm>
-            <a:off x="731520" y="2871216"/>
-            <a:ext cx="10716768" cy="2103120"/>
+            <a:off x="731520" y="2852928"/>
+            <a:ext cx="3438144" cy="2459736"/>
           </a:xfrm>
           <a:prstGeom prst="roundRect">
             <a:avLst/>
@@ -11867,8 +11867,8 @@
         </p:nvSpPr>
         <p:spPr>
           <a:xfrm>
-            <a:off x="996696" y="3154680"/>
-            <a:ext cx="9966960" cy="365760"/>
+            <a:off x="914400" y="3063240"/>
+            <a:ext cx="3054096" cy="630936"/>
           </a:xfrm>
           <a:prstGeom prst="rect">
             <a:avLst/>
@@ -11890,13 +11890,13 @@
               </a:spcAft>
             </a:pPr>
             <a:r>
-              <a:rPr sz="2200" b="1">
+              <a:rPr sz="1800" b="1">
                 <a:solidFill>
                   <a:srgbClr val="0F676D"/>
                 </a:solidFill>
                 <a:latin typeface="Arial"/>
               </a:rPr>
-              <a:t>Do not add impact counts together</a:t>
+              <a:t>Bugs 0 · Vulnerabilities 0</a:t>
             </a:r>
           </a:p>
         </p:txBody>
@@ -11909,8 +11909,8 @@
         </p:nvSpPr>
         <p:spPr>
           <a:xfrm>
-            <a:off x="996696" y="3657600"/>
-            <a:ext cx="9948672" cy="758952"/>
+            <a:off x="914400" y="3794760"/>
+            <a:ext cx="3054096" cy="1271016"/>
           </a:xfrm>
           <a:prstGeom prst="rect">
             <a:avLst/>
@@ -11932,27 +11932,285 @@
               </a:spcAft>
             </a:pPr>
             <a:r>
-              <a:rPr sz="1900" b="0">
+              <a:rPr sz="1600" b="0">
                 <a:solidFill>
                   <a:srgbClr val="252B33"/>
                 </a:solidFill>
                 <a:latin typeface="Arial"/>
               </a:rPr>
-              <a:t>The 17 findings had overlapping impacts: Reliability 2, Security 1, Maintainability 16. Complexity rose 886 → 889; duplication stayed 0.0%.</a:t>
-            </a:r>
-          </a:p>
-        </p:txBody>
-      </p:sp>
-      <p:sp>
-        <p:nvSpPr>
-          <p:cNvPr id="24" name="TextBox 23"/>
+              <a:t>All 17 baseline issues were legacy Code Smells. Newer impact labels can still mention Reliability or Security.</a:t>
+            </a:r>
+          </a:p>
+        </p:txBody>
+      </p:sp>
+      <p:sp>
+        <p:nvSpPr>
+          <p:cNvPr id="24" name="Rounded Rectangle 23"/>
+          <p:cNvSpPr/>
+          <p:nvPr/>
+        </p:nvSpPr>
+        <p:spPr>
+          <a:xfrm>
+            <a:off x="4370832" y="2852928"/>
+            <a:ext cx="3438144" cy="2459736"/>
+          </a:xfrm>
+          <a:prstGeom prst="roundRect">
+            <a:avLst/>
+          </a:prstGeom>
+          <a:solidFill>
+            <a:srgbClr val="FFFFFF"/>
+          </a:solidFill>
+          <a:ln w="12700">
+            <a:solidFill>
+              <a:srgbClr val="D8E0E9"/>
+            </a:solidFill>
+          </a:ln>
+        </p:spPr>
+        <p:style>
+          <a:lnRef idx="1">
+            <a:schemeClr val="accent1"/>
+          </a:lnRef>
+          <a:fillRef idx="3">
+            <a:schemeClr val="accent1"/>
+          </a:fillRef>
+          <a:effectRef idx="2">
+            <a:schemeClr val="accent1"/>
+          </a:effectRef>
+          <a:fontRef idx="minor">
+            <a:schemeClr val="lt1"/>
+          </a:fontRef>
+        </p:style>
+        <p:txBody>
+          <a:bodyPr rtlCol="0" anchor="ctr"/>
+          <a:lstStyle/>
+          <a:p>
+            <a:pPr algn="ctr"/>
+          </a:p>
+        </p:txBody>
+      </p:sp>
+      <p:sp>
+        <p:nvSpPr>
+          <p:cNvPr id="25" name="TextBox 24"/>
           <p:cNvSpPr txBox="1"/>
           <p:nvPr/>
         </p:nvSpPr>
         <p:spPr>
           <a:xfrm>
-            <a:off x="996696" y="4480560"/>
-            <a:ext cx="9948672" cy="402336"/>
+            <a:off x="4553712" y="3063240"/>
+            <a:ext cx="3054096" cy="630936"/>
+          </a:xfrm>
+          <a:prstGeom prst="rect">
+            <a:avLst/>
+          </a:prstGeom>
+          <a:noFill/>
+        </p:spPr>
+        <p:txBody>
+          <a:bodyPr wrap="square" lIns="18288" rIns="18288" tIns="18288" bIns="18288" anchor="ctr">
+            <a:spAutoFit/>
+          </a:bodyPr>
+          <a:lstStyle/>
+          <a:p>
+            <a:pPr algn="l">
+              <a:spcBef>
+                <a:spcPts val="0"/>
+              </a:spcBef>
+              <a:spcAft>
+                <a:spcPts val="0"/>
+              </a:spcAft>
+            </a:pPr>
+            <a:r>
+              <a:rPr sz="1800" b="1">
+                <a:solidFill>
+                  <a:srgbClr val="0F676D"/>
+                </a:solidFill>
+                <a:latin typeface="Arial"/>
+              </a:rPr>
+              <a:t>Duplicated-line density 0.0%</a:t>
+            </a:r>
+          </a:p>
+        </p:txBody>
+      </p:sp>
+      <p:sp>
+        <p:nvSpPr>
+          <p:cNvPr id="26" name="TextBox 25"/>
+          <p:cNvSpPr txBox="1"/>
+          <p:nvPr/>
+        </p:nvSpPr>
+        <p:spPr>
+          <a:xfrm>
+            <a:off x="4553712" y="3794760"/>
+            <a:ext cx="3054096" cy="1271016"/>
+          </a:xfrm>
+          <a:prstGeom prst="rect">
+            <a:avLst/>
+          </a:prstGeom>
+          <a:noFill/>
+        </p:spPr>
+        <p:txBody>
+          <a:bodyPr wrap="square" lIns="18288" rIns="18288" tIns="18288" bIns="18288" anchor="ctr">
+            <a:spAutoFit/>
+          </a:bodyPr>
+          <a:lstStyle/>
+          <a:p>
+            <a:pPr algn="l">
+              <a:spcBef>
+                <a:spcPts val="0"/>
+              </a:spcBef>
+              <a:spcAft>
+                <a:spcPts val="0"/>
+              </a:spcAft>
+            </a:pPr>
+            <a:r>
+              <a:rPr sz="1600" b="0">
+                <a:solidFill>
+                  <a:srgbClr val="252B33"/>
+                </a:solidFill>
+                <a:latin typeface="Arial"/>
+              </a:rPr>
+              <a:t>SonarQube reported 0.0% for the analyzed code; that is not proof of no repeated code.</a:t>
+            </a:r>
+          </a:p>
+        </p:txBody>
+      </p:sp>
+      <p:sp>
+        <p:nvSpPr>
+          <p:cNvPr id="27" name="Rounded Rectangle 26"/>
+          <p:cNvSpPr/>
+          <p:nvPr/>
+        </p:nvSpPr>
+        <p:spPr>
+          <a:xfrm>
+            <a:off x="8010144" y="2852928"/>
+            <a:ext cx="3438144" cy="2459736"/>
+          </a:xfrm>
+          <a:prstGeom prst="roundRect">
+            <a:avLst/>
+          </a:prstGeom>
+          <a:solidFill>
+            <a:srgbClr val="FFFFFF"/>
+          </a:solidFill>
+          <a:ln w="12700">
+            <a:solidFill>
+              <a:srgbClr val="D8E0E9"/>
+            </a:solidFill>
+          </a:ln>
+        </p:spPr>
+        <p:style>
+          <a:lnRef idx="1">
+            <a:schemeClr val="accent1"/>
+          </a:lnRef>
+          <a:fillRef idx="3">
+            <a:schemeClr val="accent1"/>
+          </a:fillRef>
+          <a:effectRef idx="2">
+            <a:schemeClr val="accent1"/>
+          </a:effectRef>
+          <a:fontRef idx="minor">
+            <a:schemeClr val="lt1"/>
+          </a:fontRef>
+        </p:style>
+        <p:txBody>
+          <a:bodyPr rtlCol="0" anchor="ctr"/>
+          <a:lstStyle/>
+          <a:p>
+            <a:pPr algn="ctr"/>
+          </a:p>
+        </p:txBody>
+      </p:sp>
+      <p:sp>
+        <p:nvSpPr>
+          <p:cNvPr id="28" name="TextBox 27"/>
+          <p:cNvSpPr txBox="1"/>
+          <p:nvPr/>
+        </p:nvSpPr>
+        <p:spPr>
+          <a:xfrm>
+            <a:off x="8193023" y="3063240"/>
+            <a:ext cx="3054096" cy="630936"/>
+          </a:xfrm>
+          <a:prstGeom prst="rect">
+            <a:avLst/>
+          </a:prstGeom>
+          <a:noFill/>
+        </p:spPr>
+        <p:txBody>
+          <a:bodyPr wrap="square" lIns="18288" rIns="18288" tIns="18288" bIns="18288" anchor="ctr">
+            <a:spAutoFit/>
+          </a:bodyPr>
+          <a:lstStyle/>
+          <a:p>
+            <a:pPr algn="l">
+              <a:spcBef>
+                <a:spcPts val="0"/>
+              </a:spcBef>
+              <a:spcAft>
+                <a:spcPts val="0"/>
+              </a:spcAft>
+            </a:pPr>
+            <a:r>
+              <a:rPr sz="1800" b="1">
+                <a:solidFill>
+                  <a:srgbClr val="0F676D"/>
+                </a:solidFill>
+                <a:latin typeface="Arial"/>
+              </a:rPr>
+              <a:t>Coverage: 0.1 percentage point down</a:t>
+            </a:r>
+          </a:p>
+        </p:txBody>
+      </p:sp>
+      <p:sp>
+        <p:nvSpPr>
+          <p:cNvPr id="29" name="TextBox 28"/>
+          <p:cNvSpPr txBox="1"/>
+          <p:nvPr/>
+        </p:nvSpPr>
+        <p:spPr>
+          <a:xfrm>
+            <a:off x="8193023" y="3794760"/>
+            <a:ext cx="3054096" cy="1271016"/>
+          </a:xfrm>
+          <a:prstGeom prst="rect">
+            <a:avLst/>
+          </a:prstGeom>
+          <a:noFill/>
+        </p:spPr>
+        <p:txBody>
+          <a:bodyPr wrap="square" lIns="18288" rIns="18288" tIns="18288" bIns="18288" anchor="ctr">
+            <a:spAutoFit/>
+          </a:bodyPr>
+          <a:lstStyle/>
+          <a:p>
+            <a:pPr algn="l">
+              <a:spcBef>
+                <a:spcPts val="0"/>
+              </a:spcBef>
+              <a:spcAft>
+                <a:spcPts val="0"/>
+              </a:spcAft>
+            </a:pPr>
+            <a:r>
+              <a:rPr sz="1600" b="0">
+                <a:solidFill>
+                  <a:srgbClr val="252B33"/>
+                </a:solidFill>
+                <a:latin typeface="Arial"/>
+              </a:rPr>
+              <a:t>74.4% → 74.3%. This is a small measured decrease; saved summaries do not explain its exact cause.</a:t>
+            </a:r>
+          </a:p>
+        </p:txBody>
+      </p:sp>
+      <p:sp>
+        <p:nvSpPr>
+          <p:cNvPr id="30" name="TextBox 29"/>
+          <p:cNvSpPr txBox="1"/>
+          <p:nvPr/>
+        </p:nvSpPr>
+        <p:spPr>
+          <a:xfrm>
+            <a:off x="786384" y="5632704"/>
+            <a:ext cx="10616184" cy="411480"/>
           </a:xfrm>
           <a:prstGeom prst="rect">
             <a:avLst/>
@@ -11980,7 +12238,7 @@
                 </a:solidFill>
                 <a:latin typeface="Arial"/>
               </a:rPr>
-              <a:t>Cyclomatic complexity counts possible decision paths through code; a higher count can need more tests.</a:t>
+              <a:t>Impact labels overlap (Reliability 2, Security 1, Maintainability 16); complexity rose 886 → 889.</a:t>
             </a:r>
           </a:p>
         </p:txBody>
@@ -38893,7 +39151,7 @@
                 </a:solidFill>
                 <a:latin typeface="Arial"/>
               </a:rPr>
-              <a:t>The study tested one existing accounting API</a:t>
+              <a:t>An applied case study of one existing API</a:t>
             </a:r>
           </a:p>
         </p:txBody>
@@ -39005,7 +39263,7 @@
                 </a:solidFill>
                 <a:latin typeface="Arial"/>
               </a:rPr>
-              <a:t>Current report §§3.1-3.2; Table 3.3</a:t>
+              <a:t>Current report §§1.6 and 3.1-3.3; Table 3.3</a:t>
             </a:r>
           </a:p>
         </p:txBody>
@@ -39060,8 +39318,8 @@
         </p:nvSpPr>
         <p:spPr>
           <a:xfrm>
-            <a:off x="731520" y="1417320"/>
-            <a:ext cx="3749039" cy="4416552"/>
+            <a:off x="731520" y="1481328"/>
+            <a:ext cx="3438144" cy="3593592"/>
           </a:xfrm>
           <a:prstGeom prst="roundRect">
             <a:avLst/>
@@ -39105,8 +39363,8 @@
         </p:nvSpPr>
         <p:spPr>
           <a:xfrm>
-            <a:off x="996696" y="1719072"/>
-            <a:ext cx="3218688" cy="457200"/>
+            <a:off x="932688" y="1737360"/>
+            <a:ext cx="3017520" cy="256032"/>
           </a:xfrm>
           <a:prstGeom prst="rect">
             <a:avLst/>
@@ -39128,13 +39386,13 @@
               </a:spcAft>
             </a:pPr>
             <a:r>
-              <a:rPr sz="2700" b="1">
+              <a:rPr sz="1400" b="1">
                 <a:solidFill>
                   <a:srgbClr val="24466C"/>
                 </a:solidFill>
                 <a:latin typeface="Arial"/>
               </a:rPr>
-              <a:t>ASP.NET Core 8</a:t>
+              <a:t>WHAT I STUDIED</a:t>
             </a:r>
           </a:p>
         </p:txBody>
@@ -39147,8 +39405,8 @@
         </p:nvSpPr>
         <p:spPr>
           <a:xfrm>
-            <a:off x="996696" y="2386584"/>
-            <a:ext cx="3218688" cy="2414016"/>
+            <a:off x="932688" y="2212848"/>
+            <a:ext cx="3017520" cy="530352"/>
           </a:xfrm>
           <a:prstGeom prst="rect">
             <a:avLst/>
@@ -39170,29 +39428,114 @@
               </a:spcAft>
             </a:pPr>
             <a:r>
-              <a:rPr sz="2200" b="0">
+              <a:rPr sz="2400" b="1">
+                <a:solidFill>
+                  <a:srgbClr val="24466C"/>
+                </a:solidFill>
+                <a:latin typeface="Arial"/>
+              </a:rPr>
+              <a:t>Applied case study</a:t>
+            </a:r>
+          </a:p>
+        </p:txBody>
+      </p:sp>
+      <p:sp>
+        <p:nvSpPr>
+          <p:cNvPr id="12" name="TextBox 11"/>
+          <p:cNvSpPr txBox="1"/>
+          <p:nvPr/>
+        </p:nvSpPr>
+        <p:spPr>
+          <a:xfrm>
+            <a:off x="932688" y="2944368"/>
+            <a:ext cx="3017520" cy="1746504"/>
+          </a:xfrm>
+          <a:prstGeom prst="rect">
+            <a:avLst/>
+          </a:prstGeom>
+          <a:noFill/>
+        </p:spPr>
+        <p:txBody>
+          <a:bodyPr wrap="square" lIns="18288" rIns="18288" tIns="18288" bIns="18288" anchor="ctr">
+            <a:spAutoFit/>
+          </a:bodyPr>
+          <a:lstStyle/>
+          <a:p>
+            <a:pPr algn="l">
+              <a:spcBef>
+                <a:spcPts val="0"/>
+              </a:spcBef>
+              <a:spcAft>
+                <a:spcPts val="0"/>
+              </a:spcAft>
+            </a:pPr>
+            <a:r>
+              <a:rPr sz="2000" b="0">
                 <a:solidFill>
                   <a:srgbClr val="252B33"/>
                 </a:solidFill>
                 <a:latin typeface="Arial"/>
               </a:rPr>
-              <a:t>SQL Server financial database
-JWT authentication · RBAC
-Double-entry posting · audit log</a:t>
-            </a:r>
-          </a:p>
-        </p:txBody>
-      </p:sp>
-      <p:sp>
-        <p:nvSpPr>
-          <p:cNvPr id="12" name="TextBox 11"/>
+              <a:t>One ASP.NET Core financial API with accounts, journal entries, reports, and four user roles.</a:t>
+            </a:r>
+          </a:p>
+        </p:txBody>
+      </p:sp>
+      <p:sp>
+        <p:nvSpPr>
+          <p:cNvPr id="13" name="Rounded Rectangle 12"/>
+          <p:cNvSpPr/>
+          <p:nvPr/>
+        </p:nvSpPr>
+        <p:spPr>
+          <a:xfrm>
+            <a:off x="4370832" y="1481328"/>
+            <a:ext cx="3438144" cy="3593592"/>
+          </a:xfrm>
+          <a:prstGeom prst="roundRect">
+            <a:avLst/>
+          </a:prstGeom>
+          <a:solidFill>
+            <a:srgbClr val="E7F6F6"/>
+          </a:solidFill>
+          <a:ln w="12700">
+            <a:solidFill>
+              <a:srgbClr val="D8E0E9"/>
+            </a:solidFill>
+          </a:ln>
+        </p:spPr>
+        <p:style>
+          <a:lnRef idx="1">
+            <a:schemeClr val="accent1"/>
+          </a:lnRef>
+          <a:fillRef idx="3">
+            <a:schemeClr val="accent1"/>
+          </a:fillRef>
+          <a:effectRef idx="2">
+            <a:schemeClr val="accent1"/>
+          </a:effectRef>
+          <a:fontRef idx="minor">
+            <a:schemeClr val="lt1"/>
+          </a:fontRef>
+        </p:style>
+        <p:txBody>
+          <a:bodyPr rtlCol="0" anchor="ctr"/>
+          <a:lstStyle/>
+          <a:p>
+            <a:pPr algn="ctr"/>
+          </a:p>
+        </p:txBody>
+      </p:sp>
+      <p:sp>
+        <p:nvSpPr>
+          <p:cNvPr id="14" name="TextBox 13"/>
           <p:cNvSpPr txBox="1"/>
           <p:nvPr/>
         </p:nvSpPr>
         <p:spPr>
           <a:xfrm>
-            <a:off x="996696" y="5129784"/>
-            <a:ext cx="3182112" cy="438912"/>
+            <a:off x="4572000" y="1737360"/>
+            <a:ext cx="3017520" cy="256032"/>
           </a:xfrm>
           <a:prstGeom prst="rect">
             <a:avLst/>
@@ -39214,27 +39557,282 @@
               </a:spcAft>
             </a:pPr>
             <a:r>
-              <a:rPr sz="1500" b="0">
+              <a:rPr sz="1400" b="1">
                 <a:solidFill>
-                  <a:srgbClr val="5B6874"/>
+                  <a:srgbClr val="0F676D"/>
                 </a:solidFill>
                 <a:latin typeface="Arial"/>
               </a:rPr>
-              <a:t>Four roles: Admin, FinanceManager, User, Auditor</a:t>
-            </a:r>
-          </a:p>
-        </p:txBody>
-      </p:sp>
-      <p:sp>
-        <p:nvSpPr>
-          <p:cNvPr id="13" name="Rounded Rectangle 12"/>
+              <a:t>WHY THIS ASSISTANT</a:t>
+            </a:r>
+          </a:p>
+        </p:txBody>
+      </p:sp>
+      <p:sp>
+        <p:nvSpPr>
+          <p:cNvPr id="15" name="TextBox 14"/>
+          <p:cNvSpPr txBox="1"/>
+          <p:nvPr/>
+        </p:nvSpPr>
+        <p:spPr>
+          <a:xfrm>
+            <a:off x="4572000" y="2212848"/>
+            <a:ext cx="3017520" cy="530352"/>
+          </a:xfrm>
+          <a:prstGeom prst="rect">
+            <a:avLst/>
+          </a:prstGeom>
+          <a:noFill/>
+        </p:spPr>
+        <p:txBody>
+          <a:bodyPr wrap="square" lIns="18288" rIns="18288" tIns="18288" bIns="18288" anchor="ctr">
+            <a:spAutoFit/>
+          </a:bodyPr>
+          <a:lstStyle/>
+          <a:p>
+            <a:pPr algn="l">
+              <a:spcBef>
+                <a:spcPts val="0"/>
+              </a:spcBef>
+              <a:spcAft>
+                <a:spcPts val="0"/>
+              </a:spcAft>
+            </a:pPr>
+            <a:r>
+              <a:rPr sz="2400" b="1">
+                <a:solidFill>
+                  <a:srgbClr val="0F676D"/>
+                </a:solidFill>
+                <a:latin typeface="Arial"/>
+              </a:rPr>
+              <a:t>Why ChatGPT?</a:t>
+            </a:r>
+          </a:p>
+        </p:txBody>
+      </p:sp>
+      <p:sp>
+        <p:nvSpPr>
+          <p:cNvPr id="16" name="TextBox 15"/>
+          <p:cNvSpPr txBox="1"/>
+          <p:nvPr/>
+        </p:nvSpPr>
+        <p:spPr>
+          <a:xfrm>
+            <a:off x="4572000" y="2944368"/>
+            <a:ext cx="3017520" cy="1746504"/>
+          </a:xfrm>
+          <a:prstGeom prst="rect">
+            <a:avLst/>
+          </a:prstGeom>
+          <a:noFill/>
+        </p:spPr>
+        <p:txBody>
+          <a:bodyPr wrap="square" lIns="18288" rIns="18288" tIns="18288" bIns="18288" anchor="ctr">
+            <a:spAutoFit/>
+          </a:bodyPr>
+          <a:lstStyle/>
+          <a:p>
+            <a:pPr algn="l">
+              <a:spcBef>
+                <a:spcPts val="0"/>
+              </a:spcBef>
+              <a:spcAft>
+                <a:spcPts val="0"/>
+              </a:spcAft>
+            </a:pPr>
+            <a:r>
+              <a:rPr sz="2000" b="0">
+                <a:solidFill>
+                  <a:srgbClr val="252B33"/>
+                </a:solidFill>
+                <a:latin typeface="Arial"/>
+              </a:rPr>
+              <a:t>Chosen for this case because Codex 5.4 can use scanner findings and source context to propose traceable code edits.</a:t>
+            </a:r>
+          </a:p>
+        </p:txBody>
+      </p:sp>
+      <p:sp>
+        <p:nvSpPr>
+          <p:cNvPr id="17" name="Rounded Rectangle 16"/>
           <p:cNvSpPr/>
           <p:nvPr/>
         </p:nvSpPr>
         <p:spPr>
           <a:xfrm>
-            <a:off x="4681728" y="1417320"/>
-            <a:ext cx="6766560" cy="4416552"/>
+            <a:off x="8010144" y="1481328"/>
+            <a:ext cx="3438144" cy="3593592"/>
+          </a:xfrm>
+          <a:prstGeom prst="roundRect">
+            <a:avLst/>
+          </a:prstGeom>
+          <a:solidFill>
+            <a:srgbClr val="E8F7EE"/>
+          </a:solidFill>
+          <a:ln w="12700">
+            <a:solidFill>
+              <a:srgbClr val="D8E0E9"/>
+            </a:solidFill>
+          </a:ln>
+        </p:spPr>
+        <p:style>
+          <a:lnRef idx="1">
+            <a:schemeClr val="accent1"/>
+          </a:lnRef>
+          <a:fillRef idx="3">
+            <a:schemeClr val="accent1"/>
+          </a:fillRef>
+          <a:effectRef idx="2">
+            <a:schemeClr val="accent1"/>
+          </a:effectRef>
+          <a:fontRef idx="minor">
+            <a:schemeClr val="lt1"/>
+          </a:fontRef>
+        </p:style>
+        <p:txBody>
+          <a:bodyPr rtlCol="0" anchor="ctr"/>
+          <a:lstStyle/>
+          <a:p>
+            <a:pPr algn="ctr"/>
+          </a:p>
+        </p:txBody>
+      </p:sp>
+      <p:sp>
+        <p:nvSpPr>
+          <p:cNvPr id="18" name="TextBox 17"/>
+          <p:cNvSpPr txBox="1"/>
+          <p:nvPr/>
+        </p:nvSpPr>
+        <p:spPr>
+          <a:xfrm>
+            <a:off x="8211312" y="1737360"/>
+            <a:ext cx="3017520" cy="256032"/>
+          </a:xfrm>
+          <a:prstGeom prst="rect">
+            <a:avLst/>
+          </a:prstGeom>
+          <a:noFill/>
+        </p:spPr>
+        <p:txBody>
+          <a:bodyPr wrap="square" lIns="18288" rIns="18288" tIns="18288" bIns="18288" anchor="ctr">
+            <a:spAutoFit/>
+          </a:bodyPr>
+          <a:lstStyle/>
+          <a:p>
+            <a:pPr algn="l">
+              <a:spcBef>
+                <a:spcPts val="0"/>
+              </a:spcBef>
+              <a:spcAft>
+                <a:spcPts val="0"/>
+              </a:spcAft>
+            </a:pPr>
+            <a:r>
+              <a:rPr sz="1400" b="1">
+                <a:solidFill>
+                  <a:srgbClr val="246F46"/>
+                </a:solidFill>
+                <a:latin typeface="Arial"/>
+              </a:rPr>
+              <a:t>HOW I JUDGED IT</a:t>
+            </a:r>
+          </a:p>
+        </p:txBody>
+      </p:sp>
+      <p:sp>
+        <p:nvSpPr>
+          <p:cNvPr id="19" name="TextBox 18"/>
+          <p:cNvSpPr txBox="1"/>
+          <p:nvPr/>
+        </p:nvSpPr>
+        <p:spPr>
+          <a:xfrm>
+            <a:off x="8211312" y="2212848"/>
+            <a:ext cx="3017520" cy="530352"/>
+          </a:xfrm>
+          <a:prstGeom prst="rect">
+            <a:avLst/>
+          </a:prstGeom>
+          <a:noFill/>
+        </p:spPr>
+        <p:txBody>
+          <a:bodyPr wrap="square" lIns="18288" rIns="18288" tIns="18288" bIns="18288" anchor="ctr">
+            <a:spAutoFit/>
+          </a:bodyPr>
+          <a:lstStyle/>
+          <a:p>
+            <a:pPr algn="l">
+              <a:spcBef>
+                <a:spcPts val="0"/>
+              </a:spcBef>
+              <a:spcAft>
+                <a:spcPts val="0"/>
+              </a:spcAft>
+            </a:pPr>
+            <a:r>
+              <a:rPr sz="2400" b="1">
+                <a:solidFill>
+                  <a:srgbClr val="246F46"/>
+                </a:solidFill>
+                <a:latin typeface="Arial"/>
+              </a:rPr>
+              <a:t>Measured comparison</a:t>
+            </a:r>
+          </a:p>
+        </p:txBody>
+      </p:sp>
+      <p:sp>
+        <p:nvSpPr>
+          <p:cNvPr id="20" name="TextBox 19"/>
+          <p:cNvSpPr txBox="1"/>
+          <p:nvPr/>
+        </p:nvSpPr>
+        <p:spPr>
+          <a:xfrm>
+            <a:off x="8211312" y="2944368"/>
+            <a:ext cx="3017520" cy="1746504"/>
+          </a:xfrm>
+          <a:prstGeom prst="rect">
+            <a:avLst/>
+          </a:prstGeom>
+          <a:noFill/>
+        </p:spPr>
+        <p:txBody>
+          <a:bodyPr wrap="square" lIns="18288" rIns="18288" tIns="18288" bIns="18288" anchor="ctr">
+            <a:spAutoFit/>
+          </a:bodyPr>
+          <a:lstStyle/>
+          <a:p>
+            <a:pPr algn="l">
+              <a:spcBef>
+                <a:spcPts val="0"/>
+              </a:spcBef>
+              <a:spcAft>
+                <a:spcPts val="0"/>
+              </a:spcAft>
+            </a:pPr>
+            <a:r>
+              <a:rPr sz="2000" b="0">
+                <a:solidFill>
+                  <a:srgbClr val="252B33"/>
+                </a:solidFill>
+                <a:latin typeface="Arial"/>
+              </a:rPr>
+              <a:t>One baseline and isolated branches; tests, SonarQube, ZAP, and JMeter judge the changes.</a:t>
+            </a:r>
+          </a:p>
+        </p:txBody>
+      </p:sp>
+      <p:sp>
+        <p:nvSpPr>
+          <p:cNvPr id="21" name="Rounded Rectangle 20"/>
+          <p:cNvSpPr/>
+          <p:nvPr/>
+        </p:nvSpPr>
+        <p:spPr>
+          <a:xfrm>
+            <a:off x="768096" y="5376672"/>
+            <a:ext cx="10643616" cy="685800"/>
           </a:xfrm>
           <a:prstGeom prst="roundRect">
             <a:avLst/>
@@ -39272,14 +39870,14 @@
       </p:sp>
       <p:sp>
         <p:nvSpPr>
-          <p:cNvPr id="14" name="TextBox 13"/>
+          <p:cNvPr id="22" name="TextBox 21"/>
           <p:cNvSpPr txBox="1"/>
           <p:nvPr/>
         </p:nvSpPr>
         <p:spPr>
           <a:xfrm>
-            <a:off x="4946904" y="1700784"/>
-            <a:ext cx="6245352" cy="384048"/>
+            <a:off x="969264" y="5522976"/>
+            <a:ext cx="10241280" cy="384048"/>
           </a:xfrm>
           <a:prstGeom prst="rect">
             <a:avLst/>
@@ -39301,438 +39899,13 @@
               </a:spcAft>
             </a:pPr>
             <a:r>
-              <a:rPr sz="2200" b="1">
+              <a:rPr sz="1800" b="1">
                 <a:solidFill>
                   <a:srgbClr val="0F676D"/>
                 </a:solidFill>
                 <a:latin typeface="Arial"/>
               </a:rPr>
-              <a:t>Endpoint groups exercised</a:t>
-            </a:r>
-          </a:p>
-        </p:txBody>
-      </p:sp>
-      <p:sp>
-        <p:nvSpPr>
-          <p:cNvPr id="15" name="Rounded Rectangle 14"/>
-          <p:cNvSpPr/>
-          <p:nvPr/>
-        </p:nvSpPr>
-        <p:spPr>
-          <a:xfrm>
-            <a:off x="4956048" y="2377440"/>
-            <a:ext cx="109728" cy="109728"/>
-          </a:xfrm>
-          <a:prstGeom prst="roundRect">
-            <a:avLst/>
-          </a:prstGeom>
-          <a:solidFill>
-            <a:srgbClr val="0F676D"/>
-          </a:solidFill>
-          <a:ln>
-            <a:noFill/>
-          </a:ln>
-        </p:spPr>
-        <p:style>
-          <a:lnRef idx="1">
-            <a:schemeClr val="accent1"/>
-          </a:lnRef>
-          <a:fillRef idx="3">
-            <a:schemeClr val="accent1"/>
-          </a:fillRef>
-          <a:effectRef idx="2">
-            <a:schemeClr val="accent1"/>
-          </a:effectRef>
-          <a:fontRef idx="minor">
-            <a:schemeClr val="lt1"/>
-          </a:fontRef>
-        </p:style>
-        <p:txBody>
-          <a:bodyPr rtlCol="0" anchor="ctr"/>
-          <a:lstStyle/>
-          <a:p>
-            <a:pPr algn="ctr"/>
-          </a:p>
-        </p:txBody>
-      </p:sp>
-      <p:sp>
-        <p:nvSpPr>
-          <p:cNvPr id="16" name="TextBox 15"/>
-          <p:cNvSpPr txBox="1"/>
-          <p:nvPr/>
-        </p:nvSpPr>
-        <p:spPr>
-          <a:xfrm>
-            <a:off x="5212080" y="2267712"/>
-            <a:ext cx="5824728" cy="621792"/>
-          </a:xfrm>
-          <a:prstGeom prst="rect">
-            <a:avLst/>
-          </a:prstGeom>
-          <a:noFill/>
-        </p:spPr>
-        <p:txBody>
-          <a:bodyPr wrap="square" lIns="18288" rIns="18288" tIns="18288" bIns="18288" anchor="ctr">
-            <a:spAutoFit/>
-          </a:bodyPr>
-          <a:lstStyle/>
-          <a:p>
-            <a:pPr algn="l">
-              <a:spcBef>
-                <a:spcPts val="0"/>
-              </a:spcBef>
-              <a:spcAft>
-                <a:spcPts val="0"/>
-              </a:spcAft>
-            </a:pPr>
-            <a:r>
-              <a:rPr sz="2000" b="0">
-                <a:solidFill>
-                  <a:srgbClr val="252B33"/>
-                </a:solidFill>
-                <a:latin typeface="Arial"/>
-              </a:rPr>
-              <a:t>Authentication and users</a:t>
-            </a:r>
-          </a:p>
-        </p:txBody>
-      </p:sp>
-      <p:sp>
-        <p:nvSpPr>
-          <p:cNvPr id="17" name="Rounded Rectangle 16"/>
-          <p:cNvSpPr/>
-          <p:nvPr/>
-        </p:nvSpPr>
-        <p:spPr>
-          <a:xfrm>
-            <a:off x="4956048" y="3017520"/>
-            <a:ext cx="109728" cy="109728"/>
-          </a:xfrm>
-          <a:prstGeom prst="roundRect">
-            <a:avLst/>
-          </a:prstGeom>
-          <a:solidFill>
-            <a:srgbClr val="0F676D"/>
-          </a:solidFill>
-          <a:ln>
-            <a:noFill/>
-          </a:ln>
-        </p:spPr>
-        <p:style>
-          <a:lnRef idx="1">
-            <a:schemeClr val="accent1"/>
-          </a:lnRef>
-          <a:fillRef idx="3">
-            <a:schemeClr val="accent1"/>
-          </a:fillRef>
-          <a:effectRef idx="2">
-            <a:schemeClr val="accent1"/>
-          </a:effectRef>
-          <a:fontRef idx="minor">
-            <a:schemeClr val="lt1"/>
-          </a:fontRef>
-        </p:style>
-        <p:txBody>
-          <a:bodyPr rtlCol="0" anchor="ctr"/>
-          <a:lstStyle/>
-          <a:p>
-            <a:pPr algn="ctr"/>
-          </a:p>
-        </p:txBody>
-      </p:sp>
-      <p:sp>
-        <p:nvSpPr>
-          <p:cNvPr id="18" name="TextBox 17"/>
-          <p:cNvSpPr txBox="1"/>
-          <p:nvPr/>
-        </p:nvSpPr>
-        <p:spPr>
-          <a:xfrm>
-            <a:off x="5212080" y="2907791"/>
-            <a:ext cx="5824728" cy="621792"/>
-          </a:xfrm>
-          <a:prstGeom prst="rect">
-            <a:avLst/>
-          </a:prstGeom>
-          <a:noFill/>
-        </p:spPr>
-        <p:txBody>
-          <a:bodyPr wrap="square" lIns="18288" rIns="18288" tIns="18288" bIns="18288" anchor="ctr">
-            <a:spAutoFit/>
-          </a:bodyPr>
-          <a:lstStyle/>
-          <a:p>
-            <a:pPr algn="l">
-              <a:spcBef>
-                <a:spcPts val="0"/>
-              </a:spcBef>
-              <a:spcAft>
-                <a:spcPts val="0"/>
-              </a:spcAft>
-            </a:pPr>
-            <a:r>
-              <a:rPr sz="2000" b="0">
-                <a:solidFill>
-                  <a:srgbClr val="252B33"/>
-                </a:solidFill>
-                <a:latin typeface="Arial"/>
-              </a:rPr>
-              <a:t>Accounts and periods</a:t>
-            </a:r>
-          </a:p>
-        </p:txBody>
-      </p:sp>
-      <p:sp>
-        <p:nvSpPr>
-          <p:cNvPr id="19" name="Rounded Rectangle 18"/>
-          <p:cNvSpPr/>
-          <p:nvPr/>
-        </p:nvSpPr>
-        <p:spPr>
-          <a:xfrm>
-            <a:off x="4956048" y="3657600"/>
-            <a:ext cx="109728" cy="109728"/>
-          </a:xfrm>
-          <a:prstGeom prst="roundRect">
-            <a:avLst/>
-          </a:prstGeom>
-          <a:solidFill>
-            <a:srgbClr val="0F676D"/>
-          </a:solidFill>
-          <a:ln>
-            <a:noFill/>
-          </a:ln>
-        </p:spPr>
-        <p:style>
-          <a:lnRef idx="1">
-            <a:schemeClr val="accent1"/>
-          </a:lnRef>
-          <a:fillRef idx="3">
-            <a:schemeClr val="accent1"/>
-          </a:fillRef>
-          <a:effectRef idx="2">
-            <a:schemeClr val="accent1"/>
-          </a:effectRef>
-          <a:fontRef idx="minor">
-            <a:schemeClr val="lt1"/>
-          </a:fontRef>
-        </p:style>
-        <p:txBody>
-          <a:bodyPr rtlCol="0" anchor="ctr"/>
-          <a:lstStyle/>
-          <a:p>
-            <a:pPr algn="ctr"/>
-          </a:p>
-        </p:txBody>
-      </p:sp>
-      <p:sp>
-        <p:nvSpPr>
-          <p:cNvPr id="20" name="TextBox 19"/>
-          <p:cNvSpPr txBox="1"/>
-          <p:nvPr/>
-        </p:nvSpPr>
-        <p:spPr>
-          <a:xfrm>
-            <a:off x="5212080" y="3547872"/>
-            <a:ext cx="5824728" cy="621792"/>
-          </a:xfrm>
-          <a:prstGeom prst="rect">
-            <a:avLst/>
-          </a:prstGeom>
-          <a:noFill/>
-        </p:spPr>
-        <p:txBody>
-          <a:bodyPr wrap="square" lIns="18288" rIns="18288" tIns="18288" bIns="18288" anchor="ctr">
-            <a:spAutoFit/>
-          </a:bodyPr>
-          <a:lstStyle/>
-          <a:p>
-            <a:pPr algn="l">
-              <a:spcBef>
-                <a:spcPts val="0"/>
-              </a:spcBef>
-              <a:spcAft>
-                <a:spcPts val="0"/>
-              </a:spcAft>
-            </a:pPr>
-            <a:r>
-              <a:rPr sz="2000" b="0">
-                <a:solidFill>
-                  <a:srgbClr val="252B33"/>
-                </a:solidFill>
-                <a:latin typeface="Arial"/>
-              </a:rPr>
-              <a:t>Journal entries and bulk posting</a:t>
-            </a:r>
-          </a:p>
-        </p:txBody>
-      </p:sp>
-      <p:sp>
-        <p:nvSpPr>
-          <p:cNvPr id="21" name="Rounded Rectangle 20"/>
-          <p:cNvSpPr/>
-          <p:nvPr/>
-        </p:nvSpPr>
-        <p:spPr>
-          <a:xfrm>
-            <a:off x="4956048" y="4297680"/>
-            <a:ext cx="109728" cy="109728"/>
-          </a:xfrm>
-          <a:prstGeom prst="roundRect">
-            <a:avLst/>
-          </a:prstGeom>
-          <a:solidFill>
-            <a:srgbClr val="0F676D"/>
-          </a:solidFill>
-          <a:ln>
-            <a:noFill/>
-          </a:ln>
-        </p:spPr>
-        <p:style>
-          <a:lnRef idx="1">
-            <a:schemeClr val="accent1"/>
-          </a:lnRef>
-          <a:fillRef idx="3">
-            <a:schemeClr val="accent1"/>
-          </a:fillRef>
-          <a:effectRef idx="2">
-            <a:schemeClr val="accent1"/>
-          </a:effectRef>
-          <a:fontRef idx="minor">
-            <a:schemeClr val="lt1"/>
-          </a:fontRef>
-        </p:style>
-        <p:txBody>
-          <a:bodyPr rtlCol="0" anchor="ctr"/>
-          <a:lstStyle/>
-          <a:p>
-            <a:pPr algn="ctr"/>
-          </a:p>
-        </p:txBody>
-      </p:sp>
-      <p:sp>
-        <p:nvSpPr>
-          <p:cNvPr id="22" name="TextBox 21"/>
-          <p:cNvSpPr txBox="1"/>
-          <p:nvPr/>
-        </p:nvSpPr>
-        <p:spPr>
-          <a:xfrm>
-            <a:off x="5212080" y="4187952"/>
-            <a:ext cx="5824728" cy="621792"/>
-          </a:xfrm>
-          <a:prstGeom prst="rect">
-            <a:avLst/>
-          </a:prstGeom>
-          <a:noFill/>
-        </p:spPr>
-        <p:txBody>
-          <a:bodyPr wrap="square" lIns="18288" rIns="18288" tIns="18288" bIns="18288" anchor="ctr">
-            <a:spAutoFit/>
-          </a:bodyPr>
-          <a:lstStyle/>
-          <a:p>
-            <a:pPr algn="l">
-              <a:spcBef>
-                <a:spcPts val="0"/>
-              </a:spcBef>
-              <a:spcAft>
-                <a:spcPts val="0"/>
-              </a:spcAft>
-            </a:pPr>
-            <a:r>
-              <a:rPr sz="2000" b="0">
-                <a:solidFill>
-                  <a:srgbClr val="252B33"/>
-                </a:solidFill>
-                <a:latin typeface="Arial"/>
-              </a:rPr>
-              <a:t>Financial reports</a:t>
-            </a:r>
-          </a:p>
-        </p:txBody>
-      </p:sp>
-      <p:sp>
-        <p:nvSpPr>
-          <p:cNvPr id="23" name="Rounded Rectangle 22"/>
-          <p:cNvSpPr/>
-          <p:nvPr/>
-        </p:nvSpPr>
-        <p:spPr>
-          <a:xfrm>
-            <a:off x="4956048" y="4937759"/>
-            <a:ext cx="109728" cy="109728"/>
-          </a:xfrm>
-          <a:prstGeom prst="roundRect">
-            <a:avLst/>
-          </a:prstGeom>
-          <a:solidFill>
-            <a:srgbClr val="0F676D"/>
-          </a:solidFill>
-          <a:ln>
-            <a:noFill/>
-          </a:ln>
-        </p:spPr>
-        <p:style>
-          <a:lnRef idx="1">
-            <a:schemeClr val="accent1"/>
-          </a:lnRef>
-          <a:fillRef idx="3">
-            <a:schemeClr val="accent1"/>
-          </a:fillRef>
-          <a:effectRef idx="2">
-            <a:schemeClr val="accent1"/>
-          </a:effectRef>
-          <a:fontRef idx="minor">
-            <a:schemeClr val="lt1"/>
-          </a:fontRef>
-        </p:style>
-        <p:txBody>
-          <a:bodyPr rtlCol="0" anchor="ctr"/>
-          <a:lstStyle/>
-          <a:p>
-            <a:pPr algn="ctr"/>
-          </a:p>
-        </p:txBody>
-      </p:sp>
-      <p:sp>
-        <p:nvSpPr>
-          <p:cNvPr id="24" name="TextBox 23"/>
-          <p:cNvSpPr txBox="1"/>
-          <p:nvPr/>
-        </p:nvSpPr>
-        <p:spPr>
-          <a:xfrm>
-            <a:off x="5212080" y="4828031"/>
-            <a:ext cx="5824728" cy="621792"/>
-          </a:xfrm>
-          <a:prstGeom prst="rect">
-            <a:avLst/>
-          </a:prstGeom>
-          <a:noFill/>
-        </p:spPr>
-        <p:txBody>
-          <a:bodyPr wrap="square" lIns="18288" rIns="18288" tIns="18288" bIns="18288" anchor="ctr">
-            <a:spAutoFit/>
-          </a:bodyPr>
-          <a:lstStyle/>
-          <a:p>
-            <a:pPr algn="l">
-              <a:spcBef>
-                <a:spcPts val="0"/>
-              </a:spcBef>
-              <a:spcAft>
-                <a:spcPts val="0"/>
-              </a:spcAft>
-            </a:pPr>
-            <a:r>
-              <a:rPr sz="2000" b="0">
-                <a:solidFill>
-                  <a:srgbClr val="252B33"/>
-                </a:solidFill>
-                <a:latin typeface="Arial"/>
-              </a:rPr>
-              <a:t>Audit logs</a:t>
+              <a:t>Contribution: evidence-backed AI-assisted remediation—not a new algorithm, matrix, or model comparison.</a:t>
             </a:r>
           </a:p>
         </p:txBody>

</xml_diff>

<commit_message>
docs: justify ChatGPT as a single case without exclusivity claim
</commit_message>
<xml_diff>
--- a/Document/outputs/final-defense/G6519692_Zaw_Ye_Htut_Ko_Final_Thesis_Defense.pptx
+++ b/Document/outputs/final-defense/G6519692_Zaw_Ye_Htut_Ko_Final_Thesis_Defense.pptx
@@ -4449,13 +4449,13 @@
           </a:p>
           <a:p>
             <a:r>
-              <a:t>This is applied research: I study one existing financial accounting API and ask what happens when ChatGPT helps me address measured problems. I am not inventing a new algorithm or a scoring matrix. Why ChatGPT? It is the one assistant named in my research question, and through Codex 5.4 I can give it an actual scanner finding plus repository code and ask for a candidate change. I keep that one assistant fixed so I can examine this workflow in depth; I am not comparing AI assistants or claiming ChatGPT is the best one. I review the proposed edits, while tests and the three independent tools decide the outcomes.</a:t>
+              <a:t>This is applied research: I study one existing financial accounting API and ask what happens when ChatGPT helps me address measured problems. I am not inventing a new algorithm or a scoring matrix. Why ChatGPT rather than Claude or Copilot? ChatGPT is widely used and recognizable, making it a relevant case to examine. Claude and Copilot can also analyze code and suggest changes. I used ChatGPT through Codex 5.4 and held that one assistant fixed so I could trace findings, suggestions, my review, and independent results in depth. I am not comparing AI assistants, and I cannot claim ChatGPT is better or uniquely capable. I also would not call it the first AI coding tool. I review the proposed edits; tests and the three independent tools judge the outcomes.</a:t>
             </a:r>
           </a:p>
           <a:p/>
           <a:p>
             <a:r>
-              <a:t>SOURCE: Current report §§1.6 and 3.1-3.3, Table 3.3 and §3.6.</a:t>
+              <a:t>SOURCE: Current report §§1.6 and 3.1-3.3, Table 3.3 and §3.6; OpenAI adoption study: https://openai.com/business/guides-and-resources/chatgpt-usage-and-adoption-patterns-at-work/ ; Claude Code overview: https://code.claude.com/docs/en/overview ; GitHub Copilot GA: https://github.blog/news-insights/product-news/github-copilot-is-generally-available-to-all-developers/ .</a:t>
             </a:r>
           </a:p>
         </p:txBody>
@@ -39263,7 +39263,7 @@
                 </a:solidFill>
                 <a:latin typeface="Arial"/>
               </a:rPr>
-              <a:t>Current report §§1.6 and 3.1-3.3; Table 3.3</a:t>
+              <a:t>Current report §§1.6 and 3.1-3.3; OpenAI adoption study</a:t>
             </a:r>
           </a:p>
         </p:txBody>
@@ -39647,7 +39647,7 @@
                 </a:solidFill>
                 <a:latin typeface="Arial"/>
               </a:rPr>
-              <a:t>Chosen for this case because Codex 5.4 can use scanner findings and source context to propose traceable code edits.</a:t>
+              <a:t>ChatGPT is widely used and recognizable. It is one case to study deeply—not uniquely capable of coding fixes.</a:t>
             </a:r>
           </a:p>
         </p:txBody>

</xml_diff>

<commit_message>
docs: lead defense with research question and focused Sonar outcome
</commit_message>
<xml_diff>
--- a/Document/outputs/final-defense/G6519692_Zaw_Ye_Htut_Ko_Final_Thesis_Defense.pptx
+++ b/Document/outputs/final-defense/G6519692_Zaw_Ye_Htut_Ko_Final_Thesis_Defense.pptx
@@ -550,7 +550,7 @@
           </a:p>
           <a:p>
             <a:r>
-              <a:t>KEY MESSAGE: This is an evidence-based evaluation of Codex 5.4 as an advisor.</a:t>
+              <a:t>KEY MESSAGE: This is an evidence-based evaluation of ChatGPT as an advisor.</a:t>
             </a:r>
           </a:p>
           <a:p>
@@ -571,7 +571,7 @@
           </a:p>
           <a:p>
             <a:r>
-              <a:t>Good morning. I evaluate whether ChatGPT, used through Codex 5.4, can help improve an existing financial accounting API. The model suggests changes; I review and apply selected ones; SonarQube, OWASP ZAP, and JMeter show what the measured results support.</a:t>
+              <a:t>Good morning. I evaluate whether ChatGPT can help improve an existing financial accounting API. The assistant suggests changes; I review and apply selected ones; SonarQube, OWASP ZAP, and JMeter show what the measured results support.</a:t>
             </a:r>
           </a:p>
           <a:p/>
@@ -775,7 +775,7 @@
           </a:p>
           <a:p>
             <a:r>
-              <a:t>Read this diagram from left to right. On the left, I start with a real tool finding and the source code needed to understand it. For example, SonarQube flagged eight controller parameters. In the middle, Codex proposes a change, but it does not decide whether that change is correct. I reviewed the request DTO for accounting behavior and access control before using it. On the right, I run focused tests and rerun the same tool on the changed branch. I compare that result with the saved baseline and the study target. SonarQube's unique issue count went from 17 to zero; JMeter did not meet its main speed target. The arrows represent checks, not automatic acceptance of an AI suggestion.</a:t>
+              <a:t>Read this diagram from left to right. On the left, I start with a real tool finding and the source code needed to understand it. For example, SonarQube flagged eight controller parameters. In the middle, ChatGPT proposes a change, but it does not decide whether that change is correct. I reviewed the request DTO for accounting behavior and access control before using it. On the right, I run focused tests and rerun the same tool on the changed branch. I compare that result with the saved baseline and the study target. SonarQube's unique issue count went from 17 to zero; JMeter did not meet its main speed target. The arrows represent checks, not automatic acceptance of an AI suggestion.</a:t>
             </a:r>
           </a:p>
           <a:p/>
@@ -953,12 +953,12 @@
           <a:lstStyle/>
           <a:p>
             <a:r>
-              <a:t>TIMING: 100 seconds</a:t>
-            </a:r>
-          </a:p>
-          <a:p>
-            <a:r>
-              <a:t>KEY MESSAGE: The zeros and the small coverage decrease have different meanings.</a:t>
+              <a:t>TIMING: 85 seconds</a:t>
+            </a:r>
+          </a:p>
+          <a:p>
+            <a:r>
+              <a:t>KEY MESSAGE: The targeted 17 findings were resolved; other metrics are controls, not improvements.</a:t>
             </a:r>
           </a:p>
           <a:p>
@@ -979,18 +979,18 @@
           </a:p>
           <a:p>
             <a:r>
-              <a:t>SonarQube reported 17 unique baseline issues and zero after the changes. Why do Bugs and Vulnerabilities show zero even at baseline? In the legacy issue-type field, all 17 were classified as code smells. SonarQube's newer impact labels also marked some of those same issues as Reliability or Security concerns. Those labels overlap; they are not additional unique bugs or vulnerabilities. Duplicated-line density was 0.0 percent in both scans: the tool did not report duplicated lines at its displayed precision in this analyzed scope. It does not prove the whole codebase has no repeated logic. Coverage moved from 74.4 to 74.3 percent, a decrease of 0.1 percentage point. The saved summaries give the percentages but not the underlying covered and uncovered counts, so I cannot identify the exact cause. Cyclomatic complexity roughly counts decision paths through code; it rose from 886 to 889. I report both changes as small regressions. The Quality Gate said OK on both branches but its saved conditions list was empty, so the issue count is the clearer comparison.</a:t>
+              <a:t>The main result is 17 distinct SonarQube issues in the baseline and zero after the reviewed fixes. In the legacy issue-type field, all 17 were classified as code smells. I ran tests and repeated the scan on the isolated code-quality branch. The right-hand metrics are controls, not gains: coverage stayed close to baseline at 74.4 versus 74.3 percent; legacy Bugs and Vulnerabilities stayed at zero; duplicated-line density stayed at 0.0 percent; the Quality Gate stayed OK; and complexity rose slightly from 886 to 889. This supports targeted maintainability remediation with adjacent measures monitored. I do not claim the zero Bug or Vulnerability count proves the running API is secure—that is why I test security separately with ZAP. Cyclomatic complexity roughly counts decision paths through code. If asked why newer Reliability and Security impacts appeared, those labels overlap on the same legacy code-smell issues. The saved coverage summary lacks the underlying counts, so I cannot identify the exact cause of the 0.1 percentage-point change.</a:t>
             </a:r>
           </a:p>
           <a:p/>
           <a:p>
             <a:r>
-              <a:t>SOURCE: Next slides 14-15; backup slides 29 and 35-36; SonarQube quality-gate.json and summary.json; current report Table 4.2, Appendices E and L.</a:t>
-            </a:r>
-          </a:p>
-          <a:p>
-            <a:r>
-              <a:t>CAUTION: The full report lists OK/OK; explain that the captured gate response has an empty conditions list.</a:t>
+              <a:t>SOURCE: Next slides 14-15; backup slides 29 and 35-36; SonarQube issues.json, measures.json and quality-gate.json; current report Table 4.2, Appendices E and L.</a:t>
+            </a:r>
+          </a:p>
+          <a:p>
+            <a:r>
+              <a:t>CAUTION: Do not call the baseline zeros an improvement or treat Quality Gate OK/OK as evidence of issue closure; its captured condition list is empty.</a:t>
             </a:r>
           </a:p>
         </p:txBody>
@@ -1065,7 +1065,7 @@
           </a:p>
           <a:p>
             <a:r>
-              <a:t>KEY MESSAGE: Both dashboards say OK, but the issue count is the useful comparison.</a:t>
+              <a:t>KEY MESSAGE: The saved dashboard views corroborate the issue-count change.</a:t>
             </a:r>
           </a:p>
           <a:p>
@@ -1086,13 +1086,18 @@
           </a:p>
           <a:p>
             <a:r>
-              <a:t>If asked why both Quality Gates passed, point out that the saved gate files show OK with an empty list of conditions on each branch. That status therefore did not distinguish the scans. The baseline had 17 distinct issues; the changed branch had zero. Coverage moved from 74.4 to 74.3 percent, so I show that small decrease too. These are screenshots of the tool, not a new chart I made.</a:t>
+              <a:t>I now point to the two actual SonarQube dashboard captures. The baseline scan reports 17 unique issues; the code-quality branch reports zero. The Quality Gate reads OK in both, so I use the issue count—not a change in gate status—as the evidence of remediation. Slide 15 shows representative source-code changes behind this result, and Appendix L has larger dashboard views.</a:t>
             </a:r>
           </a:p>
           <a:p/>
           <a:p>
             <a:r>
-              <a:t>SOURCE: Next slide 15; backup slides 29 and 35-36; Appendix L Figures L.1-L.4; sonar/baseline and remediation quality-gate.json.</a:t>
+              <a:t>SOURCE: Next slide 15; backup slides 29 and 35-36; Appendix L Figures L.1-L.4; sonar/baseline and remediation issues.json and quality-gate.json.</a:t>
+            </a:r>
+          </a:p>
+          <a:p>
+            <a:r>
+              <a:t>CAUTION: The saved Quality Gate responses contain no conditions; do not describe this as a failed-to-passed gate.</a:t>
             </a:r>
           </a:p>
         </p:txBody>
@@ -1677,22 +1682,22 @@
           <a:lstStyle/>
           <a:p>
             <a:r>
-              <a:t>TIMING: 60 seconds</a:t>
-            </a:r>
-          </a:p>
-          <a:p>
-            <a:r>
-              <a:t>KEY MESSAGE: The results are mixed: code quality improved, security has one remaining alert, and core speed missed its target.</a:t>
-            </a:r>
-          </a:p>
-          <a:p>
-            <a:r>
-              <a:t>SHOW IF ASKED: backup slides 29-31 (three measured outcomes)</a:t>
-            </a:r>
-          </a:p>
-          <a:p>
-            <a:r>
-              <a:t>APPENDIX: Appendices E-G and M</a:t>
+              <a:t>TIMING: 55 seconds</a:t>
+            </a:r>
+          </a:p>
+          <a:p>
+            <a:r>
+              <a:t>KEY MESSAGE: The opening question is whether reviewed AI advice withstands measurement.</a:t>
+            </a:r>
+          </a:p>
+          <a:p>
+            <a:r>
+              <a:t>SHOW IF ASKED: next slides 3-7 (problem and method)</a:t>
+            </a:r>
+          </a:p>
+          <a:p>
+            <a:r>
+              <a:t>APPENDIX: Appendices A and M</a:t>
             </a:r>
           </a:p>
           <a:p/>
@@ -1703,18 +1708,13 @@
           </a:p>
           <a:p>
             <a:r>
-              <a:t>Here is the result first. SonarQube issues fell from 17 to zero. ZAP's selected checks passed, but the API scan still had one Medium alert because the local site used HTTP. JMeter response times at 100 and 500 simulated users were above our study limits. Soak and spike improved, but they are separate tests.</a:t>
+              <a:t>Before I show any result, I want to define the question. ChatGPT can suggest a code change that looks reasonable, but that does not mean the accounting API is better. I use one existing API, review each candidate change myself, run functional tests, and compare independent tool measurements with a saved baseline. I will explain the problem and the method first, then let the results answer whether the suggestions helped.</a:t>
             </a:r>
           </a:p>
           <a:p/>
           <a:p>
             <a:r>
-              <a:t>SOURCE: Current report Table 4.5 and Appendix M.</a:t>
-            </a:r>
-          </a:p>
-          <a:p>
-            <a:r>
-              <a:t>CAUTION: Do not claim that the 50, 100, or 500 VU core p95 values improved; all three increased.</a:t>
+              <a:t>SOURCE: Current report §§1.1-1.5 and Chapter 3; next slides 3-7; Appendices A and M.</a:t>
             </a:r>
           </a:p>
         </p:txBody>
@@ -2427,7 +2427,7 @@
           </a:p>
           <a:p>
             <a:r>
-              <a:t>This was an applied case study, not a new algorithm, scoring matrix, or comparison of AI assistants. Codex helped me propose code changes. I reviewed them, and the original tools measured the results. Code warnings reached zero and selected security checks passed, but the main performance target was not met. My contribution is the traceable process and this honest mixed result, not a claim that ChatGPT always improves an API. Thank you; I welcome questions.</a:t>
+              <a:t>This was an applied case study, not a new algorithm, scoring matrix, or comparison of AI assistants. ChatGPT helped me propose code changes. I reviewed them, and the original tools measured the results. Code warnings reached zero and selected security checks passed, but the main performance target was not met. My contribution is the traceable process and this honest mixed result, not a claim that ChatGPT always improves an API. Thank you; I welcome questions.</a:t>
             </a:r>
           </a:p>
           <a:p/>
@@ -3862,7 +3862,7 @@
           </a:p>
           <a:p>
             <a:r>
-              <a:t>First, did the code warnings decrease, and did coverage or complexity get worse? Second, did security alerts decrease, and what remained? Third, did the API stay within the response-time limits at the three user counts? I answer each question with the tool's before-and-after result, not with an AI opinion.</a:t>
+              <a:t>First, did the code warnings decrease, and did coverage or complexity get worse? Second, did security alerts decrease, and what remained? Third, did the API stay within the response-time limits at the three different user counts? I answer each question with the tool's before-and-after result, not with an AI opinion.</a:t>
             </a:r>
           </a:p>
           <a:p/>
@@ -4449,7 +4449,7 @@
           </a:p>
           <a:p>
             <a:r>
-              <a:t>This is applied research: I study one existing financial accounting API and ask what happens when ChatGPT helps me address measured problems. I am not inventing a new algorithm or a scoring matrix. Why ChatGPT rather than Claude or Copilot? ChatGPT is widely used and recognizable, making it a relevant case to examine. Claude and Copilot can also analyze code and suggest changes. I used ChatGPT through Codex 5.4 and held that one assistant fixed so I could trace findings, suggestions, my review, and independent results in depth. I am not comparing AI assistants, and I cannot claim ChatGPT is better or uniquely capable. I also would not call it the first AI coding tool. I review the proposed edits; tests and the three independent tools judge the outcomes.</a:t>
+              <a:t>This is applied research: I study one existing financial accounting API and ask what happens when ChatGPT helps me address measured problems. I am not inventing a new algorithm or a scoring matrix. Why ChatGPT rather than Claude or Copilot? ChatGPT is widely used and recognizable, making it a relevant case to examine. Claude and Copilot can also analyze code and suggest changes. I held ChatGPT fixed as the one assistant so I could trace findings, suggestions, my review, and independent results in depth. I am not comparing AI assistants, and I cannot claim ChatGPT is better or uniquely capable. I also would not call it the first AI coding tool. I review the proposed edits; tests and the three independent tools judge the outcomes.</a:t>
             </a:r>
           </a:p>
           <a:p/>
@@ -4653,7 +4653,7 @@
           </a:p>
           <a:p>
             <a:r>
-              <a:t>First I saved the baseline result. Next I gave Codex a specific tool warning and the relevant code. Then I reviewed the suggested edit, ran tests, and ran the same tool again. Finally I compared the new number with the baseline and the study rule. A patch that looks good is not automatically a success.</a:t>
+              <a:t>First I saved the baseline result. Next I gave ChatGPT a specific tool warning and the relevant code. Then I reviewed the suggested edit, ran tests, and ran the same tool again. Finally I compared the new number with the baseline and the study rule. A patch that looks good is not automatically a success.</a:t>
             </a:r>
           </a:p>
           <a:p/>
@@ -9770,7 +9770,7 @@
                 </a:solidFill>
                 <a:latin typeface="Arial"/>
               </a:rPr>
-              <a:t>Codex suggests; I decide.</a:t>
+              <a:t>ChatGPT suggests; I decide.</a:t>
             </a:r>
           </a:p>
         </p:txBody>
@@ -11142,7 +11142,7 @@
                 </a:solidFill>
                 <a:latin typeface="Arial"/>
               </a:rPr>
-              <a:t>SonarQube closed all 17 fresh issues</a:t>
+              <a:t>SonarQube: 17 findings closed</a:t>
             </a:r>
           </a:p>
         </p:txBody>
@@ -11309,8 +11309,8 @@
         </p:nvSpPr>
         <p:spPr>
           <a:xfrm>
-            <a:off x="731520" y="1371600"/>
-            <a:ext cx="3438144" cy="1115568"/>
+            <a:off x="731520" y="1417320"/>
+            <a:ext cx="5001768" cy="4251960"/>
           </a:xfrm>
           <a:prstGeom prst="roundRect">
             <a:avLst/>
@@ -11354,8 +11354,8 @@
         </p:nvSpPr>
         <p:spPr>
           <a:xfrm>
-            <a:off x="896112" y="1481328"/>
-            <a:ext cx="3108960" cy="201168"/>
+            <a:off x="1024128" y="1719072"/>
+            <a:ext cx="4416552" cy="292608"/>
           </a:xfrm>
           <a:prstGeom prst="rect">
             <a:avLst/>
@@ -11377,13 +11377,13 @@
               </a:spcAft>
             </a:pPr>
             <a:r>
-              <a:rPr sz="1100" b="1">
+              <a:rPr sz="1600" b="1">
                 <a:solidFill>
-                  <a:srgbClr val="5B6874"/>
+                  <a:srgbClr val="246F46"/>
                 </a:solidFill>
                 <a:latin typeface="Arial"/>
               </a:rPr>
-              <a:t>UNIQUE ISSUES</a:t>
+              <a:t>PRIMARY OUTCOME</a:t>
             </a:r>
           </a:p>
         </p:txBody>
@@ -11396,8 +11396,8 @@
         </p:nvSpPr>
         <p:spPr>
           <a:xfrm>
-            <a:off x="896112" y="1728216"/>
-            <a:ext cx="3108960" cy="411480"/>
+            <a:off x="1005840" y="2212848"/>
+            <a:ext cx="4434840" cy="923544"/>
           </a:xfrm>
           <a:prstGeom prst="rect">
             <a:avLst/>
@@ -11419,7 +11419,7 @@
               </a:spcAft>
             </a:pPr>
             <a:r>
-              <a:rPr sz="2500" b="1">
+              <a:rPr sz="5300" b="1">
                 <a:solidFill>
                   <a:srgbClr val="246F46"/>
                 </a:solidFill>
@@ -11438,8 +11438,8 @@
         </p:nvSpPr>
         <p:spPr>
           <a:xfrm>
-            <a:off x="896112" y="2221992"/>
-            <a:ext cx="3108960" cy="164592"/>
+            <a:off x="1024128" y="3209544"/>
+            <a:ext cx="4361688" cy="420624"/>
           </a:xfrm>
           <a:prstGeom prst="rect">
             <a:avLst/>
@@ -11461,156 +11461,27 @@
               </a:spcAft>
             </a:pPr>
             <a:r>
-              <a:rPr sz="1100" b="0">
-                <a:solidFill>
-                  <a:srgbClr val="5B6874"/>
-                </a:solidFill>
-                <a:latin typeface="Arial"/>
-              </a:rPr>
-              <a:t>Current run</a:t>
-            </a:r>
-          </a:p>
-        </p:txBody>
-      </p:sp>
-      <p:sp>
-        <p:nvSpPr>
-          <p:cNvPr id="13" name="Rounded Rectangle 12"/>
-          <p:cNvSpPr/>
-          <p:nvPr/>
-        </p:nvSpPr>
-        <p:spPr>
-          <a:xfrm>
-            <a:off x="4370832" y="1371600"/>
-            <a:ext cx="3438144" cy="1115568"/>
-          </a:xfrm>
-          <a:prstGeom prst="roundRect">
-            <a:avLst/>
-          </a:prstGeom>
-          <a:solidFill>
-            <a:srgbClr val="E8F7EE"/>
-          </a:solidFill>
-          <a:ln w="12700">
-            <a:solidFill>
-              <a:srgbClr val="D8E0E9"/>
-            </a:solidFill>
-          </a:ln>
-        </p:spPr>
-        <p:style>
-          <a:lnRef idx="1">
-            <a:schemeClr val="accent1"/>
-          </a:lnRef>
-          <a:fillRef idx="3">
-            <a:schemeClr val="accent1"/>
-          </a:fillRef>
-          <a:effectRef idx="2">
-            <a:schemeClr val="accent1"/>
-          </a:effectRef>
-          <a:fontRef idx="minor">
-            <a:schemeClr val="lt1"/>
-          </a:fontRef>
-        </p:style>
-        <p:txBody>
-          <a:bodyPr rtlCol="0" anchor="ctr"/>
-          <a:lstStyle/>
-          <a:p>
-            <a:pPr algn="ctr"/>
-          </a:p>
-        </p:txBody>
-      </p:sp>
-      <p:sp>
-        <p:nvSpPr>
-          <p:cNvPr id="14" name="TextBox 13"/>
-          <p:cNvSpPr txBox="1"/>
-          <p:nvPr/>
-        </p:nvSpPr>
-        <p:spPr>
-          <a:xfrm>
-            <a:off x="4535424" y="1481328"/>
-            <a:ext cx="3108960" cy="201168"/>
-          </a:xfrm>
-          <a:prstGeom prst="rect">
-            <a:avLst/>
-          </a:prstGeom>
-          <a:noFill/>
-        </p:spPr>
-        <p:txBody>
-          <a:bodyPr wrap="square" lIns="18288" rIns="18288" tIns="18288" bIns="18288" anchor="ctr">
-            <a:spAutoFit/>
-          </a:bodyPr>
-          <a:lstStyle/>
-          <a:p>
-            <a:pPr algn="l">
-              <a:spcBef>
-                <a:spcPts val="0"/>
-              </a:spcBef>
-              <a:spcAft>
-                <a:spcPts val="0"/>
-              </a:spcAft>
-            </a:pPr>
-            <a:r>
-              <a:rPr sz="1100" b="1">
-                <a:solidFill>
-                  <a:srgbClr val="5B6874"/>
-                </a:solidFill>
-                <a:latin typeface="Arial"/>
-              </a:rPr>
-              <a:t>QUALITY GATE</a:t>
-            </a:r>
-          </a:p>
-        </p:txBody>
-      </p:sp>
-      <p:sp>
-        <p:nvSpPr>
-          <p:cNvPr id="15" name="TextBox 14"/>
-          <p:cNvSpPr txBox="1"/>
-          <p:nvPr/>
-        </p:nvSpPr>
-        <p:spPr>
-          <a:xfrm>
-            <a:off x="4535424" y="1728216"/>
-            <a:ext cx="3108960" cy="411480"/>
-          </a:xfrm>
-          <a:prstGeom prst="rect">
-            <a:avLst/>
-          </a:prstGeom>
-          <a:noFill/>
-        </p:spPr>
-        <p:txBody>
-          <a:bodyPr wrap="square" lIns="18288" rIns="18288" tIns="18288" bIns="18288" anchor="ctr">
-            <a:spAutoFit/>
-          </a:bodyPr>
-          <a:lstStyle/>
-          <a:p>
-            <a:pPr algn="l">
-              <a:spcBef>
-                <a:spcPts val="0"/>
-              </a:spcBef>
-              <a:spcAft>
-                <a:spcPts val="0"/>
-              </a:spcAft>
-            </a:pPr>
-            <a:r>
-              <a:rPr sz="2500" b="1">
+              <a:rPr sz="2400" b="1">
                 <a:solidFill>
                   <a:srgbClr val="246F46"/>
                 </a:solidFill>
                 <a:latin typeface="Arial"/>
               </a:rPr>
-              <a:t>OK → OK</a:t>
-            </a:r>
-          </a:p>
-        </p:txBody>
-      </p:sp>
-      <p:sp>
-        <p:nvSpPr>
-          <p:cNvPr id="16" name="TextBox 15"/>
+              <a:t>unique SonarQube issues</a:t>
+            </a:r>
+          </a:p>
+        </p:txBody>
+      </p:sp>
+      <p:sp>
+        <p:nvSpPr>
+          <p:cNvPr id="13" name="TextBox 12"/>
           <p:cNvSpPr txBox="1"/>
           <p:nvPr/>
         </p:nvSpPr>
         <p:spPr>
           <a:xfrm>
-            <a:off x="4535424" y="2221992"/>
-            <a:ext cx="3108960" cy="164592"/>
+            <a:off x="1024128" y="3931920"/>
+            <a:ext cx="4325112" cy="621792"/>
           </a:xfrm>
           <a:prstGeom prst="rect">
             <a:avLst/>
@@ -11632,72 +11503,27 @@
               </a:spcAft>
             </a:pPr>
             <a:r>
-              <a:rPr sz="1100" b="0">
+              <a:rPr sz="1900" b="0">
                 <a:solidFill>
-                  <a:srgbClr val="5B6874"/>
+                  <a:srgbClr val="252B33"/>
                 </a:solidFill>
                 <a:latin typeface="Arial"/>
               </a:rPr>
-              <a:t>No gate conditions recorded</a:t>
-            </a:r>
-          </a:p>
-        </p:txBody>
-      </p:sp>
-      <p:sp>
-        <p:nvSpPr>
-          <p:cNvPr id="17" name="Rounded Rectangle 16"/>
-          <p:cNvSpPr/>
-          <p:nvPr/>
-        </p:nvSpPr>
-        <p:spPr>
-          <a:xfrm>
-            <a:off x="8010144" y="1371600"/>
-            <a:ext cx="3438144" cy="1115568"/>
-          </a:xfrm>
-          <a:prstGeom prst="roundRect">
-            <a:avLst/>
-          </a:prstGeom>
-          <a:solidFill>
-            <a:srgbClr val="FFF6E7"/>
-          </a:solidFill>
-          <a:ln w="12700">
-            <a:solidFill>
-              <a:srgbClr val="D8E0E9"/>
-            </a:solidFill>
-          </a:ln>
-        </p:spPr>
-        <p:style>
-          <a:lnRef idx="1">
-            <a:schemeClr val="accent1"/>
-          </a:lnRef>
-          <a:fillRef idx="3">
-            <a:schemeClr val="accent1"/>
-          </a:fillRef>
-          <a:effectRef idx="2">
-            <a:schemeClr val="accent1"/>
-          </a:effectRef>
-          <a:fontRef idx="minor">
-            <a:schemeClr val="lt1"/>
-          </a:fontRef>
-        </p:style>
-        <p:txBody>
-          <a:bodyPr rtlCol="0" anchor="ctr"/>
-          <a:lstStyle/>
-          <a:p>
-            <a:pPr algn="ctr"/>
-          </a:p>
-        </p:txBody>
-      </p:sp>
-      <p:sp>
-        <p:nvSpPr>
-          <p:cNvPr id="18" name="TextBox 17"/>
+              <a:t>All 17 baseline issues were legacy Code Smells.</a:t>
+            </a:r>
+          </a:p>
+        </p:txBody>
+      </p:sp>
+      <p:sp>
+        <p:nvSpPr>
+          <p:cNvPr id="14" name="TextBox 13"/>
           <p:cNvSpPr txBox="1"/>
           <p:nvPr/>
         </p:nvSpPr>
         <p:spPr>
           <a:xfrm>
-            <a:off x="8174736" y="1481328"/>
-            <a:ext cx="3108960" cy="201168"/>
+            <a:off x="1024128" y="4754880"/>
+            <a:ext cx="4325112" cy="685800"/>
           </a:xfrm>
           <a:prstGeom prst="rect">
             <a:avLst/>
@@ -11719,111 +11545,27 @@
               </a:spcAft>
             </a:pPr>
             <a:r>
-              <a:rPr sz="1100" b="1">
+              <a:rPr sz="1800" b="0">
                 <a:solidFill>
-                  <a:srgbClr val="5B6874"/>
+                  <a:srgbClr val="252B33"/>
                 </a:solidFill>
                 <a:latin typeface="Arial"/>
               </a:rPr>
-              <a:t>COVERAGE</a:t>
-            </a:r>
-          </a:p>
-        </p:txBody>
-      </p:sp>
-      <p:sp>
-        <p:nvSpPr>
-          <p:cNvPr id="19" name="TextBox 18"/>
-          <p:cNvSpPr txBox="1"/>
-          <p:nvPr/>
-        </p:nvSpPr>
-        <p:spPr>
-          <a:xfrm>
-            <a:off x="8174736" y="1728216"/>
-            <a:ext cx="3108960" cy="411480"/>
-          </a:xfrm>
-          <a:prstGeom prst="rect">
-            <a:avLst/>
-          </a:prstGeom>
-          <a:noFill/>
-        </p:spPr>
-        <p:txBody>
-          <a:bodyPr wrap="square" lIns="18288" rIns="18288" tIns="18288" bIns="18288" anchor="ctr">
-            <a:spAutoFit/>
-          </a:bodyPr>
-          <a:lstStyle/>
-          <a:p>
-            <a:pPr algn="l">
-              <a:spcBef>
-                <a:spcPts val="0"/>
-              </a:spcBef>
-              <a:spcAft>
-                <a:spcPts val="0"/>
-              </a:spcAft>
-            </a:pPr>
-            <a:r>
-              <a:rPr sz="2500" b="1">
-                <a:solidFill>
-                  <a:srgbClr val="BE7414"/>
-                </a:solidFill>
-                <a:latin typeface="Arial"/>
-              </a:rPr>
-              <a:t>74.4 → 74.3%</a:t>
-            </a:r>
-          </a:p>
-        </p:txBody>
-      </p:sp>
-      <p:sp>
-        <p:nvSpPr>
-          <p:cNvPr id="20" name="TextBox 19"/>
-          <p:cNvSpPr txBox="1"/>
-          <p:nvPr/>
-        </p:nvSpPr>
-        <p:spPr>
-          <a:xfrm>
-            <a:off x="8174736" y="2221992"/>
-            <a:ext cx="3108960" cy="164592"/>
-          </a:xfrm>
-          <a:prstGeom prst="rect">
-            <a:avLst/>
-          </a:prstGeom>
-          <a:noFill/>
-        </p:spPr>
-        <p:txBody>
-          <a:bodyPr wrap="square" lIns="18288" rIns="18288" tIns="18288" bIns="18288" anchor="ctr">
-            <a:spAutoFit/>
-          </a:bodyPr>
-          <a:lstStyle/>
-          <a:p>
-            <a:pPr algn="l">
-              <a:spcBef>
-                <a:spcPts val="0"/>
-              </a:spcBef>
-              <a:spcAft>
-                <a:spcPts val="0"/>
-              </a:spcAft>
-            </a:pPr>
-            <a:r>
-              <a:rPr sz="1100" b="0">
-                <a:solidFill>
-                  <a:srgbClr val="5B6874"/>
-                </a:solidFill>
-                <a:latin typeface="Arial"/>
-              </a:rPr>
-              <a:t>Down 0.1 percentage point</a:t>
-            </a:r>
-          </a:p>
-        </p:txBody>
-      </p:sp>
-      <p:sp>
-        <p:nvSpPr>
-          <p:cNvPr id="21" name="Rounded Rectangle 20"/>
+              <a:t>Example fix: eight controller parameters → one request DTO.</a:t>
+            </a:r>
+          </a:p>
+        </p:txBody>
+      </p:sp>
+      <p:sp>
+        <p:nvSpPr>
+          <p:cNvPr id="15" name="Rounded Rectangle 14"/>
           <p:cNvSpPr/>
           <p:nvPr/>
         </p:nvSpPr>
         <p:spPr>
           <a:xfrm>
-            <a:off x="731520" y="2852928"/>
-            <a:ext cx="3438144" cy="2459736"/>
+            <a:off x="5961888" y="1417320"/>
+            <a:ext cx="5486400" cy="4251960"/>
           </a:xfrm>
           <a:prstGeom prst="roundRect">
             <a:avLst/>
@@ -11861,14 +11603,14 @@
       </p:sp>
       <p:sp>
         <p:nvSpPr>
-          <p:cNvPr id="22" name="TextBox 21"/>
+          <p:cNvPr id="16" name="TextBox 15"/>
           <p:cNvSpPr txBox="1"/>
           <p:nvPr/>
         </p:nvSpPr>
         <p:spPr>
           <a:xfrm>
-            <a:off x="914400" y="3063240"/>
-            <a:ext cx="3054096" cy="630936"/>
+            <a:off x="6236208" y="1719072"/>
+            <a:ext cx="4910328" cy="310896"/>
           </a:xfrm>
           <a:prstGeom prst="rect">
             <a:avLst/>
@@ -11890,27 +11632,27 @@
               </a:spcAft>
             </a:pPr>
             <a:r>
-              <a:rPr sz="1800" b="1">
+              <a:rPr sz="1600" b="1">
                 <a:solidFill>
                   <a:srgbClr val="0F676D"/>
                 </a:solidFill>
                 <a:latin typeface="Arial"/>
               </a:rPr>
-              <a:t>Bugs 0 · Vulnerabilities 0</a:t>
-            </a:r>
-          </a:p>
-        </p:txBody>
-      </p:sp>
-      <p:sp>
-        <p:nvSpPr>
-          <p:cNvPr id="23" name="TextBox 22"/>
+              <a:t>CONTROLS MONITORED</a:t>
+            </a:r>
+          </a:p>
+        </p:txBody>
+      </p:sp>
+      <p:sp>
+        <p:nvSpPr>
+          <p:cNvPr id="17" name="TextBox 16"/>
           <p:cNvSpPr txBox="1"/>
           <p:nvPr/>
         </p:nvSpPr>
         <p:spPr>
           <a:xfrm>
-            <a:off x="914400" y="3794760"/>
-            <a:ext cx="3054096" cy="1271016"/>
+            <a:off x="6236208" y="2212848"/>
+            <a:ext cx="4901184" cy="393192"/>
           </a:xfrm>
           <a:prstGeom prst="rect">
             <a:avLst/>
@@ -11932,34 +11674,31 @@
               </a:spcAft>
             </a:pPr>
             <a:r>
-              <a:rPr sz="1600" b="0">
+              <a:rPr sz="1800" b="0">
                 <a:solidFill>
                   <a:srgbClr val="252B33"/>
                 </a:solidFill>
                 <a:latin typeface="Arial"/>
               </a:rPr>
-              <a:t>All 17 baseline issues were legacy Code Smells. Newer impact labels can still mention Reliability or Security.</a:t>
-            </a:r>
-          </a:p>
-        </p:txBody>
-      </p:sp>
-      <p:sp>
-        <p:nvSpPr>
-          <p:cNvPr id="24" name="Rounded Rectangle 23"/>
-          <p:cNvSpPr/>
-          <p:nvPr/>
-        </p:nvSpPr>
-        <p:spPr>
-          <a:xfrm>
-            <a:off x="4370832" y="2852928"/>
-            <a:ext cx="3438144" cy="2459736"/>
-          </a:xfrm>
-          <a:prstGeom prst="roundRect">
-            <a:avLst/>
-          </a:prstGeom>
-          <a:solidFill>
-            <a:srgbClr val="FFFFFF"/>
-          </a:solidFill>
+              <a:t>Coverage 74.4% → 74.3% (−0.1 pp)</a:t>
+            </a:r>
+          </a:p>
+        </p:txBody>
+      </p:sp>
+      <p:cxnSp>
+        <p:nvCxnSpPr>
+          <p:cNvPr id="18" name="Connector 17"/>
+          <p:cNvCxnSpPr/>
+          <p:nvPr/>
+        </p:nvCxnSpPr>
+        <p:spPr>
+          <a:xfrm>
+            <a:off x="6236208" y="2743200"/>
+            <a:ext cx="4901184" cy="0"/>
+          </a:xfrm>
+          <a:prstGeom prst="line">
+            <a:avLst/>
+          </a:prstGeom>
           <a:ln w="12700">
             <a:solidFill>
               <a:srgbClr val="D8E0E9"/>
@@ -11967,6 +11706,315 @@
           </a:ln>
         </p:spPr>
         <p:style>
+          <a:lnRef idx="2">
+            <a:schemeClr val="accent1"/>
+          </a:lnRef>
+          <a:fillRef idx="0">
+            <a:schemeClr val="accent1"/>
+          </a:fillRef>
+          <a:effectRef idx="1">
+            <a:schemeClr val="accent1"/>
+          </a:effectRef>
+          <a:fontRef idx="minor">
+            <a:schemeClr val="tx1"/>
+          </a:fontRef>
+        </p:style>
+      </p:cxnSp>
+      <p:sp>
+        <p:nvSpPr>
+          <p:cNvPr id="19" name="TextBox 18"/>
+          <p:cNvSpPr txBox="1"/>
+          <p:nvPr/>
+        </p:nvSpPr>
+        <p:spPr>
+          <a:xfrm>
+            <a:off x="6236208" y="2871215"/>
+            <a:ext cx="4901184" cy="393192"/>
+          </a:xfrm>
+          <a:prstGeom prst="rect">
+            <a:avLst/>
+          </a:prstGeom>
+          <a:noFill/>
+        </p:spPr>
+        <p:txBody>
+          <a:bodyPr wrap="square" lIns="18288" rIns="18288" tIns="18288" bIns="18288" anchor="ctr">
+            <a:spAutoFit/>
+          </a:bodyPr>
+          <a:lstStyle/>
+          <a:p>
+            <a:pPr algn="l">
+              <a:spcBef>
+                <a:spcPts val="0"/>
+              </a:spcBef>
+              <a:spcAft>
+                <a:spcPts val="0"/>
+              </a:spcAft>
+            </a:pPr>
+            <a:r>
+              <a:rPr sz="1800" b="0">
+                <a:solidFill>
+                  <a:srgbClr val="252B33"/>
+                </a:solidFill>
+                <a:latin typeface="Arial"/>
+              </a:rPr>
+              <a:t>Bugs / Vulnerabilities 0 / 0 → 0 / 0</a:t>
+            </a:r>
+          </a:p>
+        </p:txBody>
+      </p:sp>
+      <p:cxnSp>
+        <p:nvCxnSpPr>
+          <p:cNvPr id="20" name="Connector 19"/>
+          <p:cNvCxnSpPr/>
+          <p:nvPr/>
+        </p:nvCxnSpPr>
+        <p:spPr>
+          <a:xfrm>
+            <a:off x="6236208" y="3401568"/>
+            <a:ext cx="4901184" cy="0"/>
+          </a:xfrm>
+          <a:prstGeom prst="line">
+            <a:avLst/>
+          </a:prstGeom>
+          <a:ln w="12700">
+            <a:solidFill>
+              <a:srgbClr val="D8E0E9"/>
+            </a:solidFill>
+          </a:ln>
+        </p:spPr>
+        <p:style>
+          <a:lnRef idx="2">
+            <a:schemeClr val="accent1"/>
+          </a:lnRef>
+          <a:fillRef idx="0">
+            <a:schemeClr val="accent1"/>
+          </a:fillRef>
+          <a:effectRef idx="1">
+            <a:schemeClr val="accent1"/>
+          </a:effectRef>
+          <a:fontRef idx="minor">
+            <a:schemeClr val="tx1"/>
+          </a:fontRef>
+        </p:style>
+      </p:cxnSp>
+      <p:sp>
+        <p:nvSpPr>
+          <p:cNvPr id="21" name="TextBox 20"/>
+          <p:cNvSpPr txBox="1"/>
+          <p:nvPr/>
+        </p:nvSpPr>
+        <p:spPr>
+          <a:xfrm>
+            <a:off x="6236208" y="3529584"/>
+            <a:ext cx="4901184" cy="393192"/>
+          </a:xfrm>
+          <a:prstGeom prst="rect">
+            <a:avLst/>
+          </a:prstGeom>
+          <a:noFill/>
+        </p:spPr>
+        <p:txBody>
+          <a:bodyPr wrap="square" lIns="18288" rIns="18288" tIns="18288" bIns="18288" anchor="ctr">
+            <a:spAutoFit/>
+          </a:bodyPr>
+          <a:lstStyle/>
+          <a:p>
+            <a:pPr algn="l">
+              <a:spcBef>
+                <a:spcPts val="0"/>
+              </a:spcBef>
+              <a:spcAft>
+                <a:spcPts val="0"/>
+              </a:spcAft>
+            </a:pPr>
+            <a:r>
+              <a:rPr sz="1800" b="0">
+                <a:solidFill>
+                  <a:srgbClr val="252B33"/>
+                </a:solidFill>
+                <a:latin typeface="Arial"/>
+              </a:rPr>
+              <a:t>Duplicate density 0.0% → 0.0%</a:t>
+            </a:r>
+          </a:p>
+        </p:txBody>
+      </p:sp>
+      <p:cxnSp>
+        <p:nvCxnSpPr>
+          <p:cNvPr id="22" name="Connector 21"/>
+          <p:cNvCxnSpPr/>
+          <p:nvPr/>
+        </p:nvCxnSpPr>
+        <p:spPr>
+          <a:xfrm>
+            <a:off x="6236208" y="4059935"/>
+            <a:ext cx="4901184" cy="0"/>
+          </a:xfrm>
+          <a:prstGeom prst="line">
+            <a:avLst/>
+          </a:prstGeom>
+          <a:ln w="12700">
+            <a:solidFill>
+              <a:srgbClr val="D8E0E9"/>
+            </a:solidFill>
+          </a:ln>
+        </p:spPr>
+        <p:style>
+          <a:lnRef idx="2">
+            <a:schemeClr val="accent1"/>
+          </a:lnRef>
+          <a:fillRef idx="0">
+            <a:schemeClr val="accent1"/>
+          </a:fillRef>
+          <a:effectRef idx="1">
+            <a:schemeClr val="accent1"/>
+          </a:effectRef>
+          <a:fontRef idx="minor">
+            <a:schemeClr val="tx1"/>
+          </a:fontRef>
+        </p:style>
+      </p:cxnSp>
+      <p:sp>
+        <p:nvSpPr>
+          <p:cNvPr id="23" name="TextBox 22"/>
+          <p:cNvSpPr txBox="1"/>
+          <p:nvPr/>
+        </p:nvSpPr>
+        <p:spPr>
+          <a:xfrm>
+            <a:off x="6236208" y="4187952"/>
+            <a:ext cx="4901184" cy="393192"/>
+          </a:xfrm>
+          <a:prstGeom prst="rect">
+            <a:avLst/>
+          </a:prstGeom>
+          <a:noFill/>
+        </p:spPr>
+        <p:txBody>
+          <a:bodyPr wrap="square" lIns="18288" rIns="18288" tIns="18288" bIns="18288" anchor="ctr">
+            <a:spAutoFit/>
+          </a:bodyPr>
+          <a:lstStyle/>
+          <a:p>
+            <a:pPr algn="l">
+              <a:spcBef>
+                <a:spcPts val="0"/>
+              </a:spcBef>
+              <a:spcAft>
+                <a:spcPts val="0"/>
+              </a:spcAft>
+            </a:pPr>
+            <a:r>
+              <a:rPr sz="1800" b="0">
+                <a:solidFill>
+                  <a:srgbClr val="252B33"/>
+                </a:solidFill>
+                <a:latin typeface="Arial"/>
+              </a:rPr>
+              <a:t>Quality Gate OK → OK</a:t>
+            </a:r>
+          </a:p>
+        </p:txBody>
+      </p:sp>
+      <p:cxnSp>
+        <p:nvCxnSpPr>
+          <p:cNvPr id="24" name="Connector 23"/>
+          <p:cNvCxnSpPr/>
+          <p:nvPr/>
+        </p:nvCxnSpPr>
+        <p:spPr>
+          <a:xfrm>
+            <a:off x="6236208" y="4718304"/>
+            <a:ext cx="4901184" cy="0"/>
+          </a:xfrm>
+          <a:prstGeom prst="line">
+            <a:avLst/>
+          </a:prstGeom>
+          <a:ln w="12700">
+            <a:solidFill>
+              <a:srgbClr val="D8E0E9"/>
+            </a:solidFill>
+          </a:ln>
+        </p:spPr>
+        <p:style>
+          <a:lnRef idx="2">
+            <a:schemeClr val="accent1"/>
+          </a:lnRef>
+          <a:fillRef idx="0">
+            <a:schemeClr val="accent1"/>
+          </a:fillRef>
+          <a:effectRef idx="1">
+            <a:schemeClr val="accent1"/>
+          </a:effectRef>
+          <a:fontRef idx="minor">
+            <a:schemeClr val="tx1"/>
+          </a:fontRef>
+        </p:style>
+      </p:cxnSp>
+      <p:sp>
+        <p:nvSpPr>
+          <p:cNvPr id="25" name="TextBox 24"/>
+          <p:cNvSpPr txBox="1"/>
+          <p:nvPr/>
+        </p:nvSpPr>
+        <p:spPr>
+          <a:xfrm>
+            <a:off x="6236208" y="4846320"/>
+            <a:ext cx="4901184" cy="393192"/>
+          </a:xfrm>
+          <a:prstGeom prst="rect">
+            <a:avLst/>
+          </a:prstGeom>
+          <a:noFill/>
+        </p:spPr>
+        <p:txBody>
+          <a:bodyPr wrap="square" lIns="18288" rIns="18288" tIns="18288" bIns="18288" anchor="ctr">
+            <a:spAutoFit/>
+          </a:bodyPr>
+          <a:lstStyle/>
+          <a:p>
+            <a:pPr algn="l">
+              <a:spcBef>
+                <a:spcPts val="0"/>
+              </a:spcBef>
+              <a:spcAft>
+                <a:spcPts val="0"/>
+              </a:spcAft>
+            </a:pPr>
+            <a:r>
+              <a:rPr sz="1800" b="0">
+                <a:solidFill>
+                  <a:srgbClr val="252B33"/>
+                </a:solidFill>
+                <a:latin typeface="Arial"/>
+              </a:rPr>
+              <a:t>Complexity 886 → 889</a:t>
+            </a:r>
+          </a:p>
+        </p:txBody>
+      </p:sp>
+      <p:sp>
+        <p:nvSpPr>
+          <p:cNvPr id="26" name="Rounded Rectangle 25"/>
+          <p:cNvSpPr/>
+          <p:nvPr/>
+        </p:nvSpPr>
+        <p:spPr>
+          <a:xfrm>
+            <a:off x="768096" y="5824728"/>
+            <a:ext cx="10643616" cy="448056"/>
+          </a:xfrm>
+          <a:prstGeom prst="roundRect">
+            <a:avLst/>
+          </a:prstGeom>
+          <a:solidFill>
+            <a:srgbClr val="E8F7EE"/>
+          </a:solidFill>
+          <a:ln>
+            <a:noFill/>
+          </a:ln>
+        </p:spPr>
+        <p:style>
           <a:lnRef idx="1">
             <a:schemeClr val="accent1"/>
           </a:lnRef>
@@ -11990,14 +12038,14 @@
       </p:sp>
       <p:sp>
         <p:nvSpPr>
-          <p:cNvPr id="25" name="TextBox 24"/>
+          <p:cNvPr id="27" name="TextBox 26"/>
           <p:cNvSpPr txBox="1"/>
           <p:nvPr/>
         </p:nvSpPr>
         <p:spPr>
           <a:xfrm>
-            <a:off x="4553712" y="3063240"/>
-            <a:ext cx="3054096" cy="630936"/>
+            <a:off x="978408" y="5879592"/>
+            <a:ext cx="10222992" cy="320040"/>
           </a:xfrm>
           <a:prstGeom prst="rect">
             <a:avLst/>
@@ -12019,226 +12067,13 @@
               </a:spcAft>
             </a:pPr>
             <a:r>
-              <a:rPr sz="1800" b="1">
+              <a:rPr sz="1700" b="1">
                 <a:solidFill>
-                  <a:srgbClr val="0F676D"/>
+                  <a:srgbClr val="246F46"/>
                 </a:solidFill>
                 <a:latin typeface="Arial"/>
               </a:rPr>
-              <a:t>Duplicated-line density 0.0%</a:t>
-            </a:r>
-          </a:p>
-        </p:txBody>
-      </p:sp>
-      <p:sp>
-        <p:nvSpPr>
-          <p:cNvPr id="26" name="TextBox 25"/>
-          <p:cNvSpPr txBox="1"/>
-          <p:nvPr/>
-        </p:nvSpPr>
-        <p:spPr>
-          <a:xfrm>
-            <a:off x="4553712" y="3794760"/>
-            <a:ext cx="3054096" cy="1271016"/>
-          </a:xfrm>
-          <a:prstGeom prst="rect">
-            <a:avLst/>
-          </a:prstGeom>
-          <a:noFill/>
-        </p:spPr>
-        <p:txBody>
-          <a:bodyPr wrap="square" lIns="18288" rIns="18288" tIns="18288" bIns="18288" anchor="ctr">
-            <a:spAutoFit/>
-          </a:bodyPr>
-          <a:lstStyle/>
-          <a:p>
-            <a:pPr algn="l">
-              <a:spcBef>
-                <a:spcPts val="0"/>
-              </a:spcBef>
-              <a:spcAft>
-                <a:spcPts val="0"/>
-              </a:spcAft>
-            </a:pPr>
-            <a:r>
-              <a:rPr sz="1600" b="0">
-                <a:solidFill>
-                  <a:srgbClr val="252B33"/>
-                </a:solidFill>
-                <a:latin typeface="Arial"/>
-              </a:rPr>
-              <a:t>SonarQube reported 0.0% for the analyzed code; that is not proof of no repeated code.</a:t>
-            </a:r>
-          </a:p>
-        </p:txBody>
-      </p:sp>
-      <p:sp>
-        <p:nvSpPr>
-          <p:cNvPr id="27" name="Rounded Rectangle 26"/>
-          <p:cNvSpPr/>
-          <p:nvPr/>
-        </p:nvSpPr>
-        <p:spPr>
-          <a:xfrm>
-            <a:off x="8010144" y="2852928"/>
-            <a:ext cx="3438144" cy="2459736"/>
-          </a:xfrm>
-          <a:prstGeom prst="roundRect">
-            <a:avLst/>
-          </a:prstGeom>
-          <a:solidFill>
-            <a:srgbClr val="FFFFFF"/>
-          </a:solidFill>
-          <a:ln w="12700">
-            <a:solidFill>
-              <a:srgbClr val="D8E0E9"/>
-            </a:solidFill>
-          </a:ln>
-        </p:spPr>
-        <p:style>
-          <a:lnRef idx="1">
-            <a:schemeClr val="accent1"/>
-          </a:lnRef>
-          <a:fillRef idx="3">
-            <a:schemeClr val="accent1"/>
-          </a:fillRef>
-          <a:effectRef idx="2">
-            <a:schemeClr val="accent1"/>
-          </a:effectRef>
-          <a:fontRef idx="minor">
-            <a:schemeClr val="lt1"/>
-          </a:fontRef>
-        </p:style>
-        <p:txBody>
-          <a:bodyPr rtlCol="0" anchor="ctr"/>
-          <a:lstStyle/>
-          <a:p>
-            <a:pPr algn="ctr"/>
-          </a:p>
-        </p:txBody>
-      </p:sp>
-      <p:sp>
-        <p:nvSpPr>
-          <p:cNvPr id="28" name="TextBox 27"/>
-          <p:cNvSpPr txBox="1"/>
-          <p:nvPr/>
-        </p:nvSpPr>
-        <p:spPr>
-          <a:xfrm>
-            <a:off x="8193023" y="3063240"/>
-            <a:ext cx="3054096" cy="630936"/>
-          </a:xfrm>
-          <a:prstGeom prst="rect">
-            <a:avLst/>
-          </a:prstGeom>
-          <a:noFill/>
-        </p:spPr>
-        <p:txBody>
-          <a:bodyPr wrap="square" lIns="18288" rIns="18288" tIns="18288" bIns="18288" anchor="ctr">
-            <a:spAutoFit/>
-          </a:bodyPr>
-          <a:lstStyle/>
-          <a:p>
-            <a:pPr algn="l">
-              <a:spcBef>
-                <a:spcPts val="0"/>
-              </a:spcBef>
-              <a:spcAft>
-                <a:spcPts val="0"/>
-              </a:spcAft>
-            </a:pPr>
-            <a:r>
-              <a:rPr sz="1800" b="1">
-                <a:solidFill>
-                  <a:srgbClr val="0F676D"/>
-                </a:solidFill>
-                <a:latin typeface="Arial"/>
-              </a:rPr>
-              <a:t>Coverage: 0.1 percentage point down</a:t>
-            </a:r>
-          </a:p>
-        </p:txBody>
-      </p:sp>
-      <p:sp>
-        <p:nvSpPr>
-          <p:cNvPr id="29" name="TextBox 28"/>
-          <p:cNvSpPr txBox="1"/>
-          <p:nvPr/>
-        </p:nvSpPr>
-        <p:spPr>
-          <a:xfrm>
-            <a:off x="8193023" y="3794760"/>
-            <a:ext cx="3054096" cy="1271016"/>
-          </a:xfrm>
-          <a:prstGeom prst="rect">
-            <a:avLst/>
-          </a:prstGeom>
-          <a:noFill/>
-        </p:spPr>
-        <p:txBody>
-          <a:bodyPr wrap="square" lIns="18288" rIns="18288" tIns="18288" bIns="18288" anchor="ctr">
-            <a:spAutoFit/>
-          </a:bodyPr>
-          <a:lstStyle/>
-          <a:p>
-            <a:pPr algn="l">
-              <a:spcBef>
-                <a:spcPts val="0"/>
-              </a:spcBef>
-              <a:spcAft>
-                <a:spcPts val="0"/>
-              </a:spcAft>
-            </a:pPr>
-            <a:r>
-              <a:rPr sz="1600" b="0">
-                <a:solidFill>
-                  <a:srgbClr val="252B33"/>
-                </a:solidFill>
-                <a:latin typeface="Arial"/>
-              </a:rPr>
-              <a:t>74.4% → 74.3%. This is a small measured decrease; saved summaries do not explain its exact cause.</a:t>
-            </a:r>
-          </a:p>
-        </p:txBody>
-      </p:sp>
-      <p:sp>
-        <p:nvSpPr>
-          <p:cNvPr id="30" name="TextBox 29"/>
-          <p:cNvSpPr txBox="1"/>
-          <p:nvPr/>
-        </p:nvSpPr>
-        <p:spPr>
-          <a:xfrm>
-            <a:off x="786384" y="5632704"/>
-            <a:ext cx="10616184" cy="411480"/>
-          </a:xfrm>
-          <a:prstGeom prst="rect">
-            <a:avLst/>
-          </a:prstGeom>
-          <a:noFill/>
-        </p:spPr>
-        <p:txBody>
-          <a:bodyPr wrap="square" lIns="18288" rIns="18288" tIns="18288" bIns="18288" anchor="ctr">
-            <a:spAutoFit/>
-          </a:bodyPr>
-          <a:lstStyle/>
-          <a:p>
-            <a:pPr algn="l">
-              <a:spcBef>
-                <a:spcPts val="0"/>
-              </a:spcBef>
-              <a:spcAft>
-                <a:spcPts val="0"/>
-              </a:spcAft>
-            </a:pPr>
-            <a:r>
-              <a:rPr sz="1600" b="0">
-                <a:solidFill>
-                  <a:srgbClr val="5B6874"/>
-                </a:solidFill>
-                <a:latin typeface="Arial"/>
-              </a:rPr>
-              <a:t>Impact labels overlap (Reliability 2, Security 1, Maintainability 16); complexity rose 886 → 889.</a:t>
+              <a:t>The targeted gain is issue closure; adjacent quality measures stayed close to baseline.</a:t>
             </a:r>
           </a:p>
         </p:txBody>
@@ -12349,7 +12184,7 @@
                 </a:solidFill>
                 <a:latin typeface="Arial"/>
               </a:rPr>
-              <a:t>RESULTS</a:t>
+              <a:t>EVIDENCE</a:t>
             </a:r>
           </a:p>
         </p:txBody>
@@ -12391,7 +12226,7 @@
                 </a:solidFill>
                 <a:latin typeface="Arial"/>
               </a:rPr>
-              <a:t>SonarQube issues changed; gate status did not</a:t>
+              <a:t>The SonarQube dashboards confirm 17 → 0</a:t>
             </a:r>
           </a:p>
         </p:txBody>
@@ -12848,7 +12683,7 @@
                 </a:solidFill>
                 <a:latin typeface="Arial"/>
               </a:rPr>
-              <a:t>Gate OK/OK has no recorded conditions; the measured improvement is 17 issues → 0.</a:t>
+              <a:t>17 unique issues → 0; Quality Gate remained OK on both branches.</a:t>
             </a:r>
           </a:p>
         </p:txBody>
@@ -17359,7 +17194,7 @@
                 </a:solidFill>
                 <a:latin typeface="Arial"/>
               </a:rPr>
-              <a:t>The fresh evidence is mixed</a:t>
+              <a:t>When is an AI suggestion an improvement?</a:t>
             </a:r>
           </a:p>
         </p:txBody>
@@ -17471,7 +17306,7 @@
                 </a:solidFill>
                 <a:latin typeface="Arial"/>
               </a:rPr>
-              <a:t>Current report §4.5; Table 4.5; Appendix M</a:t>
+              <a:t>Current report §§1.1-1.5 and Chapter 3</a:t>
             </a:r>
           </a:p>
         </p:txBody>
@@ -17526,8 +17361,479 @@
         </p:nvSpPr>
         <p:spPr>
           <a:xfrm>
-            <a:off x="713232" y="1426464"/>
-            <a:ext cx="3456432" cy="1115568"/>
+            <a:off x="731520" y="1417320"/>
+            <a:ext cx="10716768" cy="1554480"/>
+          </a:xfrm>
+          <a:prstGeom prst="roundRect">
+            <a:avLst/>
+          </a:prstGeom>
+          <a:solidFill>
+            <a:srgbClr val="FFFFFF"/>
+          </a:solidFill>
+          <a:ln w="12700">
+            <a:solidFill>
+              <a:srgbClr val="D8E0E9"/>
+            </a:solidFill>
+          </a:ln>
+        </p:spPr>
+        <p:style>
+          <a:lnRef idx="1">
+            <a:schemeClr val="accent1"/>
+          </a:lnRef>
+          <a:fillRef idx="3">
+            <a:schemeClr val="accent1"/>
+          </a:fillRef>
+          <a:effectRef idx="2">
+            <a:schemeClr val="accent1"/>
+          </a:effectRef>
+          <a:fontRef idx="minor">
+            <a:schemeClr val="lt1"/>
+          </a:fontRef>
+        </p:style>
+        <p:txBody>
+          <a:bodyPr rtlCol="0" anchor="ctr"/>
+          <a:lstStyle/>
+          <a:p>
+            <a:pPr algn="ctr"/>
+          </a:p>
+        </p:txBody>
+      </p:sp>
+      <p:sp>
+        <p:nvSpPr>
+          <p:cNvPr id="10" name="TextBox 9"/>
+          <p:cNvSpPr txBox="1"/>
+          <p:nvPr/>
+        </p:nvSpPr>
+        <p:spPr>
+          <a:xfrm>
+            <a:off x="1033271" y="1636776"/>
+            <a:ext cx="10131552" cy="448056"/>
+          </a:xfrm>
+          <a:prstGeom prst="rect">
+            <a:avLst/>
+          </a:prstGeom>
+          <a:noFill/>
+        </p:spPr>
+        <p:txBody>
+          <a:bodyPr wrap="square" lIns="18288" rIns="18288" tIns="18288" bIns="18288" anchor="ctr">
+            <a:spAutoFit/>
+          </a:bodyPr>
+          <a:lstStyle/>
+          <a:p>
+            <a:pPr algn="l">
+              <a:spcBef>
+                <a:spcPts val="0"/>
+              </a:spcBef>
+              <a:spcAft>
+                <a:spcPts val="0"/>
+              </a:spcAft>
+            </a:pPr>
+            <a:r>
+              <a:rPr sz="2700" b="1">
+                <a:solidFill>
+                  <a:srgbClr val="252B33"/>
+                </a:solidFill>
+                <a:latin typeface="Arial"/>
+              </a:rPr>
+              <a:t>A plausible code change is not enough for a financial API.</a:t>
+            </a:r>
+          </a:p>
+        </p:txBody>
+      </p:sp>
+      <p:sp>
+        <p:nvSpPr>
+          <p:cNvPr id="11" name="TextBox 10"/>
+          <p:cNvSpPr txBox="1"/>
+          <p:nvPr/>
+        </p:nvSpPr>
+        <p:spPr>
+          <a:xfrm>
+            <a:off x="1033271" y="2258568"/>
+            <a:ext cx="10131552" cy="448056"/>
+          </a:xfrm>
+          <a:prstGeom prst="rect">
+            <a:avLst/>
+          </a:prstGeom>
+          <a:noFill/>
+        </p:spPr>
+        <p:txBody>
+          <a:bodyPr wrap="square" lIns="18288" rIns="18288" tIns="18288" bIns="18288" anchor="ctr">
+            <a:spAutoFit/>
+          </a:bodyPr>
+          <a:lstStyle/>
+          <a:p>
+            <a:pPr algn="l">
+              <a:spcBef>
+                <a:spcPts val="0"/>
+              </a:spcBef>
+              <a:spcAft>
+                <a:spcPts val="0"/>
+              </a:spcAft>
+            </a:pPr>
+            <a:r>
+              <a:rPr sz="1900" b="0">
+                <a:solidFill>
+                  <a:srgbClr val="0F676D"/>
+                </a:solidFill>
+                <a:latin typeface="Arial"/>
+              </a:rPr>
+              <a:t>The question is whether a reviewed ChatGPT suggestion survives functional and independent tool checks.</a:t>
+            </a:r>
+          </a:p>
+        </p:txBody>
+      </p:sp>
+      <p:sp>
+        <p:nvSpPr>
+          <p:cNvPr id="12" name="Rounded Rectangle 11"/>
+          <p:cNvSpPr/>
+          <p:nvPr/>
+        </p:nvSpPr>
+        <p:spPr>
+          <a:xfrm>
+            <a:off x="731520" y="3410712"/>
+            <a:ext cx="3438144" cy="2020824"/>
+          </a:xfrm>
+          <a:prstGeom prst="roundRect">
+            <a:avLst/>
+          </a:prstGeom>
+          <a:solidFill>
+            <a:srgbClr val="EBF3FB"/>
+          </a:solidFill>
+          <a:ln w="12700">
+            <a:solidFill>
+              <a:srgbClr val="D8E0E9"/>
+            </a:solidFill>
+          </a:ln>
+        </p:spPr>
+        <p:style>
+          <a:lnRef idx="1">
+            <a:schemeClr val="accent1"/>
+          </a:lnRef>
+          <a:fillRef idx="3">
+            <a:schemeClr val="accent1"/>
+          </a:fillRef>
+          <a:effectRef idx="2">
+            <a:schemeClr val="accent1"/>
+          </a:effectRef>
+          <a:fontRef idx="minor">
+            <a:schemeClr val="lt1"/>
+          </a:fontRef>
+        </p:style>
+        <p:txBody>
+          <a:bodyPr rtlCol="0" anchor="ctr"/>
+          <a:lstStyle/>
+          <a:p>
+            <a:pPr algn="ctr"/>
+          </a:p>
+        </p:txBody>
+      </p:sp>
+      <p:sp>
+        <p:nvSpPr>
+          <p:cNvPr id="13" name="TextBox 12"/>
+          <p:cNvSpPr txBox="1"/>
+          <p:nvPr/>
+        </p:nvSpPr>
+        <p:spPr>
+          <a:xfrm>
+            <a:off x="941832" y="3666744"/>
+            <a:ext cx="466344" cy="320040"/>
+          </a:xfrm>
+          <a:prstGeom prst="rect">
+            <a:avLst/>
+          </a:prstGeom>
+          <a:noFill/>
+        </p:spPr>
+        <p:txBody>
+          <a:bodyPr wrap="square" lIns="18288" rIns="18288" tIns="18288" bIns="18288" anchor="ctr">
+            <a:spAutoFit/>
+          </a:bodyPr>
+          <a:lstStyle/>
+          <a:p>
+            <a:pPr algn="l">
+              <a:spcBef>
+                <a:spcPts val="0"/>
+              </a:spcBef>
+              <a:spcAft>
+                <a:spcPts val="0"/>
+              </a:spcAft>
+            </a:pPr>
+            <a:r>
+              <a:rPr sz="1700" b="1">
+                <a:solidFill>
+                  <a:srgbClr val="24466C"/>
+                </a:solidFill>
+                <a:latin typeface="Arial"/>
+              </a:rPr>
+              <a:t>01</a:t>
+            </a:r>
+          </a:p>
+        </p:txBody>
+      </p:sp>
+      <p:sp>
+        <p:nvSpPr>
+          <p:cNvPr id="14" name="TextBox 13"/>
+          <p:cNvSpPr txBox="1"/>
+          <p:nvPr/>
+        </p:nvSpPr>
+        <p:spPr>
+          <a:xfrm>
+            <a:off x="941832" y="4105656"/>
+            <a:ext cx="2999232" cy="393192"/>
+          </a:xfrm>
+          <a:prstGeom prst="rect">
+            <a:avLst/>
+          </a:prstGeom>
+          <a:noFill/>
+        </p:spPr>
+        <p:txBody>
+          <a:bodyPr wrap="square" lIns="18288" rIns="18288" tIns="18288" bIns="18288" anchor="ctr">
+            <a:spAutoFit/>
+          </a:bodyPr>
+          <a:lstStyle/>
+          <a:p>
+            <a:pPr algn="l">
+              <a:spcBef>
+                <a:spcPts val="0"/>
+              </a:spcBef>
+              <a:spcAft>
+                <a:spcPts val="0"/>
+              </a:spcAft>
+            </a:pPr>
+            <a:r>
+              <a:rPr sz="2200" b="1">
+                <a:solidFill>
+                  <a:srgbClr val="24466C"/>
+                </a:solidFill>
+                <a:latin typeface="Arial"/>
+              </a:rPr>
+              <a:t>Existing system</a:t>
+            </a:r>
+          </a:p>
+        </p:txBody>
+      </p:sp>
+      <p:sp>
+        <p:nvSpPr>
+          <p:cNvPr id="15" name="TextBox 14"/>
+          <p:cNvSpPr txBox="1"/>
+          <p:nvPr/>
+        </p:nvSpPr>
+        <p:spPr>
+          <a:xfrm>
+            <a:off x="941832" y="4663440"/>
+            <a:ext cx="2999232" cy="557784"/>
+          </a:xfrm>
+          <a:prstGeom prst="rect">
+            <a:avLst/>
+          </a:prstGeom>
+          <a:noFill/>
+        </p:spPr>
+        <p:txBody>
+          <a:bodyPr wrap="square" lIns="18288" rIns="18288" tIns="18288" bIns="18288" anchor="ctr">
+            <a:spAutoFit/>
+          </a:bodyPr>
+          <a:lstStyle/>
+          <a:p>
+            <a:pPr algn="l">
+              <a:spcBef>
+                <a:spcPts val="0"/>
+              </a:spcBef>
+              <a:spcAft>
+                <a:spcPts val="0"/>
+              </a:spcAft>
+            </a:pPr>
+            <a:r>
+              <a:rPr sz="1700" b="0">
+                <a:solidFill>
+                  <a:srgbClr val="252B33"/>
+                </a:solidFill>
+                <a:latin typeface="Arial"/>
+              </a:rPr>
+              <a:t>One accounting API with real routes and roles</a:t>
+            </a:r>
+          </a:p>
+        </p:txBody>
+      </p:sp>
+      <p:sp>
+        <p:nvSpPr>
+          <p:cNvPr id="16" name="Rounded Rectangle 15"/>
+          <p:cNvSpPr/>
+          <p:nvPr/>
+        </p:nvSpPr>
+        <p:spPr>
+          <a:xfrm>
+            <a:off x="4370832" y="3410712"/>
+            <a:ext cx="3438144" cy="2020824"/>
+          </a:xfrm>
+          <a:prstGeom prst="roundRect">
+            <a:avLst/>
+          </a:prstGeom>
+          <a:solidFill>
+            <a:srgbClr val="E7F6F6"/>
+          </a:solidFill>
+          <a:ln w="12700">
+            <a:solidFill>
+              <a:srgbClr val="D8E0E9"/>
+            </a:solidFill>
+          </a:ln>
+        </p:spPr>
+        <p:style>
+          <a:lnRef idx="1">
+            <a:schemeClr val="accent1"/>
+          </a:lnRef>
+          <a:fillRef idx="3">
+            <a:schemeClr val="accent1"/>
+          </a:fillRef>
+          <a:effectRef idx="2">
+            <a:schemeClr val="accent1"/>
+          </a:effectRef>
+          <a:fontRef idx="minor">
+            <a:schemeClr val="lt1"/>
+          </a:fontRef>
+        </p:style>
+        <p:txBody>
+          <a:bodyPr rtlCol="0" anchor="ctr"/>
+          <a:lstStyle/>
+          <a:p>
+            <a:pPr algn="ctr"/>
+          </a:p>
+        </p:txBody>
+      </p:sp>
+      <p:sp>
+        <p:nvSpPr>
+          <p:cNvPr id="17" name="TextBox 16"/>
+          <p:cNvSpPr txBox="1"/>
+          <p:nvPr/>
+        </p:nvSpPr>
+        <p:spPr>
+          <a:xfrm>
+            <a:off x="4581144" y="3666744"/>
+            <a:ext cx="466344" cy="320040"/>
+          </a:xfrm>
+          <a:prstGeom prst="rect">
+            <a:avLst/>
+          </a:prstGeom>
+          <a:noFill/>
+        </p:spPr>
+        <p:txBody>
+          <a:bodyPr wrap="square" lIns="18288" rIns="18288" tIns="18288" bIns="18288" anchor="ctr">
+            <a:spAutoFit/>
+          </a:bodyPr>
+          <a:lstStyle/>
+          <a:p>
+            <a:pPr algn="l">
+              <a:spcBef>
+                <a:spcPts val="0"/>
+              </a:spcBef>
+              <a:spcAft>
+                <a:spcPts val="0"/>
+              </a:spcAft>
+            </a:pPr>
+            <a:r>
+              <a:rPr sz="1700" b="1">
+                <a:solidFill>
+                  <a:srgbClr val="0F676D"/>
+                </a:solidFill>
+                <a:latin typeface="Arial"/>
+              </a:rPr>
+              <a:t>02</a:t>
+            </a:r>
+          </a:p>
+        </p:txBody>
+      </p:sp>
+      <p:sp>
+        <p:nvSpPr>
+          <p:cNvPr id="18" name="TextBox 17"/>
+          <p:cNvSpPr txBox="1"/>
+          <p:nvPr/>
+        </p:nvSpPr>
+        <p:spPr>
+          <a:xfrm>
+            <a:off x="4581144" y="4105656"/>
+            <a:ext cx="2999232" cy="393192"/>
+          </a:xfrm>
+          <a:prstGeom prst="rect">
+            <a:avLst/>
+          </a:prstGeom>
+          <a:noFill/>
+        </p:spPr>
+        <p:txBody>
+          <a:bodyPr wrap="square" lIns="18288" rIns="18288" tIns="18288" bIns="18288" anchor="ctr">
+            <a:spAutoFit/>
+          </a:bodyPr>
+          <a:lstStyle/>
+          <a:p>
+            <a:pPr algn="l">
+              <a:spcBef>
+                <a:spcPts val="0"/>
+              </a:spcBef>
+              <a:spcAft>
+                <a:spcPts val="0"/>
+              </a:spcAft>
+            </a:pPr>
+            <a:r>
+              <a:rPr sz="2200" b="1">
+                <a:solidFill>
+                  <a:srgbClr val="0F676D"/>
+                </a:solidFill>
+                <a:latin typeface="Arial"/>
+              </a:rPr>
+              <a:t>Human review</a:t>
+            </a:r>
+          </a:p>
+        </p:txBody>
+      </p:sp>
+      <p:sp>
+        <p:nvSpPr>
+          <p:cNvPr id="19" name="TextBox 18"/>
+          <p:cNvSpPr txBox="1"/>
+          <p:nvPr/>
+        </p:nvSpPr>
+        <p:spPr>
+          <a:xfrm>
+            <a:off x="4581144" y="4663440"/>
+            <a:ext cx="2999232" cy="557784"/>
+          </a:xfrm>
+          <a:prstGeom prst="rect">
+            <a:avLst/>
+          </a:prstGeom>
+          <a:noFill/>
+        </p:spPr>
+        <p:txBody>
+          <a:bodyPr wrap="square" lIns="18288" rIns="18288" tIns="18288" bIns="18288" anchor="ctr">
+            <a:spAutoFit/>
+          </a:bodyPr>
+          <a:lstStyle/>
+          <a:p>
+            <a:pPr algn="l">
+              <a:spcBef>
+                <a:spcPts val="0"/>
+              </a:spcBef>
+              <a:spcAft>
+                <a:spcPts val="0"/>
+              </a:spcAft>
+            </a:pPr>
+            <a:r>
+              <a:rPr sz="1700" b="0">
+                <a:solidFill>
+                  <a:srgbClr val="252B33"/>
+                </a:solidFill>
+                <a:latin typeface="Arial"/>
+              </a:rPr>
+              <a:t>I accept or reject each proposed change</a:t>
+            </a:r>
+          </a:p>
+        </p:txBody>
+      </p:sp>
+      <p:sp>
+        <p:nvSpPr>
+          <p:cNvPr id="20" name="Rounded Rectangle 19"/>
+          <p:cNvSpPr/>
+          <p:nvPr/>
+        </p:nvSpPr>
+        <p:spPr>
+          <a:xfrm>
+            <a:off x="8010144" y="3410712"/>
+            <a:ext cx="3438144" cy="2020824"/>
           </a:xfrm>
           <a:prstGeom prst="roundRect">
             <a:avLst/>
@@ -17565,14 +17871,14 @@
       </p:sp>
       <p:sp>
         <p:nvSpPr>
-          <p:cNvPr id="10" name="TextBox 9"/>
+          <p:cNvPr id="21" name="TextBox 20"/>
           <p:cNvSpPr txBox="1"/>
           <p:nvPr/>
         </p:nvSpPr>
         <p:spPr>
           <a:xfrm>
-            <a:off x="877824" y="1536192"/>
-            <a:ext cx="3127248" cy="201168"/>
+            <a:off x="8220456" y="3666744"/>
+            <a:ext cx="466344" cy="320040"/>
           </a:xfrm>
           <a:prstGeom prst="rect">
             <a:avLst/>
@@ -17594,69 +17900,27 @@
               </a:spcAft>
             </a:pPr>
             <a:r>
-              <a:rPr sz="1100" b="1">
-                <a:solidFill>
-                  <a:srgbClr val="5B6874"/>
-                </a:solidFill>
-                <a:latin typeface="Arial"/>
-              </a:rPr>
-              <a:t>STATIC QUALITY</a:t>
-            </a:r>
-          </a:p>
-        </p:txBody>
-      </p:sp>
-      <p:sp>
-        <p:nvSpPr>
-          <p:cNvPr id="11" name="TextBox 10"/>
-          <p:cNvSpPr txBox="1"/>
-          <p:nvPr/>
-        </p:nvSpPr>
-        <p:spPr>
-          <a:xfrm>
-            <a:off x="877824" y="1783080"/>
-            <a:ext cx="3127248" cy="411480"/>
-          </a:xfrm>
-          <a:prstGeom prst="rect">
-            <a:avLst/>
-          </a:prstGeom>
-          <a:noFill/>
-        </p:spPr>
-        <p:txBody>
-          <a:bodyPr wrap="square" lIns="18288" rIns="18288" tIns="18288" bIns="18288" anchor="ctr">
-            <a:spAutoFit/>
-          </a:bodyPr>
-          <a:lstStyle/>
-          <a:p>
-            <a:pPr algn="l">
-              <a:spcBef>
-                <a:spcPts val="0"/>
-              </a:spcBef>
-              <a:spcAft>
-                <a:spcPts val="0"/>
-              </a:spcAft>
-            </a:pPr>
-            <a:r>
-              <a:rPr sz="2500" b="1">
+              <a:rPr sz="1700" b="1">
                 <a:solidFill>
                   <a:srgbClr val="246F46"/>
                 </a:solidFill>
                 <a:latin typeface="Arial"/>
               </a:rPr>
-              <a:t>17 to 0</a:t>
-            </a:r>
-          </a:p>
-        </p:txBody>
-      </p:sp>
-      <p:sp>
-        <p:nvSpPr>
-          <p:cNvPr id="12" name="TextBox 11"/>
+              <a:t>03</a:t>
+            </a:r>
+          </a:p>
+        </p:txBody>
+      </p:sp>
+      <p:sp>
+        <p:nvSpPr>
+          <p:cNvPr id="22" name="TextBox 21"/>
           <p:cNvSpPr txBox="1"/>
           <p:nvPr/>
         </p:nvSpPr>
         <p:spPr>
           <a:xfrm>
-            <a:off x="877824" y="2276856"/>
-            <a:ext cx="3127248" cy="164592"/>
+            <a:off x="8220456" y="4105656"/>
+            <a:ext cx="2999232" cy="393192"/>
           </a:xfrm>
           <a:prstGeom prst="rect">
             <a:avLst/>
@@ -17678,72 +17942,27 @@
               </a:spcAft>
             </a:pPr>
             <a:r>
-              <a:rPr sz="1100" b="0">
+              <a:rPr sz="2200" b="1">
                 <a:solidFill>
-                  <a:srgbClr val="5B6874"/>
+                  <a:srgbClr val="246F46"/>
                 </a:solidFill>
                 <a:latin typeface="Arial"/>
               </a:rPr>
-              <a:t>Unique SonarQube issues</a:t>
-            </a:r>
-          </a:p>
-        </p:txBody>
-      </p:sp>
-      <p:sp>
-        <p:nvSpPr>
-          <p:cNvPr id="13" name="Rounded Rectangle 12"/>
-          <p:cNvSpPr/>
-          <p:nvPr/>
-        </p:nvSpPr>
-        <p:spPr>
-          <a:xfrm>
-            <a:off x="4370832" y="1426464"/>
-            <a:ext cx="3456432" cy="1115568"/>
-          </a:xfrm>
-          <a:prstGeom prst="roundRect">
-            <a:avLst/>
-          </a:prstGeom>
-          <a:solidFill>
-            <a:srgbClr val="FFF6E7"/>
-          </a:solidFill>
-          <a:ln w="12700">
-            <a:solidFill>
-              <a:srgbClr val="D8E0E9"/>
-            </a:solidFill>
-          </a:ln>
-        </p:spPr>
-        <p:style>
-          <a:lnRef idx="1">
-            <a:schemeClr val="accent1"/>
-          </a:lnRef>
-          <a:fillRef idx="3">
-            <a:schemeClr val="accent1"/>
-          </a:fillRef>
-          <a:effectRef idx="2">
-            <a:schemeClr val="accent1"/>
-          </a:effectRef>
-          <a:fontRef idx="minor">
-            <a:schemeClr val="lt1"/>
-          </a:fontRef>
-        </p:style>
-        <p:txBody>
-          <a:bodyPr rtlCol="0" anchor="ctr"/>
-          <a:lstStyle/>
-          <a:p>
-            <a:pPr algn="ctr"/>
-          </a:p>
-        </p:txBody>
-      </p:sp>
-      <p:sp>
-        <p:nvSpPr>
-          <p:cNvPr id="14" name="TextBox 13"/>
+              <a:t>Independent checks</a:t>
+            </a:r>
+          </a:p>
+        </p:txBody>
+      </p:sp>
+      <p:sp>
+        <p:nvSpPr>
+          <p:cNvPr id="23" name="TextBox 22"/>
           <p:cNvSpPr txBox="1"/>
           <p:nvPr/>
         </p:nvSpPr>
         <p:spPr>
           <a:xfrm>
-            <a:off x="4535424" y="1536192"/>
-            <a:ext cx="3127248" cy="201168"/>
+            <a:off x="8220456" y="4663440"/>
+            <a:ext cx="2999232" cy="557784"/>
           </a:xfrm>
           <a:prstGeom prst="rect">
             <a:avLst/>
@@ -17765,27 +17984,27 @@
               </a:spcAft>
             </a:pPr>
             <a:r>
-              <a:rPr sz="1100" b="1">
+              <a:rPr sz="1700" b="0">
                 <a:solidFill>
-                  <a:srgbClr val="5B6874"/>
+                  <a:srgbClr val="252B33"/>
                 </a:solidFill>
                 <a:latin typeface="Arial"/>
               </a:rPr>
-              <a:t>SECURITY</a:t>
-            </a:r>
-          </a:p>
-        </p:txBody>
-      </p:sp>
-      <p:sp>
-        <p:nvSpPr>
-          <p:cNvPr id="15" name="TextBox 14"/>
+              <a:t>Tests, SonarQube, ZAP, and JMeter</a:t>
+            </a:r>
+          </a:p>
+        </p:txBody>
+      </p:sp>
+      <p:sp>
+        <p:nvSpPr>
+          <p:cNvPr id="24" name="TextBox 23"/>
           <p:cNvSpPr txBox="1"/>
           <p:nvPr/>
         </p:nvSpPr>
         <p:spPr>
           <a:xfrm>
-            <a:off x="4535424" y="1783080"/>
-            <a:ext cx="3127248" cy="411480"/>
+            <a:off x="786384" y="5779008"/>
+            <a:ext cx="10607040" cy="384048"/>
           </a:xfrm>
           <a:prstGeom prst="rect">
             <a:avLst/>
@@ -17807,355 +18026,13 @@
               </a:spcAft>
             </a:pPr>
             <a:r>
-              <a:rPr sz="2500" b="1">
-                <a:solidFill>
-                  <a:srgbClr val="BE7414"/>
-                </a:solidFill>
-                <a:latin typeface="Arial"/>
-              </a:rPr>
-              <a:t>Gate PASS</a:t>
-            </a:r>
-          </a:p>
-        </p:txBody>
-      </p:sp>
-      <p:sp>
-        <p:nvSpPr>
-          <p:cNvPr id="16" name="TextBox 15"/>
-          <p:cNvSpPr txBox="1"/>
-          <p:nvPr/>
-        </p:nvSpPr>
-        <p:spPr>
-          <a:xfrm>
-            <a:off x="4535424" y="2276856"/>
-            <a:ext cx="3127248" cy="164592"/>
-          </a:xfrm>
-          <a:prstGeom prst="rect">
-            <a:avLst/>
-          </a:prstGeom>
-          <a:noFill/>
-        </p:spPr>
-        <p:txBody>
-          <a:bodyPr wrap="square" lIns="18288" rIns="18288" tIns="18288" bIns="18288" anchor="ctr">
-            <a:spAutoFit/>
-          </a:bodyPr>
-          <a:lstStyle/>
-          <a:p>
-            <a:pPr algn="l">
-              <a:spcBef>
-                <a:spcPts val="0"/>
-              </a:spcBef>
-              <a:spcAft>
-                <a:spcPts val="0"/>
-              </a:spcAft>
-            </a:pPr>
-            <a:r>
-              <a:rPr sz="1100" b="0">
-                <a:solidFill>
-                  <a:srgbClr val="5B6874"/>
-                </a:solidFill>
-                <a:latin typeface="Arial"/>
-              </a:rPr>
-              <a:t>One raw API Medium remains</a:t>
-            </a:r>
-          </a:p>
-        </p:txBody>
-      </p:sp>
-      <p:sp>
-        <p:nvSpPr>
-          <p:cNvPr id="17" name="Rounded Rectangle 16"/>
-          <p:cNvSpPr/>
-          <p:nvPr/>
-        </p:nvSpPr>
-        <p:spPr>
-          <a:xfrm>
-            <a:off x="8028431" y="1426464"/>
-            <a:ext cx="3456432" cy="1115568"/>
-          </a:xfrm>
-          <a:prstGeom prst="roundRect">
-            <a:avLst/>
-          </a:prstGeom>
-          <a:solidFill>
-            <a:srgbClr val="FDEFF0"/>
-          </a:solidFill>
-          <a:ln w="12700">
-            <a:solidFill>
-              <a:srgbClr val="D8E0E9"/>
-            </a:solidFill>
-          </a:ln>
-        </p:spPr>
-        <p:style>
-          <a:lnRef idx="1">
-            <a:schemeClr val="accent1"/>
-          </a:lnRef>
-          <a:fillRef idx="3">
-            <a:schemeClr val="accent1"/>
-          </a:fillRef>
-          <a:effectRef idx="2">
-            <a:schemeClr val="accent1"/>
-          </a:effectRef>
-          <a:fontRef idx="minor">
-            <a:schemeClr val="lt1"/>
-          </a:fontRef>
-        </p:style>
-        <p:txBody>
-          <a:bodyPr rtlCol="0" anchor="ctr"/>
-          <a:lstStyle/>
-          <a:p>
-            <a:pPr algn="ctr"/>
-          </a:p>
-        </p:txBody>
-      </p:sp>
-      <p:sp>
-        <p:nvSpPr>
-          <p:cNvPr id="18" name="TextBox 17"/>
-          <p:cNvSpPr txBox="1"/>
-          <p:nvPr/>
-        </p:nvSpPr>
-        <p:spPr>
-          <a:xfrm>
-            <a:off x="8193023" y="1536192"/>
-            <a:ext cx="3127248" cy="201168"/>
-          </a:xfrm>
-          <a:prstGeom prst="rect">
-            <a:avLst/>
-          </a:prstGeom>
-          <a:noFill/>
-        </p:spPr>
-        <p:txBody>
-          <a:bodyPr wrap="square" lIns="18288" rIns="18288" tIns="18288" bIns="18288" anchor="ctr">
-            <a:spAutoFit/>
-          </a:bodyPr>
-          <a:lstStyle/>
-          <a:p>
-            <a:pPr algn="l">
-              <a:spcBef>
-                <a:spcPts val="0"/>
-              </a:spcBef>
-              <a:spcAft>
-                <a:spcPts val="0"/>
-              </a:spcAft>
-            </a:pPr>
-            <a:r>
-              <a:rPr sz="1100" b="1">
-                <a:solidFill>
-                  <a:srgbClr val="5B6874"/>
-                </a:solidFill>
-                <a:latin typeface="Arial"/>
-              </a:rPr>
-              <a:t>PERFORMANCE</a:t>
-            </a:r>
-          </a:p>
-        </p:txBody>
-      </p:sp>
-      <p:sp>
-        <p:nvSpPr>
-          <p:cNvPr id="19" name="TextBox 18"/>
-          <p:cNvSpPr txBox="1"/>
-          <p:nvPr/>
-        </p:nvSpPr>
-        <p:spPr>
-          <a:xfrm>
-            <a:off x="8193023" y="1783080"/>
-            <a:ext cx="3127248" cy="411480"/>
-          </a:xfrm>
-          <a:prstGeom prst="rect">
-            <a:avLst/>
-          </a:prstGeom>
-          <a:noFill/>
-        </p:spPr>
-        <p:txBody>
-          <a:bodyPr wrap="square" lIns="18288" rIns="18288" tIns="18288" bIns="18288" anchor="ctr">
-            <a:spAutoFit/>
-          </a:bodyPr>
-          <a:lstStyle/>
-          <a:p>
-            <a:pPr algn="l">
-              <a:spcBef>
-                <a:spcPts val="0"/>
-              </a:spcBef>
-              <a:spcAft>
-                <a:spcPts val="0"/>
-              </a:spcAft>
-            </a:pPr>
-            <a:r>
-              <a:rPr sz="2500" b="1">
-                <a:solidFill>
-                  <a:srgbClr val="B3373D"/>
-                </a:solidFill>
-                <a:latin typeface="Arial"/>
-              </a:rPr>
-              <a:t>Target not met</a:t>
-            </a:r>
-          </a:p>
-        </p:txBody>
-      </p:sp>
-      <p:sp>
-        <p:nvSpPr>
-          <p:cNvPr id="20" name="TextBox 19"/>
-          <p:cNvSpPr txBox="1"/>
-          <p:nvPr/>
-        </p:nvSpPr>
-        <p:spPr>
-          <a:xfrm>
-            <a:off x="8193023" y="2276856"/>
-            <a:ext cx="3127248" cy="164592"/>
-          </a:xfrm>
-          <a:prstGeom prst="rect">
-            <a:avLst/>
-          </a:prstGeom>
-          <a:noFill/>
-        </p:spPr>
-        <p:txBody>
-          <a:bodyPr wrap="square" lIns="18288" rIns="18288" tIns="18288" bIns="18288" anchor="ctr">
-            <a:spAutoFit/>
-          </a:bodyPr>
-          <a:lstStyle/>
-          <a:p>
-            <a:pPr algn="l">
-              <a:spcBef>
-                <a:spcPts val="0"/>
-              </a:spcBef>
-              <a:spcAft>
-                <a:spcPts val="0"/>
-              </a:spcAft>
-            </a:pPr>
-            <a:r>
-              <a:rPr sz="1100" b="0">
-                <a:solidFill>
-                  <a:srgbClr val="5B6874"/>
-                </a:solidFill>
-                <a:latin typeface="Arial"/>
-              </a:rPr>
-              <a:t>100 and 500 VU exceed limits</a:t>
-            </a:r>
-          </a:p>
-        </p:txBody>
-      </p:sp>
-      <p:sp>
-        <p:nvSpPr>
-          <p:cNvPr id="21" name="Rounded Rectangle 20"/>
-          <p:cNvSpPr/>
-          <p:nvPr/>
-        </p:nvSpPr>
-        <p:spPr>
-          <a:xfrm>
-            <a:off x="713232" y="2999232"/>
-            <a:ext cx="10771632" cy="2414016"/>
-          </a:xfrm>
-          <a:prstGeom prst="roundRect">
-            <a:avLst/>
-          </a:prstGeom>
-          <a:solidFill>
-            <a:srgbClr val="FFFFFF"/>
-          </a:solidFill>
-          <a:ln w="12700">
-            <a:solidFill>
-              <a:srgbClr val="D8E0E9"/>
-            </a:solidFill>
-          </a:ln>
-        </p:spPr>
-        <p:style>
-          <a:lnRef idx="1">
-            <a:schemeClr val="accent1"/>
-          </a:lnRef>
-          <a:fillRef idx="3">
-            <a:schemeClr val="accent1"/>
-          </a:fillRef>
-          <a:effectRef idx="2">
-            <a:schemeClr val="accent1"/>
-          </a:effectRef>
-          <a:fontRef idx="minor">
-            <a:schemeClr val="lt1"/>
-          </a:fontRef>
-        </p:style>
-        <p:txBody>
-          <a:bodyPr rtlCol="0" anchor="ctr"/>
-          <a:lstStyle/>
-          <a:p>
-            <a:pPr algn="ctr"/>
-          </a:p>
-        </p:txBody>
-      </p:sp>
-      <p:sp>
-        <p:nvSpPr>
-          <p:cNvPr id="22" name="TextBox 21"/>
-          <p:cNvSpPr txBox="1"/>
-          <p:nvPr/>
-        </p:nvSpPr>
-        <p:spPr>
-          <a:xfrm>
-            <a:off x="960120" y="3310128"/>
-            <a:ext cx="9966960" cy="329184"/>
-          </a:xfrm>
-          <a:prstGeom prst="rect">
-            <a:avLst/>
-          </a:prstGeom>
-          <a:noFill/>
-        </p:spPr>
-        <p:txBody>
-          <a:bodyPr wrap="square" lIns="18288" rIns="18288" tIns="18288" bIns="18288" anchor="ctr">
-            <a:spAutoFit/>
-          </a:bodyPr>
-          <a:lstStyle/>
-          <a:p>
-            <a:pPr algn="l">
-              <a:spcBef>
-                <a:spcPts val="0"/>
-              </a:spcBef>
-              <a:spcAft>
-                <a:spcPts val="0"/>
-              </a:spcAft>
-            </a:pPr>
-            <a:r>
-              <a:rPr sz="2000" b="1">
+              <a:rPr sz="1900" b="1">
                 <a:solidFill>
                   <a:srgbClr val="0F676D"/>
                 </a:solidFill>
                 <a:latin typeface="Arial"/>
               </a:rPr>
-              <a:t>Defensible conclusion</a:t>
-            </a:r>
-          </a:p>
-        </p:txBody>
-      </p:sp>
-      <p:sp>
-        <p:nvSpPr>
-          <p:cNvPr id="23" name="TextBox 22"/>
-          <p:cNvSpPr txBox="1"/>
-          <p:nvPr/>
-        </p:nvSpPr>
-        <p:spPr>
-          <a:xfrm>
-            <a:off x="960120" y="3749039"/>
-            <a:ext cx="9966960" cy="1188720"/>
-          </a:xfrm>
-          <a:prstGeom prst="rect">
-            <a:avLst/>
-          </a:prstGeom>
-          <a:noFill/>
-        </p:spPr>
-        <p:txBody>
-          <a:bodyPr wrap="square" lIns="18288" rIns="18288" tIns="18288" bIns="18288" anchor="ctr">
-            <a:spAutoFit/>
-          </a:bodyPr>
-          <a:lstStyle/>
-          <a:p>
-            <a:pPr algn="l">
-              <a:spcBef>
-                <a:spcPts val="0"/>
-              </a:spcBef>
-              <a:spcAft>
-                <a:spcPts val="0"/>
-              </a:spcAft>
-            </a:pPr>
-            <a:r>
-              <a:rPr sz="2300" b="0">
-                <a:solidFill>
-                  <a:srgbClr val="252B33"/>
-                </a:solidFill>
-                <a:latin typeface="Arial"/>
-              </a:rPr>
-              <a:t>ChatGPT-guided remediation closed the fresh static issues and passed the configured ZAP gate. It did not meet the predefined core performance target, despite lower soak and spike p95 values.</a:t>
+              <a:t>The measurements—not the assistant's confidence—will answer the question.</a:t>
             </a:r>
           </a:p>
         </p:txBody>
@@ -24375,7 +24252,7 @@
                 <a:gridCol w="5036880"/>
                 <a:gridCol w="3000695"/>
               </a:tblGrid>
-              <a:tr h="739140">
+              <a:tr h="886968">
                 <a:tc>
                   <a:txBody>
                     <a:bodyPr/>
@@ -24458,7 +24335,7 @@
                   </a:tcPr>
                 </a:tc>
               </a:tr>
-              <a:tr h="739140">
+              <a:tr h="886968">
                 <a:tc>
                   <a:txBody>
                     <a:bodyPr/>
@@ -24541,7 +24418,7 @@
                   </a:tcPr>
                 </a:tc>
               </a:tr>
-              <a:tr h="739140">
+              <a:tr h="886968">
                 <a:tc>
                   <a:txBody>
                     <a:bodyPr/>
@@ -24624,7 +24501,7 @@
                   </a:tcPr>
                 </a:tc>
               </a:tr>
-              <a:tr h="739140">
+              <a:tr h="886968">
                 <a:tc>
                   <a:txBody>
                     <a:bodyPr/>
@@ -24707,7 +24584,7 @@
                   </a:tcPr>
                 </a:tc>
               </a:tr>
-              <a:tr h="739140">
+              <a:tr h="886968">
                 <a:tc>
                   <a:txBody>
                     <a:bodyPr/>
@@ -24786,89 +24663,6 @@
                   <a:tcPr marL="109728" marR="91440" marT="36576" marB="36576">
                     <a:solidFill>
                       <a:srgbClr val="F7F9FC"/>
-                    </a:solidFill>
-                  </a:tcPr>
-                </a:tc>
-              </a:tr>
-              <a:tr h="739140">
-                <a:tc>
-                  <a:txBody>
-                    <a:bodyPr/>
-                    <a:lstStyle/>
-                    <a:p>
-                      <a:pPr algn="l">
-                        <a:spcAft>
-                          <a:spcPts val="0"/>
-                        </a:spcAft>
-                      </a:pPr>
-                      <a:r>
-                        <a:rPr sz="1700" b="0">
-                          <a:solidFill>
-                            <a:srgbClr val="252B33"/>
-                          </a:solidFill>
-                          <a:latin typeface="Arial"/>
-                        </a:rPr>
-                        <a:t>Reproduction</a:t>
-                      </a:r>
-                    </a:p>
-                  </a:txBody>
-                  <a:tcPr marL="109728" marR="91440" marT="36576" marB="36576">
-                    <a:solidFill>
-                      <a:srgbClr val="FFFFFF"/>
-                    </a:solidFill>
-                  </a:tcPr>
-                </a:tc>
-                <a:tc>
-                  <a:txBody>
-                    <a:bodyPr/>
-                    <a:lstStyle/>
-                    <a:p>
-                      <a:pPr algn="l">
-                        <a:spcAft>
-                          <a:spcPts val="0"/>
-                        </a:spcAft>
-                      </a:pPr>
-                      <a:r>
-                        <a:rPr sz="1700" b="0">
-                          <a:solidFill>
-                            <a:srgbClr val="252B33"/>
-                          </a:solidFill>
-                          <a:latin typeface="Arial"/>
-                        </a:rPr>
-                        <a:t>codex/thesis-reproducibility-v1</a:t>
-                      </a:r>
-                    </a:p>
-                  </a:txBody>
-                  <a:tcPr marL="109728" marR="91440" marT="36576" marB="36576">
-                    <a:solidFill>
-                      <a:srgbClr val="FFFFFF"/>
-                    </a:solidFill>
-                  </a:tcPr>
-                </a:tc>
-                <a:tc>
-                  <a:txBody>
-                    <a:bodyPr/>
-                    <a:lstStyle/>
-                    <a:p>
-                      <a:pPr algn="l">
-                        <a:spcAft>
-                          <a:spcPts val="0"/>
-                        </a:spcAft>
-                      </a:pPr>
-                      <a:r>
-                        <a:rPr sz="1700" b="0">
-                          <a:solidFill>
-                            <a:srgbClr val="252B33"/>
-                          </a:solidFill>
-                          <a:latin typeface="Arial"/>
-                        </a:rPr>
-                        <a:t>efa19cea</a:t>
-                      </a:r>
-                    </a:p>
-                  </a:txBody>
-                  <a:tcPr marL="109728" marR="91440" marT="36576" marB="36576">
-                    <a:solidFill>
-                      <a:srgbClr val="FFFFFF"/>
                     </a:solidFill>
                   </a:tcPr>
                 </a:tc>
@@ -41821,7 +41615,7 @@
                 </a:solidFill>
                 <a:latin typeface="Arial"/>
               </a:rPr>
-              <a:t>Give Codex the finding, source context, and constraints</a:t>
+              <a:t>Give ChatGPT the finding, source context, and constraints</a:t>
             </a:r>
           </a:p>
         </p:txBody>
@@ -42954,8 +42748,8 @@
         </p:nvSpPr>
         <p:spPr>
           <a:xfrm>
-            <a:off x="8193023" y="1801368"/>
-            <a:ext cx="3118104" cy="411480"/>
+            <a:off x="8193023" y="1796281"/>
+            <a:ext cx="3118104" cy="421654"/>
           </a:xfrm>
           <a:prstGeom prst="rect">
             <a:avLst/>
@@ -42983,7 +42777,7 @@
                 </a:solidFill>
                 <a:latin typeface="Arial"/>
               </a:rPr>
-              <a:t>Windows 11</a:t>
+              <a:t>Local </a:t>
             </a:r>
           </a:p>
         </p:txBody>

</xml_diff>

<commit_message>
docs: add request-level soak and spike evidence slides
</commit_message>
<xml_diff>
--- a/Document/outputs/final-defense/G6519692_Zaw_Ye_Htut_Ko_Final_Thesis_Defense.pptx
+++ b/Document/outputs/final-defense/G6519692_Zaw_Ye_Htut_Ko_Final_Thesis_Defense.pptx
@@ -50,6 +50,8 @@
     <p:sldId id="298" r:id="rId50"/>
     <p:sldId id="299" r:id="rId51"/>
     <p:sldId id="300" r:id="rId52"/>
+    <p:sldId id="301" r:id="rId53"/>
+    <p:sldId id="302" r:id="rId54"/>
   </p:sldIdLst>
   <p:sldSz cx="12191695" cy="6858000" type="screen4x3"/>
   <p:notesSz cx="6858000" cy="9144000"/>
@@ -1989,17 +1991,17 @@
           <a:lstStyle/>
           <a:p>
             <a:r>
-              <a:t>TIMING: 75 seconds</a:t>
-            </a:r>
-          </a:p>
-          <a:p>
-            <a:r>
-              <a:t>KEY MESSAGE: Exactly which measurements improved differs by test shape.</a:t>
-            </a:r>
-          </a:p>
-          <a:p>
-            <a:r>
-              <a:t>SHOW IF ASKED: backup slides 32 and 41-42 (soak and spike)</a:t>
+              <a:t>TIMING: 85 seconds</a:t>
+            </a:r>
+          </a:p>
+          <a:p>
+            <a:r>
+              <a:t>KEY MESSAGE: The pooled total and individual requests must be read together.</a:t>
+            </a:r>
+          </a:p>
+          <a:p>
+            <a:r>
+              <a:t>SHOW IF ASKED: backup slides 32 and 41-42 (soak and spike); per-request slides 46-47</a:t>
             </a:r>
           </a:p>
           <a:p>
@@ -2015,13 +2017,13 @@
           </a:p>
           <a:p>
             <a:r>
-              <a:t>Soak means repeated traffic over time; I look for performance getting worse as requests continue. Spike means many users arrive quickly; I look at the burst and whether response times recover afterward. In these runs, total p95 fell from 443.95 to 171 milliseconds for soak and from about 33.4 to 4.7 seconds for spike. These whole-run numbers are not direct proof of no soak drift or spike recovery. The core 50, 100, and 500 VU p95 results worsened, so I cannot claim overall performance success.</a:t>
+              <a:t>Soak means repeated traffic over time. Spike means many users arrive quickly. The whole-run Total p95 fell in both profiles. But the request-level records add an important distinction: in soak, 9 of 10 individual request p95 values rose after the change, even though the pooled Total p95 fell. The Total is recalculated from all requests; it is not an average of the individual request p95 values. In spike, all 10 individual request p95 values fell and overall errors went from 218 to zero. This is why I do not say every soak request improved. The detailed request tables are on slides 46 and 47, and the native dashboards remain in Appendix L. These whole-run figures are not direct proof of no soak drift or spike recovery. The core 50, 100, and 500 VU p95 results worsened, so I cannot claim overall performance success.</a:t>
             </a:r>
           </a:p>
           <a:p/>
           <a:p>
             <a:r>
-              <a:t>SOURCE: Fresh JMeter baseline/remediation summary.json; current report §4.4; Appendix L Figures L.12-L.13 and L.17-L.18.</a:t>
+              <a:t>SOURCE: Fresh JMeter baseline/remediation statistics.json and summary.json; current report §4.4; Appendix L Figures L.12-L.13 and L.17-L.18.</a:t>
             </a:r>
           </a:p>
           <a:p>
@@ -2106,7 +2108,7 @@
           </a:p>
           <a:p>
             <a:r>
-              <a:t>SHOW IF ASKED: backup slides 34 and 41-42 (mixed endpoint behavior)</a:t>
+              <a:t>SHOW IF ASKED: backup slides 34 and 41-42 (mixed endpoint behavior); per-request slides 46-47</a:t>
             </a:r>
           </a:p>
           <a:p>
@@ -2326,7 +2328,7 @@
           </a:p>
           <a:p>
             <a:r>
-              <a:t>Code warnings fell from 17 to zero, although coverage fell a little and complexity rose. ZAP's selected checks passed, but the local HTTP alert stayed. JMeter missed the main 100- and 500-user speed targets even though soak and spike improved. Each tool therefore answers a different part of the research question. On the next slide I will explain which conclusions apply to this tested case and what would need more validation before generalizing them.</a:t>
+              <a:t>Code warnings fell from 17 to zero, although coverage fell a little and complexity rose. ZAP's selected checks passed, but the local HTTP alert stayed. JMeter missed the main 100- and 500-user speed targets. The pooled soak and spike p95 values fell, but nine of ten soak request p95 values actually rose; all ten spike request p95 values fell. Each tool therefore answers a different part of the research question. On the next slide I will explain which conclusions apply to this tested case and what would need more validation before generalizing them.</a:t>
             </a:r>
           </a:p>
           <a:p/>
@@ -4057,7 +4059,7 @@
           </a:p>
           <a:p>
             <a:r>
-              <a:t>This long steady soak test had a lower total p95 after the change: 443.95 to 171 milliseconds. That is an improvement for this test only. It does not change the unmet 100- and 500-user core targets on slide 31.</a:t>
+              <a:t>The pooled Total p95 fell from 443.95 to 171 milliseconds, but 9 of 10 individual request p95 values rose. Open the request table on slide 46. The core 100- and 500-user targets were still not met.</a:t>
             </a:r>
           </a:p>
           <a:p/>
@@ -4154,7 +4156,7 @@
           </a:p>
           <a:p>
             <a:r>
-              <a:t>This sudden spike test had a lower total p95 after the change: 33401.8 to 4730.85 milliseconds. That is an improvement for this test only. It does not change the unmet 100- and 500-user core targets on slide 31.</a:t>
+              <a:t>The spike Total p95 fell from 33401.8 to 4730.85 milliseconds, and all 10 individual request p95 values fell. Open the request table on slide 47. The core 100- and 500-user targets were still not met.</a:t>
             </a:r>
           </a:p>
           <a:p/>
@@ -4457,6 +4459,190 @@
           <a:p>
             <a:r>
               <a:t>CAUTION: These are browser workflow captures; visible live application counts are not JMeter benchmark metrics.</a:t>
+            </a:r>
+          </a:p>
+        </p:txBody>
+      </p:sp>
+      <p:sp>
+        <p:nvSpPr>
+          <p:cNvPr id="4" name="Slide Number Placeholder 3"/>
+          <p:cNvSpPr>
+            <a:spLocks noGrp="1"/>
+          </p:cNvSpPr>
+          <p:nvPr>
+            <p:ph type="sldNum" idx="5" sz="quarter"/>
+          </p:nvPr>
+        </p:nvSpPr>
+        <p:spPr/>
+      </p:sp>
+    </p:spTree>
+  </p:cSld>
+  <p:clrMapOvr>
+    <a:masterClrMapping/>
+  </p:clrMapOvr>
+</p:notes>
+</file>
+
+<file path=ppt/notesSlides/notesSlide46.xml><?xml version="1.0" encoding="utf-8"?>
+<p:notes xmlns:a="http://schemas.openxmlformats.org/drawingml/2006/main" xmlns:p="http://schemas.openxmlformats.org/presentationml/2006/main" xmlns:r="http://schemas.openxmlformats.org/officeDocument/2006/relationships">
+  <p:cSld>
+    <p:spTree>
+      <p:nvGrpSpPr>
+        <p:cNvPr id="1" name=""/>
+        <p:cNvGrpSpPr/>
+        <p:nvPr/>
+      </p:nvGrpSpPr>
+      <p:grpSpPr>
+        <a:xfrm>
+          <a:off x="0" y="0"/>
+          <a:ext cx="0" cy="0"/>
+          <a:chOff x="0" y="0"/>
+          <a:chExt cx="0" cy="0"/>
+        </a:xfrm>
+      </p:grpSpPr>
+      <p:sp>
+        <p:nvSpPr>
+          <p:cNvPr id="2" name="Slide Image Placeholder 1"/>
+          <p:cNvSpPr>
+            <a:spLocks noGrp="1"/>
+          </p:cNvSpPr>
+          <p:nvPr>
+            <p:ph type="sldImg" idx="2"/>
+          </p:nvPr>
+        </p:nvSpPr>
+        <p:spPr/>
+      </p:sp>
+      <p:sp>
+        <p:nvSpPr>
+          <p:cNvPr id="3" name="Notes Placeholder 2"/>
+          <p:cNvSpPr>
+            <a:spLocks noGrp="1"/>
+          </p:cNvSpPr>
+          <p:nvPr>
+            <p:ph type="body" idx="3" sz="quarter"/>
+          </p:nvPr>
+        </p:nvSpPr>
+        <p:spPr/>
+        <p:txBody>
+          <a:bodyPr/>
+          <a:lstStyle/>
+          <a:p>
+            <a:r>
+              <a:t>TIMING: 0 seconds</a:t>
+            </a:r>
+          </a:p>
+          <a:p>
+            <a:r>
+              <a:t>KEY MESSAGE: Backup evidence: soak request-level JMeter results.</a:t>
+            </a:r>
+          </a:p>
+          <a:p/>
+          <a:p>
+            <a:r>
+              <a:t>SCRIPT:</a:t>
+            </a:r>
+          </a:p>
+          <a:p>
+            <a:r>
+              <a:t>The pooled Total p95 fell, but nine of ten individual request p95 values rose. Total p95 is a pooled percentile, not the average of the request p95 values. Only profit-loss had a lower request p95. All requests had zero failures before and after. The before/after sample count matches for every request. Point to the requested endpoint in this table, then to the native soak dashboards on slide 41 if asked for the tool view.</a:t>
+            </a:r>
+          </a:p>
+          <a:p/>
+          <a:p>
+            <a:r>
+              <a:t>SOURCE: Fresh JMeter baseline/remediation statistics.json; Appendix L Figures L.12 and L.17</a:t>
+            </a:r>
+          </a:p>
+        </p:txBody>
+      </p:sp>
+      <p:sp>
+        <p:nvSpPr>
+          <p:cNvPr id="4" name="Slide Number Placeholder 3"/>
+          <p:cNvSpPr>
+            <a:spLocks noGrp="1"/>
+          </p:cNvSpPr>
+          <p:nvPr>
+            <p:ph type="sldNum" idx="5" sz="quarter"/>
+          </p:nvPr>
+        </p:nvSpPr>
+        <p:spPr/>
+      </p:sp>
+    </p:spTree>
+  </p:cSld>
+  <p:clrMapOvr>
+    <a:masterClrMapping/>
+  </p:clrMapOvr>
+</p:notes>
+</file>
+
+<file path=ppt/notesSlides/notesSlide47.xml><?xml version="1.0" encoding="utf-8"?>
+<p:notes xmlns:a="http://schemas.openxmlformats.org/drawingml/2006/main" xmlns:p="http://schemas.openxmlformats.org/presentationml/2006/main" xmlns:r="http://schemas.openxmlformats.org/officeDocument/2006/relationships">
+  <p:cSld>
+    <p:spTree>
+      <p:nvGrpSpPr>
+        <p:cNvPr id="1" name=""/>
+        <p:cNvGrpSpPr/>
+        <p:nvPr/>
+      </p:nvGrpSpPr>
+      <p:grpSpPr>
+        <a:xfrm>
+          <a:off x="0" y="0"/>
+          <a:ext cx="0" cy="0"/>
+          <a:chOff x="0" y="0"/>
+          <a:chExt cx="0" cy="0"/>
+        </a:xfrm>
+      </p:grpSpPr>
+      <p:sp>
+        <p:nvSpPr>
+          <p:cNvPr id="2" name="Slide Image Placeholder 1"/>
+          <p:cNvSpPr>
+            <a:spLocks noGrp="1"/>
+          </p:cNvSpPr>
+          <p:nvPr>
+            <p:ph type="sldImg" idx="2"/>
+          </p:nvPr>
+        </p:nvSpPr>
+        <p:spPr/>
+      </p:sp>
+      <p:sp>
+        <p:nvSpPr>
+          <p:cNvPr id="3" name="Notes Placeholder 2"/>
+          <p:cNvSpPr>
+            <a:spLocks noGrp="1"/>
+          </p:cNvSpPr>
+          <p:nvPr>
+            <p:ph type="body" idx="3" sz="quarter"/>
+          </p:nvPr>
+        </p:nvSpPr>
+        <p:spPr/>
+        <p:txBody>
+          <a:bodyPr/>
+          <a:lstStyle/>
+          <a:p>
+            <a:r>
+              <a:t>TIMING: 0 seconds</a:t>
+            </a:r>
+          </a:p>
+          <a:p>
+            <a:r>
+              <a:t>KEY MESSAGE: Backup evidence: spike request-level JMeter results.</a:t>
+            </a:r>
+          </a:p>
+          <a:p/>
+          <a:p>
+            <a:r>
+              <a:t>SCRIPT:</a:t>
+            </a:r>
+          </a:p>
+          <a:p>
+            <a:r>
+              <a:t>All ten individual request p95 values fell in the spike run. The total failed samples fell from 218 to zero. The before/after sample count matches for every request. This is a burst-specific improvement, not proof that the core 100- and 500-user targets passed. Open the native spike dashboards on slide 42 if asked for the tool view.</a:t>
+            </a:r>
+          </a:p>
+          <a:p/>
+          <a:p>
+            <a:r>
+              <a:t>SOURCE: Fresh JMeter baseline/remediation statistics.json; Appendix L Figures L.13 and L.18</a:t>
             </a:r>
           </a:p>
         </p:txBody>
@@ -19508,7 +19694,7 @@
                 </a:solidFill>
                 <a:latin typeface="Arial"/>
               </a:rPr>
-              <a:t>Soak/spike p95 fell; core p95 rose</a:t>
+              <a:t>Pooled soak/spike p95 fell; core p95 rose</a:t>
             </a:r>
           </a:p>
         </p:txBody>
@@ -19620,7 +19806,7 @@
                 </a:solidFill>
                 <a:latin typeface="Arial"/>
               </a:rPr>
-              <a:t>Current report §4.4; fresh JMeter summary.json</a:t>
+              <a:t>Current report §4.4; fresh JMeter summaries and request statistics</a:t>
             </a:r>
           </a:p>
         </p:txBody>
@@ -19676,6 +19862,219 @@
         <p:spPr>
           <a:xfrm>
             <a:off x="731520" y="1554480"/>
+            <a:ext cx="5175504" cy="3401568"/>
+          </a:xfrm>
+          <a:prstGeom prst="roundRect">
+            <a:avLst/>
+          </a:prstGeom>
+          <a:solidFill>
+            <a:srgbClr val="FFF6E7"/>
+          </a:solidFill>
+          <a:ln w="12700">
+            <a:solidFill>
+              <a:srgbClr val="D8E0E9"/>
+            </a:solidFill>
+          </a:ln>
+        </p:spPr>
+        <p:style>
+          <a:lnRef idx="1">
+            <a:schemeClr val="accent1"/>
+          </a:lnRef>
+          <a:fillRef idx="3">
+            <a:schemeClr val="accent1"/>
+          </a:fillRef>
+          <a:effectRef idx="2">
+            <a:schemeClr val="accent1"/>
+          </a:effectRef>
+          <a:fontRef idx="minor">
+            <a:schemeClr val="lt1"/>
+          </a:fontRef>
+        </p:style>
+        <p:txBody>
+          <a:bodyPr rtlCol="0" anchor="ctr"/>
+          <a:lstStyle/>
+          <a:p>
+            <a:pPr algn="ctr"/>
+          </a:p>
+        </p:txBody>
+      </p:sp>
+      <p:sp>
+        <p:nvSpPr>
+          <p:cNvPr id="10" name="TextBox 9"/>
+          <p:cNvSpPr txBox="1"/>
+          <p:nvPr/>
+        </p:nvSpPr>
+        <p:spPr>
+          <a:xfrm>
+            <a:off x="1005840" y="1865376"/>
+            <a:ext cx="4626864" cy="292608"/>
+          </a:xfrm>
+          <a:prstGeom prst="rect">
+            <a:avLst/>
+          </a:prstGeom>
+          <a:noFill/>
+        </p:spPr>
+        <p:txBody>
+          <a:bodyPr wrap="square" lIns="18288" rIns="18288" tIns="18288" bIns="18288" anchor="ctr">
+            <a:spAutoFit/>
+          </a:bodyPr>
+          <a:lstStyle/>
+          <a:p>
+            <a:pPr algn="l">
+              <a:spcBef>
+                <a:spcPts val="0"/>
+              </a:spcBef>
+              <a:spcAft>
+                <a:spcPts val="0"/>
+              </a:spcAft>
+            </a:pPr>
+            <a:r>
+              <a:rPr sz="1600" b="1">
+                <a:solidFill>
+                  <a:srgbClr val="BE7414"/>
+                </a:solidFill>
+                <a:latin typeface="Arial"/>
+              </a:rPr>
+              <a:t>SOAK TOTAL p95</a:t>
+            </a:r>
+          </a:p>
+        </p:txBody>
+      </p:sp>
+      <p:sp>
+        <p:nvSpPr>
+          <p:cNvPr id="11" name="TextBox 10"/>
+          <p:cNvSpPr txBox="1"/>
+          <p:nvPr/>
+        </p:nvSpPr>
+        <p:spPr>
+          <a:xfrm>
+            <a:off x="1005840" y="2450592"/>
+            <a:ext cx="4617720" cy="566928"/>
+          </a:xfrm>
+          <a:prstGeom prst="rect">
+            <a:avLst/>
+          </a:prstGeom>
+          <a:noFill/>
+        </p:spPr>
+        <p:txBody>
+          <a:bodyPr wrap="square" lIns="18288" rIns="18288" tIns="18288" bIns="18288" anchor="ctr">
+            <a:spAutoFit/>
+          </a:bodyPr>
+          <a:lstStyle/>
+          <a:p>
+            <a:pPr algn="l">
+              <a:spcBef>
+                <a:spcPts val="0"/>
+              </a:spcBef>
+              <a:spcAft>
+                <a:spcPts val="0"/>
+              </a:spcAft>
+            </a:pPr>
+            <a:r>
+              <a:rPr sz="3000" b="1">
+                <a:solidFill>
+                  <a:srgbClr val="BE7414"/>
+                </a:solidFill>
+                <a:latin typeface="Arial"/>
+              </a:rPr>
+              <a:t>443.95 → 171 ms</a:t>
+            </a:r>
+          </a:p>
+        </p:txBody>
+      </p:sp>
+      <p:sp>
+        <p:nvSpPr>
+          <p:cNvPr id="12" name="TextBox 11"/>
+          <p:cNvSpPr txBox="1"/>
+          <p:nvPr/>
+        </p:nvSpPr>
+        <p:spPr>
+          <a:xfrm>
+            <a:off x="1005840" y="3337560"/>
+            <a:ext cx="4617720" cy="475488"/>
+          </a:xfrm>
+          <a:prstGeom prst="rect">
+            <a:avLst/>
+          </a:prstGeom>
+          <a:noFill/>
+        </p:spPr>
+        <p:txBody>
+          <a:bodyPr wrap="square" lIns="18288" rIns="18288" tIns="18288" bIns="18288" anchor="ctr">
+            <a:spAutoFit/>
+          </a:bodyPr>
+          <a:lstStyle/>
+          <a:p>
+            <a:pPr algn="l">
+              <a:spcBef>
+                <a:spcPts val="0"/>
+              </a:spcBef>
+              <a:spcAft>
+                <a:spcPts val="0"/>
+              </a:spcAft>
+            </a:pPr>
+            <a:r>
+              <a:rPr sz="2100" b="0">
+                <a:solidFill>
+                  <a:srgbClr val="252B33"/>
+                </a:solidFill>
+                <a:latin typeface="Arial"/>
+              </a:rPr>
+              <a:t>61% lower on the fresh run</a:t>
+            </a:r>
+          </a:p>
+        </p:txBody>
+      </p:sp>
+      <p:sp>
+        <p:nvSpPr>
+          <p:cNvPr id="13" name="TextBox 12"/>
+          <p:cNvSpPr txBox="1"/>
+          <p:nvPr/>
+        </p:nvSpPr>
+        <p:spPr>
+          <a:xfrm>
+            <a:off x="1005840" y="4059936"/>
+            <a:ext cx="4617720" cy="612648"/>
+          </a:xfrm>
+          <a:prstGeom prst="rect">
+            <a:avLst/>
+          </a:prstGeom>
+          <a:noFill/>
+        </p:spPr>
+        <p:txBody>
+          <a:bodyPr wrap="square" lIns="18288" rIns="18288" tIns="18288" bIns="18288" anchor="ctr">
+            <a:spAutoFit/>
+          </a:bodyPr>
+          <a:lstStyle/>
+          <a:p>
+            <a:pPr algn="l">
+              <a:spcBef>
+                <a:spcPts val="0"/>
+              </a:spcBef>
+              <a:spcAft>
+                <a:spcPts val="0"/>
+              </a:spcAft>
+            </a:pPr>
+            <a:r>
+              <a:rPr sz="1600" b="0">
+                <a:solidFill>
+                  <a:srgbClr val="5B6874"/>
+                </a:solidFill>
+                <a:latin typeface="Arial"/>
+              </a:rPr>
+              <a:t>p99 lower; average time and throughput worse</a:t>
+            </a:r>
+          </a:p>
+        </p:txBody>
+      </p:sp>
+      <p:sp>
+        <p:nvSpPr>
+          <p:cNvPr id="14" name="Rounded Rectangle 13"/>
+          <p:cNvSpPr/>
+          <p:nvPr/>
+        </p:nvSpPr>
+        <p:spPr>
+          <a:xfrm>
+            <a:off x="6254496" y="1554480"/>
             <a:ext cx="5175504" cy="3401568"/>
           </a:xfrm>
           <a:prstGeom prst="roundRect">
@@ -19714,219 +20113,6 @@
       </p:sp>
       <p:sp>
         <p:nvSpPr>
-          <p:cNvPr id="10" name="TextBox 9"/>
-          <p:cNvSpPr txBox="1"/>
-          <p:nvPr/>
-        </p:nvSpPr>
-        <p:spPr>
-          <a:xfrm>
-            <a:off x="1005840" y="1865376"/>
-            <a:ext cx="4626864" cy="292608"/>
-          </a:xfrm>
-          <a:prstGeom prst="rect">
-            <a:avLst/>
-          </a:prstGeom>
-          <a:noFill/>
-        </p:spPr>
-        <p:txBody>
-          <a:bodyPr wrap="square" lIns="18288" rIns="18288" tIns="18288" bIns="18288" anchor="ctr">
-            <a:spAutoFit/>
-          </a:bodyPr>
-          <a:lstStyle/>
-          <a:p>
-            <a:pPr algn="l">
-              <a:spcBef>
-                <a:spcPts val="0"/>
-              </a:spcBef>
-              <a:spcAft>
-                <a:spcPts val="0"/>
-              </a:spcAft>
-            </a:pPr>
-            <a:r>
-              <a:rPr sz="1600" b="1">
-                <a:solidFill>
-                  <a:srgbClr val="246F46"/>
-                </a:solidFill>
-                <a:latin typeface="Arial"/>
-              </a:rPr>
-              <a:t>SOAK TOTAL p95</a:t>
-            </a:r>
-          </a:p>
-        </p:txBody>
-      </p:sp>
-      <p:sp>
-        <p:nvSpPr>
-          <p:cNvPr id="11" name="TextBox 10"/>
-          <p:cNvSpPr txBox="1"/>
-          <p:nvPr/>
-        </p:nvSpPr>
-        <p:spPr>
-          <a:xfrm>
-            <a:off x="1005840" y="2450592"/>
-            <a:ext cx="4617720" cy="566928"/>
-          </a:xfrm>
-          <a:prstGeom prst="rect">
-            <a:avLst/>
-          </a:prstGeom>
-          <a:noFill/>
-        </p:spPr>
-        <p:txBody>
-          <a:bodyPr wrap="square" lIns="18288" rIns="18288" tIns="18288" bIns="18288" anchor="ctr">
-            <a:spAutoFit/>
-          </a:bodyPr>
-          <a:lstStyle/>
-          <a:p>
-            <a:pPr algn="l">
-              <a:spcBef>
-                <a:spcPts val="0"/>
-              </a:spcBef>
-              <a:spcAft>
-                <a:spcPts val="0"/>
-              </a:spcAft>
-            </a:pPr>
-            <a:r>
-              <a:rPr sz="3000" b="1">
-                <a:solidFill>
-                  <a:srgbClr val="246F46"/>
-                </a:solidFill>
-                <a:latin typeface="Arial"/>
-              </a:rPr>
-              <a:t>443.95 → 171 ms</a:t>
-            </a:r>
-          </a:p>
-        </p:txBody>
-      </p:sp>
-      <p:sp>
-        <p:nvSpPr>
-          <p:cNvPr id="12" name="TextBox 11"/>
-          <p:cNvSpPr txBox="1"/>
-          <p:nvPr/>
-        </p:nvSpPr>
-        <p:spPr>
-          <a:xfrm>
-            <a:off x="1005840" y="3337560"/>
-            <a:ext cx="4617720" cy="475488"/>
-          </a:xfrm>
-          <a:prstGeom prst="rect">
-            <a:avLst/>
-          </a:prstGeom>
-          <a:noFill/>
-        </p:spPr>
-        <p:txBody>
-          <a:bodyPr wrap="square" lIns="18288" rIns="18288" tIns="18288" bIns="18288" anchor="ctr">
-            <a:spAutoFit/>
-          </a:bodyPr>
-          <a:lstStyle/>
-          <a:p>
-            <a:pPr algn="l">
-              <a:spcBef>
-                <a:spcPts val="0"/>
-              </a:spcBef>
-              <a:spcAft>
-                <a:spcPts val="0"/>
-              </a:spcAft>
-            </a:pPr>
-            <a:r>
-              <a:rPr sz="2100" b="0">
-                <a:solidFill>
-                  <a:srgbClr val="252B33"/>
-                </a:solidFill>
-                <a:latin typeface="Arial"/>
-              </a:rPr>
-              <a:t>61% lower on the fresh run</a:t>
-            </a:r>
-          </a:p>
-        </p:txBody>
-      </p:sp>
-      <p:sp>
-        <p:nvSpPr>
-          <p:cNvPr id="13" name="TextBox 12"/>
-          <p:cNvSpPr txBox="1"/>
-          <p:nvPr/>
-        </p:nvSpPr>
-        <p:spPr>
-          <a:xfrm>
-            <a:off x="1005840" y="4059936"/>
-            <a:ext cx="4617720" cy="612648"/>
-          </a:xfrm>
-          <a:prstGeom prst="rect">
-            <a:avLst/>
-          </a:prstGeom>
-          <a:noFill/>
-        </p:spPr>
-        <p:txBody>
-          <a:bodyPr wrap="square" lIns="18288" rIns="18288" tIns="18288" bIns="18288" anchor="ctr">
-            <a:spAutoFit/>
-          </a:bodyPr>
-          <a:lstStyle/>
-          <a:p>
-            <a:pPr algn="l">
-              <a:spcBef>
-                <a:spcPts val="0"/>
-              </a:spcBef>
-              <a:spcAft>
-                <a:spcPts val="0"/>
-              </a:spcAft>
-            </a:pPr>
-            <a:r>
-              <a:rPr sz="1600" b="0">
-                <a:solidFill>
-                  <a:srgbClr val="5B6874"/>
-                </a:solidFill>
-                <a:latin typeface="Arial"/>
-              </a:rPr>
-              <a:t>p99 lower; average time and throughput worse</a:t>
-            </a:r>
-          </a:p>
-        </p:txBody>
-      </p:sp>
-      <p:sp>
-        <p:nvSpPr>
-          <p:cNvPr id="14" name="Rounded Rectangle 13"/>
-          <p:cNvSpPr/>
-          <p:nvPr/>
-        </p:nvSpPr>
-        <p:spPr>
-          <a:xfrm>
-            <a:off x="6254496" y="1554480"/>
-            <a:ext cx="5175504" cy="3401568"/>
-          </a:xfrm>
-          <a:prstGeom prst="roundRect">
-            <a:avLst/>
-          </a:prstGeom>
-          <a:solidFill>
-            <a:srgbClr val="E8F7EE"/>
-          </a:solidFill>
-          <a:ln w="12700">
-            <a:solidFill>
-              <a:srgbClr val="D8E0E9"/>
-            </a:solidFill>
-          </a:ln>
-        </p:spPr>
-        <p:style>
-          <a:lnRef idx="1">
-            <a:schemeClr val="accent1"/>
-          </a:lnRef>
-          <a:fillRef idx="3">
-            <a:schemeClr val="accent1"/>
-          </a:fillRef>
-          <a:effectRef idx="2">
-            <a:schemeClr val="accent1"/>
-          </a:effectRef>
-          <a:fontRef idx="minor">
-            <a:schemeClr val="lt1"/>
-          </a:fontRef>
-        </p:style>
-        <p:txBody>
-          <a:bodyPr rtlCol="0" anchor="ctr"/>
-          <a:lstStyle/>
-          <a:p>
-            <a:pPr algn="ctr"/>
-          </a:p>
-        </p:txBody>
-      </p:sp>
-      <p:sp>
-        <p:nvSpPr>
           <p:cNvPr id="15" name="TextBox 14"/>
           <p:cNvSpPr txBox="1"/>
           <p:nvPr/>
@@ -20131,6 +20317,48 @@
                 <a:latin typeface="Arial"/>
               </a:rPr>
               <a:t>Core 50, 100, and 500 VU p95 all worsened; these separate gains do not reverse that result.</a:t>
+            </a:r>
+          </a:p>
+        </p:txBody>
+      </p:sp>
+      <p:sp>
+        <p:nvSpPr>
+          <p:cNvPr id="20" name="TextBox 19"/>
+          <p:cNvSpPr txBox="1"/>
+          <p:nvPr/>
+        </p:nvSpPr>
+        <p:spPr>
+          <a:xfrm>
+            <a:off x="768096" y="5833872"/>
+            <a:ext cx="10698480" cy="356616"/>
+          </a:xfrm>
+          <a:prstGeom prst="rect">
+            <a:avLst/>
+          </a:prstGeom>
+          <a:noFill/>
+        </p:spPr>
+        <p:txBody>
+          <a:bodyPr wrap="square" lIns="18288" rIns="18288" tIns="18288" bIns="18288" anchor="ctr">
+            <a:spAutoFit/>
+          </a:bodyPr>
+          <a:lstStyle/>
+          <a:p>
+            <a:pPr algn="l">
+              <a:spcBef>
+                <a:spcPts val="0"/>
+              </a:spcBef>
+              <a:spcAft>
+                <a:spcPts val="0"/>
+              </a:spcAft>
+            </a:pPr>
+            <a:r>
+              <a:rPr sz="1600" b="1">
+                <a:solidFill>
+                  <a:srgbClr val="BE7414"/>
+                </a:solidFill>
+                <a:latin typeface="Arial"/>
+              </a:rPr>
+              <a:t>Soak: 9 of 10 request p95 values higher · Spike: all 10 request p95 values lower.</a:t>
             </a:r>
           </a:p>
         </p:txBody>
@@ -22247,7 +22475,7 @@
                           </a:solidFill>
                           <a:latin typeface="Arial"/>
                         </a:rPr>
-                        <a:t>Improved separately</a:t>
+                        <a:t>Total p95 lower</a:t>
                       </a:r>
                     </a:p>
                   </a:txBody>
@@ -22274,7 +22502,7 @@
                           </a:solidFill>
                           <a:latin typeface="Arial"/>
                         </a:rPr>
-                        <a:t>Tail p95 fell; other measures were mixed</a:t>
+                        <a:t>Soak: 9/10 requests higher; spike: 10/10 lower</a:t>
                       </a:r>
                     </a:p>
                   </a:txBody>
@@ -39815,6 +40043,4136 @@
 </p:sld>
 </file>
 
+<file path=ppt/slides/slide46.xml><?xml version="1.0" encoding="utf-8"?>
+<p:sld xmlns:a="http://schemas.openxmlformats.org/drawingml/2006/main" xmlns:p="http://schemas.openxmlformats.org/presentationml/2006/main" xmlns:r="http://schemas.openxmlformats.org/officeDocument/2006/relationships">
+  <p:cSld>
+    <p:bg>
+      <p:bgPr>
+        <a:solidFill>
+          <a:srgbClr val="F7F9FC"/>
+        </a:solidFill>
+        <a:effectLst/>
+      </p:bgPr>
+    </p:bg>
+    <p:spTree>
+      <p:nvGrpSpPr>
+        <p:cNvPr id="1" name=""/>
+        <p:cNvGrpSpPr/>
+        <p:nvPr/>
+      </p:nvGrpSpPr>
+      <p:grpSpPr/>
+      <p:sp>
+        <p:nvSpPr>
+          <p:cNvPr id="2" name="Rectangle 1"/>
+          <p:cNvSpPr/>
+          <p:nvPr/>
+        </p:nvSpPr>
+        <p:spPr>
+          <a:xfrm>
+            <a:off x="0" y="0"/>
+            <a:ext cx="146304" cy="6858000"/>
+          </a:xfrm>
+          <a:prstGeom prst="rect">
+            <a:avLst/>
+          </a:prstGeom>
+          <a:solidFill>
+            <a:srgbClr val="BE7414"/>
+          </a:solidFill>
+          <a:ln>
+            <a:noFill/>
+          </a:ln>
+        </p:spPr>
+        <p:style>
+          <a:lnRef idx="1">
+            <a:schemeClr val="accent1"/>
+          </a:lnRef>
+          <a:fillRef idx="3">
+            <a:schemeClr val="accent1"/>
+          </a:fillRef>
+          <a:effectRef idx="2">
+            <a:schemeClr val="accent1"/>
+          </a:effectRef>
+          <a:fontRef idx="minor">
+            <a:schemeClr val="lt1"/>
+          </a:fontRef>
+        </p:style>
+        <p:txBody>
+          <a:bodyPr rtlCol="0" anchor="ctr"/>
+          <a:lstStyle/>
+          <a:p>
+            <a:pPr algn="ctr"/>
+          </a:p>
+        </p:txBody>
+      </p:sp>
+      <p:sp>
+        <p:nvSpPr>
+          <p:cNvPr id="3" name="TextBox 2"/>
+          <p:cNvSpPr txBox="1"/>
+          <p:nvPr/>
+        </p:nvSpPr>
+        <p:spPr>
+          <a:xfrm>
+            <a:off x="585216" y="201168"/>
+            <a:ext cx="10881360" cy="219456"/>
+          </a:xfrm>
+          <a:prstGeom prst="rect">
+            <a:avLst/>
+          </a:prstGeom>
+          <a:noFill/>
+        </p:spPr>
+        <p:txBody>
+          <a:bodyPr wrap="square" lIns="18288" rIns="18288" tIns="18288" bIns="18288" anchor="ctr">
+            <a:spAutoFit/>
+          </a:bodyPr>
+          <a:lstStyle/>
+          <a:p>
+            <a:pPr algn="l">
+              <a:spcBef>
+                <a:spcPts val="0"/>
+              </a:spcBef>
+              <a:spcAft>
+                <a:spcPts val="0"/>
+              </a:spcAft>
+            </a:pPr>
+            <a:r>
+              <a:rPr sz="1100" b="1">
+                <a:solidFill>
+                  <a:srgbClr val="BE7414"/>
+                </a:solidFill>
+                <a:latin typeface="Arial"/>
+              </a:rPr>
+              <a:t>BACKUP EVIDENCE</a:t>
+            </a:r>
+          </a:p>
+        </p:txBody>
+      </p:sp>
+      <p:sp>
+        <p:nvSpPr>
+          <p:cNvPr id="4" name="TextBox 3"/>
+          <p:cNvSpPr txBox="1"/>
+          <p:nvPr/>
+        </p:nvSpPr>
+        <p:spPr>
+          <a:xfrm>
+            <a:off x="585216" y="502920"/>
+            <a:ext cx="10972800" cy="530352"/>
+          </a:xfrm>
+          <a:prstGeom prst="rect">
+            <a:avLst/>
+          </a:prstGeom>
+          <a:noFill/>
+        </p:spPr>
+        <p:txBody>
+          <a:bodyPr wrap="square" lIns="18288" rIns="18288" tIns="18288" bIns="18288" anchor="ctr">
+            <a:spAutoFit/>
+          </a:bodyPr>
+          <a:lstStyle/>
+          <a:p>
+            <a:pPr algn="l">
+              <a:spcBef>
+                <a:spcPts val="0"/>
+              </a:spcBef>
+              <a:spcAft>
+                <a:spcPts val="0"/>
+              </a:spcAft>
+            </a:pPr>
+            <a:r>
+              <a:rPr sz="2900" b="1">
+                <a:solidFill>
+                  <a:srgbClr val="252B33"/>
+                </a:solidFill>
+                <a:latin typeface="Arial"/>
+              </a:rPr>
+              <a:t>JMeter soak · every request</a:t>
+            </a:r>
+          </a:p>
+        </p:txBody>
+      </p:sp>
+      <p:cxnSp>
+        <p:nvCxnSpPr>
+          <p:cNvPr id="5" name="Connector 4"/>
+          <p:cNvCxnSpPr/>
+          <p:nvPr/>
+        </p:nvCxnSpPr>
+        <p:spPr>
+          <a:xfrm>
+            <a:off x="585216" y="1078992"/>
+            <a:ext cx="11000232" cy="0"/>
+          </a:xfrm>
+          <a:prstGeom prst="line">
+            <a:avLst/>
+          </a:prstGeom>
+          <a:ln w="12700">
+            <a:solidFill>
+              <a:srgbClr val="D8E0E9"/>
+            </a:solidFill>
+          </a:ln>
+        </p:spPr>
+        <p:style>
+          <a:lnRef idx="2">
+            <a:schemeClr val="accent1"/>
+          </a:lnRef>
+          <a:fillRef idx="0">
+            <a:schemeClr val="accent1"/>
+          </a:fillRef>
+          <a:effectRef idx="1">
+            <a:schemeClr val="accent1"/>
+          </a:effectRef>
+          <a:fontRef idx="minor">
+            <a:schemeClr val="tx1"/>
+          </a:fontRef>
+        </p:style>
+      </p:cxnSp>
+      <p:cxnSp>
+        <p:nvCxnSpPr>
+          <p:cNvPr id="6" name="Connector 5"/>
+          <p:cNvCxnSpPr/>
+          <p:nvPr/>
+        </p:nvCxnSpPr>
+        <p:spPr>
+          <a:xfrm>
+            <a:off x="585216" y="6428232"/>
+            <a:ext cx="11000232" cy="0"/>
+          </a:xfrm>
+          <a:prstGeom prst="line">
+            <a:avLst/>
+          </a:prstGeom>
+          <a:ln w="12700">
+            <a:solidFill>
+              <a:srgbClr val="D8E0E9"/>
+            </a:solidFill>
+          </a:ln>
+        </p:spPr>
+        <p:style>
+          <a:lnRef idx="2">
+            <a:schemeClr val="accent1"/>
+          </a:lnRef>
+          <a:fillRef idx="0">
+            <a:schemeClr val="accent1"/>
+          </a:fillRef>
+          <a:effectRef idx="1">
+            <a:schemeClr val="accent1"/>
+          </a:effectRef>
+          <a:fontRef idx="minor">
+            <a:schemeClr val="tx1"/>
+          </a:fontRef>
+        </p:style>
+      </p:cxnSp>
+      <p:sp>
+        <p:nvSpPr>
+          <p:cNvPr id="7" name="TextBox 6"/>
+          <p:cNvSpPr txBox="1"/>
+          <p:nvPr/>
+        </p:nvSpPr>
+        <p:spPr>
+          <a:xfrm>
+            <a:off x="585216" y="6473952"/>
+            <a:ext cx="10424160" cy="182880"/>
+          </a:xfrm>
+          <a:prstGeom prst="rect">
+            <a:avLst/>
+          </a:prstGeom>
+          <a:noFill/>
+        </p:spPr>
+        <p:txBody>
+          <a:bodyPr wrap="square" lIns="18288" rIns="18288" tIns="18288" bIns="18288" anchor="ctr">
+            <a:spAutoFit/>
+          </a:bodyPr>
+          <a:lstStyle/>
+          <a:p>
+            <a:pPr algn="l">
+              <a:spcBef>
+                <a:spcPts val="0"/>
+              </a:spcBef>
+              <a:spcAft>
+                <a:spcPts val="0"/>
+              </a:spcAft>
+            </a:pPr>
+            <a:r>
+              <a:rPr sz="1000" b="0">
+                <a:solidFill>
+                  <a:srgbClr val="5B6874"/>
+                </a:solidFill>
+                <a:latin typeface="Arial"/>
+              </a:rPr>
+              <a:t>Fresh JMeter baseline/remediation statistics.json; Appendix L Figures L.12 and L.17</a:t>
+            </a:r>
+          </a:p>
+        </p:txBody>
+      </p:sp>
+      <p:sp>
+        <p:nvSpPr>
+          <p:cNvPr id="8" name="TextBox 7"/>
+          <p:cNvSpPr txBox="1"/>
+          <p:nvPr/>
+        </p:nvSpPr>
+        <p:spPr>
+          <a:xfrm>
+            <a:off x="11119104" y="6473952"/>
+            <a:ext cx="438912" cy="182880"/>
+          </a:xfrm>
+          <a:prstGeom prst="rect">
+            <a:avLst/>
+          </a:prstGeom>
+          <a:noFill/>
+        </p:spPr>
+        <p:txBody>
+          <a:bodyPr wrap="square" lIns="18288" rIns="18288" tIns="18288" bIns="18288" anchor="ctr">
+            <a:spAutoFit/>
+          </a:bodyPr>
+          <a:lstStyle/>
+          <a:p>
+            <a:pPr algn="r">
+              <a:spcBef>
+                <a:spcPts val="0"/>
+              </a:spcBef>
+              <a:spcAft>
+                <a:spcPts val="0"/>
+              </a:spcAft>
+            </a:pPr>
+            <a:r>
+              <a:rPr sz="1100" b="1">
+                <a:solidFill>
+                  <a:srgbClr val="BE7414"/>
+                </a:solidFill>
+                <a:latin typeface="Arial"/>
+              </a:rPr>
+              <a:t>46</a:t>
+            </a:r>
+          </a:p>
+        </p:txBody>
+      </p:sp>
+      <p:graphicFrame>
+        <p:nvGraphicFramePr>
+          <p:cNvPr id="9" name="Table 8"/>
+          <p:cNvGraphicFramePr>
+            <a:graphicFrameLocks noGrp="1"/>
+          </p:cNvGraphicFramePr>
+          <p:nvPr/>
+        </p:nvGraphicFramePr>
+        <p:xfrm>
+          <a:off x="731520" y="1344168"/>
+          <a:ext cx="10716766" cy="4361688"/>
+        </p:xfrm>
+        <a:graphic>
+          <a:graphicData uri="http://schemas.openxmlformats.org/drawingml/2006/table">
+            <a:tbl>
+              <a:tblPr firstRow="1" bandRow="1">
+                <a:tableStyleId>{5C22544A-7EE6-4342-B048-85BDC9FD1C3A}</a:tableStyleId>
+              </a:tblPr>
+              <a:tblGrid>
+                <a:gridCol w="3965204"/>
+                <a:gridCol w="1821850"/>
+                <a:gridCol w="1821850"/>
+                <a:gridCol w="1607515"/>
+                <a:gridCol w="1500347"/>
+              </a:tblGrid>
+              <a:tr h="363474">
+                <a:tc>
+                  <a:txBody>
+                    <a:bodyPr/>
+                    <a:lstStyle/>
+                    <a:p>
+                      <a:pPr algn="l">
+                        <a:spcAft>
+                          <a:spcPts val="0"/>
+                        </a:spcAft>
+                      </a:pPr>
+                      <a:r>
+                        <a:rPr sz="1500" b="1">
+                          <a:solidFill>
+                            <a:srgbClr val="FFFFFF"/>
+                          </a:solidFill>
+                          <a:latin typeface="Arial"/>
+                        </a:rPr>
+                        <a:t>Request</a:t>
+                      </a:r>
+                    </a:p>
+                  </a:txBody>
+                  <a:tcPr marL="109728" marR="91440" marT="36576" marB="36576">
+                    <a:solidFill>
+                      <a:srgbClr val="252B33"/>
+                    </a:solidFill>
+                  </a:tcPr>
+                </a:tc>
+                <a:tc>
+                  <a:txBody>
+                    <a:bodyPr/>
+                    <a:lstStyle/>
+                    <a:p>
+                      <a:pPr algn="l">
+                        <a:spcAft>
+                          <a:spcPts val="0"/>
+                        </a:spcAft>
+                      </a:pPr>
+                      <a:r>
+                        <a:rPr sz="1500" b="1">
+                          <a:solidFill>
+                            <a:srgbClr val="FFFFFF"/>
+                          </a:solidFill>
+                          <a:latin typeface="Arial"/>
+                        </a:rPr>
+                        <a:t>Baseline p95</a:t>
+                      </a:r>
+                    </a:p>
+                  </a:txBody>
+                  <a:tcPr marL="109728" marR="91440" marT="36576" marB="36576">
+                    <a:solidFill>
+                      <a:srgbClr val="252B33"/>
+                    </a:solidFill>
+                  </a:tcPr>
+                </a:tc>
+                <a:tc>
+                  <a:txBody>
+                    <a:bodyPr/>
+                    <a:lstStyle/>
+                    <a:p>
+                      <a:pPr algn="l">
+                        <a:spcAft>
+                          <a:spcPts val="0"/>
+                        </a:spcAft>
+                      </a:pPr>
+                      <a:r>
+                        <a:rPr sz="1500" b="1">
+                          <a:solidFill>
+                            <a:srgbClr val="FFFFFF"/>
+                          </a:solidFill>
+                          <a:latin typeface="Arial"/>
+                        </a:rPr>
+                        <a:t>After p95</a:t>
+                      </a:r>
+                    </a:p>
+                  </a:txBody>
+                  <a:tcPr marL="109728" marR="91440" marT="36576" marB="36576">
+                    <a:solidFill>
+                      <a:srgbClr val="252B33"/>
+                    </a:solidFill>
+                  </a:tcPr>
+                </a:tc>
+                <a:tc>
+                  <a:txBody>
+                    <a:bodyPr/>
+                    <a:lstStyle/>
+                    <a:p>
+                      <a:pPr algn="l">
+                        <a:spcAft>
+                          <a:spcPts val="0"/>
+                        </a:spcAft>
+                      </a:pPr>
+                      <a:r>
+                        <a:rPr sz="1500" b="1">
+                          <a:solidFill>
+                            <a:srgbClr val="FFFFFF"/>
+                          </a:solidFill>
+                          <a:latin typeface="Arial"/>
+                        </a:rPr>
+                        <a:t>Failures B→A</a:t>
+                      </a:r>
+                    </a:p>
+                  </a:txBody>
+                  <a:tcPr marL="109728" marR="91440" marT="36576" marB="36576">
+                    <a:solidFill>
+                      <a:srgbClr val="252B33"/>
+                    </a:solidFill>
+                  </a:tcPr>
+                </a:tc>
+                <a:tc>
+                  <a:txBody>
+                    <a:bodyPr/>
+                    <a:lstStyle/>
+                    <a:p>
+                      <a:pPr algn="l">
+                        <a:spcAft>
+                          <a:spcPts val="0"/>
+                        </a:spcAft>
+                      </a:pPr>
+                      <a:r>
+                        <a:rPr sz="1500" b="1">
+                          <a:solidFill>
+                            <a:srgbClr val="FFFFFF"/>
+                          </a:solidFill>
+                          <a:latin typeface="Arial"/>
+                        </a:rPr>
+                        <a:t>p95</a:t>
+                      </a:r>
+                    </a:p>
+                  </a:txBody>
+                  <a:tcPr marL="109728" marR="91440" marT="36576" marB="36576">
+                    <a:solidFill>
+                      <a:srgbClr val="252B33"/>
+                    </a:solidFill>
+                  </a:tcPr>
+                </a:tc>
+              </a:tr>
+              <a:tr h="363474">
+                <a:tc>
+                  <a:txBody>
+                    <a:bodyPr/>
+                    <a:lstStyle/>
+                    <a:p>
+                      <a:pPr algn="l">
+                        <a:spcAft>
+                          <a:spcPts val="0"/>
+                        </a:spcAft>
+                      </a:pPr>
+                      <a:r>
+                        <a:rPr sz="1500" b="0">
+                          <a:solidFill>
+                            <a:srgbClr val="252B33"/>
+                          </a:solidFill>
+                          <a:latin typeface="Arial"/>
+                        </a:rPr>
+                        <a:t>Total</a:t>
+                      </a:r>
+                    </a:p>
+                  </a:txBody>
+                  <a:tcPr marL="109728" marR="91440" marT="36576" marB="36576">
+                    <a:solidFill>
+                      <a:srgbClr val="FFFFFF"/>
+                    </a:solidFill>
+                  </a:tcPr>
+                </a:tc>
+                <a:tc>
+                  <a:txBody>
+                    <a:bodyPr/>
+                    <a:lstStyle/>
+                    <a:p>
+                      <a:pPr algn="l">
+                        <a:spcAft>
+                          <a:spcPts val="0"/>
+                        </a:spcAft>
+                      </a:pPr>
+                      <a:r>
+                        <a:rPr sz="1500" b="0">
+                          <a:solidFill>
+                            <a:srgbClr val="252B33"/>
+                          </a:solidFill>
+                          <a:latin typeface="Arial"/>
+                        </a:rPr>
+                        <a:t>443.95</a:t>
+                      </a:r>
+                    </a:p>
+                  </a:txBody>
+                  <a:tcPr marL="109728" marR="91440" marT="36576" marB="36576">
+                    <a:solidFill>
+                      <a:srgbClr val="FFFFFF"/>
+                    </a:solidFill>
+                  </a:tcPr>
+                </a:tc>
+                <a:tc>
+                  <a:txBody>
+                    <a:bodyPr/>
+                    <a:lstStyle/>
+                    <a:p>
+                      <a:pPr algn="l">
+                        <a:spcAft>
+                          <a:spcPts val="0"/>
+                        </a:spcAft>
+                      </a:pPr>
+                      <a:r>
+                        <a:rPr sz="1500" b="0">
+                          <a:solidFill>
+                            <a:srgbClr val="252B33"/>
+                          </a:solidFill>
+                          <a:latin typeface="Arial"/>
+                        </a:rPr>
+                        <a:t>171.00</a:t>
+                      </a:r>
+                    </a:p>
+                  </a:txBody>
+                  <a:tcPr marL="109728" marR="91440" marT="36576" marB="36576">
+                    <a:solidFill>
+                      <a:srgbClr val="FFFFFF"/>
+                    </a:solidFill>
+                  </a:tcPr>
+                </a:tc>
+                <a:tc>
+                  <a:txBody>
+                    <a:bodyPr/>
+                    <a:lstStyle/>
+                    <a:p>
+                      <a:pPr algn="l">
+                        <a:spcAft>
+                          <a:spcPts val="0"/>
+                        </a:spcAft>
+                      </a:pPr>
+                      <a:r>
+                        <a:rPr sz="1500" b="0">
+                          <a:solidFill>
+                            <a:srgbClr val="252B33"/>
+                          </a:solidFill>
+                          <a:latin typeface="Arial"/>
+                        </a:rPr>
+                        <a:t>0→0</a:t>
+                      </a:r>
+                    </a:p>
+                  </a:txBody>
+                  <a:tcPr marL="109728" marR="91440" marT="36576" marB="36576">
+                    <a:solidFill>
+                      <a:srgbClr val="FFFFFF"/>
+                    </a:solidFill>
+                  </a:tcPr>
+                </a:tc>
+                <a:tc>
+                  <a:txBody>
+                    <a:bodyPr/>
+                    <a:lstStyle/>
+                    <a:p>
+                      <a:pPr algn="l">
+                        <a:spcAft>
+                          <a:spcPts val="0"/>
+                        </a:spcAft>
+                      </a:pPr>
+                      <a:r>
+                        <a:rPr sz="1500" b="1">
+                          <a:solidFill>
+                            <a:srgbClr val="246F46"/>
+                          </a:solidFill>
+                          <a:latin typeface="Arial"/>
+                        </a:rPr>
+                        <a:t>Lower</a:t>
+                      </a:r>
+                    </a:p>
+                  </a:txBody>
+                  <a:tcPr marL="109728" marR="91440" marT="36576" marB="36576">
+                    <a:solidFill>
+                      <a:srgbClr val="FFFFFF"/>
+                    </a:solidFill>
+                  </a:tcPr>
+                </a:tc>
+              </a:tr>
+              <a:tr h="363474">
+                <a:tc>
+                  <a:txBody>
+                    <a:bodyPr/>
+                    <a:lstStyle/>
+                    <a:p>
+                      <a:pPr algn="l">
+                        <a:spcAft>
+                          <a:spcPts val="0"/>
+                        </a:spcAft>
+                      </a:pPr>
+                      <a:r>
+                        <a:rPr sz="1500" b="0">
+                          <a:solidFill>
+                            <a:srgbClr val="252B33"/>
+                          </a:solidFill>
+                          <a:latin typeface="Arial"/>
+                        </a:rPr>
+                        <a:t>GET /accounts</a:t>
+                      </a:r>
+                    </a:p>
+                  </a:txBody>
+                  <a:tcPr marL="109728" marR="91440" marT="36576" marB="36576">
+                    <a:solidFill>
+                      <a:srgbClr val="F7F9FC"/>
+                    </a:solidFill>
+                  </a:tcPr>
+                </a:tc>
+                <a:tc>
+                  <a:txBody>
+                    <a:bodyPr/>
+                    <a:lstStyle/>
+                    <a:p>
+                      <a:pPr algn="l">
+                        <a:spcAft>
+                          <a:spcPts val="0"/>
+                        </a:spcAft>
+                      </a:pPr>
+                      <a:r>
+                        <a:rPr sz="1500" b="0">
+                          <a:solidFill>
+                            <a:srgbClr val="252B33"/>
+                          </a:solidFill>
+                          <a:latin typeface="Arial"/>
+                        </a:rPr>
+                        <a:t>47.95</a:t>
+                      </a:r>
+                    </a:p>
+                  </a:txBody>
+                  <a:tcPr marL="109728" marR="91440" marT="36576" marB="36576">
+                    <a:solidFill>
+                      <a:srgbClr val="F7F9FC"/>
+                    </a:solidFill>
+                  </a:tcPr>
+                </a:tc>
+                <a:tc>
+                  <a:txBody>
+                    <a:bodyPr/>
+                    <a:lstStyle/>
+                    <a:p>
+                      <a:pPr algn="l">
+                        <a:spcAft>
+                          <a:spcPts val="0"/>
+                        </a:spcAft>
+                      </a:pPr>
+                      <a:r>
+                        <a:rPr sz="1500" b="0">
+                          <a:solidFill>
+                            <a:srgbClr val="252B33"/>
+                          </a:solidFill>
+                          <a:latin typeface="Arial"/>
+                        </a:rPr>
+                        <a:t>1,360.85</a:t>
+                      </a:r>
+                    </a:p>
+                  </a:txBody>
+                  <a:tcPr marL="109728" marR="91440" marT="36576" marB="36576">
+                    <a:solidFill>
+                      <a:srgbClr val="F7F9FC"/>
+                    </a:solidFill>
+                  </a:tcPr>
+                </a:tc>
+                <a:tc>
+                  <a:txBody>
+                    <a:bodyPr/>
+                    <a:lstStyle/>
+                    <a:p>
+                      <a:pPr algn="l">
+                        <a:spcAft>
+                          <a:spcPts val="0"/>
+                        </a:spcAft>
+                      </a:pPr>
+                      <a:r>
+                        <a:rPr sz="1500" b="0">
+                          <a:solidFill>
+                            <a:srgbClr val="252B33"/>
+                          </a:solidFill>
+                          <a:latin typeface="Arial"/>
+                        </a:rPr>
+                        <a:t>0→0</a:t>
+                      </a:r>
+                    </a:p>
+                  </a:txBody>
+                  <a:tcPr marL="109728" marR="91440" marT="36576" marB="36576">
+                    <a:solidFill>
+                      <a:srgbClr val="F7F9FC"/>
+                    </a:solidFill>
+                  </a:tcPr>
+                </a:tc>
+                <a:tc>
+                  <a:txBody>
+                    <a:bodyPr/>
+                    <a:lstStyle/>
+                    <a:p>
+                      <a:pPr algn="l">
+                        <a:spcAft>
+                          <a:spcPts val="0"/>
+                        </a:spcAft>
+                      </a:pPr>
+                      <a:r>
+                        <a:rPr sz="1500" b="1">
+                          <a:solidFill>
+                            <a:srgbClr val="B3373D"/>
+                          </a:solidFill>
+                          <a:latin typeface="Arial"/>
+                        </a:rPr>
+                        <a:t>Higher</a:t>
+                      </a:r>
+                    </a:p>
+                  </a:txBody>
+                  <a:tcPr marL="109728" marR="91440" marT="36576" marB="36576">
+                    <a:solidFill>
+                      <a:srgbClr val="F7F9FC"/>
+                    </a:solidFill>
+                  </a:tcPr>
+                </a:tc>
+              </a:tr>
+              <a:tr h="363474">
+                <a:tc>
+                  <a:txBody>
+                    <a:bodyPr/>
+                    <a:lstStyle/>
+                    <a:p>
+                      <a:pPr algn="l">
+                        <a:spcAft>
+                          <a:spcPts val="0"/>
+                        </a:spcAft>
+                      </a:pPr>
+                      <a:r>
+                        <a:rPr sz="1500" b="0">
+                          <a:solidFill>
+                            <a:srgbClr val="252B33"/>
+                          </a:solidFill>
+                          <a:latin typeface="Arial"/>
+                        </a:rPr>
+                        <a:t>GET /journal-entries</a:t>
+                      </a:r>
+                    </a:p>
+                  </a:txBody>
+                  <a:tcPr marL="109728" marR="91440" marT="36576" marB="36576">
+                    <a:solidFill>
+                      <a:srgbClr val="FFFFFF"/>
+                    </a:solidFill>
+                  </a:tcPr>
+                </a:tc>
+                <a:tc>
+                  <a:txBody>
+                    <a:bodyPr/>
+                    <a:lstStyle/>
+                    <a:p>
+                      <a:pPr algn="l">
+                        <a:spcAft>
+                          <a:spcPts val="0"/>
+                        </a:spcAft>
+                      </a:pPr>
+                      <a:r>
+                        <a:rPr sz="1500" b="0">
+                          <a:solidFill>
+                            <a:srgbClr val="252B33"/>
+                          </a:solidFill>
+                          <a:latin typeface="Arial"/>
+                        </a:rPr>
+                        <a:t>95.00</a:t>
+                      </a:r>
+                    </a:p>
+                  </a:txBody>
+                  <a:tcPr marL="109728" marR="91440" marT="36576" marB="36576">
+                    <a:solidFill>
+                      <a:srgbClr val="FFFFFF"/>
+                    </a:solidFill>
+                  </a:tcPr>
+                </a:tc>
+                <a:tc>
+                  <a:txBody>
+                    <a:bodyPr/>
+                    <a:lstStyle/>
+                    <a:p>
+                      <a:pPr algn="l">
+                        <a:spcAft>
+                          <a:spcPts val="0"/>
+                        </a:spcAft>
+                      </a:pPr>
+                      <a:r>
+                        <a:rPr sz="1500" b="0">
+                          <a:solidFill>
+                            <a:srgbClr val="252B33"/>
+                          </a:solidFill>
+                          <a:latin typeface="Arial"/>
+                        </a:rPr>
+                        <a:t>1,321.00</a:t>
+                      </a:r>
+                    </a:p>
+                  </a:txBody>
+                  <a:tcPr marL="109728" marR="91440" marT="36576" marB="36576">
+                    <a:solidFill>
+                      <a:srgbClr val="FFFFFF"/>
+                    </a:solidFill>
+                  </a:tcPr>
+                </a:tc>
+                <a:tc>
+                  <a:txBody>
+                    <a:bodyPr/>
+                    <a:lstStyle/>
+                    <a:p>
+                      <a:pPr algn="l">
+                        <a:spcAft>
+                          <a:spcPts val="0"/>
+                        </a:spcAft>
+                      </a:pPr>
+                      <a:r>
+                        <a:rPr sz="1500" b="0">
+                          <a:solidFill>
+                            <a:srgbClr val="252B33"/>
+                          </a:solidFill>
+                          <a:latin typeface="Arial"/>
+                        </a:rPr>
+                        <a:t>0→0</a:t>
+                      </a:r>
+                    </a:p>
+                  </a:txBody>
+                  <a:tcPr marL="109728" marR="91440" marT="36576" marB="36576">
+                    <a:solidFill>
+                      <a:srgbClr val="FFFFFF"/>
+                    </a:solidFill>
+                  </a:tcPr>
+                </a:tc>
+                <a:tc>
+                  <a:txBody>
+                    <a:bodyPr/>
+                    <a:lstStyle/>
+                    <a:p>
+                      <a:pPr algn="l">
+                        <a:spcAft>
+                          <a:spcPts val="0"/>
+                        </a:spcAft>
+                      </a:pPr>
+                      <a:r>
+                        <a:rPr sz="1500" b="1">
+                          <a:solidFill>
+                            <a:srgbClr val="B3373D"/>
+                          </a:solidFill>
+                          <a:latin typeface="Arial"/>
+                        </a:rPr>
+                        <a:t>Higher</a:t>
+                      </a:r>
+                    </a:p>
+                  </a:txBody>
+                  <a:tcPr marL="109728" marR="91440" marT="36576" marB="36576">
+                    <a:solidFill>
+                      <a:srgbClr val="FFFFFF"/>
+                    </a:solidFill>
+                  </a:tcPr>
+                </a:tc>
+              </a:tr>
+              <a:tr h="363474">
+                <a:tc>
+                  <a:txBody>
+                    <a:bodyPr/>
+                    <a:lstStyle/>
+                    <a:p>
+                      <a:pPr algn="l">
+                        <a:spcAft>
+                          <a:spcPts val="0"/>
+                        </a:spcAft>
+                      </a:pPr>
+                      <a:r>
+                        <a:rPr sz="1500" b="0">
+                          <a:solidFill>
+                            <a:srgbClr val="252B33"/>
+                          </a:solidFill>
+                          <a:latin typeface="Arial"/>
+                        </a:rPr>
+                        <a:t>GET /periods</a:t>
+                      </a:r>
+                    </a:p>
+                  </a:txBody>
+                  <a:tcPr marL="109728" marR="91440" marT="36576" marB="36576">
+                    <a:solidFill>
+                      <a:srgbClr val="F7F9FC"/>
+                    </a:solidFill>
+                  </a:tcPr>
+                </a:tc>
+                <a:tc>
+                  <a:txBody>
+                    <a:bodyPr/>
+                    <a:lstStyle/>
+                    <a:p>
+                      <a:pPr algn="l">
+                        <a:spcAft>
+                          <a:spcPts val="0"/>
+                        </a:spcAft>
+                      </a:pPr>
+                      <a:r>
+                        <a:rPr sz="1500" b="0">
+                          <a:solidFill>
+                            <a:srgbClr val="252B33"/>
+                          </a:solidFill>
+                          <a:latin typeface="Arial"/>
+                        </a:rPr>
+                        <a:t>27.00</a:t>
+                      </a:r>
+                    </a:p>
+                  </a:txBody>
+                  <a:tcPr marL="109728" marR="91440" marT="36576" marB="36576">
+                    <a:solidFill>
+                      <a:srgbClr val="F7F9FC"/>
+                    </a:solidFill>
+                  </a:tcPr>
+                </a:tc>
+                <a:tc>
+                  <a:txBody>
+                    <a:bodyPr/>
+                    <a:lstStyle/>
+                    <a:p>
+                      <a:pPr algn="l">
+                        <a:spcAft>
+                          <a:spcPts val="0"/>
+                        </a:spcAft>
+                      </a:pPr>
+                      <a:r>
+                        <a:rPr sz="1500" b="0">
+                          <a:solidFill>
+                            <a:srgbClr val="252B33"/>
+                          </a:solidFill>
+                          <a:latin typeface="Arial"/>
+                        </a:rPr>
+                        <a:t>625.95</a:t>
+                      </a:r>
+                    </a:p>
+                  </a:txBody>
+                  <a:tcPr marL="109728" marR="91440" marT="36576" marB="36576">
+                    <a:solidFill>
+                      <a:srgbClr val="F7F9FC"/>
+                    </a:solidFill>
+                  </a:tcPr>
+                </a:tc>
+                <a:tc>
+                  <a:txBody>
+                    <a:bodyPr/>
+                    <a:lstStyle/>
+                    <a:p>
+                      <a:pPr algn="l">
+                        <a:spcAft>
+                          <a:spcPts val="0"/>
+                        </a:spcAft>
+                      </a:pPr>
+                      <a:r>
+                        <a:rPr sz="1500" b="0">
+                          <a:solidFill>
+                            <a:srgbClr val="252B33"/>
+                          </a:solidFill>
+                          <a:latin typeface="Arial"/>
+                        </a:rPr>
+                        <a:t>0→0</a:t>
+                      </a:r>
+                    </a:p>
+                  </a:txBody>
+                  <a:tcPr marL="109728" marR="91440" marT="36576" marB="36576">
+                    <a:solidFill>
+                      <a:srgbClr val="F7F9FC"/>
+                    </a:solidFill>
+                  </a:tcPr>
+                </a:tc>
+                <a:tc>
+                  <a:txBody>
+                    <a:bodyPr/>
+                    <a:lstStyle/>
+                    <a:p>
+                      <a:pPr algn="l">
+                        <a:spcAft>
+                          <a:spcPts val="0"/>
+                        </a:spcAft>
+                      </a:pPr>
+                      <a:r>
+                        <a:rPr sz="1500" b="1">
+                          <a:solidFill>
+                            <a:srgbClr val="B3373D"/>
+                          </a:solidFill>
+                          <a:latin typeface="Arial"/>
+                        </a:rPr>
+                        <a:t>Higher</a:t>
+                      </a:r>
+                    </a:p>
+                  </a:txBody>
+                  <a:tcPr marL="109728" marR="91440" marT="36576" marB="36576">
+                    <a:solidFill>
+                      <a:srgbClr val="F7F9FC"/>
+                    </a:solidFill>
+                  </a:tcPr>
+                </a:tc>
+              </a:tr>
+              <a:tr h="363474">
+                <a:tc>
+                  <a:txBody>
+                    <a:bodyPr/>
+                    <a:lstStyle/>
+                    <a:p>
+                      <a:pPr algn="l">
+                        <a:spcAft>
+                          <a:spcPts val="0"/>
+                        </a:spcAft>
+                      </a:pPr>
+                      <a:r>
+                        <a:rPr sz="1500" b="0">
+                          <a:solidFill>
+                            <a:srgbClr val="252B33"/>
+                          </a:solidFill>
+                          <a:latin typeface="Arial"/>
+                        </a:rPr>
+                        <a:t>GET /reports/account-ledger</a:t>
+                      </a:r>
+                    </a:p>
+                  </a:txBody>
+                  <a:tcPr marL="109728" marR="91440" marT="36576" marB="36576">
+                    <a:solidFill>
+                      <a:srgbClr val="FFFFFF"/>
+                    </a:solidFill>
+                  </a:tcPr>
+                </a:tc>
+                <a:tc>
+                  <a:txBody>
+                    <a:bodyPr/>
+                    <a:lstStyle/>
+                    <a:p>
+                      <a:pPr algn="l">
+                        <a:spcAft>
+                          <a:spcPts val="0"/>
+                        </a:spcAft>
+                      </a:pPr>
+                      <a:r>
+                        <a:rPr sz="1500" b="0">
+                          <a:solidFill>
+                            <a:srgbClr val="252B33"/>
+                          </a:solidFill>
+                          <a:latin typeface="Arial"/>
+                        </a:rPr>
+                        <a:t>741.95</a:t>
+                      </a:r>
+                    </a:p>
+                  </a:txBody>
+                  <a:tcPr marL="109728" marR="91440" marT="36576" marB="36576">
+                    <a:solidFill>
+                      <a:srgbClr val="FFFFFF"/>
+                    </a:solidFill>
+                  </a:tcPr>
+                </a:tc>
+                <a:tc>
+                  <a:txBody>
+                    <a:bodyPr/>
+                    <a:lstStyle/>
+                    <a:p>
+                      <a:pPr algn="l">
+                        <a:spcAft>
+                          <a:spcPts val="0"/>
+                        </a:spcAft>
+                      </a:pPr>
+                      <a:r>
+                        <a:rPr sz="1500" b="0">
+                          <a:solidFill>
+                            <a:srgbClr val="252B33"/>
+                          </a:solidFill>
+                          <a:latin typeface="Arial"/>
+                        </a:rPr>
+                        <a:t>3,825.70</a:t>
+                      </a:r>
+                    </a:p>
+                  </a:txBody>
+                  <a:tcPr marL="109728" marR="91440" marT="36576" marB="36576">
+                    <a:solidFill>
+                      <a:srgbClr val="FFFFFF"/>
+                    </a:solidFill>
+                  </a:tcPr>
+                </a:tc>
+                <a:tc>
+                  <a:txBody>
+                    <a:bodyPr/>
+                    <a:lstStyle/>
+                    <a:p>
+                      <a:pPr algn="l">
+                        <a:spcAft>
+                          <a:spcPts val="0"/>
+                        </a:spcAft>
+                      </a:pPr>
+                      <a:r>
+                        <a:rPr sz="1500" b="0">
+                          <a:solidFill>
+                            <a:srgbClr val="252B33"/>
+                          </a:solidFill>
+                          <a:latin typeface="Arial"/>
+                        </a:rPr>
+                        <a:t>0→0</a:t>
+                      </a:r>
+                    </a:p>
+                  </a:txBody>
+                  <a:tcPr marL="109728" marR="91440" marT="36576" marB="36576">
+                    <a:solidFill>
+                      <a:srgbClr val="FFFFFF"/>
+                    </a:solidFill>
+                  </a:tcPr>
+                </a:tc>
+                <a:tc>
+                  <a:txBody>
+                    <a:bodyPr/>
+                    <a:lstStyle/>
+                    <a:p>
+                      <a:pPr algn="l">
+                        <a:spcAft>
+                          <a:spcPts val="0"/>
+                        </a:spcAft>
+                      </a:pPr>
+                      <a:r>
+                        <a:rPr sz="1500" b="1">
+                          <a:solidFill>
+                            <a:srgbClr val="B3373D"/>
+                          </a:solidFill>
+                          <a:latin typeface="Arial"/>
+                        </a:rPr>
+                        <a:t>Higher</a:t>
+                      </a:r>
+                    </a:p>
+                  </a:txBody>
+                  <a:tcPr marL="109728" marR="91440" marT="36576" marB="36576">
+                    <a:solidFill>
+                      <a:srgbClr val="FFFFFF"/>
+                    </a:solidFill>
+                  </a:tcPr>
+                </a:tc>
+              </a:tr>
+              <a:tr h="363474">
+                <a:tc>
+                  <a:txBody>
+                    <a:bodyPr/>
+                    <a:lstStyle/>
+                    <a:p>
+                      <a:pPr algn="l">
+                        <a:spcAft>
+                          <a:spcPts val="0"/>
+                        </a:spcAft>
+                      </a:pPr>
+                      <a:r>
+                        <a:rPr sz="1500" b="0">
+                          <a:solidFill>
+                            <a:srgbClr val="252B33"/>
+                          </a:solidFill>
+                          <a:latin typeface="Arial"/>
+                        </a:rPr>
+                        <a:t>GET /reports/balance-sheet</a:t>
+                      </a:r>
+                    </a:p>
+                  </a:txBody>
+                  <a:tcPr marL="109728" marR="91440" marT="36576" marB="36576">
+                    <a:solidFill>
+                      <a:srgbClr val="F7F9FC"/>
+                    </a:solidFill>
+                  </a:tcPr>
+                </a:tc>
+                <a:tc>
+                  <a:txBody>
+                    <a:bodyPr/>
+                    <a:lstStyle/>
+                    <a:p>
+                      <a:pPr algn="l">
+                        <a:spcAft>
+                          <a:spcPts val="0"/>
+                        </a:spcAft>
+                      </a:pPr>
+                      <a:r>
+                        <a:rPr sz="1500" b="0">
+                          <a:solidFill>
+                            <a:srgbClr val="252B33"/>
+                          </a:solidFill>
+                          <a:latin typeface="Arial"/>
+                        </a:rPr>
+                        <a:t>443.00</a:t>
+                      </a:r>
+                    </a:p>
+                  </a:txBody>
+                  <a:tcPr marL="109728" marR="91440" marT="36576" marB="36576">
+                    <a:solidFill>
+                      <a:srgbClr val="F7F9FC"/>
+                    </a:solidFill>
+                  </a:tcPr>
+                </a:tc>
+                <a:tc>
+                  <a:txBody>
+                    <a:bodyPr/>
+                    <a:lstStyle/>
+                    <a:p>
+                      <a:pPr algn="l">
+                        <a:spcAft>
+                          <a:spcPts val="0"/>
+                        </a:spcAft>
+                      </a:pPr>
+                      <a:r>
+                        <a:rPr sz="1500" b="0">
+                          <a:solidFill>
+                            <a:srgbClr val="252B33"/>
+                          </a:solidFill>
+                          <a:latin typeface="Arial"/>
+                        </a:rPr>
+                        <a:t>487.85</a:t>
+                      </a:r>
+                    </a:p>
+                  </a:txBody>
+                  <a:tcPr marL="109728" marR="91440" marT="36576" marB="36576">
+                    <a:solidFill>
+                      <a:srgbClr val="F7F9FC"/>
+                    </a:solidFill>
+                  </a:tcPr>
+                </a:tc>
+                <a:tc>
+                  <a:txBody>
+                    <a:bodyPr/>
+                    <a:lstStyle/>
+                    <a:p>
+                      <a:pPr algn="l">
+                        <a:spcAft>
+                          <a:spcPts val="0"/>
+                        </a:spcAft>
+                      </a:pPr>
+                      <a:r>
+                        <a:rPr sz="1500" b="0">
+                          <a:solidFill>
+                            <a:srgbClr val="252B33"/>
+                          </a:solidFill>
+                          <a:latin typeface="Arial"/>
+                        </a:rPr>
+                        <a:t>0→0</a:t>
+                      </a:r>
+                    </a:p>
+                  </a:txBody>
+                  <a:tcPr marL="109728" marR="91440" marT="36576" marB="36576">
+                    <a:solidFill>
+                      <a:srgbClr val="F7F9FC"/>
+                    </a:solidFill>
+                  </a:tcPr>
+                </a:tc>
+                <a:tc>
+                  <a:txBody>
+                    <a:bodyPr/>
+                    <a:lstStyle/>
+                    <a:p>
+                      <a:pPr algn="l">
+                        <a:spcAft>
+                          <a:spcPts val="0"/>
+                        </a:spcAft>
+                      </a:pPr>
+                      <a:r>
+                        <a:rPr sz="1500" b="1">
+                          <a:solidFill>
+                            <a:srgbClr val="B3373D"/>
+                          </a:solidFill>
+                          <a:latin typeface="Arial"/>
+                        </a:rPr>
+                        <a:t>Higher</a:t>
+                      </a:r>
+                    </a:p>
+                  </a:txBody>
+                  <a:tcPr marL="109728" marR="91440" marT="36576" marB="36576">
+                    <a:solidFill>
+                      <a:srgbClr val="F7F9FC"/>
+                    </a:solidFill>
+                  </a:tcPr>
+                </a:tc>
+              </a:tr>
+              <a:tr h="363474">
+                <a:tc>
+                  <a:txBody>
+                    <a:bodyPr/>
+                    <a:lstStyle/>
+                    <a:p>
+                      <a:pPr algn="l">
+                        <a:spcAft>
+                          <a:spcPts val="0"/>
+                        </a:spcAft>
+                      </a:pPr>
+                      <a:r>
+                        <a:rPr sz="1500" b="0">
+                          <a:solidFill>
+                            <a:srgbClr val="252B33"/>
+                          </a:solidFill>
+                          <a:latin typeface="Arial"/>
+                        </a:rPr>
+                        <a:t>GET /reports/profit-loss</a:t>
+                      </a:r>
+                    </a:p>
+                  </a:txBody>
+                  <a:tcPr marL="109728" marR="91440" marT="36576" marB="36576">
+                    <a:solidFill>
+                      <a:srgbClr val="FFFFFF"/>
+                    </a:solidFill>
+                  </a:tcPr>
+                </a:tc>
+                <a:tc>
+                  <a:txBody>
+                    <a:bodyPr/>
+                    <a:lstStyle/>
+                    <a:p>
+                      <a:pPr algn="l">
+                        <a:spcAft>
+                          <a:spcPts val="0"/>
+                        </a:spcAft>
+                      </a:pPr>
+                      <a:r>
+                        <a:rPr sz="1500" b="0">
+                          <a:solidFill>
+                            <a:srgbClr val="252B33"/>
+                          </a:solidFill>
+                          <a:latin typeface="Arial"/>
+                        </a:rPr>
+                        <a:t>437.95</a:t>
+                      </a:r>
+                    </a:p>
+                  </a:txBody>
+                  <a:tcPr marL="109728" marR="91440" marT="36576" marB="36576">
+                    <a:solidFill>
+                      <a:srgbClr val="FFFFFF"/>
+                    </a:solidFill>
+                  </a:tcPr>
+                </a:tc>
+                <a:tc>
+                  <a:txBody>
+                    <a:bodyPr/>
+                    <a:lstStyle/>
+                    <a:p>
+                      <a:pPr algn="l">
+                        <a:spcAft>
+                          <a:spcPts val="0"/>
+                        </a:spcAft>
+                      </a:pPr>
+                      <a:r>
+                        <a:rPr sz="1500" b="0">
+                          <a:solidFill>
+                            <a:srgbClr val="252B33"/>
+                          </a:solidFill>
+                          <a:latin typeface="Arial"/>
+                        </a:rPr>
+                        <a:t>427.85</a:t>
+                      </a:r>
+                    </a:p>
+                  </a:txBody>
+                  <a:tcPr marL="109728" marR="91440" marT="36576" marB="36576">
+                    <a:solidFill>
+                      <a:srgbClr val="FFFFFF"/>
+                    </a:solidFill>
+                  </a:tcPr>
+                </a:tc>
+                <a:tc>
+                  <a:txBody>
+                    <a:bodyPr/>
+                    <a:lstStyle/>
+                    <a:p>
+                      <a:pPr algn="l">
+                        <a:spcAft>
+                          <a:spcPts val="0"/>
+                        </a:spcAft>
+                      </a:pPr>
+                      <a:r>
+                        <a:rPr sz="1500" b="0">
+                          <a:solidFill>
+                            <a:srgbClr val="252B33"/>
+                          </a:solidFill>
+                          <a:latin typeface="Arial"/>
+                        </a:rPr>
+                        <a:t>0→0</a:t>
+                      </a:r>
+                    </a:p>
+                  </a:txBody>
+                  <a:tcPr marL="109728" marR="91440" marT="36576" marB="36576">
+                    <a:solidFill>
+                      <a:srgbClr val="FFFFFF"/>
+                    </a:solidFill>
+                  </a:tcPr>
+                </a:tc>
+                <a:tc>
+                  <a:txBody>
+                    <a:bodyPr/>
+                    <a:lstStyle/>
+                    <a:p>
+                      <a:pPr algn="l">
+                        <a:spcAft>
+                          <a:spcPts val="0"/>
+                        </a:spcAft>
+                      </a:pPr>
+                      <a:r>
+                        <a:rPr sz="1500" b="1">
+                          <a:solidFill>
+                            <a:srgbClr val="246F46"/>
+                          </a:solidFill>
+                          <a:latin typeface="Arial"/>
+                        </a:rPr>
+                        <a:t>Lower</a:t>
+                      </a:r>
+                    </a:p>
+                  </a:txBody>
+                  <a:tcPr marL="109728" marR="91440" marT="36576" marB="36576">
+                    <a:solidFill>
+                      <a:srgbClr val="FFFFFF"/>
+                    </a:solidFill>
+                  </a:tcPr>
+                </a:tc>
+              </a:tr>
+              <a:tr h="363474">
+                <a:tc>
+                  <a:txBody>
+                    <a:bodyPr/>
+                    <a:lstStyle/>
+                    <a:p>
+                      <a:pPr algn="l">
+                        <a:spcAft>
+                          <a:spcPts val="0"/>
+                        </a:spcAft>
+                      </a:pPr>
+                      <a:r>
+                        <a:rPr sz="1500" b="0">
+                          <a:solidFill>
+                            <a:srgbClr val="252B33"/>
+                          </a:solidFill>
+                          <a:latin typeface="Arial"/>
+                        </a:rPr>
+                        <a:t>GET /reports/trial-balance</a:t>
+                      </a:r>
+                    </a:p>
+                  </a:txBody>
+                  <a:tcPr marL="109728" marR="91440" marT="36576" marB="36576">
+                    <a:solidFill>
+                      <a:srgbClr val="F7F9FC"/>
+                    </a:solidFill>
+                  </a:tcPr>
+                </a:tc>
+                <a:tc>
+                  <a:txBody>
+                    <a:bodyPr/>
+                    <a:lstStyle/>
+                    <a:p>
+                      <a:pPr algn="l">
+                        <a:spcAft>
+                          <a:spcPts val="0"/>
+                        </a:spcAft>
+                      </a:pPr>
+                      <a:r>
+                        <a:rPr sz="1500" b="0">
+                          <a:solidFill>
+                            <a:srgbClr val="252B33"/>
+                          </a:solidFill>
+                          <a:latin typeface="Arial"/>
+                        </a:rPr>
+                        <a:t>442.00</a:t>
+                      </a:r>
+                    </a:p>
+                  </a:txBody>
+                  <a:tcPr marL="109728" marR="91440" marT="36576" marB="36576">
+                    <a:solidFill>
+                      <a:srgbClr val="F7F9FC"/>
+                    </a:solidFill>
+                  </a:tcPr>
+                </a:tc>
+                <a:tc>
+                  <a:txBody>
+                    <a:bodyPr/>
+                    <a:lstStyle/>
+                    <a:p>
+                      <a:pPr algn="l">
+                        <a:spcAft>
+                          <a:spcPts val="0"/>
+                        </a:spcAft>
+                      </a:pPr>
+                      <a:r>
+                        <a:rPr sz="1500" b="0">
+                          <a:solidFill>
+                            <a:srgbClr val="252B33"/>
+                          </a:solidFill>
+                          <a:latin typeface="Arial"/>
+                        </a:rPr>
+                        <a:t>446.95</a:t>
+                      </a:r>
+                    </a:p>
+                  </a:txBody>
+                  <a:tcPr marL="109728" marR="91440" marT="36576" marB="36576">
+                    <a:solidFill>
+                      <a:srgbClr val="F7F9FC"/>
+                    </a:solidFill>
+                  </a:tcPr>
+                </a:tc>
+                <a:tc>
+                  <a:txBody>
+                    <a:bodyPr/>
+                    <a:lstStyle/>
+                    <a:p>
+                      <a:pPr algn="l">
+                        <a:spcAft>
+                          <a:spcPts val="0"/>
+                        </a:spcAft>
+                      </a:pPr>
+                      <a:r>
+                        <a:rPr sz="1500" b="0">
+                          <a:solidFill>
+                            <a:srgbClr val="252B33"/>
+                          </a:solidFill>
+                          <a:latin typeface="Arial"/>
+                        </a:rPr>
+                        <a:t>0→0</a:t>
+                      </a:r>
+                    </a:p>
+                  </a:txBody>
+                  <a:tcPr marL="109728" marR="91440" marT="36576" marB="36576">
+                    <a:solidFill>
+                      <a:srgbClr val="F7F9FC"/>
+                    </a:solidFill>
+                  </a:tcPr>
+                </a:tc>
+                <a:tc>
+                  <a:txBody>
+                    <a:bodyPr/>
+                    <a:lstStyle/>
+                    <a:p>
+                      <a:pPr algn="l">
+                        <a:spcAft>
+                          <a:spcPts val="0"/>
+                        </a:spcAft>
+                      </a:pPr>
+                      <a:r>
+                        <a:rPr sz="1500" b="1">
+                          <a:solidFill>
+                            <a:srgbClr val="B3373D"/>
+                          </a:solidFill>
+                          <a:latin typeface="Arial"/>
+                        </a:rPr>
+                        <a:t>Higher</a:t>
+                      </a:r>
+                    </a:p>
+                  </a:txBody>
+                  <a:tcPr marL="109728" marR="91440" marT="36576" marB="36576">
+                    <a:solidFill>
+                      <a:srgbClr val="F7F9FC"/>
+                    </a:solidFill>
+                  </a:tcPr>
+                </a:tc>
+              </a:tr>
+              <a:tr h="363474">
+                <a:tc>
+                  <a:txBody>
+                    <a:bodyPr/>
+                    <a:lstStyle/>
+                    <a:p>
+                      <a:pPr algn="l">
+                        <a:spcAft>
+                          <a:spcPts val="0"/>
+                        </a:spcAft>
+                      </a:pPr>
+                      <a:r>
+                        <a:rPr sz="1500" b="0">
+                          <a:solidFill>
+                            <a:srgbClr val="252B33"/>
+                          </a:solidFill>
+                          <a:latin typeface="Arial"/>
+                        </a:rPr>
+                        <a:t>GET /users/me</a:t>
+                      </a:r>
+                    </a:p>
+                  </a:txBody>
+                  <a:tcPr marL="109728" marR="91440" marT="36576" marB="36576">
+                    <a:solidFill>
+                      <a:srgbClr val="FFFFFF"/>
+                    </a:solidFill>
+                  </a:tcPr>
+                </a:tc>
+                <a:tc>
+                  <a:txBody>
+                    <a:bodyPr/>
+                    <a:lstStyle/>
+                    <a:p>
+                      <a:pPr algn="l">
+                        <a:spcAft>
+                          <a:spcPts val="0"/>
+                        </a:spcAft>
+                      </a:pPr>
+                      <a:r>
+                        <a:rPr sz="1500" b="0">
+                          <a:solidFill>
+                            <a:srgbClr val="252B33"/>
+                          </a:solidFill>
+                          <a:latin typeface="Arial"/>
+                        </a:rPr>
+                        <a:t>36.00</a:t>
+                      </a:r>
+                    </a:p>
+                  </a:txBody>
+                  <a:tcPr marL="109728" marR="91440" marT="36576" marB="36576">
+                    <a:solidFill>
+                      <a:srgbClr val="FFFFFF"/>
+                    </a:solidFill>
+                  </a:tcPr>
+                </a:tc>
+                <a:tc>
+                  <a:txBody>
+                    <a:bodyPr/>
+                    <a:lstStyle/>
+                    <a:p>
+                      <a:pPr algn="l">
+                        <a:spcAft>
+                          <a:spcPts val="0"/>
+                        </a:spcAft>
+                      </a:pPr>
+                      <a:r>
+                        <a:rPr sz="1500" b="0">
+                          <a:solidFill>
+                            <a:srgbClr val="252B33"/>
+                          </a:solidFill>
+                          <a:latin typeface="Arial"/>
+                        </a:rPr>
+                        <a:t>586.00</a:t>
+                      </a:r>
+                    </a:p>
+                  </a:txBody>
+                  <a:tcPr marL="109728" marR="91440" marT="36576" marB="36576">
+                    <a:solidFill>
+                      <a:srgbClr val="FFFFFF"/>
+                    </a:solidFill>
+                  </a:tcPr>
+                </a:tc>
+                <a:tc>
+                  <a:txBody>
+                    <a:bodyPr/>
+                    <a:lstStyle/>
+                    <a:p>
+                      <a:pPr algn="l">
+                        <a:spcAft>
+                          <a:spcPts val="0"/>
+                        </a:spcAft>
+                      </a:pPr>
+                      <a:r>
+                        <a:rPr sz="1500" b="0">
+                          <a:solidFill>
+                            <a:srgbClr val="252B33"/>
+                          </a:solidFill>
+                          <a:latin typeface="Arial"/>
+                        </a:rPr>
+                        <a:t>0→0</a:t>
+                      </a:r>
+                    </a:p>
+                  </a:txBody>
+                  <a:tcPr marL="109728" marR="91440" marT="36576" marB="36576">
+                    <a:solidFill>
+                      <a:srgbClr val="FFFFFF"/>
+                    </a:solidFill>
+                  </a:tcPr>
+                </a:tc>
+                <a:tc>
+                  <a:txBody>
+                    <a:bodyPr/>
+                    <a:lstStyle/>
+                    <a:p>
+                      <a:pPr algn="l">
+                        <a:spcAft>
+                          <a:spcPts val="0"/>
+                        </a:spcAft>
+                      </a:pPr>
+                      <a:r>
+                        <a:rPr sz="1500" b="1">
+                          <a:solidFill>
+                            <a:srgbClr val="B3373D"/>
+                          </a:solidFill>
+                          <a:latin typeface="Arial"/>
+                        </a:rPr>
+                        <a:t>Higher</a:t>
+                      </a:r>
+                    </a:p>
+                  </a:txBody>
+                  <a:tcPr marL="109728" marR="91440" marT="36576" marB="36576">
+                    <a:solidFill>
+                      <a:srgbClr val="FFFFFF"/>
+                    </a:solidFill>
+                  </a:tcPr>
+                </a:tc>
+              </a:tr>
+              <a:tr h="363474">
+                <a:tc>
+                  <a:txBody>
+                    <a:bodyPr/>
+                    <a:lstStyle/>
+                    <a:p>
+                      <a:pPr algn="l">
+                        <a:spcAft>
+                          <a:spcPts val="0"/>
+                        </a:spcAft>
+                      </a:pPr>
+                      <a:r>
+                        <a:rPr sz="1500" b="0">
+                          <a:solidFill>
+                            <a:srgbClr val="252B33"/>
+                          </a:solidFill>
+                          <a:latin typeface="Arial"/>
+                        </a:rPr>
+                        <a:t>POST /auth/login</a:t>
+                      </a:r>
+                    </a:p>
+                  </a:txBody>
+                  <a:tcPr marL="109728" marR="91440" marT="36576" marB="36576">
+                    <a:solidFill>
+                      <a:srgbClr val="F7F9FC"/>
+                    </a:solidFill>
+                  </a:tcPr>
+                </a:tc>
+                <a:tc>
+                  <a:txBody>
+                    <a:bodyPr/>
+                    <a:lstStyle/>
+                    <a:p>
+                      <a:pPr algn="l">
+                        <a:spcAft>
+                          <a:spcPts val="0"/>
+                        </a:spcAft>
+                      </a:pPr>
+                      <a:r>
+                        <a:rPr sz="1500" b="0">
+                          <a:solidFill>
+                            <a:srgbClr val="252B33"/>
+                          </a:solidFill>
+                          <a:latin typeface="Arial"/>
+                        </a:rPr>
+                        <a:t>119.30</a:t>
+                      </a:r>
+                    </a:p>
+                  </a:txBody>
+                  <a:tcPr marL="109728" marR="91440" marT="36576" marB="36576">
+                    <a:solidFill>
+                      <a:srgbClr val="F7F9FC"/>
+                    </a:solidFill>
+                  </a:tcPr>
+                </a:tc>
+                <a:tc>
+                  <a:txBody>
+                    <a:bodyPr/>
+                    <a:lstStyle/>
+                    <a:p>
+                      <a:pPr algn="l">
+                        <a:spcAft>
+                          <a:spcPts val="0"/>
+                        </a:spcAft>
+                      </a:pPr>
+                      <a:r>
+                        <a:rPr sz="1500" b="0">
+                          <a:solidFill>
+                            <a:srgbClr val="252B33"/>
+                          </a:solidFill>
+                          <a:latin typeface="Arial"/>
+                        </a:rPr>
+                        <a:t>1,831.90</a:t>
+                      </a:r>
+                    </a:p>
+                  </a:txBody>
+                  <a:tcPr marL="109728" marR="91440" marT="36576" marB="36576">
+                    <a:solidFill>
+                      <a:srgbClr val="F7F9FC"/>
+                    </a:solidFill>
+                  </a:tcPr>
+                </a:tc>
+                <a:tc>
+                  <a:txBody>
+                    <a:bodyPr/>
+                    <a:lstStyle/>
+                    <a:p>
+                      <a:pPr algn="l">
+                        <a:spcAft>
+                          <a:spcPts val="0"/>
+                        </a:spcAft>
+                      </a:pPr>
+                      <a:r>
+                        <a:rPr sz="1500" b="0">
+                          <a:solidFill>
+                            <a:srgbClr val="252B33"/>
+                          </a:solidFill>
+                          <a:latin typeface="Arial"/>
+                        </a:rPr>
+                        <a:t>0→0</a:t>
+                      </a:r>
+                    </a:p>
+                  </a:txBody>
+                  <a:tcPr marL="109728" marR="91440" marT="36576" marB="36576">
+                    <a:solidFill>
+                      <a:srgbClr val="F7F9FC"/>
+                    </a:solidFill>
+                  </a:tcPr>
+                </a:tc>
+                <a:tc>
+                  <a:txBody>
+                    <a:bodyPr/>
+                    <a:lstStyle/>
+                    <a:p>
+                      <a:pPr algn="l">
+                        <a:spcAft>
+                          <a:spcPts val="0"/>
+                        </a:spcAft>
+                      </a:pPr>
+                      <a:r>
+                        <a:rPr sz="1500" b="1">
+                          <a:solidFill>
+                            <a:srgbClr val="B3373D"/>
+                          </a:solidFill>
+                          <a:latin typeface="Arial"/>
+                        </a:rPr>
+                        <a:t>Higher</a:t>
+                      </a:r>
+                    </a:p>
+                  </a:txBody>
+                  <a:tcPr marL="109728" marR="91440" marT="36576" marB="36576">
+                    <a:solidFill>
+                      <a:srgbClr val="F7F9FC"/>
+                    </a:solidFill>
+                  </a:tcPr>
+                </a:tc>
+              </a:tr>
+              <a:tr h="363474">
+                <a:tc>
+                  <a:txBody>
+                    <a:bodyPr/>
+                    <a:lstStyle/>
+                    <a:p>
+                      <a:pPr algn="l">
+                        <a:spcAft>
+                          <a:spcPts val="0"/>
+                        </a:spcAft>
+                      </a:pPr>
+                      <a:r>
+                        <a:rPr sz="1500" b="0">
+                          <a:solidFill>
+                            <a:srgbClr val="252B33"/>
+                          </a:solidFill>
+                          <a:latin typeface="Arial"/>
+                        </a:rPr>
+                        <a:t>POST /journal-entries/bulk</a:t>
+                      </a:r>
+                    </a:p>
+                  </a:txBody>
+                  <a:tcPr marL="109728" marR="91440" marT="36576" marB="36576">
+                    <a:solidFill>
+                      <a:srgbClr val="FFFFFF"/>
+                    </a:solidFill>
+                  </a:tcPr>
+                </a:tc>
+                <a:tc>
+                  <a:txBody>
+                    <a:bodyPr/>
+                    <a:lstStyle/>
+                    <a:p>
+                      <a:pPr algn="l">
+                        <a:spcAft>
+                          <a:spcPts val="0"/>
+                        </a:spcAft>
+                      </a:pPr>
+                      <a:r>
+                        <a:rPr sz="1500" b="0">
+                          <a:solidFill>
+                            <a:srgbClr val="252B33"/>
+                          </a:solidFill>
+                          <a:latin typeface="Arial"/>
+                        </a:rPr>
+                        <a:t>90.00</a:t>
+                      </a:r>
+                    </a:p>
+                  </a:txBody>
+                  <a:tcPr marL="109728" marR="91440" marT="36576" marB="36576">
+                    <a:solidFill>
+                      <a:srgbClr val="FFFFFF"/>
+                    </a:solidFill>
+                  </a:tcPr>
+                </a:tc>
+                <a:tc>
+                  <a:txBody>
+                    <a:bodyPr/>
+                    <a:lstStyle/>
+                    <a:p>
+                      <a:pPr algn="l">
+                        <a:spcAft>
+                          <a:spcPts val="0"/>
+                        </a:spcAft>
+                      </a:pPr>
+                      <a:r>
+                        <a:rPr sz="1500" b="0">
+                          <a:solidFill>
+                            <a:srgbClr val="252B33"/>
+                          </a:solidFill>
+                          <a:latin typeface="Arial"/>
+                        </a:rPr>
+                        <a:t>597.85</a:t>
+                      </a:r>
+                    </a:p>
+                  </a:txBody>
+                  <a:tcPr marL="109728" marR="91440" marT="36576" marB="36576">
+                    <a:solidFill>
+                      <a:srgbClr val="FFFFFF"/>
+                    </a:solidFill>
+                  </a:tcPr>
+                </a:tc>
+                <a:tc>
+                  <a:txBody>
+                    <a:bodyPr/>
+                    <a:lstStyle/>
+                    <a:p>
+                      <a:pPr algn="l">
+                        <a:spcAft>
+                          <a:spcPts val="0"/>
+                        </a:spcAft>
+                      </a:pPr>
+                      <a:r>
+                        <a:rPr sz="1500" b="0">
+                          <a:solidFill>
+                            <a:srgbClr val="252B33"/>
+                          </a:solidFill>
+                          <a:latin typeface="Arial"/>
+                        </a:rPr>
+                        <a:t>0→0</a:t>
+                      </a:r>
+                    </a:p>
+                  </a:txBody>
+                  <a:tcPr marL="109728" marR="91440" marT="36576" marB="36576">
+                    <a:solidFill>
+                      <a:srgbClr val="FFFFFF"/>
+                    </a:solidFill>
+                  </a:tcPr>
+                </a:tc>
+                <a:tc>
+                  <a:txBody>
+                    <a:bodyPr/>
+                    <a:lstStyle/>
+                    <a:p>
+                      <a:pPr algn="l">
+                        <a:spcAft>
+                          <a:spcPts val="0"/>
+                        </a:spcAft>
+                      </a:pPr>
+                      <a:r>
+                        <a:rPr sz="1500" b="1">
+                          <a:solidFill>
+                            <a:srgbClr val="B3373D"/>
+                          </a:solidFill>
+                          <a:latin typeface="Arial"/>
+                        </a:rPr>
+                        <a:t>Higher</a:t>
+                      </a:r>
+                    </a:p>
+                  </a:txBody>
+                  <a:tcPr marL="109728" marR="91440" marT="36576" marB="36576">
+                    <a:solidFill>
+                      <a:srgbClr val="FFFFFF"/>
+                    </a:solidFill>
+                  </a:tcPr>
+                </a:tc>
+              </a:tr>
+            </a:tbl>
+          </a:graphicData>
+        </a:graphic>
+      </p:graphicFrame>
+      <p:sp>
+        <p:nvSpPr>
+          <p:cNvPr id="10" name="Rounded Rectangle 9"/>
+          <p:cNvSpPr/>
+          <p:nvPr/>
+        </p:nvSpPr>
+        <p:spPr>
+          <a:xfrm>
+            <a:off x="768096" y="5797296"/>
+            <a:ext cx="10643616" cy="411480"/>
+          </a:xfrm>
+          <a:prstGeom prst="roundRect">
+            <a:avLst/>
+          </a:prstGeom>
+          <a:solidFill>
+            <a:srgbClr val="FFF6E7"/>
+          </a:solidFill>
+          <a:ln>
+            <a:noFill/>
+          </a:ln>
+        </p:spPr>
+        <p:style>
+          <a:lnRef idx="1">
+            <a:schemeClr val="accent1"/>
+          </a:lnRef>
+          <a:fillRef idx="3">
+            <a:schemeClr val="accent1"/>
+          </a:fillRef>
+          <a:effectRef idx="2">
+            <a:schemeClr val="accent1"/>
+          </a:effectRef>
+          <a:fontRef idx="minor">
+            <a:schemeClr val="lt1"/>
+          </a:fontRef>
+        </p:style>
+        <p:txBody>
+          <a:bodyPr rtlCol="0" anchor="ctr"/>
+          <a:lstStyle/>
+          <a:p>
+            <a:pPr algn="ctr"/>
+          </a:p>
+        </p:txBody>
+      </p:sp>
+      <p:sp>
+        <p:nvSpPr>
+          <p:cNvPr id="11" name="TextBox 10"/>
+          <p:cNvSpPr txBox="1"/>
+          <p:nvPr/>
+        </p:nvSpPr>
+        <p:spPr>
+          <a:xfrm>
+            <a:off x="950976" y="5843016"/>
+            <a:ext cx="10287000" cy="301752"/>
+          </a:xfrm>
+          <a:prstGeom prst="rect">
+            <a:avLst/>
+          </a:prstGeom>
+          <a:noFill/>
+        </p:spPr>
+        <p:txBody>
+          <a:bodyPr wrap="square" lIns="18288" rIns="18288" tIns="18288" bIns="18288" anchor="ctr">
+            <a:spAutoFit/>
+          </a:bodyPr>
+          <a:lstStyle/>
+          <a:p>
+            <a:pPr algn="l">
+              <a:spcBef>
+                <a:spcPts val="0"/>
+              </a:spcBef>
+              <a:spcAft>
+                <a:spcPts val="0"/>
+              </a:spcAft>
+            </a:pPr>
+            <a:r>
+              <a:rPr sz="1600" b="1">
+                <a:solidFill>
+                  <a:srgbClr val="BE7414"/>
+                </a:solidFill>
+                <a:latin typeface="Arial"/>
+              </a:rPr>
+              <a:t>Soak: Total p95 lower, but 9/10 request p95 values higher; failures remained zero.</a:t>
+            </a:r>
+          </a:p>
+        </p:txBody>
+      </p:sp>
+    </p:spTree>
+  </p:cSld>
+  <p:clrMapOvr>
+    <a:masterClrMapping/>
+  </p:clrMapOvr>
+</p:sld>
+</file>
+
+<file path=ppt/slides/slide47.xml><?xml version="1.0" encoding="utf-8"?>
+<p:sld xmlns:a="http://schemas.openxmlformats.org/drawingml/2006/main" xmlns:p="http://schemas.openxmlformats.org/presentationml/2006/main" xmlns:r="http://schemas.openxmlformats.org/officeDocument/2006/relationships">
+  <p:cSld>
+    <p:bg>
+      <p:bgPr>
+        <a:solidFill>
+          <a:srgbClr val="F7F9FC"/>
+        </a:solidFill>
+        <a:effectLst/>
+      </p:bgPr>
+    </p:bg>
+    <p:spTree>
+      <p:nvGrpSpPr>
+        <p:cNvPr id="1" name=""/>
+        <p:cNvGrpSpPr/>
+        <p:nvPr/>
+      </p:nvGrpSpPr>
+      <p:grpSpPr/>
+      <p:sp>
+        <p:nvSpPr>
+          <p:cNvPr id="2" name="Rectangle 1"/>
+          <p:cNvSpPr/>
+          <p:nvPr/>
+        </p:nvSpPr>
+        <p:spPr>
+          <a:xfrm>
+            <a:off x="0" y="0"/>
+            <a:ext cx="146304" cy="6858000"/>
+          </a:xfrm>
+          <a:prstGeom prst="rect">
+            <a:avLst/>
+          </a:prstGeom>
+          <a:solidFill>
+            <a:srgbClr val="BE7414"/>
+          </a:solidFill>
+          <a:ln>
+            <a:noFill/>
+          </a:ln>
+        </p:spPr>
+        <p:style>
+          <a:lnRef idx="1">
+            <a:schemeClr val="accent1"/>
+          </a:lnRef>
+          <a:fillRef idx="3">
+            <a:schemeClr val="accent1"/>
+          </a:fillRef>
+          <a:effectRef idx="2">
+            <a:schemeClr val="accent1"/>
+          </a:effectRef>
+          <a:fontRef idx="minor">
+            <a:schemeClr val="lt1"/>
+          </a:fontRef>
+        </p:style>
+        <p:txBody>
+          <a:bodyPr rtlCol="0" anchor="ctr"/>
+          <a:lstStyle/>
+          <a:p>
+            <a:pPr algn="ctr"/>
+          </a:p>
+        </p:txBody>
+      </p:sp>
+      <p:sp>
+        <p:nvSpPr>
+          <p:cNvPr id="3" name="TextBox 2"/>
+          <p:cNvSpPr txBox="1"/>
+          <p:nvPr/>
+        </p:nvSpPr>
+        <p:spPr>
+          <a:xfrm>
+            <a:off x="585216" y="201168"/>
+            <a:ext cx="10881360" cy="219456"/>
+          </a:xfrm>
+          <a:prstGeom prst="rect">
+            <a:avLst/>
+          </a:prstGeom>
+          <a:noFill/>
+        </p:spPr>
+        <p:txBody>
+          <a:bodyPr wrap="square" lIns="18288" rIns="18288" tIns="18288" bIns="18288" anchor="ctr">
+            <a:spAutoFit/>
+          </a:bodyPr>
+          <a:lstStyle/>
+          <a:p>
+            <a:pPr algn="l">
+              <a:spcBef>
+                <a:spcPts val="0"/>
+              </a:spcBef>
+              <a:spcAft>
+                <a:spcPts val="0"/>
+              </a:spcAft>
+            </a:pPr>
+            <a:r>
+              <a:rPr sz="1100" b="1">
+                <a:solidFill>
+                  <a:srgbClr val="BE7414"/>
+                </a:solidFill>
+                <a:latin typeface="Arial"/>
+              </a:rPr>
+              <a:t>BACKUP EVIDENCE</a:t>
+            </a:r>
+          </a:p>
+        </p:txBody>
+      </p:sp>
+      <p:sp>
+        <p:nvSpPr>
+          <p:cNvPr id="4" name="TextBox 3"/>
+          <p:cNvSpPr txBox="1"/>
+          <p:nvPr/>
+        </p:nvSpPr>
+        <p:spPr>
+          <a:xfrm>
+            <a:off x="585216" y="502920"/>
+            <a:ext cx="10972800" cy="530352"/>
+          </a:xfrm>
+          <a:prstGeom prst="rect">
+            <a:avLst/>
+          </a:prstGeom>
+          <a:noFill/>
+        </p:spPr>
+        <p:txBody>
+          <a:bodyPr wrap="square" lIns="18288" rIns="18288" tIns="18288" bIns="18288" anchor="ctr">
+            <a:spAutoFit/>
+          </a:bodyPr>
+          <a:lstStyle/>
+          <a:p>
+            <a:pPr algn="l">
+              <a:spcBef>
+                <a:spcPts val="0"/>
+              </a:spcBef>
+              <a:spcAft>
+                <a:spcPts val="0"/>
+              </a:spcAft>
+            </a:pPr>
+            <a:r>
+              <a:rPr sz="2900" b="1">
+                <a:solidFill>
+                  <a:srgbClr val="252B33"/>
+                </a:solidFill>
+                <a:latin typeface="Arial"/>
+              </a:rPr>
+              <a:t>JMeter spike · every request</a:t>
+            </a:r>
+          </a:p>
+        </p:txBody>
+      </p:sp>
+      <p:cxnSp>
+        <p:nvCxnSpPr>
+          <p:cNvPr id="5" name="Connector 4"/>
+          <p:cNvCxnSpPr/>
+          <p:nvPr/>
+        </p:nvCxnSpPr>
+        <p:spPr>
+          <a:xfrm>
+            <a:off x="585216" y="1078992"/>
+            <a:ext cx="11000232" cy="0"/>
+          </a:xfrm>
+          <a:prstGeom prst="line">
+            <a:avLst/>
+          </a:prstGeom>
+          <a:ln w="12700">
+            <a:solidFill>
+              <a:srgbClr val="D8E0E9"/>
+            </a:solidFill>
+          </a:ln>
+        </p:spPr>
+        <p:style>
+          <a:lnRef idx="2">
+            <a:schemeClr val="accent1"/>
+          </a:lnRef>
+          <a:fillRef idx="0">
+            <a:schemeClr val="accent1"/>
+          </a:fillRef>
+          <a:effectRef idx="1">
+            <a:schemeClr val="accent1"/>
+          </a:effectRef>
+          <a:fontRef idx="minor">
+            <a:schemeClr val="tx1"/>
+          </a:fontRef>
+        </p:style>
+      </p:cxnSp>
+      <p:cxnSp>
+        <p:nvCxnSpPr>
+          <p:cNvPr id="6" name="Connector 5"/>
+          <p:cNvCxnSpPr/>
+          <p:nvPr/>
+        </p:nvCxnSpPr>
+        <p:spPr>
+          <a:xfrm>
+            <a:off x="585216" y="6428232"/>
+            <a:ext cx="11000232" cy="0"/>
+          </a:xfrm>
+          <a:prstGeom prst="line">
+            <a:avLst/>
+          </a:prstGeom>
+          <a:ln w="12700">
+            <a:solidFill>
+              <a:srgbClr val="D8E0E9"/>
+            </a:solidFill>
+          </a:ln>
+        </p:spPr>
+        <p:style>
+          <a:lnRef idx="2">
+            <a:schemeClr val="accent1"/>
+          </a:lnRef>
+          <a:fillRef idx="0">
+            <a:schemeClr val="accent1"/>
+          </a:fillRef>
+          <a:effectRef idx="1">
+            <a:schemeClr val="accent1"/>
+          </a:effectRef>
+          <a:fontRef idx="minor">
+            <a:schemeClr val="tx1"/>
+          </a:fontRef>
+        </p:style>
+      </p:cxnSp>
+      <p:sp>
+        <p:nvSpPr>
+          <p:cNvPr id="7" name="TextBox 6"/>
+          <p:cNvSpPr txBox="1"/>
+          <p:nvPr/>
+        </p:nvSpPr>
+        <p:spPr>
+          <a:xfrm>
+            <a:off x="585216" y="6473952"/>
+            <a:ext cx="10424160" cy="182880"/>
+          </a:xfrm>
+          <a:prstGeom prst="rect">
+            <a:avLst/>
+          </a:prstGeom>
+          <a:noFill/>
+        </p:spPr>
+        <p:txBody>
+          <a:bodyPr wrap="square" lIns="18288" rIns="18288" tIns="18288" bIns="18288" anchor="ctr">
+            <a:spAutoFit/>
+          </a:bodyPr>
+          <a:lstStyle/>
+          <a:p>
+            <a:pPr algn="l">
+              <a:spcBef>
+                <a:spcPts val="0"/>
+              </a:spcBef>
+              <a:spcAft>
+                <a:spcPts val="0"/>
+              </a:spcAft>
+            </a:pPr>
+            <a:r>
+              <a:rPr sz="1000" b="0">
+                <a:solidFill>
+                  <a:srgbClr val="5B6874"/>
+                </a:solidFill>
+                <a:latin typeface="Arial"/>
+              </a:rPr>
+              <a:t>Fresh JMeter baseline/remediation statistics.json; Appendix L Figures L.13 and L.18</a:t>
+            </a:r>
+          </a:p>
+        </p:txBody>
+      </p:sp>
+      <p:sp>
+        <p:nvSpPr>
+          <p:cNvPr id="8" name="TextBox 7"/>
+          <p:cNvSpPr txBox="1"/>
+          <p:nvPr/>
+        </p:nvSpPr>
+        <p:spPr>
+          <a:xfrm>
+            <a:off x="11119104" y="6473952"/>
+            <a:ext cx="438912" cy="182880"/>
+          </a:xfrm>
+          <a:prstGeom prst="rect">
+            <a:avLst/>
+          </a:prstGeom>
+          <a:noFill/>
+        </p:spPr>
+        <p:txBody>
+          <a:bodyPr wrap="square" lIns="18288" rIns="18288" tIns="18288" bIns="18288" anchor="ctr">
+            <a:spAutoFit/>
+          </a:bodyPr>
+          <a:lstStyle/>
+          <a:p>
+            <a:pPr algn="r">
+              <a:spcBef>
+                <a:spcPts val="0"/>
+              </a:spcBef>
+              <a:spcAft>
+                <a:spcPts val="0"/>
+              </a:spcAft>
+            </a:pPr>
+            <a:r>
+              <a:rPr sz="1100" b="1">
+                <a:solidFill>
+                  <a:srgbClr val="BE7414"/>
+                </a:solidFill>
+                <a:latin typeface="Arial"/>
+              </a:rPr>
+              <a:t>47</a:t>
+            </a:r>
+          </a:p>
+        </p:txBody>
+      </p:sp>
+      <p:graphicFrame>
+        <p:nvGraphicFramePr>
+          <p:cNvPr id="9" name="Table 8"/>
+          <p:cNvGraphicFramePr>
+            <a:graphicFrameLocks noGrp="1"/>
+          </p:cNvGraphicFramePr>
+          <p:nvPr/>
+        </p:nvGraphicFramePr>
+        <p:xfrm>
+          <a:off x="731520" y="1344168"/>
+          <a:ext cx="10716766" cy="4361688"/>
+        </p:xfrm>
+        <a:graphic>
+          <a:graphicData uri="http://schemas.openxmlformats.org/drawingml/2006/table">
+            <a:tbl>
+              <a:tblPr firstRow="1" bandRow="1">
+                <a:tableStyleId>{5C22544A-7EE6-4342-B048-85BDC9FD1C3A}</a:tableStyleId>
+              </a:tblPr>
+              <a:tblGrid>
+                <a:gridCol w="3965204"/>
+                <a:gridCol w="1821850"/>
+                <a:gridCol w="1821850"/>
+                <a:gridCol w="1607515"/>
+                <a:gridCol w="1500347"/>
+              </a:tblGrid>
+              <a:tr h="363474">
+                <a:tc>
+                  <a:txBody>
+                    <a:bodyPr/>
+                    <a:lstStyle/>
+                    <a:p>
+                      <a:pPr algn="l">
+                        <a:spcAft>
+                          <a:spcPts val="0"/>
+                        </a:spcAft>
+                      </a:pPr>
+                      <a:r>
+                        <a:rPr sz="1500" b="1">
+                          <a:solidFill>
+                            <a:srgbClr val="FFFFFF"/>
+                          </a:solidFill>
+                          <a:latin typeface="Arial"/>
+                        </a:rPr>
+                        <a:t>Request</a:t>
+                      </a:r>
+                    </a:p>
+                  </a:txBody>
+                  <a:tcPr marL="109728" marR="91440" marT="36576" marB="36576">
+                    <a:solidFill>
+                      <a:srgbClr val="252B33"/>
+                    </a:solidFill>
+                  </a:tcPr>
+                </a:tc>
+                <a:tc>
+                  <a:txBody>
+                    <a:bodyPr/>
+                    <a:lstStyle/>
+                    <a:p>
+                      <a:pPr algn="l">
+                        <a:spcAft>
+                          <a:spcPts val="0"/>
+                        </a:spcAft>
+                      </a:pPr>
+                      <a:r>
+                        <a:rPr sz="1500" b="1">
+                          <a:solidFill>
+                            <a:srgbClr val="FFFFFF"/>
+                          </a:solidFill>
+                          <a:latin typeface="Arial"/>
+                        </a:rPr>
+                        <a:t>Baseline p95</a:t>
+                      </a:r>
+                    </a:p>
+                  </a:txBody>
+                  <a:tcPr marL="109728" marR="91440" marT="36576" marB="36576">
+                    <a:solidFill>
+                      <a:srgbClr val="252B33"/>
+                    </a:solidFill>
+                  </a:tcPr>
+                </a:tc>
+                <a:tc>
+                  <a:txBody>
+                    <a:bodyPr/>
+                    <a:lstStyle/>
+                    <a:p>
+                      <a:pPr algn="l">
+                        <a:spcAft>
+                          <a:spcPts val="0"/>
+                        </a:spcAft>
+                      </a:pPr>
+                      <a:r>
+                        <a:rPr sz="1500" b="1">
+                          <a:solidFill>
+                            <a:srgbClr val="FFFFFF"/>
+                          </a:solidFill>
+                          <a:latin typeface="Arial"/>
+                        </a:rPr>
+                        <a:t>After p95</a:t>
+                      </a:r>
+                    </a:p>
+                  </a:txBody>
+                  <a:tcPr marL="109728" marR="91440" marT="36576" marB="36576">
+                    <a:solidFill>
+                      <a:srgbClr val="252B33"/>
+                    </a:solidFill>
+                  </a:tcPr>
+                </a:tc>
+                <a:tc>
+                  <a:txBody>
+                    <a:bodyPr/>
+                    <a:lstStyle/>
+                    <a:p>
+                      <a:pPr algn="l">
+                        <a:spcAft>
+                          <a:spcPts val="0"/>
+                        </a:spcAft>
+                      </a:pPr>
+                      <a:r>
+                        <a:rPr sz="1500" b="1">
+                          <a:solidFill>
+                            <a:srgbClr val="FFFFFF"/>
+                          </a:solidFill>
+                          <a:latin typeface="Arial"/>
+                        </a:rPr>
+                        <a:t>Failures B→A</a:t>
+                      </a:r>
+                    </a:p>
+                  </a:txBody>
+                  <a:tcPr marL="109728" marR="91440" marT="36576" marB="36576">
+                    <a:solidFill>
+                      <a:srgbClr val="252B33"/>
+                    </a:solidFill>
+                  </a:tcPr>
+                </a:tc>
+                <a:tc>
+                  <a:txBody>
+                    <a:bodyPr/>
+                    <a:lstStyle/>
+                    <a:p>
+                      <a:pPr algn="l">
+                        <a:spcAft>
+                          <a:spcPts val="0"/>
+                        </a:spcAft>
+                      </a:pPr>
+                      <a:r>
+                        <a:rPr sz="1500" b="1">
+                          <a:solidFill>
+                            <a:srgbClr val="FFFFFF"/>
+                          </a:solidFill>
+                          <a:latin typeface="Arial"/>
+                        </a:rPr>
+                        <a:t>p95</a:t>
+                      </a:r>
+                    </a:p>
+                  </a:txBody>
+                  <a:tcPr marL="109728" marR="91440" marT="36576" marB="36576">
+                    <a:solidFill>
+                      <a:srgbClr val="252B33"/>
+                    </a:solidFill>
+                  </a:tcPr>
+                </a:tc>
+              </a:tr>
+              <a:tr h="363474">
+                <a:tc>
+                  <a:txBody>
+                    <a:bodyPr/>
+                    <a:lstStyle/>
+                    <a:p>
+                      <a:pPr algn="l">
+                        <a:spcAft>
+                          <a:spcPts val="0"/>
+                        </a:spcAft>
+                      </a:pPr>
+                      <a:r>
+                        <a:rPr sz="1500" b="0">
+                          <a:solidFill>
+                            <a:srgbClr val="252B33"/>
+                          </a:solidFill>
+                          <a:latin typeface="Arial"/>
+                        </a:rPr>
+                        <a:t>Total</a:t>
+                      </a:r>
+                    </a:p>
+                  </a:txBody>
+                  <a:tcPr marL="109728" marR="91440" marT="36576" marB="36576">
+                    <a:solidFill>
+                      <a:srgbClr val="FFFFFF"/>
+                    </a:solidFill>
+                  </a:tcPr>
+                </a:tc>
+                <a:tc>
+                  <a:txBody>
+                    <a:bodyPr/>
+                    <a:lstStyle/>
+                    <a:p>
+                      <a:pPr algn="l">
+                        <a:spcAft>
+                          <a:spcPts val="0"/>
+                        </a:spcAft>
+                      </a:pPr>
+                      <a:r>
+                        <a:rPr sz="1500" b="0">
+                          <a:solidFill>
+                            <a:srgbClr val="252B33"/>
+                          </a:solidFill>
+                          <a:latin typeface="Arial"/>
+                        </a:rPr>
+                        <a:t>33,401.75</a:t>
+                      </a:r>
+                    </a:p>
+                  </a:txBody>
+                  <a:tcPr marL="109728" marR="91440" marT="36576" marB="36576">
+                    <a:solidFill>
+                      <a:srgbClr val="FFFFFF"/>
+                    </a:solidFill>
+                  </a:tcPr>
+                </a:tc>
+                <a:tc>
+                  <a:txBody>
+                    <a:bodyPr/>
+                    <a:lstStyle/>
+                    <a:p>
+                      <a:pPr algn="l">
+                        <a:spcAft>
+                          <a:spcPts val="0"/>
+                        </a:spcAft>
+                      </a:pPr>
+                      <a:r>
+                        <a:rPr sz="1500" b="0">
+                          <a:solidFill>
+                            <a:srgbClr val="252B33"/>
+                          </a:solidFill>
+                          <a:latin typeface="Arial"/>
+                        </a:rPr>
+                        <a:t>4,730.85</a:t>
+                      </a:r>
+                    </a:p>
+                  </a:txBody>
+                  <a:tcPr marL="109728" marR="91440" marT="36576" marB="36576">
+                    <a:solidFill>
+                      <a:srgbClr val="FFFFFF"/>
+                    </a:solidFill>
+                  </a:tcPr>
+                </a:tc>
+                <a:tc>
+                  <a:txBody>
+                    <a:bodyPr/>
+                    <a:lstStyle/>
+                    <a:p>
+                      <a:pPr algn="l">
+                        <a:spcAft>
+                          <a:spcPts val="0"/>
+                        </a:spcAft>
+                      </a:pPr>
+                      <a:r>
+                        <a:rPr sz="1500" b="0">
+                          <a:solidFill>
+                            <a:srgbClr val="252B33"/>
+                          </a:solidFill>
+                          <a:latin typeface="Arial"/>
+                        </a:rPr>
+                        <a:t>218→0</a:t>
+                      </a:r>
+                    </a:p>
+                  </a:txBody>
+                  <a:tcPr marL="109728" marR="91440" marT="36576" marB="36576">
+                    <a:solidFill>
+                      <a:srgbClr val="FFFFFF"/>
+                    </a:solidFill>
+                  </a:tcPr>
+                </a:tc>
+                <a:tc>
+                  <a:txBody>
+                    <a:bodyPr/>
+                    <a:lstStyle/>
+                    <a:p>
+                      <a:pPr algn="l">
+                        <a:spcAft>
+                          <a:spcPts val="0"/>
+                        </a:spcAft>
+                      </a:pPr>
+                      <a:r>
+                        <a:rPr sz="1500" b="1">
+                          <a:solidFill>
+                            <a:srgbClr val="246F46"/>
+                          </a:solidFill>
+                          <a:latin typeface="Arial"/>
+                        </a:rPr>
+                        <a:t>Lower</a:t>
+                      </a:r>
+                    </a:p>
+                  </a:txBody>
+                  <a:tcPr marL="109728" marR="91440" marT="36576" marB="36576">
+                    <a:solidFill>
+                      <a:srgbClr val="FFFFFF"/>
+                    </a:solidFill>
+                  </a:tcPr>
+                </a:tc>
+              </a:tr>
+              <a:tr h="363474">
+                <a:tc>
+                  <a:txBody>
+                    <a:bodyPr/>
+                    <a:lstStyle/>
+                    <a:p>
+                      <a:pPr algn="l">
+                        <a:spcAft>
+                          <a:spcPts val="0"/>
+                        </a:spcAft>
+                      </a:pPr>
+                      <a:r>
+                        <a:rPr sz="1500" b="0">
+                          <a:solidFill>
+                            <a:srgbClr val="252B33"/>
+                          </a:solidFill>
+                          <a:latin typeface="Arial"/>
+                        </a:rPr>
+                        <a:t>GET /accounts</a:t>
+                      </a:r>
+                    </a:p>
+                  </a:txBody>
+                  <a:tcPr marL="109728" marR="91440" marT="36576" marB="36576">
+                    <a:solidFill>
+                      <a:srgbClr val="F7F9FC"/>
+                    </a:solidFill>
+                  </a:tcPr>
+                </a:tc>
+                <a:tc>
+                  <a:txBody>
+                    <a:bodyPr/>
+                    <a:lstStyle/>
+                    <a:p>
+                      <a:pPr algn="l">
+                        <a:spcAft>
+                          <a:spcPts val="0"/>
+                        </a:spcAft>
+                      </a:pPr>
+                      <a:r>
+                        <a:rPr sz="1500" b="0">
+                          <a:solidFill>
+                            <a:srgbClr val="252B33"/>
+                          </a:solidFill>
+                          <a:latin typeface="Arial"/>
+                        </a:rPr>
+                        <a:t>18,515.45</a:t>
+                      </a:r>
+                    </a:p>
+                  </a:txBody>
+                  <a:tcPr marL="109728" marR="91440" marT="36576" marB="36576">
+                    <a:solidFill>
+                      <a:srgbClr val="F7F9FC"/>
+                    </a:solidFill>
+                  </a:tcPr>
+                </a:tc>
+                <a:tc>
+                  <a:txBody>
+                    <a:bodyPr/>
+                    <a:lstStyle/>
+                    <a:p>
+                      <a:pPr algn="l">
+                        <a:spcAft>
+                          <a:spcPts val="0"/>
+                        </a:spcAft>
+                      </a:pPr>
+                      <a:r>
+                        <a:rPr sz="1500" b="0">
+                          <a:solidFill>
+                            <a:srgbClr val="252B33"/>
+                          </a:solidFill>
+                          <a:latin typeface="Arial"/>
+                        </a:rPr>
+                        <a:t>3,083.00</a:t>
+                      </a:r>
+                    </a:p>
+                  </a:txBody>
+                  <a:tcPr marL="109728" marR="91440" marT="36576" marB="36576">
+                    <a:solidFill>
+                      <a:srgbClr val="F7F9FC"/>
+                    </a:solidFill>
+                  </a:tcPr>
+                </a:tc>
+                <a:tc>
+                  <a:txBody>
+                    <a:bodyPr/>
+                    <a:lstStyle/>
+                    <a:p>
+                      <a:pPr algn="l">
+                        <a:spcAft>
+                          <a:spcPts val="0"/>
+                        </a:spcAft>
+                      </a:pPr>
+                      <a:r>
+                        <a:rPr sz="1500" b="0">
+                          <a:solidFill>
+                            <a:srgbClr val="252B33"/>
+                          </a:solidFill>
+                          <a:latin typeface="Arial"/>
+                        </a:rPr>
+                        <a:t>0→0</a:t>
+                      </a:r>
+                    </a:p>
+                  </a:txBody>
+                  <a:tcPr marL="109728" marR="91440" marT="36576" marB="36576">
+                    <a:solidFill>
+                      <a:srgbClr val="F7F9FC"/>
+                    </a:solidFill>
+                  </a:tcPr>
+                </a:tc>
+                <a:tc>
+                  <a:txBody>
+                    <a:bodyPr/>
+                    <a:lstStyle/>
+                    <a:p>
+                      <a:pPr algn="l">
+                        <a:spcAft>
+                          <a:spcPts val="0"/>
+                        </a:spcAft>
+                      </a:pPr>
+                      <a:r>
+                        <a:rPr sz="1500" b="1">
+                          <a:solidFill>
+                            <a:srgbClr val="246F46"/>
+                          </a:solidFill>
+                          <a:latin typeface="Arial"/>
+                        </a:rPr>
+                        <a:t>Lower</a:t>
+                      </a:r>
+                    </a:p>
+                  </a:txBody>
+                  <a:tcPr marL="109728" marR="91440" marT="36576" marB="36576">
+                    <a:solidFill>
+                      <a:srgbClr val="F7F9FC"/>
+                    </a:solidFill>
+                  </a:tcPr>
+                </a:tc>
+              </a:tr>
+              <a:tr h="363474">
+                <a:tc>
+                  <a:txBody>
+                    <a:bodyPr/>
+                    <a:lstStyle/>
+                    <a:p>
+                      <a:pPr algn="l">
+                        <a:spcAft>
+                          <a:spcPts val="0"/>
+                        </a:spcAft>
+                      </a:pPr>
+                      <a:r>
+                        <a:rPr sz="1500" b="0">
+                          <a:solidFill>
+                            <a:srgbClr val="252B33"/>
+                          </a:solidFill>
+                          <a:latin typeface="Arial"/>
+                        </a:rPr>
+                        <a:t>GET /journal-entries</a:t>
+                      </a:r>
+                    </a:p>
+                  </a:txBody>
+                  <a:tcPr marL="109728" marR="91440" marT="36576" marB="36576">
+                    <a:solidFill>
+                      <a:srgbClr val="FFFFFF"/>
+                    </a:solidFill>
+                  </a:tcPr>
+                </a:tc>
+                <a:tc>
+                  <a:txBody>
+                    <a:bodyPr/>
+                    <a:lstStyle/>
+                    <a:p>
+                      <a:pPr algn="l">
+                        <a:spcAft>
+                          <a:spcPts val="0"/>
+                        </a:spcAft>
+                      </a:pPr>
+                      <a:r>
+                        <a:rPr sz="1500" b="0">
+                          <a:solidFill>
+                            <a:srgbClr val="252B33"/>
+                          </a:solidFill>
+                          <a:latin typeface="Arial"/>
+                        </a:rPr>
+                        <a:t>15,215.85</a:t>
+                      </a:r>
+                    </a:p>
+                  </a:txBody>
+                  <a:tcPr marL="109728" marR="91440" marT="36576" marB="36576">
+                    <a:solidFill>
+                      <a:srgbClr val="FFFFFF"/>
+                    </a:solidFill>
+                  </a:tcPr>
+                </a:tc>
+                <a:tc>
+                  <a:txBody>
+                    <a:bodyPr/>
+                    <a:lstStyle/>
+                    <a:p>
+                      <a:pPr algn="l">
+                        <a:spcAft>
+                          <a:spcPts val="0"/>
+                        </a:spcAft>
+                      </a:pPr>
+                      <a:r>
+                        <a:rPr sz="1500" b="0">
+                          <a:solidFill>
+                            <a:srgbClr val="252B33"/>
+                          </a:solidFill>
+                          <a:latin typeface="Arial"/>
+                        </a:rPr>
+                        <a:t>2,609.95</a:t>
+                      </a:r>
+                    </a:p>
+                  </a:txBody>
+                  <a:tcPr marL="109728" marR="91440" marT="36576" marB="36576">
+                    <a:solidFill>
+                      <a:srgbClr val="FFFFFF"/>
+                    </a:solidFill>
+                  </a:tcPr>
+                </a:tc>
+                <a:tc>
+                  <a:txBody>
+                    <a:bodyPr/>
+                    <a:lstStyle/>
+                    <a:p>
+                      <a:pPr algn="l">
+                        <a:spcAft>
+                          <a:spcPts val="0"/>
+                        </a:spcAft>
+                      </a:pPr>
+                      <a:r>
+                        <a:rPr sz="1500" b="0">
+                          <a:solidFill>
+                            <a:srgbClr val="252B33"/>
+                          </a:solidFill>
+                          <a:latin typeface="Arial"/>
+                        </a:rPr>
+                        <a:t>0→0</a:t>
+                      </a:r>
+                    </a:p>
+                  </a:txBody>
+                  <a:tcPr marL="109728" marR="91440" marT="36576" marB="36576">
+                    <a:solidFill>
+                      <a:srgbClr val="FFFFFF"/>
+                    </a:solidFill>
+                  </a:tcPr>
+                </a:tc>
+                <a:tc>
+                  <a:txBody>
+                    <a:bodyPr/>
+                    <a:lstStyle/>
+                    <a:p>
+                      <a:pPr algn="l">
+                        <a:spcAft>
+                          <a:spcPts val="0"/>
+                        </a:spcAft>
+                      </a:pPr>
+                      <a:r>
+                        <a:rPr sz="1500" b="1">
+                          <a:solidFill>
+                            <a:srgbClr val="246F46"/>
+                          </a:solidFill>
+                          <a:latin typeface="Arial"/>
+                        </a:rPr>
+                        <a:t>Lower</a:t>
+                      </a:r>
+                    </a:p>
+                  </a:txBody>
+                  <a:tcPr marL="109728" marR="91440" marT="36576" marB="36576">
+                    <a:solidFill>
+                      <a:srgbClr val="FFFFFF"/>
+                    </a:solidFill>
+                  </a:tcPr>
+                </a:tc>
+              </a:tr>
+              <a:tr h="363474">
+                <a:tc>
+                  <a:txBody>
+                    <a:bodyPr/>
+                    <a:lstStyle/>
+                    <a:p>
+                      <a:pPr algn="l">
+                        <a:spcAft>
+                          <a:spcPts val="0"/>
+                        </a:spcAft>
+                      </a:pPr>
+                      <a:r>
+                        <a:rPr sz="1500" b="0">
+                          <a:solidFill>
+                            <a:srgbClr val="252B33"/>
+                          </a:solidFill>
+                          <a:latin typeface="Arial"/>
+                        </a:rPr>
+                        <a:t>GET /periods</a:t>
+                      </a:r>
+                    </a:p>
+                  </a:txBody>
+                  <a:tcPr marL="109728" marR="91440" marT="36576" marB="36576">
+                    <a:solidFill>
+                      <a:srgbClr val="F7F9FC"/>
+                    </a:solidFill>
+                  </a:tcPr>
+                </a:tc>
+                <a:tc>
+                  <a:txBody>
+                    <a:bodyPr/>
+                    <a:lstStyle/>
+                    <a:p>
+                      <a:pPr algn="l">
+                        <a:spcAft>
+                          <a:spcPts val="0"/>
+                        </a:spcAft>
+                      </a:pPr>
+                      <a:r>
+                        <a:rPr sz="1500" b="0">
+                          <a:solidFill>
+                            <a:srgbClr val="252B33"/>
+                          </a:solidFill>
+                          <a:latin typeface="Arial"/>
+                        </a:rPr>
+                        <a:t>9,585.70</a:t>
+                      </a:r>
+                    </a:p>
+                  </a:txBody>
+                  <a:tcPr marL="109728" marR="91440" marT="36576" marB="36576">
+                    <a:solidFill>
+                      <a:srgbClr val="F7F9FC"/>
+                    </a:solidFill>
+                  </a:tcPr>
+                </a:tc>
+                <a:tc>
+                  <a:txBody>
+                    <a:bodyPr/>
+                    <a:lstStyle/>
+                    <a:p>
+                      <a:pPr algn="l">
+                        <a:spcAft>
+                          <a:spcPts val="0"/>
+                        </a:spcAft>
+                      </a:pPr>
+                      <a:r>
+                        <a:rPr sz="1500" b="0">
+                          <a:solidFill>
+                            <a:srgbClr val="252B33"/>
+                          </a:solidFill>
+                          <a:latin typeface="Arial"/>
+                        </a:rPr>
+                        <a:t>1,734.00</a:t>
+                      </a:r>
+                    </a:p>
+                  </a:txBody>
+                  <a:tcPr marL="109728" marR="91440" marT="36576" marB="36576">
+                    <a:solidFill>
+                      <a:srgbClr val="F7F9FC"/>
+                    </a:solidFill>
+                  </a:tcPr>
+                </a:tc>
+                <a:tc>
+                  <a:txBody>
+                    <a:bodyPr/>
+                    <a:lstStyle/>
+                    <a:p>
+                      <a:pPr algn="l">
+                        <a:spcAft>
+                          <a:spcPts val="0"/>
+                        </a:spcAft>
+                      </a:pPr>
+                      <a:r>
+                        <a:rPr sz="1500" b="0">
+                          <a:solidFill>
+                            <a:srgbClr val="252B33"/>
+                          </a:solidFill>
+                          <a:latin typeface="Arial"/>
+                        </a:rPr>
+                        <a:t>1→0</a:t>
+                      </a:r>
+                    </a:p>
+                  </a:txBody>
+                  <a:tcPr marL="109728" marR="91440" marT="36576" marB="36576">
+                    <a:solidFill>
+                      <a:srgbClr val="F7F9FC"/>
+                    </a:solidFill>
+                  </a:tcPr>
+                </a:tc>
+                <a:tc>
+                  <a:txBody>
+                    <a:bodyPr/>
+                    <a:lstStyle/>
+                    <a:p>
+                      <a:pPr algn="l">
+                        <a:spcAft>
+                          <a:spcPts val="0"/>
+                        </a:spcAft>
+                      </a:pPr>
+                      <a:r>
+                        <a:rPr sz="1500" b="1">
+                          <a:solidFill>
+                            <a:srgbClr val="246F46"/>
+                          </a:solidFill>
+                          <a:latin typeface="Arial"/>
+                        </a:rPr>
+                        <a:t>Lower</a:t>
+                      </a:r>
+                    </a:p>
+                  </a:txBody>
+                  <a:tcPr marL="109728" marR="91440" marT="36576" marB="36576">
+                    <a:solidFill>
+                      <a:srgbClr val="F7F9FC"/>
+                    </a:solidFill>
+                  </a:tcPr>
+                </a:tc>
+              </a:tr>
+              <a:tr h="363474">
+                <a:tc>
+                  <a:txBody>
+                    <a:bodyPr/>
+                    <a:lstStyle/>
+                    <a:p>
+                      <a:pPr algn="l">
+                        <a:spcAft>
+                          <a:spcPts val="0"/>
+                        </a:spcAft>
+                      </a:pPr>
+                      <a:r>
+                        <a:rPr sz="1500" b="0">
+                          <a:solidFill>
+                            <a:srgbClr val="252B33"/>
+                          </a:solidFill>
+                          <a:latin typeface="Arial"/>
+                        </a:rPr>
+                        <a:t>GET /reports/account-ledger</a:t>
+                      </a:r>
+                    </a:p>
+                  </a:txBody>
+                  <a:tcPr marL="109728" marR="91440" marT="36576" marB="36576">
+                    <a:solidFill>
+                      <a:srgbClr val="FFFFFF"/>
+                    </a:solidFill>
+                  </a:tcPr>
+                </a:tc>
+                <a:tc>
+                  <a:txBody>
+                    <a:bodyPr/>
+                    <a:lstStyle/>
+                    <a:p>
+                      <a:pPr algn="l">
+                        <a:spcAft>
+                          <a:spcPts val="0"/>
+                        </a:spcAft>
+                      </a:pPr>
+                      <a:r>
+                        <a:rPr sz="1500" b="0">
+                          <a:solidFill>
+                            <a:srgbClr val="252B33"/>
+                          </a:solidFill>
+                          <a:latin typeface="Arial"/>
+                        </a:rPr>
+                        <a:t>50,288.30</a:t>
+                      </a:r>
+                    </a:p>
+                  </a:txBody>
+                  <a:tcPr marL="109728" marR="91440" marT="36576" marB="36576">
+                    <a:solidFill>
+                      <a:srgbClr val="FFFFFF"/>
+                    </a:solidFill>
+                  </a:tcPr>
+                </a:tc>
+                <a:tc>
+                  <a:txBody>
+                    <a:bodyPr/>
+                    <a:lstStyle/>
+                    <a:p>
+                      <a:pPr algn="l">
+                        <a:spcAft>
+                          <a:spcPts val="0"/>
+                        </a:spcAft>
+                      </a:pPr>
+                      <a:r>
+                        <a:rPr sz="1500" b="0">
+                          <a:solidFill>
+                            <a:srgbClr val="252B33"/>
+                          </a:solidFill>
+                          <a:latin typeface="Arial"/>
+                        </a:rPr>
+                        <a:t>12,910.20</a:t>
+                      </a:r>
+                    </a:p>
+                  </a:txBody>
+                  <a:tcPr marL="109728" marR="91440" marT="36576" marB="36576">
+                    <a:solidFill>
+                      <a:srgbClr val="FFFFFF"/>
+                    </a:solidFill>
+                  </a:tcPr>
+                </a:tc>
+                <a:tc>
+                  <a:txBody>
+                    <a:bodyPr/>
+                    <a:lstStyle/>
+                    <a:p>
+                      <a:pPr algn="l">
+                        <a:spcAft>
+                          <a:spcPts val="0"/>
+                        </a:spcAft>
+                      </a:pPr>
+                      <a:r>
+                        <a:rPr sz="1500" b="0">
+                          <a:solidFill>
+                            <a:srgbClr val="252B33"/>
+                          </a:solidFill>
+                          <a:latin typeface="Arial"/>
+                        </a:rPr>
+                        <a:t>27→0</a:t>
+                      </a:r>
+                    </a:p>
+                  </a:txBody>
+                  <a:tcPr marL="109728" marR="91440" marT="36576" marB="36576">
+                    <a:solidFill>
+                      <a:srgbClr val="FFFFFF"/>
+                    </a:solidFill>
+                  </a:tcPr>
+                </a:tc>
+                <a:tc>
+                  <a:txBody>
+                    <a:bodyPr/>
+                    <a:lstStyle/>
+                    <a:p>
+                      <a:pPr algn="l">
+                        <a:spcAft>
+                          <a:spcPts val="0"/>
+                        </a:spcAft>
+                      </a:pPr>
+                      <a:r>
+                        <a:rPr sz="1500" b="1">
+                          <a:solidFill>
+                            <a:srgbClr val="246F46"/>
+                          </a:solidFill>
+                          <a:latin typeface="Arial"/>
+                        </a:rPr>
+                        <a:t>Lower</a:t>
+                      </a:r>
+                    </a:p>
+                  </a:txBody>
+                  <a:tcPr marL="109728" marR="91440" marT="36576" marB="36576">
+                    <a:solidFill>
+                      <a:srgbClr val="FFFFFF"/>
+                    </a:solidFill>
+                  </a:tcPr>
+                </a:tc>
+              </a:tr>
+              <a:tr h="363474">
+                <a:tc>
+                  <a:txBody>
+                    <a:bodyPr/>
+                    <a:lstStyle/>
+                    <a:p>
+                      <a:pPr algn="l">
+                        <a:spcAft>
+                          <a:spcPts val="0"/>
+                        </a:spcAft>
+                      </a:pPr>
+                      <a:r>
+                        <a:rPr sz="1500" b="0">
+                          <a:solidFill>
+                            <a:srgbClr val="252B33"/>
+                          </a:solidFill>
+                          <a:latin typeface="Arial"/>
+                        </a:rPr>
+                        <a:t>GET /reports/balance-sheet</a:t>
+                      </a:r>
+                    </a:p>
+                  </a:txBody>
+                  <a:tcPr marL="109728" marR="91440" marT="36576" marB="36576">
+                    <a:solidFill>
+                      <a:srgbClr val="F7F9FC"/>
+                    </a:solidFill>
+                  </a:tcPr>
+                </a:tc>
+                <a:tc>
+                  <a:txBody>
+                    <a:bodyPr/>
+                    <a:lstStyle/>
+                    <a:p>
+                      <a:pPr algn="l">
+                        <a:spcAft>
+                          <a:spcPts val="0"/>
+                        </a:spcAft>
+                      </a:pPr>
+                      <a:r>
+                        <a:rPr sz="1500" b="0">
+                          <a:solidFill>
+                            <a:srgbClr val="252B33"/>
+                          </a:solidFill>
+                          <a:latin typeface="Arial"/>
+                        </a:rPr>
+                        <a:t>32,732.65</a:t>
+                      </a:r>
+                    </a:p>
+                  </a:txBody>
+                  <a:tcPr marL="109728" marR="91440" marT="36576" marB="36576">
+                    <a:solidFill>
+                      <a:srgbClr val="F7F9FC"/>
+                    </a:solidFill>
+                  </a:tcPr>
+                </a:tc>
+                <a:tc>
+                  <a:txBody>
+                    <a:bodyPr/>
+                    <a:lstStyle/>
+                    <a:p>
+                      <a:pPr algn="l">
+                        <a:spcAft>
+                          <a:spcPts val="0"/>
+                        </a:spcAft>
+                      </a:pPr>
+                      <a:r>
+                        <a:rPr sz="1500" b="0">
+                          <a:solidFill>
+                            <a:srgbClr val="252B33"/>
+                          </a:solidFill>
+                          <a:latin typeface="Arial"/>
+                        </a:rPr>
+                        <a:t>2,554.90</a:t>
+                      </a:r>
+                    </a:p>
+                  </a:txBody>
+                  <a:tcPr marL="109728" marR="91440" marT="36576" marB="36576">
+                    <a:solidFill>
+                      <a:srgbClr val="F7F9FC"/>
+                    </a:solidFill>
+                  </a:tcPr>
+                </a:tc>
+                <a:tc>
+                  <a:txBody>
+                    <a:bodyPr/>
+                    <a:lstStyle/>
+                    <a:p>
+                      <a:pPr algn="l">
+                        <a:spcAft>
+                          <a:spcPts val="0"/>
+                        </a:spcAft>
+                      </a:pPr>
+                      <a:r>
+                        <a:rPr sz="1500" b="0">
+                          <a:solidFill>
+                            <a:srgbClr val="252B33"/>
+                          </a:solidFill>
+                          <a:latin typeface="Arial"/>
+                        </a:rPr>
+                        <a:t>69→0</a:t>
+                      </a:r>
+                    </a:p>
+                  </a:txBody>
+                  <a:tcPr marL="109728" marR="91440" marT="36576" marB="36576">
+                    <a:solidFill>
+                      <a:srgbClr val="F7F9FC"/>
+                    </a:solidFill>
+                  </a:tcPr>
+                </a:tc>
+                <a:tc>
+                  <a:txBody>
+                    <a:bodyPr/>
+                    <a:lstStyle/>
+                    <a:p>
+                      <a:pPr algn="l">
+                        <a:spcAft>
+                          <a:spcPts val="0"/>
+                        </a:spcAft>
+                      </a:pPr>
+                      <a:r>
+                        <a:rPr sz="1500" b="1">
+                          <a:solidFill>
+                            <a:srgbClr val="246F46"/>
+                          </a:solidFill>
+                          <a:latin typeface="Arial"/>
+                        </a:rPr>
+                        <a:t>Lower</a:t>
+                      </a:r>
+                    </a:p>
+                  </a:txBody>
+                  <a:tcPr marL="109728" marR="91440" marT="36576" marB="36576">
+                    <a:solidFill>
+                      <a:srgbClr val="F7F9FC"/>
+                    </a:solidFill>
+                  </a:tcPr>
+                </a:tc>
+              </a:tr>
+              <a:tr h="363474">
+                <a:tc>
+                  <a:txBody>
+                    <a:bodyPr/>
+                    <a:lstStyle/>
+                    <a:p>
+                      <a:pPr algn="l">
+                        <a:spcAft>
+                          <a:spcPts val="0"/>
+                        </a:spcAft>
+                      </a:pPr>
+                      <a:r>
+                        <a:rPr sz="1500" b="0">
+                          <a:solidFill>
+                            <a:srgbClr val="252B33"/>
+                          </a:solidFill>
+                          <a:latin typeface="Arial"/>
+                        </a:rPr>
+                        <a:t>GET /reports/profit-loss</a:t>
+                      </a:r>
+                    </a:p>
+                  </a:txBody>
+                  <a:tcPr marL="109728" marR="91440" marT="36576" marB="36576">
+                    <a:solidFill>
+                      <a:srgbClr val="FFFFFF"/>
+                    </a:solidFill>
+                  </a:tcPr>
+                </a:tc>
+                <a:tc>
+                  <a:txBody>
+                    <a:bodyPr/>
+                    <a:lstStyle/>
+                    <a:p>
+                      <a:pPr algn="l">
+                        <a:spcAft>
+                          <a:spcPts val="0"/>
+                        </a:spcAft>
+                      </a:pPr>
+                      <a:r>
+                        <a:rPr sz="1500" b="0">
+                          <a:solidFill>
+                            <a:srgbClr val="252B33"/>
+                          </a:solidFill>
+                          <a:latin typeface="Arial"/>
+                        </a:rPr>
+                        <a:t>31,487.90</a:t>
+                      </a:r>
+                    </a:p>
+                  </a:txBody>
+                  <a:tcPr marL="109728" marR="91440" marT="36576" marB="36576">
+                    <a:solidFill>
+                      <a:srgbClr val="FFFFFF"/>
+                    </a:solidFill>
+                  </a:tcPr>
+                </a:tc>
+                <a:tc>
+                  <a:txBody>
+                    <a:bodyPr/>
+                    <a:lstStyle/>
+                    <a:p>
+                      <a:pPr algn="l">
+                        <a:spcAft>
+                          <a:spcPts val="0"/>
+                        </a:spcAft>
+                      </a:pPr>
+                      <a:r>
+                        <a:rPr sz="1500" b="0">
+                          <a:solidFill>
+                            <a:srgbClr val="252B33"/>
+                          </a:solidFill>
+                          <a:latin typeface="Arial"/>
+                        </a:rPr>
+                        <a:t>2,342.75</a:t>
+                      </a:r>
+                    </a:p>
+                  </a:txBody>
+                  <a:tcPr marL="109728" marR="91440" marT="36576" marB="36576">
+                    <a:solidFill>
+                      <a:srgbClr val="FFFFFF"/>
+                    </a:solidFill>
+                  </a:tcPr>
+                </a:tc>
+                <a:tc>
+                  <a:txBody>
+                    <a:bodyPr/>
+                    <a:lstStyle/>
+                    <a:p>
+                      <a:pPr algn="l">
+                        <a:spcAft>
+                          <a:spcPts val="0"/>
+                        </a:spcAft>
+                      </a:pPr>
+                      <a:r>
+                        <a:rPr sz="1500" b="0">
+                          <a:solidFill>
+                            <a:srgbClr val="252B33"/>
+                          </a:solidFill>
+                          <a:latin typeface="Arial"/>
+                        </a:rPr>
+                        <a:t>69→0</a:t>
+                      </a:r>
+                    </a:p>
+                  </a:txBody>
+                  <a:tcPr marL="109728" marR="91440" marT="36576" marB="36576">
+                    <a:solidFill>
+                      <a:srgbClr val="FFFFFF"/>
+                    </a:solidFill>
+                  </a:tcPr>
+                </a:tc>
+                <a:tc>
+                  <a:txBody>
+                    <a:bodyPr/>
+                    <a:lstStyle/>
+                    <a:p>
+                      <a:pPr algn="l">
+                        <a:spcAft>
+                          <a:spcPts val="0"/>
+                        </a:spcAft>
+                      </a:pPr>
+                      <a:r>
+                        <a:rPr sz="1500" b="1">
+                          <a:solidFill>
+                            <a:srgbClr val="246F46"/>
+                          </a:solidFill>
+                          <a:latin typeface="Arial"/>
+                        </a:rPr>
+                        <a:t>Lower</a:t>
+                      </a:r>
+                    </a:p>
+                  </a:txBody>
+                  <a:tcPr marL="109728" marR="91440" marT="36576" marB="36576">
+                    <a:solidFill>
+                      <a:srgbClr val="FFFFFF"/>
+                    </a:solidFill>
+                  </a:tcPr>
+                </a:tc>
+              </a:tr>
+              <a:tr h="363474">
+                <a:tc>
+                  <a:txBody>
+                    <a:bodyPr/>
+                    <a:lstStyle/>
+                    <a:p>
+                      <a:pPr algn="l">
+                        <a:spcAft>
+                          <a:spcPts val="0"/>
+                        </a:spcAft>
+                      </a:pPr>
+                      <a:r>
+                        <a:rPr sz="1500" b="0">
+                          <a:solidFill>
+                            <a:srgbClr val="252B33"/>
+                          </a:solidFill>
+                          <a:latin typeface="Arial"/>
+                        </a:rPr>
+                        <a:t>GET /reports/trial-balance</a:t>
+                      </a:r>
+                    </a:p>
+                  </a:txBody>
+                  <a:tcPr marL="109728" marR="91440" marT="36576" marB="36576">
+                    <a:solidFill>
+                      <a:srgbClr val="F7F9FC"/>
+                    </a:solidFill>
+                  </a:tcPr>
+                </a:tc>
+                <a:tc>
+                  <a:txBody>
+                    <a:bodyPr/>
+                    <a:lstStyle/>
+                    <a:p>
+                      <a:pPr algn="l">
+                        <a:spcAft>
+                          <a:spcPts val="0"/>
+                        </a:spcAft>
+                      </a:pPr>
+                      <a:r>
+                        <a:rPr sz="1500" b="0">
+                          <a:solidFill>
+                            <a:srgbClr val="252B33"/>
+                          </a:solidFill>
+                          <a:latin typeface="Arial"/>
+                        </a:rPr>
+                        <a:t>31,142.45</a:t>
+                      </a:r>
+                    </a:p>
+                  </a:txBody>
+                  <a:tcPr marL="109728" marR="91440" marT="36576" marB="36576">
+                    <a:solidFill>
+                      <a:srgbClr val="F7F9FC"/>
+                    </a:solidFill>
+                  </a:tcPr>
+                </a:tc>
+                <a:tc>
+                  <a:txBody>
+                    <a:bodyPr/>
+                    <a:lstStyle/>
+                    <a:p>
+                      <a:pPr algn="l">
+                        <a:spcAft>
+                          <a:spcPts val="0"/>
+                        </a:spcAft>
+                      </a:pPr>
+                      <a:r>
+                        <a:rPr sz="1500" b="0">
+                          <a:solidFill>
+                            <a:srgbClr val="252B33"/>
+                          </a:solidFill>
+                          <a:latin typeface="Arial"/>
+                        </a:rPr>
+                        <a:t>2,797.70</a:t>
+                      </a:r>
+                    </a:p>
+                  </a:txBody>
+                  <a:tcPr marL="109728" marR="91440" marT="36576" marB="36576">
+                    <a:solidFill>
+                      <a:srgbClr val="F7F9FC"/>
+                    </a:solidFill>
+                  </a:tcPr>
+                </a:tc>
+                <a:tc>
+                  <a:txBody>
+                    <a:bodyPr/>
+                    <a:lstStyle/>
+                    <a:p>
+                      <a:pPr algn="l">
+                        <a:spcAft>
+                          <a:spcPts val="0"/>
+                        </a:spcAft>
+                      </a:pPr>
+                      <a:r>
+                        <a:rPr sz="1500" b="0">
+                          <a:solidFill>
+                            <a:srgbClr val="252B33"/>
+                          </a:solidFill>
+                          <a:latin typeface="Arial"/>
+                        </a:rPr>
+                        <a:t>51→0</a:t>
+                      </a:r>
+                    </a:p>
+                  </a:txBody>
+                  <a:tcPr marL="109728" marR="91440" marT="36576" marB="36576">
+                    <a:solidFill>
+                      <a:srgbClr val="F7F9FC"/>
+                    </a:solidFill>
+                  </a:tcPr>
+                </a:tc>
+                <a:tc>
+                  <a:txBody>
+                    <a:bodyPr/>
+                    <a:lstStyle/>
+                    <a:p>
+                      <a:pPr algn="l">
+                        <a:spcAft>
+                          <a:spcPts val="0"/>
+                        </a:spcAft>
+                      </a:pPr>
+                      <a:r>
+                        <a:rPr sz="1500" b="1">
+                          <a:solidFill>
+                            <a:srgbClr val="246F46"/>
+                          </a:solidFill>
+                          <a:latin typeface="Arial"/>
+                        </a:rPr>
+                        <a:t>Lower</a:t>
+                      </a:r>
+                    </a:p>
+                  </a:txBody>
+                  <a:tcPr marL="109728" marR="91440" marT="36576" marB="36576">
+                    <a:solidFill>
+                      <a:srgbClr val="F7F9FC"/>
+                    </a:solidFill>
+                  </a:tcPr>
+                </a:tc>
+              </a:tr>
+              <a:tr h="363474">
+                <a:tc>
+                  <a:txBody>
+                    <a:bodyPr/>
+                    <a:lstStyle/>
+                    <a:p>
+                      <a:pPr algn="l">
+                        <a:spcAft>
+                          <a:spcPts val="0"/>
+                        </a:spcAft>
+                      </a:pPr>
+                      <a:r>
+                        <a:rPr sz="1500" b="0">
+                          <a:solidFill>
+                            <a:srgbClr val="252B33"/>
+                          </a:solidFill>
+                          <a:latin typeface="Arial"/>
+                        </a:rPr>
+                        <a:t>GET /users/me</a:t>
+                      </a:r>
+                    </a:p>
+                  </a:txBody>
+                  <a:tcPr marL="109728" marR="91440" marT="36576" marB="36576">
+                    <a:solidFill>
+                      <a:srgbClr val="FFFFFF"/>
+                    </a:solidFill>
+                  </a:tcPr>
+                </a:tc>
+                <a:tc>
+                  <a:txBody>
+                    <a:bodyPr/>
+                    <a:lstStyle/>
+                    <a:p>
+                      <a:pPr algn="l">
+                        <a:spcAft>
+                          <a:spcPts val="0"/>
+                        </a:spcAft>
+                      </a:pPr>
+                      <a:r>
+                        <a:rPr sz="1500" b="0">
+                          <a:solidFill>
+                            <a:srgbClr val="252B33"/>
+                          </a:solidFill>
+                          <a:latin typeface="Arial"/>
+                        </a:rPr>
+                        <a:t>12,125.90</a:t>
+                      </a:r>
+                    </a:p>
+                  </a:txBody>
+                  <a:tcPr marL="109728" marR="91440" marT="36576" marB="36576">
+                    <a:solidFill>
+                      <a:srgbClr val="FFFFFF"/>
+                    </a:solidFill>
+                  </a:tcPr>
+                </a:tc>
+                <a:tc>
+                  <a:txBody>
+                    <a:bodyPr/>
+                    <a:lstStyle/>
+                    <a:p>
+                      <a:pPr algn="l">
+                        <a:spcAft>
+                          <a:spcPts val="0"/>
+                        </a:spcAft>
+                      </a:pPr>
+                      <a:r>
+                        <a:rPr sz="1500" b="0">
+                          <a:solidFill>
+                            <a:srgbClr val="252B33"/>
+                          </a:solidFill>
+                          <a:latin typeface="Arial"/>
+                        </a:rPr>
+                        <a:t>2,386.00</a:t>
+                      </a:r>
+                    </a:p>
+                  </a:txBody>
+                  <a:tcPr marL="109728" marR="91440" marT="36576" marB="36576">
+                    <a:solidFill>
+                      <a:srgbClr val="FFFFFF"/>
+                    </a:solidFill>
+                  </a:tcPr>
+                </a:tc>
+                <a:tc>
+                  <a:txBody>
+                    <a:bodyPr/>
+                    <a:lstStyle/>
+                    <a:p>
+                      <a:pPr algn="l">
+                        <a:spcAft>
+                          <a:spcPts val="0"/>
+                        </a:spcAft>
+                      </a:pPr>
+                      <a:r>
+                        <a:rPr sz="1500" b="0">
+                          <a:solidFill>
+                            <a:srgbClr val="252B33"/>
+                          </a:solidFill>
+                          <a:latin typeface="Arial"/>
+                        </a:rPr>
+                        <a:t>1→0</a:t>
+                      </a:r>
+                    </a:p>
+                  </a:txBody>
+                  <a:tcPr marL="109728" marR="91440" marT="36576" marB="36576">
+                    <a:solidFill>
+                      <a:srgbClr val="FFFFFF"/>
+                    </a:solidFill>
+                  </a:tcPr>
+                </a:tc>
+                <a:tc>
+                  <a:txBody>
+                    <a:bodyPr/>
+                    <a:lstStyle/>
+                    <a:p>
+                      <a:pPr algn="l">
+                        <a:spcAft>
+                          <a:spcPts val="0"/>
+                        </a:spcAft>
+                      </a:pPr>
+                      <a:r>
+                        <a:rPr sz="1500" b="1">
+                          <a:solidFill>
+                            <a:srgbClr val="246F46"/>
+                          </a:solidFill>
+                          <a:latin typeface="Arial"/>
+                        </a:rPr>
+                        <a:t>Lower</a:t>
+                      </a:r>
+                    </a:p>
+                  </a:txBody>
+                  <a:tcPr marL="109728" marR="91440" marT="36576" marB="36576">
+                    <a:solidFill>
+                      <a:srgbClr val="FFFFFF"/>
+                    </a:solidFill>
+                  </a:tcPr>
+                </a:tc>
+              </a:tr>
+              <a:tr h="363474">
+                <a:tc>
+                  <a:txBody>
+                    <a:bodyPr/>
+                    <a:lstStyle/>
+                    <a:p>
+                      <a:pPr algn="l">
+                        <a:spcAft>
+                          <a:spcPts val="0"/>
+                        </a:spcAft>
+                      </a:pPr>
+                      <a:r>
+                        <a:rPr sz="1500" b="0">
+                          <a:solidFill>
+                            <a:srgbClr val="252B33"/>
+                          </a:solidFill>
+                          <a:latin typeface="Arial"/>
+                        </a:rPr>
+                        <a:t>POST /auth/login</a:t>
+                      </a:r>
+                    </a:p>
+                  </a:txBody>
+                  <a:tcPr marL="109728" marR="91440" marT="36576" marB="36576">
+                    <a:solidFill>
+                      <a:srgbClr val="F7F9FC"/>
+                    </a:solidFill>
+                  </a:tcPr>
+                </a:tc>
+                <a:tc>
+                  <a:txBody>
+                    <a:bodyPr/>
+                    <a:lstStyle/>
+                    <a:p>
+                      <a:pPr algn="l">
+                        <a:spcAft>
+                          <a:spcPts val="0"/>
+                        </a:spcAft>
+                      </a:pPr>
+                      <a:r>
+                        <a:rPr sz="1500" b="0">
+                          <a:solidFill>
+                            <a:srgbClr val="252B33"/>
+                          </a:solidFill>
+                          <a:latin typeface="Arial"/>
+                        </a:rPr>
+                        <a:t>4,110.45</a:t>
+                      </a:r>
+                    </a:p>
+                  </a:txBody>
+                  <a:tcPr marL="109728" marR="91440" marT="36576" marB="36576">
+                    <a:solidFill>
+                      <a:srgbClr val="F7F9FC"/>
+                    </a:solidFill>
+                  </a:tcPr>
+                </a:tc>
+                <a:tc>
+                  <a:txBody>
+                    <a:bodyPr/>
+                    <a:lstStyle/>
+                    <a:p>
+                      <a:pPr algn="l">
+                        <a:spcAft>
+                          <a:spcPts val="0"/>
+                        </a:spcAft>
+                      </a:pPr>
+                      <a:r>
+                        <a:rPr sz="1500" b="0">
+                          <a:solidFill>
+                            <a:srgbClr val="252B33"/>
+                          </a:solidFill>
+                          <a:latin typeface="Arial"/>
+                        </a:rPr>
+                        <a:t>3,107.15</a:t>
+                      </a:r>
+                    </a:p>
+                  </a:txBody>
+                  <a:tcPr marL="109728" marR="91440" marT="36576" marB="36576">
+                    <a:solidFill>
+                      <a:srgbClr val="F7F9FC"/>
+                    </a:solidFill>
+                  </a:tcPr>
+                </a:tc>
+                <a:tc>
+                  <a:txBody>
+                    <a:bodyPr/>
+                    <a:lstStyle/>
+                    <a:p>
+                      <a:pPr algn="l">
+                        <a:spcAft>
+                          <a:spcPts val="0"/>
+                        </a:spcAft>
+                      </a:pPr>
+                      <a:r>
+                        <a:rPr sz="1500" b="0">
+                          <a:solidFill>
+                            <a:srgbClr val="252B33"/>
+                          </a:solidFill>
+                          <a:latin typeface="Arial"/>
+                        </a:rPr>
+                        <a:t>0→0</a:t>
+                      </a:r>
+                    </a:p>
+                  </a:txBody>
+                  <a:tcPr marL="109728" marR="91440" marT="36576" marB="36576">
+                    <a:solidFill>
+                      <a:srgbClr val="F7F9FC"/>
+                    </a:solidFill>
+                  </a:tcPr>
+                </a:tc>
+                <a:tc>
+                  <a:txBody>
+                    <a:bodyPr/>
+                    <a:lstStyle/>
+                    <a:p>
+                      <a:pPr algn="l">
+                        <a:spcAft>
+                          <a:spcPts val="0"/>
+                        </a:spcAft>
+                      </a:pPr>
+                      <a:r>
+                        <a:rPr sz="1500" b="1">
+                          <a:solidFill>
+                            <a:srgbClr val="246F46"/>
+                          </a:solidFill>
+                          <a:latin typeface="Arial"/>
+                        </a:rPr>
+                        <a:t>Lower</a:t>
+                      </a:r>
+                    </a:p>
+                  </a:txBody>
+                  <a:tcPr marL="109728" marR="91440" marT="36576" marB="36576">
+                    <a:solidFill>
+                      <a:srgbClr val="F7F9FC"/>
+                    </a:solidFill>
+                  </a:tcPr>
+                </a:tc>
+              </a:tr>
+              <a:tr h="363474">
+                <a:tc>
+                  <a:txBody>
+                    <a:bodyPr/>
+                    <a:lstStyle/>
+                    <a:p>
+                      <a:pPr algn="l">
+                        <a:spcAft>
+                          <a:spcPts val="0"/>
+                        </a:spcAft>
+                      </a:pPr>
+                      <a:r>
+                        <a:rPr sz="1500" b="0">
+                          <a:solidFill>
+                            <a:srgbClr val="252B33"/>
+                          </a:solidFill>
+                          <a:latin typeface="Arial"/>
+                        </a:rPr>
+                        <a:t>POST /journal-entries/bulk</a:t>
+                      </a:r>
+                    </a:p>
+                  </a:txBody>
+                  <a:tcPr marL="109728" marR="91440" marT="36576" marB="36576">
+                    <a:solidFill>
+                      <a:srgbClr val="FFFFFF"/>
+                    </a:solidFill>
+                  </a:tcPr>
+                </a:tc>
+                <a:tc>
+                  <a:txBody>
+                    <a:bodyPr/>
+                    <a:lstStyle/>
+                    <a:p>
+                      <a:pPr algn="l">
+                        <a:spcAft>
+                          <a:spcPts val="0"/>
+                        </a:spcAft>
+                      </a:pPr>
+                      <a:r>
+                        <a:rPr sz="1500" b="0">
+                          <a:solidFill>
+                            <a:srgbClr val="252B33"/>
+                          </a:solidFill>
+                          <a:latin typeface="Arial"/>
+                        </a:rPr>
+                        <a:t>12,734.75</a:t>
+                      </a:r>
+                    </a:p>
+                  </a:txBody>
+                  <a:tcPr marL="109728" marR="91440" marT="36576" marB="36576">
+                    <a:solidFill>
+                      <a:srgbClr val="FFFFFF"/>
+                    </a:solidFill>
+                  </a:tcPr>
+                </a:tc>
+                <a:tc>
+                  <a:txBody>
+                    <a:bodyPr/>
+                    <a:lstStyle/>
+                    <a:p>
+                      <a:pPr algn="l">
+                        <a:spcAft>
+                          <a:spcPts val="0"/>
+                        </a:spcAft>
+                      </a:pPr>
+                      <a:r>
+                        <a:rPr sz="1500" b="0">
+                          <a:solidFill>
+                            <a:srgbClr val="252B33"/>
+                          </a:solidFill>
+                          <a:latin typeface="Arial"/>
+                        </a:rPr>
+                        <a:t>2,544.10</a:t>
+                      </a:r>
+                    </a:p>
+                  </a:txBody>
+                  <a:tcPr marL="109728" marR="91440" marT="36576" marB="36576">
+                    <a:solidFill>
+                      <a:srgbClr val="FFFFFF"/>
+                    </a:solidFill>
+                  </a:tcPr>
+                </a:tc>
+                <a:tc>
+                  <a:txBody>
+                    <a:bodyPr/>
+                    <a:lstStyle/>
+                    <a:p>
+                      <a:pPr algn="l">
+                        <a:spcAft>
+                          <a:spcPts val="0"/>
+                        </a:spcAft>
+                      </a:pPr>
+                      <a:r>
+                        <a:rPr sz="1500" b="0">
+                          <a:solidFill>
+                            <a:srgbClr val="252B33"/>
+                          </a:solidFill>
+                          <a:latin typeface="Arial"/>
+                        </a:rPr>
+                        <a:t>0→0</a:t>
+                      </a:r>
+                    </a:p>
+                  </a:txBody>
+                  <a:tcPr marL="109728" marR="91440" marT="36576" marB="36576">
+                    <a:solidFill>
+                      <a:srgbClr val="FFFFFF"/>
+                    </a:solidFill>
+                  </a:tcPr>
+                </a:tc>
+                <a:tc>
+                  <a:txBody>
+                    <a:bodyPr/>
+                    <a:lstStyle/>
+                    <a:p>
+                      <a:pPr algn="l">
+                        <a:spcAft>
+                          <a:spcPts val="0"/>
+                        </a:spcAft>
+                      </a:pPr>
+                      <a:r>
+                        <a:rPr sz="1500" b="1">
+                          <a:solidFill>
+                            <a:srgbClr val="246F46"/>
+                          </a:solidFill>
+                          <a:latin typeface="Arial"/>
+                        </a:rPr>
+                        <a:t>Lower</a:t>
+                      </a:r>
+                    </a:p>
+                  </a:txBody>
+                  <a:tcPr marL="109728" marR="91440" marT="36576" marB="36576">
+                    <a:solidFill>
+                      <a:srgbClr val="FFFFFF"/>
+                    </a:solidFill>
+                  </a:tcPr>
+                </a:tc>
+              </a:tr>
+            </a:tbl>
+          </a:graphicData>
+        </a:graphic>
+      </p:graphicFrame>
+      <p:sp>
+        <p:nvSpPr>
+          <p:cNvPr id="10" name="Rounded Rectangle 9"/>
+          <p:cNvSpPr/>
+          <p:nvPr/>
+        </p:nvSpPr>
+        <p:spPr>
+          <a:xfrm>
+            <a:off x="768096" y="5797296"/>
+            <a:ext cx="10643616" cy="411480"/>
+          </a:xfrm>
+          <a:prstGeom prst="roundRect">
+            <a:avLst/>
+          </a:prstGeom>
+          <a:solidFill>
+            <a:srgbClr val="FFF6E7"/>
+          </a:solidFill>
+          <a:ln>
+            <a:noFill/>
+          </a:ln>
+        </p:spPr>
+        <p:style>
+          <a:lnRef idx="1">
+            <a:schemeClr val="accent1"/>
+          </a:lnRef>
+          <a:fillRef idx="3">
+            <a:schemeClr val="accent1"/>
+          </a:fillRef>
+          <a:effectRef idx="2">
+            <a:schemeClr val="accent1"/>
+          </a:effectRef>
+          <a:fontRef idx="minor">
+            <a:schemeClr val="lt1"/>
+          </a:fontRef>
+        </p:style>
+        <p:txBody>
+          <a:bodyPr rtlCol="0" anchor="ctr"/>
+          <a:lstStyle/>
+          <a:p>
+            <a:pPr algn="ctr"/>
+          </a:p>
+        </p:txBody>
+      </p:sp>
+      <p:sp>
+        <p:nvSpPr>
+          <p:cNvPr id="11" name="TextBox 10"/>
+          <p:cNvSpPr txBox="1"/>
+          <p:nvPr/>
+        </p:nvSpPr>
+        <p:spPr>
+          <a:xfrm>
+            <a:off x="950976" y="5843016"/>
+            <a:ext cx="10287000" cy="301752"/>
+          </a:xfrm>
+          <a:prstGeom prst="rect">
+            <a:avLst/>
+          </a:prstGeom>
+          <a:noFill/>
+        </p:spPr>
+        <p:txBody>
+          <a:bodyPr wrap="square" lIns="18288" rIns="18288" tIns="18288" bIns="18288" anchor="ctr">
+            <a:spAutoFit/>
+          </a:bodyPr>
+          <a:lstStyle/>
+          <a:p>
+            <a:pPr algn="l">
+              <a:spcBef>
+                <a:spcPts val="0"/>
+              </a:spcBef>
+              <a:spcAft>
+                <a:spcPts val="0"/>
+              </a:spcAft>
+            </a:pPr>
+            <a:r>
+              <a:rPr sz="1600" b="1">
+                <a:solidFill>
+                  <a:srgbClr val="BE7414"/>
+                </a:solidFill>
+                <a:latin typeface="Arial"/>
+              </a:rPr>
+              <a:t>Spike: all 10 request p95 values lower; total failures 218 → 0.</a:t>
+            </a:r>
+          </a:p>
+        </p:txBody>
+      </p:sp>
+    </p:spTree>
+  </p:cSld>
+  <p:clrMapOvr>
+    <a:masterClrMapping/>
+  </p:clrMapOvr>
+</p:sld>
+</file>
+
 <file path=ppt/slides/slide5.xml><?xml version="1.0" encoding="utf-8"?>
 <p:sld xmlns:a="http://schemas.openxmlformats.org/drawingml/2006/main" xmlns:p="http://schemas.openxmlformats.org/presentationml/2006/main" xmlns:r="http://schemas.openxmlformats.org/officeDocument/2006/relationships">
   <p:cSld>

</xml_diff>

<commit_message>
docs: explain all evaluation measures in defense notes
</commit_message>
<xml_diff>
--- a/Document/outputs/final-defense/G6519692_Zaw_Ye_Htut_Ko_Final_Thesis_Defense.pptx
+++ b/Document/outputs/final-defense/G6519692_Zaw_Ye_Htut_Ko_Final_Thesis_Defense.pptx
@@ -651,12 +651,12 @@
           <a:lstStyle/>
           <a:p>
             <a:r>
-              <a:t>TIMING: 70 seconds</a:t>
-            </a:r>
-          </a:p>
-          <a:p>
-            <a:r>
-              <a:t>KEY MESSAGE: Each tool has a rule, but the measured numbers still matter.</a:t>
+              <a:t>TIMING: 90 seconds</a:t>
+            </a:r>
+          </a:p>
+          <a:p>
+            <a:r>
+              <a:t>KEY MESSAGE: Each row has a primary decision and a separate check or target.</a:t>
             </a:r>
           </a:p>
           <a:p>
@@ -677,13 +677,18 @@
           </a:p>
           <a:p>
             <a:r>
-              <a:t>I named 100 simulated users the peak scenario and 500 the heavier-load scenario in the test plan. This was not a measured peak from real customers. The study set p95 targets of 500 milliseconds and 1,200 milliseconds respectively. Those numbers are study choices, not universal standards. I compare the after-fix result with each target and still report the actual time, so the committee can see more than a pass/fail label.</a:t>
+              <a:t>Read this table as four ways I checked the changes, not four promises that every number would improve. For SonarQube, I compare the number of distinct code issues before and after. I also show its Quality Gate, coverage, and complexity, so the committee can see any trade-off rather than just a lower issue count. For OWASP ZAP, I use the selected fail-rule policy to judge the scan, but a configured PASS does not mean zero raw alerts; I report their severities and any remaining observation separately. For JMeter, I measure p95 response time at 50, 100, and 500 simulated users. The 100-user limit of 500 milliseconds and the 500-user limit of 1,200 milliseconds are study targets, not measured production traffic or universal standards. Finally, Regression means I run focused tests and role checks to confirm accounting and authorization still work after a code change. Together these measures support a decision; one tool's PASS label cannot speak for all four areas.</a:t>
             </a:r>
           </a:p>
           <a:p/>
           <a:p>
             <a:r>
-              <a:t>SOURCE: Current report Table 4.1 and §4.1; Document/JMETER_ZAP_TEST_PLAN.md §4.6.</a:t>
+              <a:t>SOURCE: Current report Table 4.1 and §4.1; Document/JMETER_ZAP_TEST_PLAN.md §4.6; ZAP rule profiles and focused test records.</a:t>
+            </a:r>
+          </a:p>
+          <a:p>
+            <a:r>
+              <a:t>CAUTION: The last column intentionally combines secondary controls and predefined targets; do not describe every cell as an expected result.</a:t>
             </a:r>
           </a:p>
         </p:txBody>
@@ -9049,7 +9054,7 @@
                           </a:solidFill>
                           <a:latin typeface="Arial"/>
                         </a:rPr>
-                        <a:t>Control metric</a:t>
+                        <a:t>Additional check / target</a:t>
                       </a:r>
                     </a:p>
                   </a:txBody>
@@ -9215,7 +9220,7 @@
                           </a:solidFill>
                           <a:latin typeface="Arial"/>
                         </a:rPr>
-                        <a:t>Residual HTTP-only observation disclosed</a:t>
+                        <a:t>Raw alert severities reported, including residuals</a:t>
                       </a:r>
                     </a:p>
                   </a:txBody>

</xml_diff>